<commit_message>
TL-Pilot v0.2 deployt: Modulinhalte + Workbooks + Decks (Review-Befunde eingearbeitet)
Co-Authored-By: Claude Opus 4.8 <noreply@anthropic.com>
</commit_message>
<xml_diff>
--- a/protected-downloads/praesentation/TL00.pptx
+++ b/protected-downloads/praesentation/TL00.pptx
@@ -721,7 +721,7 @@
           <a:lstStyle/>
           <a:p>
             <a:r>
-              <a:t>Trainer-Hinweis: Musterlösung im Trainer-Abschnitt unten. Die drei Situationen sind so gesetzt, dass sie die drei Dimensionen des Rollenwechsels (Erfolgslogik, Identität, Zeit) je einmal konkret durcharbeiten. Situation B ist erfahrungsgemäß die emotionalste – Plenumsdiskussion dort nicht abwürgen, sondern moderieren.</a:t>
+              <a:t>Trainer-Hinweis: Musterlösung im Trainer-Abschnitt unten. Die Situationen decken alle vier Dimensionen des Rollenwechsels ab: Situation A (Erfolgslogik/Delegation), Situation B1+B2 (Identität/Rollenklarheit – emotionalster Block, nicht abwürgen, sondern moderieren; B2 unbedingt im Plenum besprechen, da sie den Moment der Teamakzeptanz zeigt), Situation C (Zeit/Führungsleistung benennen), Situation D (Leistungsverantwortung wahrnehmen – häufig der am stärksten gemiedene Moment des ersten Jahres; in der kollegialen Fallberatung besonders wertvoll).</a:t>
             </a:r>
           </a:p>
           <a:p>
@@ -736,12 +736,22 @@
           </a:p>
           <a:p>
             <a:r>
-              <a:t>Situation B: Thomas klärt mit Marco in einem kurzen Einzelgespräch die neue Rollenerwartung: „Ich werde deine Kreditausarbeitungen nicht mehr inhaltlich kommentieren – das ist jetzt deine fachliche Verantwortung. Ich bin da, wenn du eine Meinung brauchst, aber ich fordere sie nicht ungefragt. Wenn ich Feedback gebe, dann zur Struktur und zum Vorgehen, nicht zur Lösung." Dieser Satz setzt eine klare Grenze ohne Hierarchisierung. Das Gespräch sollte explizit, ruhig und kurz sein.</a:t>
-            </a:r>
-          </a:p>
-          <a:p>
-            <a:r>
-              <a:t>Situation C: Echte Führungsleistung in vier Monaten: Wie viele Einzelgespräche hat Thomas mit Teammitgliedern geführt? Hat er die Stärken und Entwicklungsfelder jedes Beraters identifiziert? Wurden Vertriebsziele besprochen und nachverfolgt? Hat Thomas das Team durch Rückmeldung, Ermutigung oder Klärung von Hindernissen in seiner Arbeit unterstützt? Das sind die Fragen, auf die die GL eine Antwort erwartet – nicht: Welche Kredite hat Thomas durchgesehen?</a:t>
+              <a:t>Situation B1: Thomas klärt mit Marco in einem kurzen Einzelgespräch die neue Rollenerwartung: „Ich werde deine Kreditausarbeitungen nicht mehr inhaltlich kommentieren – das ist jetzt deine fachliche Verantwortung. Ich bin da, wenn du eine Meinung brauchst, aber ich fordere sie nicht ungefragt. Wenn ich Feedback gebe, dann zur Struktur und zum Vorgehen, nicht zur Lösung." Dieser Satz setzt eine klare Grenze ohne Hierarchisierung. Das Gespräch sollte explizit, ruhig und kurz sein.</a:t>
+            </a:r>
+          </a:p>
+          <a:p>
+            <a:r>
+              <a:t>Situation B2: Thomas reagiert im Teammeeting sofort – aber ohne Eskalation. Bewährte Formulierung: „Marco, danke für den Einwand – der verdient eine Antwort. Wir haben das frühere Verfahren bewusst überprüft, und ich habe mich aus folgenden Gründen für diesen neuen Standard entschieden: [kurze Begründung, 2 Sätze]. Wer konkrete Bedenken zur Umsetzung hat, nehme ich gern im Einzelgespräch entgegen." Drei Dinge passieren gleichzeitig: Thomas zeigt, dass er sachliche Einwände ernst nimmt, nennt seine Entscheidungsgrundlage, und verschiebt die Detaildiskussion aus dem Plenum ins Vieraugengespräch. Marco behält sein Gesicht – und das Team sieht, dass Thomas entscheidungsstark bleibt. Zentral: Dieser Moment erfordert kein späteres Strafgespräch mit Marco. Die richtige Reaktion im Meeting ist die Führungshandlung.</a:t>
+            </a:r>
+          </a:p>
+          <a:p>
+            <a:r>
+              <a:t>Trainer-Hinweis: Situation B2 ist der Moment, der über Akzeptanz oder Erosion der Teamleiter-Rolle entscheidet. Im Plenum gemeinsam Formulierungsalternativen sammeln: Was würde „zu weich" klingen? Was „zu hart"? Der Raum zwischen beidem ist die Führungskompetenz. Kein Rollenspiel – stattdessen: Teilnehmer schreiben ihren eigenen Einstiegssatz auf, ein Freiwilliger liest vor.</a:t>
+            </a:r>
+          </a:p>
+          <a:p>
+            <a:r>
+              <a:t>Situation C: Echte Führungsleistung in vier Monaten: Wie viele Ei</a:t>
             </a:r>
           </a:p>
         </p:txBody>
@@ -4396,7 +4406,7 @@
                 </a:solidFill>
                 <a:latin typeface="Arial"/>
               </a:rPr>
-              <a:t>v0.1</a:t>
+              <a:t>v0.2</a:t>
             </a:r>
           </a:p>
         </p:txBody>
@@ -5590,7 +5600,7 @@
                 </a:solidFill>
                 <a:latin typeface="Arial"/>
               </a:rPr>
-              <a:t>▸  Die Kernunterschiede zwischen der Beratungsrolle und der Führungsrolle benennen und am eigenen Berufsweg beschreiben</a:t>
+              <a:t>▸  Die Kernunterschiede zwischen der Beratungsrolle und der Führungsrolle benennen</a:t>
             </a:r>
           </a:p>
           <a:p>
@@ -5628,7 +5638,7 @@
                 </a:solidFill>
                 <a:latin typeface="Arial"/>
               </a:rPr>
-              <a:t>▸  Typische Rollenfallen neu beförderte Teamleiter (z. B. Rückfall ins Fachexperten-Selbstverständnis, Loyalitätskonflikte mit ehemaligen Kollegen) einordnen und eigene Umgangsstrategien formulieren</a:t>
+              <a:t>▸  Typische Rollenfallen neu beförderter Teamleiter (z. B. Rückfall ins Fachexperten-Selbstverständnis, Loyalitätskonflikte mit ehemaligen Kollegen) erkennen und eigene Umgangsstrategien formulieren</a:t>
             </a:r>
           </a:p>
           <a:p>
@@ -6463,6 +6473,44 @@
               <a:t>Als Berater gehört die Zeit Ihnen und Ihren Kunden. Als Teamleiter gehört Ihre Zeit Ihrem Team. Diese Umverteilung ist keine Metapher – sie ist messbar. Typische Zeitverschiebung im ersten Jahr:</a:t>
             </a:r>
           </a:p>
+          <a:p>
+            <a:pPr marL="177800" indent="-177800">
+              <a:spcBef>
+                <a:spcPts val="600"/>
+              </a:spcBef>
+              <a:spcAft>
+                <a:spcPts val="200"/>
+              </a:spcAft>
+            </a:pPr>
+            <a:r>
+              <a:rPr sz="1200" i="1">
+                <a:solidFill>
+                  <a:srgbClr val="3D5466"/>
+                </a:solidFill>
+                <a:latin typeface="Arial"/>
+              </a:rPr>
+              <a:t>→  Handlungsempfehlung</a:t>
+            </a:r>
+          </a:p>
+          <a:p>
+            <a:pPr marL="177800" indent="-177800">
+              <a:spcBef>
+                <a:spcPts val="600"/>
+              </a:spcBef>
+              <a:spcAft>
+                <a:spcPts val="200"/>
+              </a:spcAft>
+            </a:pPr>
+            <a:r>
+              <a:rPr sz="1200" i="1">
+                <a:solidFill>
+                  <a:srgbClr val="3D5466"/>
+                </a:solidFill>
+                <a:latin typeface="Arial"/>
+              </a:rPr>
+              <a:t>→  Wenn die Geschäftsleitung Erwartungen an Sie als Teamleiter stellt, die Sie für Ihr Team als unrealistisch oder unfair einschätzen</a:t>
+            </a:r>
+          </a:p>
         </p:txBody>
       </p:sp>
       <p:sp>
@@ -6825,6 +6873,44 @@
           </a:bodyPr>
           <a:lstStyle/>
           <a:p>
+            <a:pPr marL="177800" indent="-177800">
+              <a:spcBef>
+                <a:spcPts val="600"/>
+              </a:spcBef>
+              <a:spcAft>
+                <a:spcPts val="200"/>
+              </a:spcAft>
+            </a:pPr>
+            <a:r>
+              <a:rPr sz="1200" i="1">
+                <a:solidFill>
+                  <a:srgbClr val="3D5466"/>
+                </a:solidFill>
+                <a:latin typeface="Arial"/>
+              </a:rPr>
+              <a:t>→  Handlungsempfehlung</a:t>
+            </a:r>
+          </a:p>
+          <a:p>
+            <a:pPr marL="177800" indent="-177800">
+              <a:spcBef>
+                <a:spcPts val="600"/>
+              </a:spcBef>
+              <a:spcAft>
+                <a:spcPts val="200"/>
+              </a:spcAft>
+            </a:pPr>
+            <a:r>
+              <a:rPr sz="1200" i="1">
+                <a:solidFill>
+                  <a:srgbClr val="3D5466"/>
+                </a:solidFill>
+                <a:latin typeface="Arial"/>
+              </a:rPr>
+              <a:t>→  Wenn ein Berater eine Teamentscheidung nicht akzeptiert und darauf besteht, seinen abweichenden Weg zu gehen</a:t>
+            </a:r>
+          </a:p>
+          <a:p>
             <a:pPr>
               <a:spcBef>
                 <a:spcPts val="400"/>
@@ -6840,7 +6926,7 @@
                 </a:solidFill>
                 <a:latin typeface="Arial"/>
               </a:rPr>
-              <a:t>Merksatz: Führung ist nicht das, was ich tue. Führung ist, was in meinem Team möglich wird.</a:t>
+              <a:t>Merksatz: Führung ist nicht das, was ich tue. Führung ist, was in meinem Team möglich wird – und was ich klar verantworte.</a:t>
             </a:r>
           </a:p>
         </p:txBody>
@@ -7239,7 +7325,7 @@
                 </a:solidFill>
                 <a:latin typeface="Arial"/>
               </a:rPr>
-              <a:t>▸  Drei Entscheidungssituationen</a:t>
+              <a:t>▸  Vier Entscheidungssituationen</a:t>
             </a:r>
           </a:p>
           <a:p>
@@ -7296,7 +7382,7 @@
                 </a:solidFill>
                 <a:latin typeface="Arial"/>
               </a:rPr>
-              <a:t>▸  Situation B – Der Kollege als Mitarbeiter:</a:t>
+              <a:t>▸  Situation B1 – Der Kollege als Mitarbeiter (Rückzugs-Variante):</a:t>
             </a:r>
           </a:p>
         </p:txBody>

</xml_diff>

<commit_message>
TL00 Vollausbau deployt: content/modules (Sec 2/3/6) + PPTX + Trainerhandbuch-PDF; ergaenzung=true
Co-Authored-By: Claude Opus 4.8 <noreply@anthropic.com>
</commit_message>
<xml_diff>
--- a/protected-downloads/praesentation/TL00.pptx
+++ b/protected-downloads/praesentation/TL00.pptx
@@ -15,6 +15,7 @@
     <p:sldId id="263" r:id="rId15"/>
     <p:sldId id="264" r:id="rId16"/>
     <p:sldId id="265" r:id="rId17"/>
+    <p:sldId id="266" r:id="rId18"/>
   </p:sldIdLst>
   <p:sldSz cx="12188952" cy="6858000" type="screen4x3"/>
   <p:notesSz cx="6858000" cy="9144000"/>
@@ -511,7 +512,7 @@
           <a:lstStyle/>
           <a:p>
             <a:r>
-              <a:t>Siehe Trainerhandbuch (Sektion 3) für Moderationshinweise, Timing und erwartete Teilnehmerreaktionen.</a:t>
+              <a:t>Agenda aus dem Ablaufplan (Sektion 3.1). Timing und Pausen siehe Trainerhandbuch.</a:t>
             </a:r>
           </a:p>
         </p:txBody>
@@ -721,37 +722,7 @@
           <a:lstStyle/>
           <a:p>
             <a:r>
-              <a:t>Trainer-Hinweis: Musterlösung im Trainer-Abschnitt unten. Die Situationen decken alle vier Dimensionen des Rollenwechsels ab: Situation A (Erfolgslogik/Delegation), Situation B1+B2 (Identität/Rollenklarheit – emotionalster Block, nicht abwürgen, sondern moderieren; B2 unbedingt im Plenum besprechen, da sie den Moment der Teamakzeptanz zeigt), Situation C (Zeit/Führungsleistung benennen), Situation D (Leistungsverantwortung wahrnehmen – häufig der am stärksten gemiedene Moment des ersten Jahres; in der kollegialen Fallberatung besonders wertvoll).</a:t>
-            </a:r>
-          </a:p>
-          <a:p>
-            <a:r>
-              <a:t>AB-1 Musterlösung (Trainer-Version)</a:t>
-            </a:r>
-          </a:p>
-          <a:p>
-            <a:r>
-              <a:t>Situation A: Thomas delegiert das Gespräch vollständig an Marcus Bauer und begleitet es im ersten Schritt als stille Beobachtung (Beobachtungsbogen, 30 Minuten). Danach gibt er Marcus strukturiertes Feedback: Was war gut? Was würde er beim nächsten Mal anders machen? Thomas tritt damit als Coach auf, nicht als besserer Berater. Der Stammkunde ist ein idealer erster „Transferfall" – der Beziehungsaufbau zwischen Marcus und dem Kunden ist echte Führungsleistung.</a:t>
-            </a:r>
-          </a:p>
-          <a:p>
-            <a:r>
-              <a:t>Situation B1: Thomas klärt mit Marco in einem kurzen Einzelgespräch die neue Rollenerwartung: „Ich werde deine Kreditausarbeitungen nicht mehr inhaltlich kommentieren – das ist jetzt deine fachliche Verantwortung. Ich bin da, wenn du eine Meinung brauchst, aber ich fordere sie nicht ungefragt. Wenn ich Feedback gebe, dann zur Struktur und zum Vorgehen, nicht zur Lösung." Dieser Satz setzt eine klare Grenze ohne Hierarchisierung. Das Gespräch sollte explizit, ruhig und kurz sein.</a:t>
-            </a:r>
-          </a:p>
-          <a:p>
-            <a:r>
-              <a:t>Situation B2: Thomas reagiert im Teammeeting sofort – aber ohne Eskalation. Bewährte Formulierung: „Marco, danke für den Einwand – der verdient eine Antwort. Wir haben das frühere Verfahren bewusst überprüft, und ich habe mich aus folgenden Gründen für diesen neuen Standard entschieden: [kurze Begründung, 2 Sätze]. Wer konkrete Bedenken zur Umsetzung hat, nehme ich gern im Einzelgespräch entgegen." Drei Dinge passieren gleichzeitig: Thomas zeigt, dass er sachliche Einwände ernst nimmt, nennt seine Entscheidungsgrundlage, und verschiebt die Detaildiskussion aus dem Plenum ins Vieraugengespräch. Marco behält sein Gesicht – und das Team sieht, dass Thomas entscheidungsstark bleibt. Zentral: Dieser Moment erfordert kein späteres Strafgespräch mit Marco. Die richtige Reaktion im Meeting ist die Führungshandlung.</a:t>
-            </a:r>
-          </a:p>
-          <a:p>
-            <a:r>
-              <a:t>Trainer-Hinweis: Situation B2 ist der Moment, der über Akzeptanz oder Erosion der Teamleiter-Rolle entscheidet. Im Plenum gemeinsam Formulierungsalternativen sammeln: Was würde „zu weich" klingen? Was „zu hart"? Der Raum zwischen beidem ist die Führungskompetenz. Kein Rollenspiel – stattdessen: Teilnehmer schreiben ihren eigenen Einstiegssatz auf, ein Freiwilliger liest vor.</a:t>
-            </a:r>
-          </a:p>
-          <a:p>
-            <a:r>
-              <a:t>Situation C: Echte Führungsleistung in vier Monaten: Wie viele Ei</a:t>
+              <a:t>Siehe Trainerhandbuch (Sektion 3) für Moderationshinweise, Timing und erwartete Teilnehmerreaktionen.</a:t>
             </a:r>
           </a:p>
         </p:txBody>
@@ -821,7 +792,37 @@
           <a:lstStyle/>
           <a:p>
             <a:r>
-              <a:t>Siehe Trainerhandbuch (Sektion 3) für Moderationshinweise, Timing und erwartete Teilnehmerreaktionen.</a:t>
+              <a:t>Trainer-Hinweis: Musterlösung im Trainer-Abschnitt unten. Die Situationen decken alle vier Dimensionen des Rollenwechsels ab: Situation A (Erfolgslogik/Delegation), Situation B1+B2 (Identität/Rollenklarheit – emotionalster Block, nicht abwürgen, sondern moderieren; B2 unbedingt im Plenum besprechen, da sie den Moment der Teamakzeptanz zeigt), Situation C (Zeit/Führungsleistung benennen), Situation D (Leistungsverantwortung wahrnehmen – häufig der am stärksten gemiedene Moment des ersten Jahres; in der kollegialen Fallberatung besonders wertvoll).</a:t>
+            </a:r>
+          </a:p>
+          <a:p>
+            <a:r>
+              <a:t>AB-1 Musterlösung (Trainer-Version)</a:t>
+            </a:r>
+          </a:p>
+          <a:p>
+            <a:r>
+              <a:t>Situation A: Thomas delegiert das Gespräch vollständig an Marcus Bauer und begleitet es im ersten Schritt als stille Beobachtung (Beobachtungsbogen, 30 Minuten). Danach gibt er Marcus strukturiertes Feedback: Was war gut? Was würde er beim nächsten Mal anders machen? Thomas tritt damit als Coach auf, nicht als besserer Berater. Der Stammkunde ist ein idealer erster „Transferfall" – der Beziehungsaufbau zwischen Marcus und dem Kunden ist echte Führungsleistung.</a:t>
+            </a:r>
+          </a:p>
+          <a:p>
+            <a:r>
+              <a:t>Situation B1: Thomas klärt mit Marco in einem kurzen Einzelgespräch die neue Rollenerwartung: „Ich werde deine Kreditausarbeitungen nicht mehr inhaltlich kommentieren – das ist jetzt deine fachliche Verantwortung. Ich bin da, wenn du eine Meinung brauchst, aber ich fordere sie nicht ungefragt. Wenn ich Feedback gebe, dann zur Struktur und zum Vorgehen, nicht zur Lösung." Dieser Satz setzt eine klare Grenze ohne Hierarchisierung. Das Gespräch sollte explizit, ruhig und kurz sein.</a:t>
+            </a:r>
+          </a:p>
+          <a:p>
+            <a:r>
+              <a:t>Situation B2: Thomas reagiert im Teammeeting sofort – aber ohne Eskalation. Bewährte Formulierung: „Marco, danke für den Einwand – der verdient eine Antwort. Wir haben das frühere Verfahren bewusst überprüft, und ich habe mich aus folgenden Gründen für diesen neuen Standard entschieden: [kurze Begründung, 2 Sätze]. Wer konkrete Bedenken zur Umsetzung hat, nehme ich gern im Einzelgespräch entgegen." Drei Dinge passieren gleichzeitig: Thomas zeigt, dass er sachliche Einwände ernst nimmt, nennt seine Entscheidungsgrundlage, und verschiebt die Detaildiskussion aus dem Plenum ins Vieraugengespräch. Marco behält sein Gesicht – und das Team sieht, dass Thomas entscheidungsstark bleibt. Zentral: Dieser Moment erfordert kein späteres Strafgespräch mit Marco. Die richtige Reaktion im Meeting ist die Führungshandlung.</a:t>
+            </a:r>
+          </a:p>
+          <a:p>
+            <a:r>
+              <a:t>Trainer-Hinweis: Situation B2 ist der Moment, der über Akzeptanz oder Erosion der Teamleiter-Rolle entscheidet. Im Plenum gemeinsam Formulierungsalternativen sammeln: Was würde „zu weich" klingen? Was „zu hart"? Der Raum zwischen beidem ist die Führungskompetenz. Kein Rollenspiel – stattdessen: Teilnehmer schreiben ihren eigenen Einstiegssatz auf, ein Freiwilliger liest vor.</a:t>
+            </a:r>
+          </a:p>
+          <a:p>
+            <a:r>
+              <a:t>Situation C: Echte Führungsleistung in vier Monaten: Wie viele Ei</a:t>
             </a:r>
           </a:p>
         </p:txBody>
@@ -917,6 +918,76 @@
 </file>
 
 <file path=ppt/notesSlides/notesSlide7.xml><?xml version="1.0" encoding="utf-8"?>
+<p:notes xmlns:a="http://schemas.openxmlformats.org/drawingml/2006/main" xmlns:p="http://schemas.openxmlformats.org/presentationml/2006/main" xmlns:r="http://schemas.openxmlformats.org/officeDocument/2006/relationships">
+  <p:cSld>
+    <p:spTree>
+      <p:nvGrpSpPr>
+        <p:cNvPr id="1" name=""/>
+        <p:cNvGrpSpPr/>
+        <p:nvPr/>
+      </p:nvGrpSpPr>
+      <p:grpSpPr>
+        <a:xfrm>
+          <a:off x="0" y="0"/>
+          <a:ext cx="0" cy="0"/>
+          <a:chOff x="0" y="0"/>
+          <a:chExt cx="0" cy="0"/>
+        </a:xfrm>
+      </p:grpSpPr>
+      <p:sp>
+        <p:nvSpPr>
+          <p:cNvPr id="2" name="Slide Image Placeholder 1"/>
+          <p:cNvSpPr>
+            <a:spLocks noGrp="1"/>
+          </p:cNvSpPr>
+          <p:nvPr>
+            <p:ph type="sldImg" idx="2"/>
+          </p:nvPr>
+        </p:nvSpPr>
+        <p:spPr/>
+      </p:sp>
+      <p:sp>
+        <p:nvSpPr>
+          <p:cNvPr id="3" name="Notes Placeholder 2"/>
+          <p:cNvSpPr>
+            <a:spLocks noGrp="1"/>
+          </p:cNvSpPr>
+          <p:nvPr>
+            <p:ph type="body" idx="3" sz="quarter"/>
+          </p:nvPr>
+        </p:nvSpPr>
+        <p:spPr/>
+        <p:txBody>
+          <a:bodyPr/>
+          <a:lstStyle/>
+          <a:p>
+            <a:r>
+              <a:t>Siehe Trainerhandbuch (Sektion 3) für Moderationshinweise, Timing und erwartete Teilnehmerreaktionen.</a:t>
+            </a:r>
+          </a:p>
+        </p:txBody>
+      </p:sp>
+      <p:sp>
+        <p:nvSpPr>
+          <p:cNvPr id="4" name="Slide Number Placeholder 3"/>
+          <p:cNvSpPr>
+            <a:spLocks noGrp="1"/>
+          </p:cNvSpPr>
+          <p:nvPr>
+            <p:ph type="sldNum" idx="5" sz="quarter"/>
+          </p:nvPr>
+        </p:nvSpPr>
+        <p:spPr/>
+      </p:sp>
+    </p:spTree>
+  </p:cSld>
+  <p:clrMapOvr>
+    <a:masterClrMapping/>
+  </p:clrMapOvr>
+</p:notes>
+</file>
+
+<file path=ppt/notesSlides/notesSlide8.xml><?xml version="1.0" encoding="utf-8"?>
 <p:notes xmlns:a="http://schemas.openxmlformats.org/drawingml/2006/main" xmlns:p="http://schemas.openxmlformats.org/presentationml/2006/main" xmlns:r="http://schemas.openxmlformats.org/officeDocument/2006/relationships">
   <p:cSld>
     <p:spTree>
@@ -4779,6 +4850,386 @@
                 </a:solidFill>
                 <a:latin typeface="Arial"/>
               </a:rPr>
+              <a:t>Checkliste: Bin ich in der Führungsrolle angekommen?</a:t>
+            </a:r>
+          </a:p>
+        </p:txBody>
+      </p:sp>
+      <p:sp>
+        <p:nvSpPr>
+          <p:cNvPr id="8" name="TextBox 7"/>
+          <p:cNvSpPr txBox="1"/>
+          <p:nvPr/>
+        </p:nvSpPr>
+        <p:spPr>
+          <a:xfrm>
+            <a:off x="685800" y="1417320"/>
+            <a:ext cx="10817352" cy="4892040"/>
+          </a:xfrm>
+          <a:prstGeom prst="rect">
+            <a:avLst/>
+          </a:prstGeom>
+          <a:noFill/>
+        </p:spPr>
+        <p:txBody>
+          <a:bodyPr wrap="square" anchor="ctr">
+            <a:spAutoFit/>
+          </a:bodyPr>
+          <a:lstStyle/>
+          <a:p>
+            <a:pPr>
+              <a:spcBef>
+                <a:spcPts val="400"/>
+              </a:spcBef>
+              <a:spcAft>
+                <a:spcPts val="200"/>
+              </a:spcAft>
+            </a:pPr>
+            <a:r>
+              <a:rPr sz="1200">
+                <a:solidFill>
+                  <a:srgbClr val="3D5466"/>
+                </a:solidFill>
+                <a:latin typeface="Arial"/>
+              </a:rPr>
+              <a:t>Beantworten Sie diese Fragen ehrlich – nach dem heutigen Workshop und erneut nach vier Wochen.</a:t>
+            </a:r>
+          </a:p>
+        </p:txBody>
+      </p:sp>
+      <p:sp>
+        <p:nvSpPr>
+          <p:cNvPr id="9" name="Rectangle 8"/>
+          <p:cNvSpPr/>
+          <p:nvPr/>
+        </p:nvSpPr>
+        <p:spPr>
+          <a:xfrm>
+            <a:off x="0" y="6510528"/>
+            <a:ext cx="12188952" cy="347472"/>
+          </a:xfrm>
+          <a:prstGeom prst="rect">
+            <a:avLst/>
+          </a:prstGeom>
+          <a:solidFill>
+            <a:srgbClr val="0A1937"/>
+          </a:solidFill>
+          <a:ln>
+            <a:noFill/>
+          </a:ln>
+        </p:spPr>
+        <p:style>
+          <a:lnRef idx="1">
+            <a:schemeClr val="accent1"/>
+          </a:lnRef>
+          <a:fillRef idx="3">
+            <a:schemeClr val="accent1"/>
+          </a:fillRef>
+          <a:effectRef idx="2">
+            <a:schemeClr val="accent1"/>
+          </a:effectRef>
+          <a:fontRef idx="minor">
+            <a:schemeClr val="lt1"/>
+          </a:fontRef>
+        </p:style>
+        <p:txBody>
+          <a:bodyPr rtlCol="0" anchor="ctr"/>
+          <a:lstStyle/>
+          <a:p>
+            <a:pPr algn="ctr"/>
+          </a:p>
+        </p:txBody>
+      </p:sp>
+      <p:sp>
+        <p:nvSpPr>
+          <p:cNvPr id="10" name="TextBox 9"/>
+          <p:cNvSpPr txBox="1"/>
+          <p:nvPr/>
+        </p:nvSpPr>
+        <p:spPr>
+          <a:xfrm>
+            <a:off x="685800" y="6583680"/>
+            <a:ext cx="6490411" cy="256032"/>
+          </a:xfrm>
+          <a:prstGeom prst="rect">
+            <a:avLst/>
+          </a:prstGeom>
+          <a:noFill/>
+        </p:spPr>
+        <p:txBody>
+          <a:bodyPr wrap="none">
+            <a:spAutoFit/>
+          </a:bodyPr>
+          <a:lstStyle/>
+          <a:p>
+            <a:pPr algn="l"/>
+            <a:r>
+              <a:rPr sz="700">
+                <a:solidFill>
+                  <a:srgbClr val="A0B4D2"/>
+                </a:solidFill>
+                <a:latin typeface="Consolas"/>
+              </a:rPr>
+              <a:t>FKB Campus  ·  TL00</a:t>
+            </a:r>
+          </a:p>
+        </p:txBody>
+      </p:sp>
+    </p:spTree>
+  </p:cSld>
+  <p:clrMapOvr>
+    <a:masterClrMapping/>
+  </p:clrMapOvr>
+</p:sld>
+</file>
+
+<file path=ppt/slides/slide11.xml><?xml version="1.0" encoding="utf-8"?>
+<p:sld xmlns:a="http://schemas.openxmlformats.org/drawingml/2006/main" xmlns:p="http://schemas.openxmlformats.org/presentationml/2006/main" xmlns:r="http://schemas.openxmlformats.org/officeDocument/2006/relationships">
+  <p:cSld>
+    <p:spTree>
+      <p:nvGrpSpPr>
+        <p:cNvPr id="1" name=""/>
+        <p:cNvGrpSpPr/>
+        <p:nvPr/>
+      </p:nvGrpSpPr>
+      <p:grpSpPr/>
+      <p:sp>
+        <p:nvSpPr>
+          <p:cNvPr id="2" name="Rectangle 1"/>
+          <p:cNvSpPr/>
+          <p:nvPr/>
+        </p:nvSpPr>
+        <p:spPr>
+          <a:xfrm>
+            <a:off x="0" y="0"/>
+            <a:ext cx="12188952" cy="6858000"/>
+          </a:xfrm>
+          <a:prstGeom prst="rect">
+            <a:avLst/>
+          </a:prstGeom>
+          <a:solidFill>
+            <a:srgbClr val="EDEDF3"/>
+          </a:solidFill>
+          <a:ln>
+            <a:noFill/>
+          </a:ln>
+        </p:spPr>
+        <p:style>
+          <a:lnRef idx="1">
+            <a:schemeClr val="accent1"/>
+          </a:lnRef>
+          <a:fillRef idx="3">
+            <a:schemeClr val="accent1"/>
+          </a:fillRef>
+          <a:effectRef idx="2">
+            <a:schemeClr val="accent1"/>
+          </a:effectRef>
+          <a:fontRef idx="minor">
+            <a:schemeClr val="lt1"/>
+          </a:fontRef>
+        </p:style>
+        <p:txBody>
+          <a:bodyPr rtlCol="0" anchor="ctr"/>
+          <a:lstStyle/>
+          <a:p>
+            <a:pPr algn="ctr"/>
+          </a:p>
+        </p:txBody>
+      </p:sp>
+      <p:sp>
+        <p:nvSpPr>
+          <p:cNvPr id="3" name="Rectangle 2"/>
+          <p:cNvSpPr/>
+          <p:nvPr/>
+        </p:nvSpPr>
+        <p:spPr>
+          <a:xfrm>
+            <a:off x="0" y="0"/>
+            <a:ext cx="12188952" cy="50292"/>
+          </a:xfrm>
+          <a:prstGeom prst="rect">
+            <a:avLst/>
+          </a:prstGeom>
+          <a:solidFill>
+            <a:srgbClr val="1F2C56"/>
+          </a:solidFill>
+          <a:ln>
+            <a:noFill/>
+          </a:ln>
+        </p:spPr>
+        <p:style>
+          <a:lnRef idx="1">
+            <a:schemeClr val="accent1"/>
+          </a:lnRef>
+          <a:fillRef idx="3">
+            <a:schemeClr val="accent1"/>
+          </a:fillRef>
+          <a:effectRef idx="2">
+            <a:schemeClr val="accent1"/>
+          </a:effectRef>
+          <a:fontRef idx="minor">
+            <a:schemeClr val="lt1"/>
+          </a:fontRef>
+        </p:style>
+        <p:txBody>
+          <a:bodyPr rtlCol="0" anchor="ctr"/>
+          <a:lstStyle/>
+          <a:p>
+            <a:pPr algn="ctr"/>
+          </a:p>
+        </p:txBody>
+      </p:sp>
+      <p:sp>
+        <p:nvSpPr>
+          <p:cNvPr id="4" name="TextBox 3"/>
+          <p:cNvSpPr txBox="1"/>
+          <p:nvPr/>
+        </p:nvSpPr>
+        <p:spPr>
+          <a:xfrm>
+            <a:off x="685800" y="109728"/>
+            <a:ext cx="10817352" cy="228600"/>
+          </a:xfrm>
+          <a:prstGeom prst="rect">
+            <a:avLst/>
+          </a:prstGeom>
+          <a:noFill/>
+        </p:spPr>
+        <p:txBody>
+          <a:bodyPr wrap="none">
+            <a:spAutoFit/>
+          </a:bodyPr>
+          <a:lstStyle/>
+          <a:p>
+            <a:pPr algn="l"/>
+            <a:r>
+              <a:rPr sz="750">
+                <a:solidFill>
+                  <a:srgbClr val="78808C"/>
+                </a:solidFill>
+                <a:latin typeface="Consolas"/>
+              </a:rPr>
+              <a:t>TL00  ·  INHALT</a:t>
+            </a:r>
+          </a:p>
+        </p:txBody>
+      </p:sp>
+      <p:sp>
+        <p:nvSpPr>
+          <p:cNvPr id="5" name="Rectangle 4"/>
+          <p:cNvSpPr/>
+          <p:nvPr/>
+        </p:nvSpPr>
+        <p:spPr>
+          <a:xfrm>
+            <a:off x="0" y="1234440"/>
+            <a:ext cx="12188952" cy="12700"/>
+          </a:xfrm>
+          <a:prstGeom prst="rect">
+            <a:avLst/>
+          </a:prstGeom>
+          <a:solidFill>
+            <a:srgbClr val="D8DFE4"/>
+          </a:solidFill>
+          <a:ln>
+            <a:noFill/>
+          </a:ln>
+        </p:spPr>
+        <p:style>
+          <a:lnRef idx="1">
+            <a:schemeClr val="accent1"/>
+          </a:lnRef>
+          <a:fillRef idx="3">
+            <a:schemeClr val="accent1"/>
+          </a:fillRef>
+          <a:effectRef idx="2">
+            <a:schemeClr val="accent1"/>
+          </a:effectRef>
+          <a:fontRef idx="minor">
+            <a:schemeClr val="lt1"/>
+          </a:fontRef>
+        </p:style>
+        <p:txBody>
+          <a:bodyPr rtlCol="0" anchor="ctr"/>
+          <a:lstStyle/>
+          <a:p>
+            <a:pPr algn="ctr"/>
+          </a:p>
+        </p:txBody>
+      </p:sp>
+      <p:sp>
+        <p:nvSpPr>
+          <p:cNvPr id="6" name="Rectangle 5"/>
+          <p:cNvSpPr/>
+          <p:nvPr/>
+        </p:nvSpPr>
+        <p:spPr>
+          <a:xfrm>
+            <a:off x="685800" y="502920"/>
+            <a:ext cx="36576" cy="658368"/>
+          </a:xfrm>
+          <a:prstGeom prst="rect">
+            <a:avLst/>
+          </a:prstGeom>
+          <a:solidFill>
+            <a:srgbClr val="D9C089"/>
+          </a:solidFill>
+          <a:ln>
+            <a:noFill/>
+          </a:ln>
+        </p:spPr>
+        <p:style>
+          <a:lnRef idx="1">
+            <a:schemeClr val="accent1"/>
+          </a:lnRef>
+          <a:fillRef idx="3">
+            <a:schemeClr val="accent1"/>
+          </a:fillRef>
+          <a:effectRef idx="2">
+            <a:schemeClr val="accent1"/>
+          </a:effectRef>
+          <a:fontRef idx="minor">
+            <a:schemeClr val="lt1"/>
+          </a:fontRef>
+        </p:style>
+        <p:txBody>
+          <a:bodyPr rtlCol="0" anchor="ctr"/>
+          <a:lstStyle/>
+          <a:p>
+            <a:pPr algn="ctr"/>
+          </a:p>
+        </p:txBody>
+      </p:sp>
+      <p:sp>
+        <p:nvSpPr>
+          <p:cNvPr id="7" name="TextBox 6"/>
+          <p:cNvSpPr txBox="1"/>
+          <p:nvPr/>
+        </p:nvSpPr>
+        <p:spPr>
+          <a:xfrm>
+            <a:off x="813816" y="502920"/>
+            <a:ext cx="10634472" cy="685800"/>
+          </a:xfrm>
+          <a:prstGeom prst="rect">
+            <a:avLst/>
+          </a:prstGeom>
+          <a:noFill/>
+        </p:spPr>
+        <p:txBody>
+          <a:bodyPr wrap="square">
+            <a:spAutoFit/>
+          </a:bodyPr>
+          <a:lstStyle/>
+          <a:p>
+            <a:pPr algn="l"/>
+            <a:r>
+              <a:rPr sz="2400" b="1" i="0">
+                <a:solidFill>
+                  <a:srgbClr val="1F2C56"/>
+                </a:solidFill>
+                <a:latin typeface="Arial"/>
+              </a:rPr>
               <a:t>Reflexionsfragen</a:t>
             </a:r>
           </a:p>
@@ -5874,7 +6325,7 @@
                 </a:solidFill>
                 <a:latin typeface="Consolas"/>
               </a:rPr>
-              <a:t>TL00  ·  INHALT</a:t>
+              <a:t>AGENDA  ·  TL00</a:t>
             </a:r>
           </a:p>
         </p:txBody>
@@ -5924,57 +6375,14 @@
       </p:sp>
       <p:sp>
         <p:nvSpPr>
-          <p:cNvPr id="6" name="Rectangle 5"/>
-          <p:cNvSpPr/>
+          <p:cNvPr id="6" name="TextBox 5"/>
+          <p:cNvSpPr txBox="1"/>
           <p:nvPr/>
         </p:nvSpPr>
         <p:spPr>
           <a:xfrm>
             <a:off x="685800" y="502920"/>
-            <a:ext cx="36576" cy="658368"/>
-          </a:xfrm>
-          <a:prstGeom prst="rect">
-            <a:avLst/>
-          </a:prstGeom>
-          <a:solidFill>
-            <a:srgbClr val="D9C089"/>
-          </a:solidFill>
-          <a:ln>
-            <a:noFill/>
-          </a:ln>
-        </p:spPr>
-        <p:style>
-          <a:lnRef idx="1">
-            <a:schemeClr val="accent1"/>
-          </a:lnRef>
-          <a:fillRef idx="3">
-            <a:schemeClr val="accent1"/>
-          </a:fillRef>
-          <a:effectRef idx="2">
-            <a:schemeClr val="accent1"/>
-          </a:effectRef>
-          <a:fontRef idx="minor">
-            <a:schemeClr val="lt1"/>
-          </a:fontRef>
-        </p:style>
-        <p:txBody>
-          <a:bodyPr rtlCol="0" anchor="ctr"/>
-          <a:lstStyle/>
-          <a:p>
-            <a:pPr algn="ctr"/>
-          </a:p>
-        </p:txBody>
-      </p:sp>
-      <p:sp>
-        <p:nvSpPr>
-          <p:cNvPr id="7" name="TextBox 6"/>
-          <p:cNvSpPr txBox="1"/>
-          <p:nvPr/>
-        </p:nvSpPr>
-        <p:spPr>
-          <a:xfrm>
-            <a:off x="813816" y="502920"/>
-            <a:ext cx="10634472" cy="685800"/>
+            <a:ext cx="10817352" cy="658368"/>
           </a:xfrm>
           <a:prstGeom prst="rect">
             <a:avLst/>
@@ -5989,13 +6397,360 @@
           <a:p>
             <a:pPr algn="l"/>
             <a:r>
-              <a:rPr sz="2400" b="1" i="0">
+              <a:rPr sz="2600" b="1" i="0">
                 <a:solidFill>
                   <a:srgbClr val="1F2C56"/>
                 </a:solidFill>
                 <a:latin typeface="Arial"/>
               </a:rPr>
-              <a:t>Theorie-Input: Warum der Rollenwechsel oft unterschätzt wird</a:t>
+              <a:t>So läuft das Modul</a:t>
+            </a:r>
+          </a:p>
+        </p:txBody>
+      </p:sp>
+      <p:sp>
+        <p:nvSpPr>
+          <p:cNvPr id="7" name="TextBox 6"/>
+          <p:cNvSpPr txBox="1"/>
+          <p:nvPr/>
+        </p:nvSpPr>
+        <p:spPr>
+          <a:xfrm>
+            <a:off x="685800" y="1463040"/>
+            <a:ext cx="10817352" cy="4937760"/>
+          </a:xfrm>
+          <a:prstGeom prst="rect">
+            <a:avLst/>
+          </a:prstGeom>
+          <a:noFill/>
+        </p:spPr>
+        <p:txBody>
+          <a:bodyPr wrap="square">
+            <a:spAutoFit/>
+          </a:bodyPr>
+          <a:lstStyle/>
+          <a:p>
+            <a:pPr>
+              <a:spcBef>
+                <a:spcPts val="700"/>
+              </a:spcBef>
+              <a:spcAft>
+                <a:spcPts val="100"/>
+              </a:spcAft>
+            </a:pPr>
+            <a:r>
+              <a:rPr sz="1200">
+                <a:solidFill>
+                  <a:srgbClr val="78808C"/>
+                </a:solidFill>
+                <a:latin typeface="Consolas"/>
+              </a:rPr>
+              <a:t>09:00–09:15 </a:t>
+            </a:r>
+            <a:r>
+              <a:rPr sz="1500" b="1">
+                <a:solidFill>
+                  <a:srgbClr val="3D5466"/>
+                </a:solidFill>
+                <a:latin typeface="Arial"/>
+              </a:rPr>
+              <a:t>  Einstieg &amp; Ankommen</a:t>
+            </a:r>
+            <a:r>
+              <a:rPr sz="1200">
+                <a:solidFill>
+                  <a:srgbClr val="78808C"/>
+                </a:solidFill>
+                <a:latin typeface="Arial"/>
+              </a:rPr>
+              <a:t>  ·  Plenum, Flipchart</a:t>
+            </a:r>
+          </a:p>
+          <a:p>
+            <a:pPr>
+              <a:spcBef>
+                <a:spcPts val="700"/>
+              </a:spcBef>
+              <a:spcAft>
+                <a:spcPts val="100"/>
+              </a:spcAft>
+            </a:pPr>
+            <a:r>
+              <a:rPr sz="1200">
+                <a:solidFill>
+                  <a:srgbClr val="78808C"/>
+                </a:solidFill>
+                <a:latin typeface="Consolas"/>
+              </a:rPr>
+              <a:t>09:15–09:45 </a:t>
+            </a:r>
+            <a:r>
+              <a:rPr sz="1500" b="1">
+                <a:solidFill>
+                  <a:srgbClr val="3D5466"/>
+                </a:solidFill>
+                <a:latin typeface="Arial"/>
+              </a:rPr>
+              <a:t>  Rollenwechsel-Impuls</a:t>
+            </a:r>
+            <a:r>
+              <a:rPr sz="1200">
+                <a:solidFill>
+                  <a:srgbClr val="78808C"/>
+                </a:solidFill>
+                <a:latin typeface="Arial"/>
+              </a:rPr>
+              <a:t>  ·  Interaktiver Vortrag, kurze Partnerreflexion (2 Min.)</a:t>
+            </a:r>
+          </a:p>
+          <a:p>
+            <a:pPr>
+              <a:spcBef>
+                <a:spcPts val="700"/>
+              </a:spcBef>
+              <a:spcAft>
+                <a:spcPts val="100"/>
+              </a:spcAft>
+            </a:pPr>
+            <a:r>
+              <a:rPr sz="1200">
+                <a:solidFill>
+                  <a:srgbClr val="78808C"/>
+                </a:solidFill>
+                <a:latin typeface="Consolas"/>
+              </a:rPr>
+              <a:t>09:45–10:20 </a:t>
+            </a:r>
+            <a:r>
+              <a:rPr sz="1500" b="1">
+                <a:solidFill>
+                  <a:srgbClr val="3D5466"/>
+                </a:solidFill>
+                <a:latin typeface="Arial"/>
+              </a:rPr>
+              <a:t>  AB-1: Standortbestimmung</a:t>
+            </a:r>
+            <a:r>
+              <a:rPr sz="1200">
+                <a:solidFill>
+                  <a:srgbClr val="78808C"/>
+                </a:solidFill>
+                <a:latin typeface="Arial"/>
+              </a:rPr>
+              <a:t>  ·  Einzelarbeit, Paarreflexion</a:t>
+            </a:r>
+          </a:p>
+          <a:p>
+            <a:pPr>
+              <a:spcBef>
+                <a:spcPts val="700"/>
+              </a:spcBef>
+              <a:spcAft>
+                <a:spcPts val="100"/>
+              </a:spcAft>
+            </a:pPr>
+            <a:r>
+              <a:rPr sz="1200">
+                <a:solidFill>
+                  <a:srgbClr val="78808C"/>
+                </a:solidFill>
+                <a:latin typeface="Consolas"/>
+              </a:rPr>
+              <a:t>10:20–10:35 </a:t>
+            </a:r>
+            <a:r>
+              <a:rPr sz="1500" b="1">
+                <a:solidFill>
+                  <a:srgbClr val="3D5466"/>
+                </a:solidFill>
+                <a:latin typeface="Arial"/>
+              </a:rPr>
+              <a:t>  Pause</a:t>
+            </a:r>
+          </a:p>
+          <a:p>
+            <a:pPr>
+              <a:spcBef>
+                <a:spcPts val="700"/>
+              </a:spcBef>
+              <a:spcAft>
+                <a:spcPts val="100"/>
+              </a:spcAft>
+            </a:pPr>
+            <a:r>
+              <a:rPr sz="1200">
+                <a:solidFill>
+                  <a:srgbClr val="78808C"/>
+                </a:solidFill>
+                <a:latin typeface="Consolas"/>
+              </a:rPr>
+              <a:t>10:35–11:05 </a:t>
+            </a:r>
+            <a:r>
+              <a:rPr sz="1500" b="1">
+                <a:solidFill>
+                  <a:srgbClr val="3D5466"/>
+                </a:solidFill>
+                <a:latin typeface="Arial"/>
+              </a:rPr>
+              <a:t>  Praxisfall Thomas K.</a:t>
+            </a:r>
+            <a:r>
+              <a:rPr sz="1200">
+                <a:solidFill>
+                  <a:srgbClr val="78808C"/>
+                </a:solidFill>
+                <a:latin typeface="Arial"/>
+              </a:rPr>
+              <a:t>  ·  Gruppenarbeit, Plenumsauswertung</a:t>
+            </a:r>
+          </a:p>
+          <a:p>
+            <a:pPr>
+              <a:spcBef>
+                <a:spcPts val="700"/>
+              </a:spcBef>
+              <a:spcAft>
+                <a:spcPts val="100"/>
+              </a:spcAft>
+            </a:pPr>
+            <a:r>
+              <a:rPr sz="1200">
+                <a:solidFill>
+                  <a:srgbClr val="78808C"/>
+                </a:solidFill>
+                <a:latin typeface="Consolas"/>
+              </a:rPr>
+              <a:t>11:05–11:30 </a:t>
+            </a:r>
+            <a:r>
+              <a:rPr sz="1500" b="1">
+                <a:solidFill>
+                  <a:srgbClr val="3D5466"/>
+                </a:solidFill>
+                <a:latin typeface="Arial"/>
+              </a:rPr>
+              <a:t>  Kollegiale Fallberatung</a:t>
+            </a:r>
+            <a:r>
+              <a:rPr sz="1200">
+                <a:solidFill>
+                  <a:srgbClr val="78808C"/>
+                </a:solidFill>
+                <a:latin typeface="Arial"/>
+              </a:rPr>
+              <a:t>  ·  Kollegiale Fallberatung</a:t>
+            </a:r>
+          </a:p>
+          <a:p>
+            <a:pPr>
+              <a:spcBef>
+                <a:spcPts val="700"/>
+              </a:spcBef>
+              <a:spcAft>
+                <a:spcPts val="100"/>
+              </a:spcAft>
+            </a:pPr>
+            <a:r>
+              <a:rPr sz="1200">
+                <a:solidFill>
+                  <a:srgbClr val="78808C"/>
+                </a:solidFill>
+                <a:latin typeface="Consolas"/>
+              </a:rPr>
+              <a:t>11:30–12:00 </a:t>
+            </a:r>
+            <a:r>
+              <a:rPr sz="1500" b="1">
+                <a:solidFill>
+                  <a:srgbClr val="3D5466"/>
+                </a:solidFill>
+                <a:latin typeface="Arial"/>
+              </a:rPr>
+              <a:t>  AB-2: Gesprächsvorbereitung</a:t>
+            </a:r>
+            <a:r>
+              <a:rPr sz="1200">
+                <a:solidFill>
+                  <a:srgbClr val="78808C"/>
+                </a:solidFill>
+                <a:latin typeface="Arial"/>
+              </a:rPr>
+              <a:t>  ·  Einzelarbeit, optional kurzes Plenum-Echo</a:t>
+            </a:r>
+          </a:p>
+          <a:p>
+            <a:pPr>
+              <a:spcBef>
+                <a:spcPts val="700"/>
+              </a:spcBef>
+              <a:spcAft>
+                <a:spcPts val="100"/>
+              </a:spcAft>
+            </a:pPr>
+            <a:r>
+              <a:rPr sz="1200">
+                <a:solidFill>
+                  <a:srgbClr val="78808C"/>
+                </a:solidFill>
+                <a:latin typeface="Consolas"/>
+              </a:rPr>
+              <a:t>12:00–12:20 </a:t>
+            </a:r>
+            <a:r>
+              <a:rPr sz="1500" b="1">
+                <a:solidFill>
+                  <a:srgbClr val="3D5466"/>
+                </a:solidFill>
+                <a:latin typeface="Arial"/>
+              </a:rPr>
+              <a:t>  Servant-Leadership-Haltung &amp; Merk-/Haltungskarte</a:t>
+            </a:r>
+            <a:r>
+              <a:rPr sz="1200">
+                <a:solidFill>
+                  <a:srgbClr val="78808C"/>
+                </a:solidFill>
+                <a:latin typeface="Arial"/>
+              </a:rPr>
+              <a:t>  ·  Kurzimpuls, stille Reflexion</a:t>
+            </a:r>
+          </a:p>
+          <a:p>
+            <a:pPr>
+              <a:spcBef>
+                <a:spcPts val="700"/>
+              </a:spcBef>
+              <a:spcAft>
+                <a:spcPts val="100"/>
+              </a:spcAft>
+            </a:pPr>
+            <a:r>
+              <a:rPr sz="1200">
+                <a:solidFill>
+                  <a:srgbClr val="78808C"/>
+                </a:solidFill>
+                <a:latin typeface="Consolas"/>
+              </a:rPr>
+              <a:t>12:20–12:30 </a:t>
+            </a:r>
+            <a:r>
+              <a:rPr sz="1500" b="1">
+                <a:solidFill>
+                  <a:srgbClr val="3D5466"/>
+                </a:solidFill>
+                <a:latin typeface="Arial"/>
+              </a:rPr>
+              <a:t>  Transfer &amp; Abschluss</a:t>
+            </a:r>
+            <a:r>
+              <a:rPr sz="1200">
+                <a:solidFill>
+                  <a:srgbClr val="78808C"/>
+                </a:solidFill>
+                <a:latin typeface="Arial"/>
+              </a:rPr>
+              <a:t>  ·  Plenum</a:t>
             </a:r>
           </a:p>
         </p:txBody>
@@ -6333,189 +7088,14 @@
                 </a:solidFill>
                 <a:latin typeface="Arial"/>
               </a:rPr>
-              <a:t>Theorie-Input: Drei Dimensionen des Rollenwechsels</a:t>
-            </a:r>
-          </a:p>
-        </p:txBody>
-      </p:sp>
-      <p:sp>
-        <p:nvSpPr>
-          <p:cNvPr id="8" name="TextBox 7"/>
-          <p:cNvSpPr txBox="1"/>
-          <p:nvPr/>
-        </p:nvSpPr>
-        <p:spPr>
-          <a:xfrm>
-            <a:off x="685800" y="1417320"/>
-            <a:ext cx="10817352" cy="4892040"/>
-          </a:xfrm>
-          <a:prstGeom prst="rect">
-            <a:avLst/>
-          </a:prstGeom>
-          <a:noFill/>
-        </p:spPr>
-        <p:txBody>
-          <a:bodyPr wrap="square">
-            <a:spAutoFit/>
-          </a:bodyPr>
-          <a:lstStyle/>
-          <a:p>
-            <a:pPr>
-              <a:spcBef>
-                <a:spcPts val="400"/>
-              </a:spcBef>
-              <a:spcAft>
-                <a:spcPts val="200"/>
-              </a:spcAft>
-            </a:pPr>
-            <a:r>
-              <a:rPr sz="1200">
-                <a:solidFill>
-                  <a:srgbClr val="3D5466"/>
-                </a:solidFill>
-                <a:latin typeface="Arial"/>
-              </a:rPr>
-              <a:t>Der Übergang von der Beratungs- zur Führungsrolle verändert drei Dimensionen gleichzeitig. Wer nur eine davon reflektiert, bleibt halb fertig.</a:t>
-            </a:r>
-          </a:p>
-          <a:p>
-            <a:pPr>
-              <a:spcBef>
-                <a:spcPts val="1000"/>
-              </a:spcBef>
-              <a:spcAft>
-                <a:spcPts val="200"/>
-              </a:spcAft>
-            </a:pPr>
-            <a:r>
-              <a:rPr sz="800" b="1">
-                <a:solidFill>
-                  <a:srgbClr val="78808C"/>
-                </a:solidFill>
-                <a:latin typeface="Consolas"/>
-              </a:rPr>
-              <a:t>DIMENSION 2: DIE IDENTITÄT</a:t>
-            </a:r>
-          </a:p>
-          <a:p>
-            <a:pPr marL="177800" indent="-177800">
-              <a:spcBef>
-                <a:spcPts val="600"/>
-              </a:spcBef>
-              <a:spcAft>
-                <a:spcPts val="200"/>
-              </a:spcAft>
-            </a:pPr>
-            <a:r>
-              <a:rPr sz="1200" i="1">
-                <a:solidFill>
-                  <a:srgbClr val="3D5466"/>
-                </a:solidFill>
-                <a:latin typeface="Arial"/>
-              </a:rPr>
-              <a:t>→  Handlungsempfehlung</a:t>
-            </a:r>
-          </a:p>
-          <a:p>
-            <a:pPr marL="177800" indent="-177800">
-              <a:spcBef>
-                <a:spcPts val="600"/>
-              </a:spcBef>
-              <a:spcAft>
-                <a:spcPts val="200"/>
-              </a:spcAft>
-            </a:pPr>
-            <a:r>
-              <a:rPr sz="1200" i="1">
-                <a:solidFill>
-                  <a:srgbClr val="3D5466"/>
-                </a:solidFill>
-                <a:latin typeface="Arial"/>
-              </a:rPr>
-              <a:t>→  Wenn Sie merken, dass Sie bei einem Kundenproblem im Team wieder selbst zur Lösung greifen, weil Sie die Antwort kennen</a:t>
-            </a:r>
-          </a:p>
-          <a:p>
-            <a:pPr>
-              <a:spcBef>
-                <a:spcPts val="1000"/>
-              </a:spcBef>
-              <a:spcAft>
-                <a:spcPts val="200"/>
-              </a:spcAft>
-            </a:pPr>
-            <a:r>
-              <a:rPr sz="800" b="1">
-                <a:solidFill>
-                  <a:srgbClr val="78808C"/>
-                </a:solidFill>
-                <a:latin typeface="Consolas"/>
-              </a:rPr>
-              <a:t>DIMENSION 3: DIE ZEIT</a:t>
-            </a:r>
-          </a:p>
-          <a:p>
-            <a:pPr>
-              <a:spcBef>
-                <a:spcPts val="400"/>
-              </a:spcBef>
-              <a:spcAft>
-                <a:spcPts val="200"/>
-              </a:spcAft>
-            </a:pPr>
-            <a:r>
-              <a:rPr sz="1200">
-                <a:solidFill>
-                  <a:srgbClr val="3D5466"/>
-                </a:solidFill>
-                <a:latin typeface="Arial"/>
-              </a:rPr>
-              <a:t>Als Berater gehört die Zeit Ihnen und Ihren Kunden. Als Teamleiter gehört Ihre Zeit Ihrem Team. Diese Umverteilung ist keine Metapher – sie ist messbar. Typische Zeitverschiebung im ersten Jahr:</a:t>
-            </a:r>
-          </a:p>
-          <a:p>
-            <a:pPr marL="177800" indent="-177800">
-              <a:spcBef>
-                <a:spcPts val="600"/>
-              </a:spcBef>
-              <a:spcAft>
-                <a:spcPts val="200"/>
-              </a:spcAft>
-            </a:pPr>
-            <a:r>
-              <a:rPr sz="1200" i="1">
-                <a:solidFill>
-                  <a:srgbClr val="3D5466"/>
-                </a:solidFill>
-                <a:latin typeface="Arial"/>
-              </a:rPr>
-              <a:t>→  Handlungsempfehlung</a:t>
-            </a:r>
-          </a:p>
-          <a:p>
-            <a:pPr marL="177800" indent="-177800">
-              <a:spcBef>
-                <a:spcPts val="600"/>
-              </a:spcBef>
-              <a:spcAft>
-                <a:spcPts val="200"/>
-              </a:spcAft>
-            </a:pPr>
-            <a:r>
-              <a:rPr sz="1200" i="1">
-                <a:solidFill>
-                  <a:srgbClr val="3D5466"/>
-                </a:solidFill>
-                <a:latin typeface="Arial"/>
-              </a:rPr>
-              <a:t>→  Wenn die Geschäftsleitung Erwartungen an Sie als Teamleiter stellt, die Sie für Ihr Team als unrealistisch oder unfair einschätzen</a:t>
-            </a:r>
-          </a:p>
-        </p:txBody>
-      </p:sp>
-      <p:sp>
-        <p:nvSpPr>
-          <p:cNvPr id="9" name="Rectangle 8"/>
+              <a:t>Theorie-Input: Warum der Rollenwechsel oft unterschätzt wird</a:t>
+            </a:r>
+          </a:p>
+        </p:txBody>
+      </p:sp>
+      <p:sp>
+        <p:nvSpPr>
+          <p:cNvPr id="8" name="Rectangle 7"/>
           <p:cNvSpPr/>
           <p:nvPr/>
         </p:nvSpPr>
@@ -6558,7 +7138,7 @@
       </p:sp>
       <p:sp>
         <p:nvSpPr>
-          <p:cNvPr id="10" name="TextBox 9"/>
+          <p:cNvPr id="9" name="TextBox 8"/>
           <p:cNvSpPr txBox="1"/>
           <p:nvPr/>
         </p:nvSpPr>
@@ -6846,7 +7426,7 @@
                 </a:solidFill>
                 <a:latin typeface="Arial"/>
               </a:rPr>
-              <a:t>Theorie-Input: Servant Leadership als Haltungsgrundlage</a:t>
+              <a:t>Theorie-Input: Drei Dimensionen des Rollenwechsels</a:t>
             </a:r>
           </a:p>
         </p:txBody>
@@ -6868,10 +7448,48 @@
           <a:noFill/>
         </p:spPr>
         <p:txBody>
-          <a:bodyPr wrap="square" anchor="ctr">
+          <a:bodyPr wrap="square">
             <a:spAutoFit/>
           </a:bodyPr>
           <a:lstStyle/>
+          <a:p>
+            <a:pPr>
+              <a:spcBef>
+                <a:spcPts val="400"/>
+              </a:spcBef>
+              <a:spcAft>
+                <a:spcPts val="200"/>
+              </a:spcAft>
+            </a:pPr>
+            <a:r>
+              <a:rPr sz="1200">
+                <a:solidFill>
+                  <a:srgbClr val="3D5466"/>
+                </a:solidFill>
+                <a:latin typeface="Arial"/>
+              </a:rPr>
+              <a:t>Der Übergang von der Beratungs- zur Führungsrolle verändert drei Dimensionen gleichzeitig. Wer nur eine davon reflektiert, bleibt halb fertig.</a:t>
+            </a:r>
+          </a:p>
+          <a:p>
+            <a:pPr>
+              <a:spcBef>
+                <a:spcPts val="1000"/>
+              </a:spcBef>
+              <a:spcAft>
+                <a:spcPts val="200"/>
+              </a:spcAft>
+            </a:pPr>
+            <a:r>
+              <a:rPr sz="800" b="1">
+                <a:solidFill>
+                  <a:srgbClr val="78808C"/>
+                </a:solidFill>
+                <a:latin typeface="Consolas"/>
+              </a:rPr>
+              <a:t>DIMENSION 2: DIE IDENTITÄT</a:t>
+            </a:r>
+          </a:p>
           <a:p>
             <a:pPr marL="177800" indent="-177800">
               <a:spcBef>
@@ -6907,7 +7525,26 @@
                 </a:solidFill>
                 <a:latin typeface="Arial"/>
               </a:rPr>
-              <a:t>→  Wenn ein Berater eine Teamentscheidung nicht akzeptiert und darauf besteht, seinen abweichenden Weg zu gehen</a:t>
+              <a:t>→  Wenn Sie merken, dass Sie bei einem Kundenproblem im Team wieder selbst zur Lösung greifen, weil Sie die Antwort kennen</a:t>
+            </a:r>
+          </a:p>
+          <a:p>
+            <a:pPr>
+              <a:spcBef>
+                <a:spcPts val="1000"/>
+              </a:spcBef>
+              <a:spcAft>
+                <a:spcPts val="200"/>
+              </a:spcAft>
+            </a:pPr>
+            <a:r>
+              <a:rPr sz="800" b="1">
+                <a:solidFill>
+                  <a:srgbClr val="78808C"/>
+                </a:solidFill>
+                <a:latin typeface="Consolas"/>
+              </a:rPr>
+              <a:t>DIMENSION 3: DIE ZEIT</a:t>
             </a:r>
           </a:p>
           <a:p>
@@ -6926,7 +7563,45 @@
                 </a:solidFill>
                 <a:latin typeface="Arial"/>
               </a:rPr>
-              <a:t>Merksatz: Führung ist nicht das, was ich tue. Führung ist, was in meinem Team möglich wird – und was ich klar verantworte.</a:t>
+              <a:t>Als Berater gehört die Zeit Ihnen und Ihren Kunden. Als Teamleiter gehört Ihre Zeit Ihrem Team. Diese Umverteilung ist keine Metapher – sie ist messbar. Typische Zeitverschiebung im ersten Jahr:</a:t>
+            </a:r>
+          </a:p>
+          <a:p>
+            <a:pPr marL="177800" indent="-177800">
+              <a:spcBef>
+                <a:spcPts val="600"/>
+              </a:spcBef>
+              <a:spcAft>
+                <a:spcPts val="200"/>
+              </a:spcAft>
+            </a:pPr>
+            <a:r>
+              <a:rPr sz="1200" i="1">
+                <a:solidFill>
+                  <a:srgbClr val="3D5466"/>
+                </a:solidFill>
+                <a:latin typeface="Arial"/>
+              </a:rPr>
+              <a:t>→  Handlungsempfehlung</a:t>
+            </a:r>
+          </a:p>
+          <a:p>
+            <a:pPr marL="177800" indent="-177800">
+              <a:spcBef>
+                <a:spcPts val="600"/>
+              </a:spcBef>
+              <a:spcAft>
+                <a:spcPts val="200"/>
+              </a:spcAft>
+            </a:pPr>
+            <a:r>
+              <a:rPr sz="1200" i="1">
+                <a:solidFill>
+                  <a:srgbClr val="3D5466"/>
+                </a:solidFill>
+                <a:latin typeface="Arial"/>
+              </a:rPr>
+              <a:t>→  Wenn die Geschäftsleitung Erwartungen an Sie als Teamleiter stellt, die Sie für Ihr Team als unrealistisch oder unfair einschätzen</a:t>
             </a:r>
           </a:p>
         </p:txBody>
@@ -7143,7 +7818,7 @@
                 </a:solidFill>
                 <a:latin typeface="Consolas"/>
               </a:rPr>
-              <a:t>TL00  ·  ARBEITSBLATT</a:t>
+              <a:t>TL00  ·  INHALT</a:t>
             </a:r>
           </a:p>
         </p:txBody>
@@ -7264,7 +7939,7 @@
                 </a:solidFill>
                 <a:latin typeface="Arial"/>
               </a:rPr>
-              <a:t>Praxisfall: Thomas K. – vier Monate als Teamleiter</a:t>
+              <a:t>Theorie-Input: Servant Leadership als Haltungsgrundlage</a:t>
             </a:r>
           </a:p>
         </p:txBody>
@@ -7277,8 +7952,8 @@
         </p:nvSpPr>
         <p:spPr>
           <a:xfrm>
-            <a:off x="685800" y="1554480"/>
-            <a:ext cx="10817352" cy="3840480"/>
+            <a:off x="685800" y="1417320"/>
+            <a:ext cx="10817352" cy="4892040"/>
           </a:xfrm>
           <a:prstGeom prst="rect">
             <a:avLst/>
@@ -7286,12 +7961,50 @@
           <a:noFill/>
         </p:spPr>
         <p:txBody>
-          <a:bodyPr wrap="square">
+          <a:bodyPr wrap="square" anchor="ctr">
             <a:spAutoFit/>
           </a:bodyPr>
           <a:lstStyle/>
           <a:p>
-            <a:pPr marL="190500" indent="-190500">
+            <a:pPr marL="177800" indent="-177800">
+              <a:spcBef>
+                <a:spcPts val="600"/>
+              </a:spcBef>
+              <a:spcAft>
+                <a:spcPts val="200"/>
+              </a:spcAft>
+            </a:pPr>
+            <a:r>
+              <a:rPr sz="1200" i="1">
+                <a:solidFill>
+                  <a:srgbClr val="3D5466"/>
+                </a:solidFill>
+                <a:latin typeface="Arial"/>
+              </a:rPr>
+              <a:t>→  Handlungsempfehlung</a:t>
+            </a:r>
+          </a:p>
+          <a:p>
+            <a:pPr marL="177800" indent="-177800">
+              <a:spcBef>
+                <a:spcPts val="600"/>
+              </a:spcBef>
+              <a:spcAft>
+                <a:spcPts val="200"/>
+              </a:spcAft>
+            </a:pPr>
+            <a:r>
+              <a:rPr sz="1200" i="1">
+                <a:solidFill>
+                  <a:srgbClr val="3D5466"/>
+                </a:solidFill>
+                <a:latin typeface="Arial"/>
+              </a:rPr>
+              <a:t>→  Wenn ein Berater eine Teamentscheidung nicht akzeptiert und darauf besteht, seinen abweichenden Weg zu gehen</a:t>
+            </a:r>
+          </a:p>
+          <a:p>
+            <a:pPr>
               <a:spcBef>
                 <a:spcPts val="400"/>
               </a:spcBef>
@@ -7300,89 +8013,13 @@
               </a:spcAft>
             </a:pPr>
             <a:r>
-              <a:rPr sz="1400">
+              <a:rPr sz="1200">
                 <a:solidFill>
                   <a:srgbClr val="3D5466"/>
                 </a:solidFill>
                 <a:latin typeface="Arial"/>
               </a:rPr>
-              <a:t>▸  Ausgangslage (anonymisiert, branchentypisch)</a:t>
-            </a:r>
-          </a:p>
-          <a:p>
-            <a:pPr marL="190500" indent="-190500">
-              <a:spcBef>
-                <a:spcPts val="400"/>
-              </a:spcBef>
-              <a:spcAft>
-                <a:spcPts val="200"/>
-              </a:spcAft>
-            </a:pPr>
-            <a:r>
-              <a:rPr sz="1400">
-                <a:solidFill>
-                  <a:srgbClr val="3D5466"/>
-                </a:solidFill>
-                <a:latin typeface="Arial"/>
-              </a:rPr>
-              <a:t>▸  Vier Entscheidungssituationen</a:t>
-            </a:r>
-          </a:p>
-          <a:p>
-            <a:pPr marL="190500" indent="-190500">
-              <a:spcBef>
-                <a:spcPts val="400"/>
-              </a:spcBef>
-              <a:spcAft>
-                <a:spcPts val="200"/>
-              </a:spcAft>
-            </a:pPr>
-            <a:r>
-              <a:rPr sz="1400">
-                <a:solidFill>
-                  <a:srgbClr val="3D5466"/>
-                </a:solidFill>
-                <a:latin typeface="Arial"/>
-              </a:rPr>
-              <a:t>▸  Situation A – Das eigene Kreditengagement:</a:t>
-            </a:r>
-          </a:p>
-          <a:p>
-            <a:pPr marL="190500" indent="-190500">
-              <a:spcBef>
-                <a:spcPts val="400"/>
-              </a:spcBef>
-              <a:spcAft>
-                <a:spcPts val="200"/>
-              </a:spcAft>
-            </a:pPr>
-            <a:r>
-              <a:rPr sz="1400">
-                <a:solidFill>
-                  <a:srgbClr val="3D5466"/>
-                </a:solidFill>
-                <a:latin typeface="Arial"/>
-              </a:rPr>
-              <a:t>▸  Welche Entscheidung trifft Thomas – und mit welcher Begründung?</a:t>
-            </a:r>
-          </a:p>
-          <a:p>
-            <a:pPr marL="190500" indent="-190500">
-              <a:spcBef>
-                <a:spcPts val="400"/>
-              </a:spcBef>
-              <a:spcAft>
-                <a:spcPts val="200"/>
-              </a:spcAft>
-            </a:pPr>
-            <a:r>
-              <a:rPr sz="1400">
-                <a:solidFill>
-                  <a:srgbClr val="3D5466"/>
-                </a:solidFill>
-                <a:latin typeface="Arial"/>
-              </a:rPr>
-              <a:t>▸  Situation B1 – Der Kollege als Mitarbeiter (Rückzugs-Variante):</a:t>
+              <a:t>Merksatz: Führung ist nicht das, was ich tue. Führung ist, was in meinem Team möglich wird – und was ich klar verantworte.</a:t>
             </a:r>
           </a:p>
         </p:txBody>
@@ -7390,84 +8027,6 @@
       <p:sp>
         <p:nvSpPr>
           <p:cNvPr id="9" name="Rectangle 8"/>
-          <p:cNvSpPr/>
-          <p:nvPr/>
-        </p:nvSpPr>
-        <p:spPr>
-          <a:xfrm>
-            <a:off x="685800" y="5486400"/>
-            <a:ext cx="10817352" cy="640080"/>
-          </a:xfrm>
-          <a:prstGeom prst="rect">
-            <a:avLst/>
-          </a:prstGeom>
-          <a:solidFill>
-            <a:srgbClr val="1F2C56"/>
-          </a:solidFill>
-          <a:ln>
-            <a:noFill/>
-          </a:ln>
-        </p:spPr>
-        <p:style>
-          <a:lnRef idx="1">
-            <a:schemeClr val="accent1"/>
-          </a:lnRef>
-          <a:fillRef idx="3">
-            <a:schemeClr val="accent1"/>
-          </a:fillRef>
-          <a:effectRef idx="2">
-            <a:schemeClr val="accent1"/>
-          </a:effectRef>
-          <a:fontRef idx="minor">
-            <a:schemeClr val="lt1"/>
-          </a:fontRef>
-        </p:style>
-        <p:txBody>
-          <a:bodyPr rtlCol="0" anchor="ctr"/>
-          <a:lstStyle/>
-          <a:p>
-            <a:pPr algn="ctr"/>
-          </a:p>
-        </p:txBody>
-      </p:sp>
-      <p:sp>
-        <p:nvSpPr>
-          <p:cNvPr id="10" name="TextBox 9"/>
-          <p:cNvSpPr txBox="1"/>
-          <p:nvPr/>
-        </p:nvSpPr>
-        <p:spPr>
-          <a:xfrm>
-            <a:off x="868680" y="5596128"/>
-            <a:ext cx="10451592" cy="457200"/>
-          </a:xfrm>
-          <a:prstGeom prst="rect">
-            <a:avLst/>
-          </a:prstGeom>
-          <a:noFill/>
-        </p:spPr>
-        <p:txBody>
-          <a:bodyPr wrap="square">
-            <a:spAutoFit/>
-          </a:bodyPr>
-          <a:lstStyle/>
-          <a:p>
-            <a:pPr algn="l"/>
-            <a:r>
-              <a:rPr sz="1300" b="1" i="0">
-                <a:solidFill>
-                  <a:srgbClr val="FFFFFF"/>
-                </a:solidFill>
-                <a:latin typeface="Arial"/>
-              </a:rPr>
-              <a:t>→  Bearbeitung im Teilnehmer-Workbook (Arbeitsblatt mit Ausfüllfeldern)</a:t>
-            </a:r>
-          </a:p>
-        </p:txBody>
-      </p:sp>
-      <p:sp>
-        <p:nvSpPr>
-          <p:cNvPr id="11" name="Rectangle 10"/>
           <p:cNvSpPr/>
           <p:nvPr/>
         </p:nvSpPr>
@@ -7510,7 +8069,7 @@
       </p:sp>
       <p:sp>
         <p:nvSpPr>
-          <p:cNvPr id="12" name="TextBox 11"/>
+          <p:cNvPr id="10" name="TextBox 9"/>
           <p:cNvSpPr txBox="1"/>
           <p:nvPr/>
         </p:nvSpPr>
@@ -7677,7 +8236,7 @@
                 </a:solidFill>
                 <a:latin typeface="Consolas"/>
               </a:rPr>
-              <a:t>TL00  ·  INHALT</a:t>
+              <a:t>TL00  ·  ARBEITSBLATT</a:t>
             </a:r>
           </a:p>
         </p:txBody>
@@ -7798,7 +8357,7 @@
                 </a:solidFill>
                 <a:latin typeface="Arial"/>
               </a:rPr>
-              <a:t>Merk- und Haltungskarte: Der Rollenwechsel in fünf Sätzen</a:t>
+              <a:t>Praxisfall: Thomas K. – vier Monate als Teamleiter</a:t>
             </a:r>
           </a:p>
         </p:txBody>
@@ -7811,8 +8370,8 @@
         </p:nvSpPr>
         <p:spPr>
           <a:xfrm>
-            <a:off x="685800" y="1417320"/>
-            <a:ext cx="10817352" cy="4892040"/>
+            <a:off x="685800" y="1554480"/>
+            <a:ext cx="10817352" cy="3840480"/>
           </a:xfrm>
           <a:prstGeom prst="rect">
             <a:avLst/>
@@ -7825,7 +8384,7 @@
           </a:bodyPr>
           <a:lstStyle/>
           <a:p>
-            <a:pPr>
+            <a:pPr marL="190500" indent="-190500">
               <a:spcBef>
                 <a:spcPts val="400"/>
               </a:spcBef>
@@ -7834,17 +8393,17 @@
               </a:spcAft>
             </a:pPr>
             <a:r>
-              <a:rPr sz="1200">
+              <a:rPr sz="1400">
                 <a:solidFill>
                   <a:srgbClr val="3D5466"/>
                 </a:solidFill>
                 <a:latin typeface="Arial"/>
               </a:rPr>
-              <a:t>Diese Karte fasst die fünf wichtigsten Haltungsanker des Rollenwechsels zusammen. Nehmen Sie sie mit – und legen Sie sie sich in zwei Wochen wieder vor.</a:t>
-            </a:r>
-          </a:p>
-          <a:p>
-            <a:pPr>
+              <a:t>▸  Ausgangslage (anonymisiert, branchentypisch)</a:t>
+            </a:r>
+          </a:p>
+          <a:p>
+            <a:pPr marL="190500" indent="-190500">
               <a:spcBef>
                 <a:spcPts val="400"/>
               </a:spcBef>
@@ -7853,17 +8412,17 @@
               </a:spcAft>
             </a:pPr>
             <a:r>
-              <a:rPr sz="1200">
+              <a:rPr sz="1400">
                 <a:solidFill>
                   <a:srgbClr val="3D5466"/>
                 </a:solidFill>
                 <a:latin typeface="Arial"/>
               </a:rPr>
-              <a:t>1. Mein Erfolg findet jetzt im Team statt.</a:t>
-            </a:r>
-          </a:p>
-          <a:p>
-            <a:pPr>
+              <a:t>▸  Vier Entscheidungssituationen</a:t>
+            </a:r>
+          </a:p>
+          <a:p>
+            <a:pPr marL="190500" indent="-190500">
               <a:spcBef>
                 <a:spcPts val="400"/>
               </a:spcBef>
@@ -7872,17 +8431,17 @@
               </a:spcAft>
             </a:pPr>
             <a:r>
-              <a:rPr sz="1200">
+              <a:rPr sz="1400">
                 <a:solidFill>
                   <a:srgbClr val="3D5466"/>
                 </a:solidFill>
                 <a:latin typeface="Arial"/>
               </a:rPr>
-              <a:t>Was ich selbst erreiche, zählt. Was mein Team erreicht, zählt mehr. Beides addiert sich – aber nur das zweite skaliert.</a:t>
-            </a:r>
-          </a:p>
-          <a:p>
-            <a:pPr>
+              <a:t>▸  Situation A – Das eigene Kreditengagement:</a:t>
+            </a:r>
+          </a:p>
+          <a:p>
+            <a:pPr marL="190500" indent="-190500">
               <a:spcBef>
                 <a:spcPts val="400"/>
               </a:spcBef>
@@ -7891,17 +8450,17 @@
               </a:spcAft>
             </a:pPr>
             <a:r>
-              <a:rPr sz="1200">
+              <a:rPr sz="1400">
                 <a:solidFill>
                   <a:srgbClr val="3D5466"/>
                 </a:solidFill>
                 <a:latin typeface="Arial"/>
               </a:rPr>
-              <a:t>2. Autorität entsteht durch Vertrauen, nicht durch Fachkompetenz.</a:t>
-            </a:r>
-          </a:p>
-          <a:p>
-            <a:pPr>
+              <a:t>▸  Welche Entscheidung trifft Thomas – und mit welcher Begründung?</a:t>
+            </a:r>
+          </a:p>
+          <a:p>
+            <a:pPr marL="190500" indent="-190500">
               <a:spcBef>
                 <a:spcPts val="400"/>
               </a:spcBef>
@@ -7910,134 +8469,98 @@
               </a:spcAft>
             </a:pPr>
             <a:r>
-              <a:rPr sz="1200">
+              <a:rPr sz="1400">
                 <a:solidFill>
                   <a:srgbClr val="3D5466"/>
                 </a:solidFill>
                 <a:latin typeface="Arial"/>
               </a:rPr>
-              <a:t>Ich muss nicht mehr der Beste in jedem Kreditthema sein. Ich muss derjenige sein, dem das Team zutraut, es zu unterstützen, fair zu behandeln und zu vertreten.</a:t>
-            </a:r>
-          </a:p>
-          <a:p>
-            <a:pPr>
-              <a:spcBef>
-                <a:spcPts val="400"/>
-              </a:spcBef>
-              <a:spcAft>
-                <a:spcPts val="200"/>
-              </a:spcAft>
-            </a:pPr>
-            <a:r>
-              <a:rPr sz="1200">
-                <a:solidFill>
-                  <a:srgbClr val="3D5466"/>
+              <a:t>▸  Situation B1 – Der Kollege als Mitarbeiter (Rückzugs-Variante):</a:t>
+            </a:r>
+          </a:p>
+        </p:txBody>
+      </p:sp>
+      <p:sp>
+        <p:nvSpPr>
+          <p:cNvPr id="9" name="Rectangle 8"/>
+          <p:cNvSpPr/>
+          <p:nvPr/>
+        </p:nvSpPr>
+        <p:spPr>
+          <a:xfrm>
+            <a:off x="685800" y="5486400"/>
+            <a:ext cx="10817352" cy="640080"/>
+          </a:xfrm>
+          <a:prstGeom prst="rect">
+            <a:avLst/>
+          </a:prstGeom>
+          <a:solidFill>
+            <a:srgbClr val="1F2C56"/>
+          </a:solidFill>
+          <a:ln>
+            <a:noFill/>
+          </a:ln>
+        </p:spPr>
+        <p:style>
+          <a:lnRef idx="1">
+            <a:schemeClr val="accent1"/>
+          </a:lnRef>
+          <a:fillRef idx="3">
+            <a:schemeClr val="accent1"/>
+          </a:fillRef>
+          <a:effectRef idx="2">
+            <a:schemeClr val="accent1"/>
+          </a:effectRef>
+          <a:fontRef idx="minor">
+            <a:schemeClr val="lt1"/>
+          </a:fontRef>
+        </p:style>
+        <p:txBody>
+          <a:bodyPr rtlCol="0" anchor="ctr"/>
+          <a:lstStyle/>
+          <a:p>
+            <a:pPr algn="ctr"/>
+          </a:p>
+        </p:txBody>
+      </p:sp>
+      <p:sp>
+        <p:nvSpPr>
+          <p:cNvPr id="10" name="TextBox 9"/>
+          <p:cNvSpPr txBox="1"/>
+          <p:nvPr/>
+        </p:nvSpPr>
+        <p:spPr>
+          <a:xfrm>
+            <a:off x="868680" y="5596128"/>
+            <a:ext cx="10451592" cy="457200"/>
+          </a:xfrm>
+          <a:prstGeom prst="rect">
+            <a:avLst/>
+          </a:prstGeom>
+          <a:noFill/>
+        </p:spPr>
+        <p:txBody>
+          <a:bodyPr wrap="square">
+            <a:spAutoFit/>
+          </a:bodyPr>
+          <a:lstStyle/>
+          <a:p>
+            <a:pPr algn="l"/>
+            <a:r>
+              <a:rPr sz="1300" b="1" i="0">
+                <a:solidFill>
+                  <a:srgbClr val="FFFFFF"/>
                 </a:solidFill>
                 <a:latin typeface="Arial"/>
               </a:rPr>
-              <a:t>3. Führung heißt: Bedingungen schaffen, nicht Lösungen liefern.</a:t>
-            </a:r>
-          </a:p>
-          <a:p>
-            <a:pPr>
-              <a:spcBef>
-                <a:spcPts val="400"/>
-              </a:spcBef>
-              <a:spcAft>
-                <a:spcPts val="200"/>
-              </a:spcAft>
-            </a:pPr>
-            <a:r>
-              <a:rPr sz="1200">
-                <a:solidFill>
-                  <a:srgbClr val="3D5466"/>
-                </a:solidFill>
-                <a:latin typeface="Arial"/>
-              </a:rPr>
-              <a:t>Wenn jemand aus meinem Team ein Problem bringt, ist meine erste Frage: „Was haben Sie schon überlegt?" – nicht: „Ich sehe das so."</a:t>
-            </a:r>
-          </a:p>
-          <a:p>
-            <a:pPr>
-              <a:spcBef>
-                <a:spcPts val="400"/>
-              </a:spcBef>
-              <a:spcAft>
-                <a:spcPts val="200"/>
-              </a:spcAft>
-            </a:pPr>
-            <a:r>
-              <a:rPr sz="1200">
-                <a:solidFill>
-                  <a:srgbClr val="3D5466"/>
-                </a:solidFill>
-                <a:latin typeface="Arial"/>
-              </a:rPr>
-              <a:t>4. Ehemalige Kollegen sind jetzt Mitarbeitende. Das ist kein Verrat – das ist Klarheit.</a:t>
-            </a:r>
-          </a:p>
-          <a:p>
-            <a:pPr>
-              <a:spcBef>
-                <a:spcPts val="400"/>
-              </a:spcBef>
-              <a:spcAft>
-                <a:spcPts val="200"/>
-              </a:spcAft>
-            </a:pPr>
-            <a:r>
-              <a:rPr sz="1200">
-                <a:solidFill>
-                  <a:srgbClr val="3D5466"/>
-                </a:solidFill>
-                <a:latin typeface="Arial"/>
-              </a:rPr>
-              <a:t>Die neue Rollenklarheit schützt beide Seiten. Ich kann und soll partnerschaftlich führen – aber die Verantwortung liegt jetzt bei mir.</a:t>
-            </a:r>
-          </a:p>
-          <a:p>
-            <a:pPr>
-              <a:spcBef>
-                <a:spcPts val="400"/>
-              </a:spcBef>
-              <a:spcAft>
-                <a:spcPts val="200"/>
-              </a:spcAft>
-            </a:pPr>
-            <a:r>
-              <a:rPr sz="1200">
-                <a:solidFill>
-                  <a:srgbClr val="3D5466"/>
-                </a:solidFill>
-                <a:latin typeface="Arial"/>
-              </a:rPr>
-              <a:t>5. Servant Leadership bedeutet: Wachstum als Führungsmaßstab.</a:t>
-            </a:r>
-          </a:p>
-          <a:p>
-            <a:pPr>
-              <a:spcBef>
-                <a:spcPts val="400"/>
-              </a:spcBef>
-              <a:spcAft>
-                <a:spcPts val="200"/>
-              </a:spcAft>
-            </a:pPr>
-            <a:r>
-              <a:rPr sz="1200">
-                <a:solidFill>
-                  <a:srgbClr val="3D5466"/>
-                </a:solidFill>
-                <a:latin typeface="Arial"/>
-              </a:rPr>
-              <a:t>Mein Maßstab ist nicht: Wie viel habe ich heute geleistet? Sondern: Was konnte mein Team heute mehr, als es gestern konnte?</a:t>
-            </a:r>
-          </a:p>
-        </p:txBody>
-      </p:sp>
-      <p:sp>
-        <p:nvSpPr>
-          <p:cNvPr id="9" name="Rectangle 8"/>
+              <a:t>→  Bearbeitung im Teilnehmer-Workbook (Arbeitsblatt mit Ausfüllfeldern)</a:t>
+            </a:r>
+          </a:p>
+        </p:txBody>
+      </p:sp>
+      <p:sp>
+        <p:nvSpPr>
+          <p:cNvPr id="11" name="Rectangle 10"/>
           <p:cNvSpPr/>
           <p:nvPr/>
         </p:nvSpPr>
@@ -8080,7 +8603,7 @@
       </p:sp>
       <p:sp>
         <p:nvSpPr>
-          <p:cNvPr id="10" name="TextBox 9"/>
+          <p:cNvPr id="12" name="TextBox 11"/>
           <p:cNvSpPr txBox="1"/>
           <p:nvPr/>
         </p:nvSpPr>
@@ -8368,7 +8891,7 @@
                 </a:solidFill>
                 <a:latin typeface="Arial"/>
               </a:rPr>
-              <a:t>Checkliste: Bin ich in der Führungsrolle angekommen?</a:t>
+              <a:t>Merk- und Haltungskarte: Der Rollenwechsel in fünf Sätzen</a:t>
             </a:r>
           </a:p>
         </p:txBody>
@@ -8390,7 +8913,7 @@
           <a:noFill/>
         </p:spPr>
         <p:txBody>
-          <a:bodyPr wrap="square" anchor="ctr">
+          <a:bodyPr wrap="square">
             <a:spAutoFit/>
           </a:bodyPr>
           <a:lstStyle/>
@@ -8410,7 +8933,197 @@
                 </a:solidFill>
                 <a:latin typeface="Arial"/>
               </a:rPr>
-              <a:t>Beantworten Sie diese Fragen ehrlich – nach dem heutigen Workshop und erneut nach vier Wochen.</a:t>
+              <a:t>Diese Karte fasst die fünf wichtigsten Haltungsanker des Rollenwechsels zusammen. Nehmen Sie sie mit – und legen Sie sie sich in zwei Wochen wieder vor.</a:t>
+            </a:r>
+          </a:p>
+          <a:p>
+            <a:pPr>
+              <a:spcBef>
+                <a:spcPts val="400"/>
+              </a:spcBef>
+              <a:spcAft>
+                <a:spcPts val="200"/>
+              </a:spcAft>
+            </a:pPr>
+            <a:r>
+              <a:rPr sz="1200">
+                <a:solidFill>
+                  <a:srgbClr val="3D5466"/>
+                </a:solidFill>
+                <a:latin typeface="Arial"/>
+              </a:rPr>
+              <a:t>1. Mein Erfolg findet jetzt im Team statt.</a:t>
+            </a:r>
+          </a:p>
+          <a:p>
+            <a:pPr>
+              <a:spcBef>
+                <a:spcPts val="400"/>
+              </a:spcBef>
+              <a:spcAft>
+                <a:spcPts val="200"/>
+              </a:spcAft>
+            </a:pPr>
+            <a:r>
+              <a:rPr sz="1200">
+                <a:solidFill>
+                  <a:srgbClr val="3D5466"/>
+                </a:solidFill>
+                <a:latin typeface="Arial"/>
+              </a:rPr>
+              <a:t>Was ich selbst erreiche, zählt. Was mein Team erreicht, zählt mehr. Beides addiert sich – aber nur das zweite skaliert.</a:t>
+            </a:r>
+          </a:p>
+          <a:p>
+            <a:pPr>
+              <a:spcBef>
+                <a:spcPts val="400"/>
+              </a:spcBef>
+              <a:spcAft>
+                <a:spcPts val="200"/>
+              </a:spcAft>
+            </a:pPr>
+            <a:r>
+              <a:rPr sz="1200">
+                <a:solidFill>
+                  <a:srgbClr val="3D5466"/>
+                </a:solidFill>
+                <a:latin typeface="Arial"/>
+              </a:rPr>
+              <a:t>2. Autorität entsteht durch Vertrauen, nicht durch Fachkompetenz.</a:t>
+            </a:r>
+          </a:p>
+          <a:p>
+            <a:pPr>
+              <a:spcBef>
+                <a:spcPts val="400"/>
+              </a:spcBef>
+              <a:spcAft>
+                <a:spcPts val="200"/>
+              </a:spcAft>
+            </a:pPr>
+            <a:r>
+              <a:rPr sz="1200">
+                <a:solidFill>
+                  <a:srgbClr val="3D5466"/>
+                </a:solidFill>
+                <a:latin typeface="Arial"/>
+              </a:rPr>
+              <a:t>Ich muss nicht mehr der Beste in jedem Kreditthema sein. Ich muss derjenige sein, dem das Team zutraut, es zu unterstützen, fair zu behandeln und zu vertreten.</a:t>
+            </a:r>
+          </a:p>
+          <a:p>
+            <a:pPr>
+              <a:spcBef>
+                <a:spcPts val="400"/>
+              </a:spcBef>
+              <a:spcAft>
+                <a:spcPts val="200"/>
+              </a:spcAft>
+            </a:pPr>
+            <a:r>
+              <a:rPr sz="1200">
+                <a:solidFill>
+                  <a:srgbClr val="3D5466"/>
+                </a:solidFill>
+                <a:latin typeface="Arial"/>
+              </a:rPr>
+              <a:t>3. Führung heißt: Bedingungen schaffen, nicht Lösungen liefern.</a:t>
+            </a:r>
+          </a:p>
+          <a:p>
+            <a:pPr>
+              <a:spcBef>
+                <a:spcPts val="400"/>
+              </a:spcBef>
+              <a:spcAft>
+                <a:spcPts val="200"/>
+              </a:spcAft>
+            </a:pPr>
+            <a:r>
+              <a:rPr sz="1200">
+                <a:solidFill>
+                  <a:srgbClr val="3D5466"/>
+                </a:solidFill>
+                <a:latin typeface="Arial"/>
+              </a:rPr>
+              <a:t>Wenn jemand aus meinem Team ein Problem bringt, ist meine erste Frage: „Was haben Sie schon überlegt?" – nicht: „Ich sehe das so."</a:t>
+            </a:r>
+          </a:p>
+          <a:p>
+            <a:pPr>
+              <a:spcBef>
+                <a:spcPts val="400"/>
+              </a:spcBef>
+              <a:spcAft>
+                <a:spcPts val="200"/>
+              </a:spcAft>
+            </a:pPr>
+            <a:r>
+              <a:rPr sz="1200">
+                <a:solidFill>
+                  <a:srgbClr val="3D5466"/>
+                </a:solidFill>
+                <a:latin typeface="Arial"/>
+              </a:rPr>
+              <a:t>4. Ehemalige Kollegen sind jetzt Mitarbeitende. Das ist kein Verrat – das ist Klarheit.</a:t>
+            </a:r>
+          </a:p>
+          <a:p>
+            <a:pPr>
+              <a:spcBef>
+                <a:spcPts val="400"/>
+              </a:spcBef>
+              <a:spcAft>
+                <a:spcPts val="200"/>
+              </a:spcAft>
+            </a:pPr>
+            <a:r>
+              <a:rPr sz="1200">
+                <a:solidFill>
+                  <a:srgbClr val="3D5466"/>
+                </a:solidFill>
+                <a:latin typeface="Arial"/>
+              </a:rPr>
+              <a:t>Die neue Rollenklarheit schützt beide Seiten. Ich kann und soll partnerschaftlich führen – aber die Verantwortung liegt jetzt bei mir.</a:t>
+            </a:r>
+          </a:p>
+          <a:p>
+            <a:pPr>
+              <a:spcBef>
+                <a:spcPts val="400"/>
+              </a:spcBef>
+              <a:spcAft>
+                <a:spcPts val="200"/>
+              </a:spcAft>
+            </a:pPr>
+            <a:r>
+              <a:rPr sz="1200">
+                <a:solidFill>
+                  <a:srgbClr val="3D5466"/>
+                </a:solidFill>
+                <a:latin typeface="Arial"/>
+              </a:rPr>
+              <a:t>5. Servant Leadership bedeutet: Wachstum als Führungsmaßstab.</a:t>
+            </a:r>
+          </a:p>
+          <a:p>
+            <a:pPr>
+              <a:spcBef>
+                <a:spcPts val="400"/>
+              </a:spcBef>
+              <a:spcAft>
+                <a:spcPts val="200"/>
+              </a:spcAft>
+            </a:pPr>
+            <a:r>
+              <a:rPr sz="1200">
+                <a:solidFill>
+                  <a:srgbClr val="3D5466"/>
+                </a:solidFill>
+                <a:latin typeface="Arial"/>
+              </a:rPr>
+              <a:t>Mein Maßstab ist nicht: Wie viel habe ich heute geleistet? Sondern: Was konnte mein Team heute mehr, als es gestern konnte?</a:t>
             </a:r>
           </a:p>
         </p:txBody>

</xml_diff>

<commit_message>
TL00 Vollausbau deployt: content/modules (Lernziele/bloom angeglichen) + Artefakte final
Co-Authored-By: Claude Opus 4.8 <noreply@anthropic.com>
</commit_message>
<xml_diff>
--- a/protected-downloads/praesentation/TL00.pptx
+++ b/protected-downloads/praesentation/TL00.pptx
@@ -6432,23 +6432,23 @@
           <a:p>
             <a:pPr>
               <a:spcBef>
-                <a:spcPts val="700"/>
+                <a:spcPts val="400"/>
               </a:spcBef>
               <a:spcAft>
                 <a:spcPts val="100"/>
               </a:spcAft>
             </a:pPr>
             <a:r>
-              <a:rPr sz="1200">
+              <a:rPr sz="900">
                 <a:solidFill>
                   <a:srgbClr val="78808C"/>
                 </a:solidFill>
                 <a:latin typeface="Consolas"/>
               </a:rPr>
-              <a:t>09:00–09:15 </a:t>
-            </a:r>
-            <a:r>
-              <a:rPr sz="1500" b="1">
+              <a:t>09:00–09:15 (15 Min.)</a:t>
+            </a:r>
+            <a:r>
+              <a:rPr sz="1200" b="1">
                 <a:solidFill>
                   <a:srgbClr val="3D5466"/>
                 </a:solidFill>
@@ -6457,7 +6457,7 @@
               <a:t>  Einstieg &amp; Ankommen</a:t>
             </a:r>
             <a:r>
-              <a:rPr sz="1200">
+              <a:rPr sz="900">
                 <a:solidFill>
                   <a:srgbClr val="78808C"/>
                 </a:solidFill>
@@ -6469,23 +6469,23 @@
           <a:p>
             <a:pPr>
               <a:spcBef>
-                <a:spcPts val="700"/>
+                <a:spcPts val="400"/>
               </a:spcBef>
               <a:spcAft>
                 <a:spcPts val="100"/>
               </a:spcAft>
             </a:pPr>
             <a:r>
-              <a:rPr sz="1200">
+              <a:rPr sz="900">
                 <a:solidFill>
                   <a:srgbClr val="78808C"/>
                 </a:solidFill>
                 <a:latin typeface="Consolas"/>
               </a:rPr>
-              <a:t>09:15–09:45 </a:t>
-            </a:r>
-            <a:r>
-              <a:rPr sz="1500" b="1">
+              <a:t>09:15–09:45 (30 Min.)</a:t>
+            </a:r>
+            <a:r>
+              <a:rPr sz="1200" b="1">
                 <a:solidFill>
                   <a:srgbClr val="3D5466"/>
                 </a:solidFill>
@@ -6494,7 +6494,7 @@
               <a:t>  Rollenwechsel-Impuls</a:t>
             </a:r>
             <a:r>
-              <a:rPr sz="1200">
+              <a:rPr sz="900">
                 <a:solidFill>
                   <a:srgbClr val="78808C"/>
                 </a:solidFill>
@@ -6506,23 +6506,23 @@
           <a:p>
             <a:pPr>
               <a:spcBef>
-                <a:spcPts val="700"/>
+                <a:spcPts val="400"/>
               </a:spcBef>
               <a:spcAft>
                 <a:spcPts val="100"/>
               </a:spcAft>
             </a:pPr>
             <a:r>
-              <a:rPr sz="1200">
+              <a:rPr sz="900">
                 <a:solidFill>
                   <a:srgbClr val="78808C"/>
                 </a:solidFill>
                 <a:latin typeface="Consolas"/>
               </a:rPr>
-              <a:t>09:45–10:20 </a:t>
-            </a:r>
-            <a:r>
-              <a:rPr sz="1500" b="1">
+              <a:t>09:45–10:20 (35 Min.)</a:t>
+            </a:r>
+            <a:r>
+              <a:rPr sz="1200" b="1">
                 <a:solidFill>
                   <a:srgbClr val="3D5466"/>
                 </a:solidFill>
@@ -6531,226 +6531,254 @@
               <a:t>  AB-1: Standortbestimmung</a:t>
             </a:r>
             <a:r>
-              <a:rPr sz="1200">
+              <a:rPr sz="900">
                 <a:solidFill>
                   <a:srgbClr val="78808C"/>
                 </a:solidFill>
                 <a:latin typeface="Arial"/>
               </a:rPr>
-              <a:t>  ·  Einzelarbeit, Paarreflexion</a:t>
+              <a:t>  ·  Einzelarbeit, Paarreflexion, Plenum</a:t>
             </a:r>
           </a:p>
           <a:p>
             <a:pPr>
               <a:spcBef>
-                <a:spcPts val="700"/>
+                <a:spcPts val="400"/>
               </a:spcBef>
               <a:spcAft>
                 <a:spcPts val="100"/>
               </a:spcAft>
             </a:pPr>
             <a:r>
-              <a:rPr sz="1200">
+              <a:rPr sz="900">
                 <a:solidFill>
                   <a:srgbClr val="78808C"/>
                 </a:solidFill>
                 <a:latin typeface="Consolas"/>
               </a:rPr>
-              <a:t>10:20–10:35 </a:t>
-            </a:r>
-            <a:r>
-              <a:rPr sz="1500" b="1">
+              <a:t>10:20–10:35 (15 Min.)</a:t>
+            </a:r>
+            <a:r>
+              <a:rPr sz="1200" b="1">
                 <a:solidFill>
                   <a:srgbClr val="3D5466"/>
                 </a:solidFill>
                 <a:latin typeface="Arial"/>
               </a:rPr>
-              <a:t>  Pause</a:t>
+              <a:t>  Erste Pause</a:t>
             </a:r>
           </a:p>
           <a:p>
             <a:pPr>
               <a:spcBef>
-                <a:spcPts val="700"/>
+                <a:spcPts val="400"/>
               </a:spcBef>
               <a:spcAft>
                 <a:spcPts val="100"/>
               </a:spcAft>
             </a:pPr>
             <a:r>
-              <a:rPr sz="1200">
+              <a:rPr sz="900">
                 <a:solidFill>
                   <a:srgbClr val="78808C"/>
                 </a:solidFill>
                 <a:latin typeface="Consolas"/>
               </a:rPr>
-              <a:t>10:35–11:05 </a:t>
-            </a:r>
-            <a:r>
-              <a:rPr sz="1500" b="1">
+              <a:t>10:35–10:45 (10 Min.)</a:t>
+            </a:r>
+            <a:r>
+              <a:rPr sz="1200" b="1">
                 <a:solidFill>
                   <a:srgbClr val="3D5466"/>
                 </a:solidFill>
                 <a:latin typeface="Arial"/>
               </a:rPr>
-              <a:t>  Praxisfall Thomas K.</a:t>
-            </a:r>
-            <a:r>
-              <a:rPr sz="1200">
+              <a:t>  Methoden-Einführung: Kollegiale Fallberatung</a:t>
+            </a:r>
+            <a:r>
+              <a:rPr sz="900">
                 <a:solidFill>
                   <a:srgbClr val="78808C"/>
                 </a:solidFill>
                 <a:latin typeface="Arial"/>
               </a:rPr>
-              <a:t>  ·  Gruppenarbeit, Plenumsauswertung</a:t>
+              <a:t>  ·  Kurzimpuls, Flipchart</a:t>
             </a:r>
           </a:p>
           <a:p>
             <a:pPr>
               <a:spcBef>
-                <a:spcPts val="700"/>
+                <a:spcPts val="400"/>
               </a:spcBef>
               <a:spcAft>
                 <a:spcPts val="100"/>
               </a:spcAft>
             </a:pPr>
             <a:r>
-              <a:rPr sz="1200">
+              <a:rPr sz="900">
                 <a:solidFill>
                   <a:srgbClr val="78808C"/>
                 </a:solidFill>
                 <a:latin typeface="Consolas"/>
               </a:rPr>
-              <a:t>11:05–11:30 </a:t>
-            </a:r>
-            <a:r>
-              <a:rPr sz="1500" b="1">
+              <a:t>10:45–11:15 (30 Min.)</a:t>
+            </a:r>
+            <a:r>
+              <a:rPr sz="1200" b="1">
                 <a:solidFill>
                   <a:srgbClr val="3D5466"/>
                 </a:solidFill>
                 <a:latin typeface="Arial"/>
               </a:rPr>
-              <a:t>  Kollegiale Fallberatung</a:t>
-            </a:r>
-            <a:r>
-              <a:rPr sz="1200">
+              <a:t>  Praxisfall Thomas K.</a:t>
+            </a:r>
+            <a:r>
+              <a:rPr sz="900">
                 <a:solidFill>
                   <a:srgbClr val="78808C"/>
                 </a:solidFill>
                 <a:latin typeface="Arial"/>
               </a:rPr>
-              <a:t>  ·  Kollegiale Fallberatung</a:t>
+              <a:t>  ·  Gruppenarbeit, Plenumsauswertung</a:t>
             </a:r>
           </a:p>
           <a:p>
             <a:pPr>
               <a:spcBef>
-                <a:spcPts val="700"/>
+                <a:spcPts val="400"/>
               </a:spcBef>
               <a:spcAft>
                 <a:spcPts val="100"/>
               </a:spcAft>
             </a:pPr>
             <a:r>
-              <a:rPr sz="1200">
+              <a:rPr sz="900">
                 <a:solidFill>
                   <a:srgbClr val="78808C"/>
                 </a:solidFill>
                 <a:latin typeface="Consolas"/>
               </a:rPr>
-              <a:t>11:30–12:00 </a:t>
-            </a:r>
-            <a:r>
-              <a:rPr sz="1500" b="1">
+              <a:t>11:15–12:15 (40 Min. – Kernblock)</a:t>
+            </a:r>
+            <a:r>
+              <a:rPr sz="1200" b="1">
                 <a:solidFill>
                   <a:srgbClr val="3D5466"/>
                 </a:solidFill>
                 <a:latin typeface="Arial"/>
               </a:rPr>
-              <a:t>  AB-2: Gesprächsvorbereitung</a:t>
-            </a:r>
-            <a:r>
-              <a:rPr sz="1200">
+              <a:t>  Kollegiale Fallberatung</a:t>
+            </a:r>
+            <a:r>
+              <a:rPr sz="900">
                 <a:solidFill>
                   <a:srgbClr val="78808C"/>
                 </a:solidFill>
                 <a:latin typeface="Arial"/>
               </a:rPr>
-              <a:t>  ·  Einzelarbeit, optional kurzes Plenum-Echo</a:t>
+              <a:t>  ·  Kollegiale Fallberatung</a:t>
             </a:r>
           </a:p>
           <a:p>
             <a:pPr>
               <a:spcBef>
-                <a:spcPts val="700"/>
+                <a:spcPts val="400"/>
               </a:spcBef>
               <a:spcAft>
                 <a:spcPts val="100"/>
               </a:spcAft>
             </a:pPr>
             <a:r>
-              <a:rPr sz="1200">
+              <a:rPr sz="900">
                 <a:solidFill>
                   <a:srgbClr val="78808C"/>
                 </a:solidFill>
                 <a:latin typeface="Consolas"/>
               </a:rPr>
-              <a:t>12:00–12:20 </a:t>
-            </a:r>
-            <a:r>
-              <a:rPr sz="1500" b="1">
+              <a:t>12:15–12:45 (30 Min.)</a:t>
+            </a:r>
+            <a:r>
+              <a:rPr sz="1200" b="1">
                 <a:solidFill>
                   <a:srgbClr val="3D5466"/>
                 </a:solidFill>
                 <a:latin typeface="Arial"/>
               </a:rPr>
-              <a:t>  Servant-Leadership-Haltung &amp; Merk-/Haltungskarte</a:t>
-            </a:r>
-            <a:r>
-              <a:rPr sz="1200">
+              <a:t>  AB-2: Gesprächsvorbereitung</a:t>
+            </a:r>
+            <a:r>
+              <a:rPr sz="900">
                 <a:solidFill>
                   <a:srgbClr val="78808C"/>
                 </a:solidFill>
                 <a:latin typeface="Arial"/>
               </a:rPr>
-              <a:t>  ·  Kurzimpuls, stille Reflexion</a:t>
+              <a:t>  ·  Einzelarbeit, optional kurzes Plenum-Echo</a:t>
             </a:r>
           </a:p>
           <a:p>
             <a:pPr>
               <a:spcBef>
-                <a:spcPts val="700"/>
+                <a:spcPts val="400"/>
               </a:spcBef>
               <a:spcAft>
                 <a:spcPts val="100"/>
               </a:spcAft>
             </a:pPr>
             <a:r>
-              <a:rPr sz="1200">
+              <a:rPr sz="900">
                 <a:solidFill>
                   <a:srgbClr val="78808C"/>
                 </a:solidFill>
                 <a:latin typeface="Consolas"/>
               </a:rPr>
-              <a:t>12:20–12:30 </a:t>
-            </a:r>
-            <a:r>
-              <a:rPr sz="1500" b="1">
+              <a:t>12:45–13:00 (15 Min.)</a:t>
+            </a:r>
+            <a:r>
+              <a:rPr sz="1200" b="1">
                 <a:solidFill>
                   <a:srgbClr val="3D5466"/>
                 </a:solidFill>
                 <a:latin typeface="Arial"/>
               </a:rPr>
-              <a:t>  Transfer &amp; Abschluss</a:t>
-            </a:r>
-            <a:r>
-              <a:rPr sz="1200">
+              <a:t>  Haltungsabschluss &amp; Transfer</a:t>
+            </a:r>
+            <a:r>
+              <a:rPr sz="900">
                 <a:solidFill>
                   <a:srgbClr val="78808C"/>
                 </a:solidFill>
                 <a:latin typeface="Arial"/>
               </a:rPr>
               <a:t>  ·  Plenum</a:t>
+            </a:r>
+          </a:p>
+          <a:p>
+            <a:pPr>
+              <a:spcBef>
+                <a:spcPts val="400"/>
+              </a:spcBef>
+              <a:spcAft>
+                <a:spcPts val="100"/>
+              </a:spcAft>
+            </a:pPr>
+            <a:r>
+              <a:rPr sz="900">
+                <a:solidFill>
+                  <a:srgbClr val="78808C"/>
+                </a:solidFill>
+                <a:latin typeface="Consolas"/>
+              </a:rPr>
+              <a:t>(13:00)     </a:t>
+            </a:r>
+            <a:r>
+              <a:rPr sz="1200" b="1">
+                <a:solidFill>
+                  <a:srgbClr val="3D5466"/>
+                </a:solidFill>
+                <a:latin typeface="Arial"/>
+              </a:rPr>
+              <a:t>  Zweite Pause / Ende</a:t>
             </a:r>
           </a:p>
         </p:txBody>

</xml_diff>

<commit_message>
TL00: Rollenwechsel-Schaubild + GRAFIKEN_MAP, Artefakte neu
- content/modules/TL00.md: Grafik in Sec 4 gesynct
- TL00-rollenwechsel.svg + GRAFIKEN_MAP-Eintrag
- Trainerhandbuch-PDF, Teilnehmer-PDF, Praesentation-PPTX neu generiert

Co-Authored-By: Claude Opus 4.8 <noreply@anthropic.com>
</commit_message>
<xml_diff>
--- a/protected-downloads/praesentation/TL00.pptx
+++ b/protected-downloads/praesentation/TL00.pptx
@@ -16,6 +16,7 @@
     <p:sldId id="264" r:id="rId16"/>
     <p:sldId id="265" r:id="rId17"/>
     <p:sldId id="266" r:id="rId18"/>
+    <p:sldId id="267" r:id="rId19"/>
   </p:sldIdLst>
   <p:sldSz cx="12188952" cy="6858000" type="screen4x3"/>
   <p:notesSz cx="6858000" cy="9144000"/>
@@ -4850,7 +4851,7 @@
                 </a:solidFill>
                 <a:latin typeface="Arial"/>
               </a:rPr>
-              <a:t>Checkliste: Bin ich in der Führungsrolle angekommen?</a:t>
+              <a:t>Merk- und Haltungskarte: Der Rollenwechsel in fünf Sätzen</a:t>
             </a:r>
           </a:p>
         </p:txBody>
@@ -4872,7 +4873,7 @@
           <a:noFill/>
         </p:spPr>
         <p:txBody>
-          <a:bodyPr wrap="square" anchor="ctr">
+          <a:bodyPr wrap="square">
             <a:spAutoFit/>
           </a:bodyPr>
           <a:lstStyle/>
@@ -4892,7 +4893,197 @@
                 </a:solidFill>
                 <a:latin typeface="Arial"/>
               </a:rPr>
-              <a:t>Beantworten Sie diese Fragen ehrlich – nach dem heutigen Workshop und erneut nach vier Wochen.</a:t>
+              <a:t>Diese Karte fasst die fünf wichtigsten Haltungsanker des Rollenwechsels zusammen. Nehmen Sie sie mit – und legen Sie sie sich in zwei Wochen wieder vor.</a:t>
+            </a:r>
+          </a:p>
+          <a:p>
+            <a:pPr>
+              <a:spcBef>
+                <a:spcPts val="400"/>
+              </a:spcBef>
+              <a:spcAft>
+                <a:spcPts val="200"/>
+              </a:spcAft>
+            </a:pPr>
+            <a:r>
+              <a:rPr sz="1200">
+                <a:solidFill>
+                  <a:srgbClr val="3D5466"/>
+                </a:solidFill>
+                <a:latin typeface="Arial"/>
+              </a:rPr>
+              <a:t>1. Mein Erfolg findet jetzt im Team statt.</a:t>
+            </a:r>
+          </a:p>
+          <a:p>
+            <a:pPr>
+              <a:spcBef>
+                <a:spcPts val="400"/>
+              </a:spcBef>
+              <a:spcAft>
+                <a:spcPts val="200"/>
+              </a:spcAft>
+            </a:pPr>
+            <a:r>
+              <a:rPr sz="1200">
+                <a:solidFill>
+                  <a:srgbClr val="3D5466"/>
+                </a:solidFill>
+                <a:latin typeface="Arial"/>
+              </a:rPr>
+              <a:t>Was ich selbst erreiche, zählt. Was mein Team erreicht, zählt mehr. Beides addiert sich – aber nur das zweite skaliert.</a:t>
+            </a:r>
+          </a:p>
+          <a:p>
+            <a:pPr>
+              <a:spcBef>
+                <a:spcPts val="400"/>
+              </a:spcBef>
+              <a:spcAft>
+                <a:spcPts val="200"/>
+              </a:spcAft>
+            </a:pPr>
+            <a:r>
+              <a:rPr sz="1200">
+                <a:solidFill>
+                  <a:srgbClr val="3D5466"/>
+                </a:solidFill>
+                <a:latin typeface="Arial"/>
+              </a:rPr>
+              <a:t>2. Autorität entsteht durch Vertrauen, nicht durch Fachkompetenz.</a:t>
+            </a:r>
+          </a:p>
+          <a:p>
+            <a:pPr>
+              <a:spcBef>
+                <a:spcPts val="400"/>
+              </a:spcBef>
+              <a:spcAft>
+                <a:spcPts val="200"/>
+              </a:spcAft>
+            </a:pPr>
+            <a:r>
+              <a:rPr sz="1200">
+                <a:solidFill>
+                  <a:srgbClr val="3D5466"/>
+                </a:solidFill>
+                <a:latin typeface="Arial"/>
+              </a:rPr>
+              <a:t>Ich muss nicht mehr der Beste in jedem Kreditthema sein. Ich muss derjenige sein, dem das Team zutraut, es zu unterstützen, fair zu behandeln und zu vertreten.</a:t>
+            </a:r>
+          </a:p>
+          <a:p>
+            <a:pPr>
+              <a:spcBef>
+                <a:spcPts val="400"/>
+              </a:spcBef>
+              <a:spcAft>
+                <a:spcPts val="200"/>
+              </a:spcAft>
+            </a:pPr>
+            <a:r>
+              <a:rPr sz="1200">
+                <a:solidFill>
+                  <a:srgbClr val="3D5466"/>
+                </a:solidFill>
+                <a:latin typeface="Arial"/>
+              </a:rPr>
+              <a:t>3. Führung heißt: Bedingungen schaffen, nicht Lösungen liefern.</a:t>
+            </a:r>
+          </a:p>
+          <a:p>
+            <a:pPr>
+              <a:spcBef>
+                <a:spcPts val="400"/>
+              </a:spcBef>
+              <a:spcAft>
+                <a:spcPts val="200"/>
+              </a:spcAft>
+            </a:pPr>
+            <a:r>
+              <a:rPr sz="1200">
+                <a:solidFill>
+                  <a:srgbClr val="3D5466"/>
+                </a:solidFill>
+                <a:latin typeface="Arial"/>
+              </a:rPr>
+              <a:t>Wenn jemand aus meinem Team ein Problem bringt, ist meine erste Frage: „Was haben Sie schon überlegt?" – nicht: „Ich sehe das so."</a:t>
+            </a:r>
+          </a:p>
+          <a:p>
+            <a:pPr>
+              <a:spcBef>
+                <a:spcPts val="400"/>
+              </a:spcBef>
+              <a:spcAft>
+                <a:spcPts val="200"/>
+              </a:spcAft>
+            </a:pPr>
+            <a:r>
+              <a:rPr sz="1200">
+                <a:solidFill>
+                  <a:srgbClr val="3D5466"/>
+                </a:solidFill>
+                <a:latin typeface="Arial"/>
+              </a:rPr>
+              <a:t>4. Ehemalige Kollegen sind jetzt Mitarbeitende. Das ist kein Verrat – das ist Klarheit.</a:t>
+            </a:r>
+          </a:p>
+          <a:p>
+            <a:pPr>
+              <a:spcBef>
+                <a:spcPts val="400"/>
+              </a:spcBef>
+              <a:spcAft>
+                <a:spcPts val="200"/>
+              </a:spcAft>
+            </a:pPr>
+            <a:r>
+              <a:rPr sz="1200">
+                <a:solidFill>
+                  <a:srgbClr val="3D5466"/>
+                </a:solidFill>
+                <a:latin typeface="Arial"/>
+              </a:rPr>
+              <a:t>Die neue Rollenklarheit schützt beide Seiten. Ich kann und soll partnerschaftlich führen – aber die Verantwortung liegt jetzt bei mir.</a:t>
+            </a:r>
+          </a:p>
+          <a:p>
+            <a:pPr>
+              <a:spcBef>
+                <a:spcPts val="400"/>
+              </a:spcBef>
+              <a:spcAft>
+                <a:spcPts val="200"/>
+              </a:spcAft>
+            </a:pPr>
+            <a:r>
+              <a:rPr sz="1200">
+                <a:solidFill>
+                  <a:srgbClr val="3D5466"/>
+                </a:solidFill>
+                <a:latin typeface="Arial"/>
+              </a:rPr>
+              <a:t>5. Servant Leadership bedeutet: Wachstum als Führungsmaßstab.</a:t>
+            </a:r>
+          </a:p>
+          <a:p>
+            <a:pPr>
+              <a:spcBef>
+                <a:spcPts val="400"/>
+              </a:spcBef>
+              <a:spcAft>
+                <a:spcPts val="200"/>
+              </a:spcAft>
+            </a:pPr>
+            <a:r>
+              <a:rPr sz="1200">
+                <a:solidFill>
+                  <a:srgbClr val="3D5466"/>
+                </a:solidFill>
+                <a:latin typeface="Arial"/>
+              </a:rPr>
+              <a:t>Mein Maßstab ist nicht: Wie viel habe ich heute geleistet? Sondern: Was konnte mein Team heute mehr, als es gestern konnte?</a:t>
             </a:r>
           </a:p>
         </p:txBody>
@@ -5230,6 +5421,386 @@
                 </a:solidFill>
                 <a:latin typeface="Arial"/>
               </a:rPr>
+              <a:t>Checkliste: Bin ich in der Führungsrolle angekommen?</a:t>
+            </a:r>
+          </a:p>
+        </p:txBody>
+      </p:sp>
+      <p:sp>
+        <p:nvSpPr>
+          <p:cNvPr id="8" name="TextBox 7"/>
+          <p:cNvSpPr txBox="1"/>
+          <p:nvPr/>
+        </p:nvSpPr>
+        <p:spPr>
+          <a:xfrm>
+            <a:off x="685800" y="1417320"/>
+            <a:ext cx="10817352" cy="4892040"/>
+          </a:xfrm>
+          <a:prstGeom prst="rect">
+            <a:avLst/>
+          </a:prstGeom>
+          <a:noFill/>
+        </p:spPr>
+        <p:txBody>
+          <a:bodyPr wrap="square" anchor="ctr">
+            <a:spAutoFit/>
+          </a:bodyPr>
+          <a:lstStyle/>
+          <a:p>
+            <a:pPr>
+              <a:spcBef>
+                <a:spcPts val="400"/>
+              </a:spcBef>
+              <a:spcAft>
+                <a:spcPts val="200"/>
+              </a:spcAft>
+            </a:pPr>
+            <a:r>
+              <a:rPr sz="1200">
+                <a:solidFill>
+                  <a:srgbClr val="3D5466"/>
+                </a:solidFill>
+                <a:latin typeface="Arial"/>
+              </a:rPr>
+              <a:t>Beantworten Sie diese Fragen ehrlich – nach dem heutigen Workshop und erneut nach vier Wochen.</a:t>
+            </a:r>
+          </a:p>
+        </p:txBody>
+      </p:sp>
+      <p:sp>
+        <p:nvSpPr>
+          <p:cNvPr id="9" name="Rectangle 8"/>
+          <p:cNvSpPr/>
+          <p:nvPr/>
+        </p:nvSpPr>
+        <p:spPr>
+          <a:xfrm>
+            <a:off x="0" y="6510528"/>
+            <a:ext cx="12188952" cy="347472"/>
+          </a:xfrm>
+          <a:prstGeom prst="rect">
+            <a:avLst/>
+          </a:prstGeom>
+          <a:solidFill>
+            <a:srgbClr val="0A1937"/>
+          </a:solidFill>
+          <a:ln>
+            <a:noFill/>
+          </a:ln>
+        </p:spPr>
+        <p:style>
+          <a:lnRef idx="1">
+            <a:schemeClr val="accent1"/>
+          </a:lnRef>
+          <a:fillRef idx="3">
+            <a:schemeClr val="accent1"/>
+          </a:fillRef>
+          <a:effectRef idx="2">
+            <a:schemeClr val="accent1"/>
+          </a:effectRef>
+          <a:fontRef idx="minor">
+            <a:schemeClr val="lt1"/>
+          </a:fontRef>
+        </p:style>
+        <p:txBody>
+          <a:bodyPr rtlCol="0" anchor="ctr"/>
+          <a:lstStyle/>
+          <a:p>
+            <a:pPr algn="ctr"/>
+          </a:p>
+        </p:txBody>
+      </p:sp>
+      <p:sp>
+        <p:nvSpPr>
+          <p:cNvPr id="10" name="TextBox 9"/>
+          <p:cNvSpPr txBox="1"/>
+          <p:nvPr/>
+        </p:nvSpPr>
+        <p:spPr>
+          <a:xfrm>
+            <a:off x="685800" y="6583680"/>
+            <a:ext cx="6490411" cy="256032"/>
+          </a:xfrm>
+          <a:prstGeom prst="rect">
+            <a:avLst/>
+          </a:prstGeom>
+          <a:noFill/>
+        </p:spPr>
+        <p:txBody>
+          <a:bodyPr wrap="none">
+            <a:spAutoFit/>
+          </a:bodyPr>
+          <a:lstStyle/>
+          <a:p>
+            <a:pPr algn="l"/>
+            <a:r>
+              <a:rPr sz="700">
+                <a:solidFill>
+                  <a:srgbClr val="A0B4D2"/>
+                </a:solidFill>
+                <a:latin typeface="Consolas"/>
+              </a:rPr>
+              <a:t>FKB Campus  ·  TL00</a:t>
+            </a:r>
+          </a:p>
+        </p:txBody>
+      </p:sp>
+    </p:spTree>
+  </p:cSld>
+  <p:clrMapOvr>
+    <a:masterClrMapping/>
+  </p:clrMapOvr>
+</p:sld>
+</file>
+
+<file path=ppt/slides/slide12.xml><?xml version="1.0" encoding="utf-8"?>
+<p:sld xmlns:a="http://schemas.openxmlformats.org/drawingml/2006/main" xmlns:p="http://schemas.openxmlformats.org/presentationml/2006/main" xmlns:r="http://schemas.openxmlformats.org/officeDocument/2006/relationships">
+  <p:cSld>
+    <p:spTree>
+      <p:nvGrpSpPr>
+        <p:cNvPr id="1" name=""/>
+        <p:cNvGrpSpPr/>
+        <p:nvPr/>
+      </p:nvGrpSpPr>
+      <p:grpSpPr/>
+      <p:sp>
+        <p:nvSpPr>
+          <p:cNvPr id="2" name="Rectangle 1"/>
+          <p:cNvSpPr/>
+          <p:nvPr/>
+        </p:nvSpPr>
+        <p:spPr>
+          <a:xfrm>
+            <a:off x="0" y="0"/>
+            <a:ext cx="12188952" cy="6858000"/>
+          </a:xfrm>
+          <a:prstGeom prst="rect">
+            <a:avLst/>
+          </a:prstGeom>
+          <a:solidFill>
+            <a:srgbClr val="EDEDF3"/>
+          </a:solidFill>
+          <a:ln>
+            <a:noFill/>
+          </a:ln>
+        </p:spPr>
+        <p:style>
+          <a:lnRef idx="1">
+            <a:schemeClr val="accent1"/>
+          </a:lnRef>
+          <a:fillRef idx="3">
+            <a:schemeClr val="accent1"/>
+          </a:fillRef>
+          <a:effectRef idx="2">
+            <a:schemeClr val="accent1"/>
+          </a:effectRef>
+          <a:fontRef idx="minor">
+            <a:schemeClr val="lt1"/>
+          </a:fontRef>
+        </p:style>
+        <p:txBody>
+          <a:bodyPr rtlCol="0" anchor="ctr"/>
+          <a:lstStyle/>
+          <a:p>
+            <a:pPr algn="ctr"/>
+          </a:p>
+        </p:txBody>
+      </p:sp>
+      <p:sp>
+        <p:nvSpPr>
+          <p:cNvPr id="3" name="Rectangle 2"/>
+          <p:cNvSpPr/>
+          <p:nvPr/>
+        </p:nvSpPr>
+        <p:spPr>
+          <a:xfrm>
+            <a:off x="0" y="0"/>
+            <a:ext cx="12188952" cy="50292"/>
+          </a:xfrm>
+          <a:prstGeom prst="rect">
+            <a:avLst/>
+          </a:prstGeom>
+          <a:solidFill>
+            <a:srgbClr val="1F2C56"/>
+          </a:solidFill>
+          <a:ln>
+            <a:noFill/>
+          </a:ln>
+        </p:spPr>
+        <p:style>
+          <a:lnRef idx="1">
+            <a:schemeClr val="accent1"/>
+          </a:lnRef>
+          <a:fillRef idx="3">
+            <a:schemeClr val="accent1"/>
+          </a:fillRef>
+          <a:effectRef idx="2">
+            <a:schemeClr val="accent1"/>
+          </a:effectRef>
+          <a:fontRef idx="minor">
+            <a:schemeClr val="lt1"/>
+          </a:fontRef>
+        </p:style>
+        <p:txBody>
+          <a:bodyPr rtlCol="0" anchor="ctr"/>
+          <a:lstStyle/>
+          <a:p>
+            <a:pPr algn="ctr"/>
+          </a:p>
+        </p:txBody>
+      </p:sp>
+      <p:sp>
+        <p:nvSpPr>
+          <p:cNvPr id="4" name="TextBox 3"/>
+          <p:cNvSpPr txBox="1"/>
+          <p:nvPr/>
+        </p:nvSpPr>
+        <p:spPr>
+          <a:xfrm>
+            <a:off x="685800" y="109728"/>
+            <a:ext cx="10817352" cy="228600"/>
+          </a:xfrm>
+          <a:prstGeom prst="rect">
+            <a:avLst/>
+          </a:prstGeom>
+          <a:noFill/>
+        </p:spPr>
+        <p:txBody>
+          <a:bodyPr wrap="none">
+            <a:spAutoFit/>
+          </a:bodyPr>
+          <a:lstStyle/>
+          <a:p>
+            <a:pPr algn="l"/>
+            <a:r>
+              <a:rPr sz="750">
+                <a:solidFill>
+                  <a:srgbClr val="78808C"/>
+                </a:solidFill>
+                <a:latin typeface="Consolas"/>
+              </a:rPr>
+              <a:t>TL00  ·  INHALT</a:t>
+            </a:r>
+          </a:p>
+        </p:txBody>
+      </p:sp>
+      <p:sp>
+        <p:nvSpPr>
+          <p:cNvPr id="5" name="Rectangle 4"/>
+          <p:cNvSpPr/>
+          <p:nvPr/>
+        </p:nvSpPr>
+        <p:spPr>
+          <a:xfrm>
+            <a:off x="0" y="1234440"/>
+            <a:ext cx="12188952" cy="12700"/>
+          </a:xfrm>
+          <a:prstGeom prst="rect">
+            <a:avLst/>
+          </a:prstGeom>
+          <a:solidFill>
+            <a:srgbClr val="D8DFE4"/>
+          </a:solidFill>
+          <a:ln>
+            <a:noFill/>
+          </a:ln>
+        </p:spPr>
+        <p:style>
+          <a:lnRef idx="1">
+            <a:schemeClr val="accent1"/>
+          </a:lnRef>
+          <a:fillRef idx="3">
+            <a:schemeClr val="accent1"/>
+          </a:fillRef>
+          <a:effectRef idx="2">
+            <a:schemeClr val="accent1"/>
+          </a:effectRef>
+          <a:fontRef idx="minor">
+            <a:schemeClr val="lt1"/>
+          </a:fontRef>
+        </p:style>
+        <p:txBody>
+          <a:bodyPr rtlCol="0" anchor="ctr"/>
+          <a:lstStyle/>
+          <a:p>
+            <a:pPr algn="ctr"/>
+          </a:p>
+        </p:txBody>
+      </p:sp>
+      <p:sp>
+        <p:nvSpPr>
+          <p:cNvPr id="6" name="Rectangle 5"/>
+          <p:cNvSpPr/>
+          <p:nvPr/>
+        </p:nvSpPr>
+        <p:spPr>
+          <a:xfrm>
+            <a:off x="685800" y="502920"/>
+            <a:ext cx="36576" cy="658368"/>
+          </a:xfrm>
+          <a:prstGeom prst="rect">
+            <a:avLst/>
+          </a:prstGeom>
+          <a:solidFill>
+            <a:srgbClr val="D9C089"/>
+          </a:solidFill>
+          <a:ln>
+            <a:noFill/>
+          </a:ln>
+        </p:spPr>
+        <p:style>
+          <a:lnRef idx="1">
+            <a:schemeClr val="accent1"/>
+          </a:lnRef>
+          <a:fillRef idx="3">
+            <a:schemeClr val="accent1"/>
+          </a:fillRef>
+          <a:effectRef idx="2">
+            <a:schemeClr val="accent1"/>
+          </a:effectRef>
+          <a:fontRef idx="minor">
+            <a:schemeClr val="lt1"/>
+          </a:fontRef>
+        </p:style>
+        <p:txBody>
+          <a:bodyPr rtlCol="0" anchor="ctr"/>
+          <a:lstStyle/>
+          <a:p>
+            <a:pPr algn="ctr"/>
+          </a:p>
+        </p:txBody>
+      </p:sp>
+      <p:sp>
+        <p:nvSpPr>
+          <p:cNvPr id="7" name="TextBox 6"/>
+          <p:cNvSpPr txBox="1"/>
+          <p:nvPr/>
+        </p:nvSpPr>
+        <p:spPr>
+          <a:xfrm>
+            <a:off x="813816" y="502920"/>
+            <a:ext cx="10634472" cy="685800"/>
+          </a:xfrm>
+          <a:prstGeom prst="rect">
+            <a:avLst/>
+          </a:prstGeom>
+          <a:noFill/>
+        </p:spPr>
+        <p:txBody>
+          <a:bodyPr wrap="square">
+            <a:spAutoFit/>
+          </a:bodyPr>
+          <a:lstStyle/>
+          <a:p>
+            <a:pPr algn="l"/>
+            <a:r>
+              <a:rPr sz="2400" b="1" i="0">
+                <a:solidFill>
+                  <a:srgbClr val="1F2C56"/>
+                </a:solidFill>
+                <a:latin typeface="Arial"/>
+              </a:rPr>
               <a:t>Reflexionsfragen</a:t>
             </a:r>
           </a:p>
@@ -7745,7 +8316,7 @@
             <a:avLst/>
           </a:prstGeom>
           <a:solidFill>
-            <a:srgbClr val="EDEDF3"/>
+            <a:srgbClr val="FFFFFF"/>
           </a:solidFill>
           <a:ln>
             <a:noFill/>
@@ -7846,51 +8417,43 @@
                 </a:solidFill>
                 <a:latin typeface="Consolas"/>
               </a:rPr>
-              <a:t>TL00  ·  INHALT</a:t>
-            </a:r>
-          </a:p>
-        </p:txBody>
-      </p:sp>
-      <p:sp>
-        <p:nvSpPr>
-          <p:cNvPr id="5" name="Rectangle 4"/>
-          <p:cNvSpPr/>
-          <p:nvPr/>
-        </p:nvSpPr>
-        <p:spPr>
-          <a:xfrm>
-            <a:off x="0" y="1234440"/>
-            <a:ext cx="12188952" cy="12700"/>
-          </a:xfrm>
-          <a:prstGeom prst="rect">
-            <a:avLst/>
-          </a:prstGeom>
-          <a:solidFill>
-            <a:srgbClr val="D8DFE4"/>
-          </a:solidFill>
-          <a:ln>
-            <a:noFill/>
-          </a:ln>
-        </p:spPr>
-        <p:style>
-          <a:lnRef idx="1">
-            <a:schemeClr val="accent1"/>
-          </a:lnRef>
-          <a:fillRef idx="3">
-            <a:schemeClr val="accent1"/>
-          </a:fillRef>
-          <a:effectRef idx="2">
-            <a:schemeClr val="accent1"/>
-          </a:effectRef>
-          <a:fontRef idx="minor">
-            <a:schemeClr val="lt1"/>
-          </a:fontRef>
-        </p:style>
-        <p:txBody>
-          <a:bodyPr rtlCol="0" anchor="ctr"/>
-          <a:lstStyle/>
-          <a:p>
-            <a:pPr algn="ctr"/>
+              <a:t>TL00  ·  SCHAUBILD</a:t>
+            </a:r>
+          </a:p>
+        </p:txBody>
+      </p:sp>
+      <p:sp>
+        <p:nvSpPr>
+          <p:cNvPr id="5" name="TextBox 4"/>
+          <p:cNvSpPr txBox="1"/>
+          <p:nvPr/>
+        </p:nvSpPr>
+        <p:spPr>
+          <a:xfrm>
+            <a:off x="685800" y="502920"/>
+            <a:ext cx="10817352" cy="594360"/>
+          </a:xfrm>
+          <a:prstGeom prst="rect">
+            <a:avLst/>
+          </a:prstGeom>
+          <a:noFill/>
+        </p:spPr>
+        <p:txBody>
+          <a:bodyPr wrap="square">
+            <a:spAutoFit/>
+          </a:bodyPr>
+          <a:lstStyle/>
+          <a:p>
+            <a:pPr algn="l"/>
+            <a:r>
+              <a:rPr sz="2000" b="1" i="0">
+                <a:solidFill>
+                  <a:srgbClr val="1F2C56"/>
+                </a:solidFill>
+                <a:latin typeface="Arial"/>
+              </a:rPr>
+              <a:t>Drei Dimensionen des Rollenwechsels: Für die Dimensionen Erfolgslogik, Identität und Zeit zeigt die Grafik jeweils die Verschiebung von der Beratungsrolle zur Führungsrolle</a:t>
+            </a:r>
           </a:p>
         </p:txBody>
       </p:sp>
@@ -7902,8 +8465,8 @@
         </p:nvSpPr>
         <p:spPr>
           <a:xfrm>
-            <a:off x="685800" y="502920"/>
-            <a:ext cx="36576" cy="658368"/>
+            <a:off x="685800" y="1143000"/>
+            <a:ext cx="10817352" cy="25400"/>
           </a:xfrm>
           <a:prstGeom prst="rect">
             <a:avLst/>
@@ -7937,124 +8500,33 @@
           </a:p>
         </p:txBody>
       </p:sp>
-      <p:sp>
-        <p:nvSpPr>
-          <p:cNvPr id="7" name="TextBox 6"/>
-          <p:cNvSpPr txBox="1"/>
-          <p:nvPr/>
-        </p:nvSpPr>
-        <p:spPr>
-          <a:xfrm>
-            <a:off x="813816" y="502920"/>
-            <a:ext cx="10634472" cy="685800"/>
-          </a:xfrm>
-          <a:prstGeom prst="rect">
-            <a:avLst/>
-          </a:prstGeom>
-          <a:noFill/>
-        </p:spPr>
-        <p:txBody>
-          <a:bodyPr wrap="square">
-            <a:spAutoFit/>
-          </a:bodyPr>
-          <a:lstStyle/>
-          <a:p>
-            <a:pPr algn="l"/>
-            <a:r>
-              <a:rPr sz="2400" b="1" i="0">
-                <a:solidFill>
-                  <a:srgbClr val="1F2C56"/>
-                </a:solidFill>
-                <a:latin typeface="Arial"/>
-              </a:rPr>
-              <a:t>Theorie-Input: Servant Leadership als Haltungsgrundlage</a:t>
-            </a:r>
-          </a:p>
-        </p:txBody>
-      </p:sp>
-      <p:sp>
-        <p:nvSpPr>
-          <p:cNvPr id="8" name="TextBox 7"/>
-          <p:cNvSpPr txBox="1"/>
-          <p:nvPr/>
-        </p:nvSpPr>
-        <p:spPr>
-          <a:xfrm>
-            <a:off x="685800" y="1417320"/>
-            <a:ext cx="10817352" cy="4892040"/>
-          </a:xfrm>
-          <a:prstGeom prst="rect">
-            <a:avLst/>
-          </a:prstGeom>
-          <a:noFill/>
-        </p:spPr>
-        <p:txBody>
-          <a:bodyPr wrap="square" anchor="ctr">
-            <a:spAutoFit/>
-          </a:bodyPr>
-          <a:lstStyle/>
-          <a:p>
-            <a:pPr marL="177800" indent="-177800">
-              <a:spcBef>
-                <a:spcPts val="600"/>
-              </a:spcBef>
-              <a:spcAft>
-                <a:spcPts val="200"/>
-              </a:spcAft>
-            </a:pPr>
-            <a:r>
-              <a:rPr sz="1200" i="1">
-                <a:solidFill>
-                  <a:srgbClr val="3D5466"/>
-                </a:solidFill>
-                <a:latin typeface="Arial"/>
-              </a:rPr>
-              <a:t>→  Handlungsempfehlung</a:t>
-            </a:r>
-          </a:p>
-          <a:p>
-            <a:pPr marL="177800" indent="-177800">
-              <a:spcBef>
-                <a:spcPts val="600"/>
-              </a:spcBef>
-              <a:spcAft>
-                <a:spcPts val="200"/>
-              </a:spcAft>
-            </a:pPr>
-            <a:r>
-              <a:rPr sz="1200" i="1">
-                <a:solidFill>
-                  <a:srgbClr val="3D5466"/>
-                </a:solidFill>
-                <a:latin typeface="Arial"/>
-              </a:rPr>
-              <a:t>→  Wenn ein Berater eine Teamentscheidung nicht akzeptiert und darauf besteht, seinen abweichenden Weg zu gehen</a:t>
-            </a:r>
-          </a:p>
-          <a:p>
-            <a:pPr>
-              <a:spcBef>
-                <a:spcPts val="400"/>
-              </a:spcBef>
-              <a:spcAft>
-                <a:spcPts val="200"/>
-              </a:spcAft>
-            </a:pPr>
-            <a:r>
-              <a:rPr sz="1200">
-                <a:solidFill>
-                  <a:srgbClr val="3D5466"/>
-                </a:solidFill>
-                <a:latin typeface="Arial"/>
-              </a:rPr>
-              <a:t>Merksatz: Führung ist nicht das, was ich tue. Führung ist, was in meinem Team möglich wird – und was ich klar verantworte.</a:t>
-            </a:r>
-          </a:p>
-        </p:txBody>
-      </p:sp>
-      <p:sp>
-        <p:nvSpPr>
-          <p:cNvPr id="9" name="Rectangle 8"/>
+      <p:pic>
+        <p:nvPicPr>
+          <p:cNvPr id="7" name="Picture 6" descr="image.png"/>
+          <p:cNvPicPr>
+            <a:picLocks noChangeAspect="1"/>
+          </p:cNvPicPr>
+          <p:nvPr/>
+        </p:nvPicPr>
+        <p:blipFill>
+          <a:blip r:embed="rId2"/>
+          <a:stretch>
+            <a:fillRect/>
+          </a:stretch>
+        </p:blipFill>
+        <p:spPr>
+          <a:xfrm>
+            <a:off x="2509895" y="1325880"/>
+            <a:ext cx="7169161" cy="4937760"/>
+          </a:xfrm>
+          <a:prstGeom prst="rect">
+            <a:avLst/>
+          </a:prstGeom>
+        </p:spPr>
+      </p:pic>
+      <p:sp>
+        <p:nvSpPr>
+          <p:cNvPr id="8" name="Rectangle 7"/>
           <p:cNvSpPr/>
           <p:nvPr/>
         </p:nvSpPr>
@@ -8097,7 +8569,7 @@
       </p:sp>
       <p:sp>
         <p:nvSpPr>
-          <p:cNvPr id="10" name="TextBox 9"/>
+          <p:cNvPr id="9" name="TextBox 8"/>
           <p:cNvSpPr txBox="1"/>
           <p:nvPr/>
         </p:nvSpPr>
@@ -8126,6 +8598,41 @@
                 <a:latin typeface="Consolas"/>
               </a:rPr>
               <a:t>FKB Campus  ·  TL00</a:t>
+            </a:r>
+          </a:p>
+        </p:txBody>
+      </p:sp>
+      <p:sp>
+        <p:nvSpPr>
+          <p:cNvPr id="10" name="TextBox 9"/>
+          <p:cNvSpPr txBox="1"/>
+          <p:nvPr/>
+        </p:nvSpPr>
+        <p:spPr>
+          <a:xfrm>
+            <a:off x="7176211" y="6583680"/>
+            <a:ext cx="4326940" cy="256032"/>
+          </a:xfrm>
+          <a:prstGeom prst="rect">
+            <a:avLst/>
+          </a:prstGeom>
+          <a:noFill/>
+        </p:spPr>
+        <p:txBody>
+          <a:bodyPr wrap="none">
+            <a:spAutoFit/>
+          </a:bodyPr>
+          <a:lstStyle/>
+          <a:p>
+            <a:pPr algn="r"/>
+            <a:r>
+              <a:rPr sz="700">
+                <a:solidFill>
+                  <a:srgbClr val="A0B4D2"/>
+                </a:solidFill>
+                <a:latin typeface="Consolas"/>
+              </a:rPr>
+              <a:t>Schaubild</a:t>
             </a:r>
           </a:p>
         </p:txBody>
@@ -8264,7 +8771,7 @@
                 </a:solidFill>
                 <a:latin typeface="Consolas"/>
               </a:rPr>
-              <a:t>TL00  ·  ARBEITSBLATT</a:t>
+              <a:t>TL00  ·  INHALT</a:t>
             </a:r>
           </a:p>
         </p:txBody>
@@ -8385,7 +8892,7 @@
                 </a:solidFill>
                 <a:latin typeface="Arial"/>
               </a:rPr>
-              <a:t>Praxisfall: Thomas K. – vier Monate als Teamleiter</a:t>
+              <a:t>Theorie-Input: Servant Leadership als Haltungsgrundlage</a:t>
             </a:r>
           </a:p>
         </p:txBody>
@@ -8398,8 +8905,8 @@
         </p:nvSpPr>
         <p:spPr>
           <a:xfrm>
-            <a:off x="685800" y="1554480"/>
-            <a:ext cx="10817352" cy="3840480"/>
+            <a:off x="685800" y="1417320"/>
+            <a:ext cx="10817352" cy="4892040"/>
           </a:xfrm>
           <a:prstGeom prst="rect">
             <a:avLst/>
@@ -8407,12 +8914,50 @@
           <a:noFill/>
         </p:spPr>
         <p:txBody>
-          <a:bodyPr wrap="square">
+          <a:bodyPr wrap="square" anchor="ctr">
             <a:spAutoFit/>
           </a:bodyPr>
           <a:lstStyle/>
           <a:p>
-            <a:pPr marL="190500" indent="-190500">
+            <a:pPr marL="177800" indent="-177800">
+              <a:spcBef>
+                <a:spcPts val="600"/>
+              </a:spcBef>
+              <a:spcAft>
+                <a:spcPts val="200"/>
+              </a:spcAft>
+            </a:pPr>
+            <a:r>
+              <a:rPr sz="1200" i="1">
+                <a:solidFill>
+                  <a:srgbClr val="3D5466"/>
+                </a:solidFill>
+                <a:latin typeface="Arial"/>
+              </a:rPr>
+              <a:t>→  Handlungsempfehlung</a:t>
+            </a:r>
+          </a:p>
+          <a:p>
+            <a:pPr marL="177800" indent="-177800">
+              <a:spcBef>
+                <a:spcPts val="600"/>
+              </a:spcBef>
+              <a:spcAft>
+                <a:spcPts val="200"/>
+              </a:spcAft>
+            </a:pPr>
+            <a:r>
+              <a:rPr sz="1200" i="1">
+                <a:solidFill>
+                  <a:srgbClr val="3D5466"/>
+                </a:solidFill>
+                <a:latin typeface="Arial"/>
+              </a:rPr>
+              <a:t>→  Wenn ein Berater eine Teamentscheidung nicht akzeptiert und darauf besteht, seinen abweichenden Weg zu gehen</a:t>
+            </a:r>
+          </a:p>
+          <a:p>
+            <a:pPr>
               <a:spcBef>
                 <a:spcPts val="400"/>
               </a:spcBef>
@@ -8421,89 +8966,13 @@
               </a:spcAft>
             </a:pPr>
             <a:r>
-              <a:rPr sz="1400">
+              <a:rPr sz="1200">
                 <a:solidFill>
                   <a:srgbClr val="3D5466"/>
                 </a:solidFill>
                 <a:latin typeface="Arial"/>
               </a:rPr>
-              <a:t>▸  Ausgangslage (anonymisiert, branchentypisch)</a:t>
-            </a:r>
-          </a:p>
-          <a:p>
-            <a:pPr marL="190500" indent="-190500">
-              <a:spcBef>
-                <a:spcPts val="400"/>
-              </a:spcBef>
-              <a:spcAft>
-                <a:spcPts val="200"/>
-              </a:spcAft>
-            </a:pPr>
-            <a:r>
-              <a:rPr sz="1400">
-                <a:solidFill>
-                  <a:srgbClr val="3D5466"/>
-                </a:solidFill>
-                <a:latin typeface="Arial"/>
-              </a:rPr>
-              <a:t>▸  Vier Entscheidungssituationen</a:t>
-            </a:r>
-          </a:p>
-          <a:p>
-            <a:pPr marL="190500" indent="-190500">
-              <a:spcBef>
-                <a:spcPts val="400"/>
-              </a:spcBef>
-              <a:spcAft>
-                <a:spcPts val="200"/>
-              </a:spcAft>
-            </a:pPr>
-            <a:r>
-              <a:rPr sz="1400">
-                <a:solidFill>
-                  <a:srgbClr val="3D5466"/>
-                </a:solidFill>
-                <a:latin typeface="Arial"/>
-              </a:rPr>
-              <a:t>▸  Situation A – Das eigene Kreditengagement:</a:t>
-            </a:r>
-          </a:p>
-          <a:p>
-            <a:pPr marL="190500" indent="-190500">
-              <a:spcBef>
-                <a:spcPts val="400"/>
-              </a:spcBef>
-              <a:spcAft>
-                <a:spcPts val="200"/>
-              </a:spcAft>
-            </a:pPr>
-            <a:r>
-              <a:rPr sz="1400">
-                <a:solidFill>
-                  <a:srgbClr val="3D5466"/>
-                </a:solidFill>
-                <a:latin typeface="Arial"/>
-              </a:rPr>
-              <a:t>▸  Welche Entscheidung trifft Thomas – und mit welcher Begründung?</a:t>
-            </a:r>
-          </a:p>
-          <a:p>
-            <a:pPr marL="190500" indent="-190500">
-              <a:spcBef>
-                <a:spcPts val="400"/>
-              </a:spcBef>
-              <a:spcAft>
-                <a:spcPts val="200"/>
-              </a:spcAft>
-            </a:pPr>
-            <a:r>
-              <a:rPr sz="1400">
-                <a:solidFill>
-                  <a:srgbClr val="3D5466"/>
-                </a:solidFill>
-                <a:latin typeface="Arial"/>
-              </a:rPr>
-              <a:t>▸  Situation B1 – Der Kollege als Mitarbeiter (Rückzugs-Variante):</a:t>
+              <a:t>Merksatz: Führung ist nicht das, was ich tue. Führung ist, was in meinem Team möglich wird – und was ich klar verantworte.</a:t>
             </a:r>
           </a:p>
         </p:txBody>
@@ -8511,84 +8980,6 @@
       <p:sp>
         <p:nvSpPr>
           <p:cNvPr id="9" name="Rectangle 8"/>
-          <p:cNvSpPr/>
-          <p:nvPr/>
-        </p:nvSpPr>
-        <p:spPr>
-          <a:xfrm>
-            <a:off x="685800" y="5486400"/>
-            <a:ext cx="10817352" cy="640080"/>
-          </a:xfrm>
-          <a:prstGeom prst="rect">
-            <a:avLst/>
-          </a:prstGeom>
-          <a:solidFill>
-            <a:srgbClr val="1F2C56"/>
-          </a:solidFill>
-          <a:ln>
-            <a:noFill/>
-          </a:ln>
-        </p:spPr>
-        <p:style>
-          <a:lnRef idx="1">
-            <a:schemeClr val="accent1"/>
-          </a:lnRef>
-          <a:fillRef idx="3">
-            <a:schemeClr val="accent1"/>
-          </a:fillRef>
-          <a:effectRef idx="2">
-            <a:schemeClr val="accent1"/>
-          </a:effectRef>
-          <a:fontRef idx="minor">
-            <a:schemeClr val="lt1"/>
-          </a:fontRef>
-        </p:style>
-        <p:txBody>
-          <a:bodyPr rtlCol="0" anchor="ctr"/>
-          <a:lstStyle/>
-          <a:p>
-            <a:pPr algn="ctr"/>
-          </a:p>
-        </p:txBody>
-      </p:sp>
-      <p:sp>
-        <p:nvSpPr>
-          <p:cNvPr id="10" name="TextBox 9"/>
-          <p:cNvSpPr txBox="1"/>
-          <p:nvPr/>
-        </p:nvSpPr>
-        <p:spPr>
-          <a:xfrm>
-            <a:off x="868680" y="5596128"/>
-            <a:ext cx="10451592" cy="457200"/>
-          </a:xfrm>
-          <a:prstGeom prst="rect">
-            <a:avLst/>
-          </a:prstGeom>
-          <a:noFill/>
-        </p:spPr>
-        <p:txBody>
-          <a:bodyPr wrap="square">
-            <a:spAutoFit/>
-          </a:bodyPr>
-          <a:lstStyle/>
-          <a:p>
-            <a:pPr algn="l"/>
-            <a:r>
-              <a:rPr sz="1300" b="1" i="0">
-                <a:solidFill>
-                  <a:srgbClr val="FFFFFF"/>
-                </a:solidFill>
-                <a:latin typeface="Arial"/>
-              </a:rPr>
-              <a:t>→  Bearbeitung im Teilnehmer-Workbook (Arbeitsblatt mit Ausfüllfeldern)</a:t>
-            </a:r>
-          </a:p>
-        </p:txBody>
-      </p:sp>
-      <p:sp>
-        <p:nvSpPr>
-          <p:cNvPr id="11" name="Rectangle 10"/>
           <p:cNvSpPr/>
           <p:nvPr/>
         </p:nvSpPr>
@@ -8631,7 +9022,7 @@
       </p:sp>
       <p:sp>
         <p:nvSpPr>
-          <p:cNvPr id="12" name="TextBox 11"/>
+          <p:cNvPr id="10" name="TextBox 9"/>
           <p:cNvSpPr txBox="1"/>
           <p:nvPr/>
         </p:nvSpPr>
@@ -8798,7 +9189,7 @@
                 </a:solidFill>
                 <a:latin typeface="Consolas"/>
               </a:rPr>
-              <a:t>TL00  ·  INHALT</a:t>
+              <a:t>TL00  ·  ARBEITSBLATT</a:t>
             </a:r>
           </a:p>
         </p:txBody>
@@ -8919,7 +9310,7 @@
                 </a:solidFill>
                 <a:latin typeface="Arial"/>
               </a:rPr>
-              <a:t>Merk- und Haltungskarte: Der Rollenwechsel in fünf Sätzen</a:t>
+              <a:t>Praxisfall: Thomas K. – vier Monate als Teamleiter</a:t>
             </a:r>
           </a:p>
         </p:txBody>
@@ -8932,8 +9323,8 @@
         </p:nvSpPr>
         <p:spPr>
           <a:xfrm>
-            <a:off x="685800" y="1417320"/>
-            <a:ext cx="10817352" cy="4892040"/>
+            <a:off x="685800" y="1554480"/>
+            <a:ext cx="10817352" cy="3840480"/>
           </a:xfrm>
           <a:prstGeom prst="rect">
             <a:avLst/>
@@ -8946,7 +9337,7 @@
           </a:bodyPr>
           <a:lstStyle/>
           <a:p>
-            <a:pPr>
+            <a:pPr marL="190500" indent="-190500">
               <a:spcBef>
                 <a:spcPts val="400"/>
               </a:spcBef>
@@ -8955,17 +9346,17 @@
               </a:spcAft>
             </a:pPr>
             <a:r>
-              <a:rPr sz="1200">
+              <a:rPr sz="1400">
                 <a:solidFill>
                   <a:srgbClr val="3D5466"/>
                 </a:solidFill>
                 <a:latin typeface="Arial"/>
               </a:rPr>
-              <a:t>Diese Karte fasst die fünf wichtigsten Haltungsanker des Rollenwechsels zusammen. Nehmen Sie sie mit – und legen Sie sie sich in zwei Wochen wieder vor.</a:t>
-            </a:r>
-          </a:p>
-          <a:p>
-            <a:pPr>
+              <a:t>▸  Ausgangslage (anonymisiert, branchentypisch)</a:t>
+            </a:r>
+          </a:p>
+          <a:p>
+            <a:pPr marL="190500" indent="-190500">
               <a:spcBef>
                 <a:spcPts val="400"/>
               </a:spcBef>
@@ -8974,17 +9365,17 @@
               </a:spcAft>
             </a:pPr>
             <a:r>
-              <a:rPr sz="1200">
+              <a:rPr sz="1400">
                 <a:solidFill>
                   <a:srgbClr val="3D5466"/>
                 </a:solidFill>
                 <a:latin typeface="Arial"/>
               </a:rPr>
-              <a:t>1. Mein Erfolg findet jetzt im Team statt.</a:t>
-            </a:r>
-          </a:p>
-          <a:p>
-            <a:pPr>
+              <a:t>▸  Vier Entscheidungssituationen</a:t>
+            </a:r>
+          </a:p>
+          <a:p>
+            <a:pPr marL="190500" indent="-190500">
               <a:spcBef>
                 <a:spcPts val="400"/>
               </a:spcBef>
@@ -8993,17 +9384,17 @@
               </a:spcAft>
             </a:pPr>
             <a:r>
-              <a:rPr sz="1200">
+              <a:rPr sz="1400">
                 <a:solidFill>
                   <a:srgbClr val="3D5466"/>
                 </a:solidFill>
                 <a:latin typeface="Arial"/>
               </a:rPr>
-              <a:t>Was ich selbst erreiche, zählt. Was mein Team erreicht, zählt mehr. Beides addiert sich – aber nur das zweite skaliert.</a:t>
-            </a:r>
-          </a:p>
-          <a:p>
-            <a:pPr>
+              <a:t>▸  Situation A – Das eigene Kreditengagement:</a:t>
+            </a:r>
+          </a:p>
+          <a:p>
+            <a:pPr marL="190500" indent="-190500">
               <a:spcBef>
                 <a:spcPts val="400"/>
               </a:spcBef>
@@ -9012,17 +9403,17 @@
               </a:spcAft>
             </a:pPr>
             <a:r>
-              <a:rPr sz="1200">
+              <a:rPr sz="1400">
                 <a:solidFill>
                   <a:srgbClr val="3D5466"/>
                 </a:solidFill>
                 <a:latin typeface="Arial"/>
               </a:rPr>
-              <a:t>2. Autorität entsteht durch Vertrauen, nicht durch Fachkompetenz.</a:t>
-            </a:r>
-          </a:p>
-          <a:p>
-            <a:pPr>
+              <a:t>▸  Welche Entscheidung trifft Thomas – und mit welcher Begründung?</a:t>
+            </a:r>
+          </a:p>
+          <a:p>
+            <a:pPr marL="190500" indent="-190500">
               <a:spcBef>
                 <a:spcPts val="400"/>
               </a:spcBef>
@@ -9031,134 +9422,98 @@
               </a:spcAft>
             </a:pPr>
             <a:r>
-              <a:rPr sz="1200">
+              <a:rPr sz="1400">
                 <a:solidFill>
                   <a:srgbClr val="3D5466"/>
                 </a:solidFill>
                 <a:latin typeface="Arial"/>
               </a:rPr>
-              <a:t>Ich muss nicht mehr der Beste in jedem Kreditthema sein. Ich muss derjenige sein, dem das Team zutraut, es zu unterstützen, fair zu behandeln und zu vertreten.</a:t>
-            </a:r>
-          </a:p>
-          <a:p>
-            <a:pPr>
-              <a:spcBef>
-                <a:spcPts val="400"/>
-              </a:spcBef>
-              <a:spcAft>
-                <a:spcPts val="200"/>
-              </a:spcAft>
-            </a:pPr>
-            <a:r>
-              <a:rPr sz="1200">
-                <a:solidFill>
-                  <a:srgbClr val="3D5466"/>
+              <a:t>▸  Situation B1 – Der Kollege als Mitarbeiter (Rückzugs-Variante):</a:t>
+            </a:r>
+          </a:p>
+        </p:txBody>
+      </p:sp>
+      <p:sp>
+        <p:nvSpPr>
+          <p:cNvPr id="9" name="Rectangle 8"/>
+          <p:cNvSpPr/>
+          <p:nvPr/>
+        </p:nvSpPr>
+        <p:spPr>
+          <a:xfrm>
+            <a:off x="685800" y="5486400"/>
+            <a:ext cx="10817352" cy="640080"/>
+          </a:xfrm>
+          <a:prstGeom prst="rect">
+            <a:avLst/>
+          </a:prstGeom>
+          <a:solidFill>
+            <a:srgbClr val="1F2C56"/>
+          </a:solidFill>
+          <a:ln>
+            <a:noFill/>
+          </a:ln>
+        </p:spPr>
+        <p:style>
+          <a:lnRef idx="1">
+            <a:schemeClr val="accent1"/>
+          </a:lnRef>
+          <a:fillRef idx="3">
+            <a:schemeClr val="accent1"/>
+          </a:fillRef>
+          <a:effectRef idx="2">
+            <a:schemeClr val="accent1"/>
+          </a:effectRef>
+          <a:fontRef idx="minor">
+            <a:schemeClr val="lt1"/>
+          </a:fontRef>
+        </p:style>
+        <p:txBody>
+          <a:bodyPr rtlCol="0" anchor="ctr"/>
+          <a:lstStyle/>
+          <a:p>
+            <a:pPr algn="ctr"/>
+          </a:p>
+        </p:txBody>
+      </p:sp>
+      <p:sp>
+        <p:nvSpPr>
+          <p:cNvPr id="10" name="TextBox 9"/>
+          <p:cNvSpPr txBox="1"/>
+          <p:nvPr/>
+        </p:nvSpPr>
+        <p:spPr>
+          <a:xfrm>
+            <a:off x="868680" y="5596128"/>
+            <a:ext cx="10451592" cy="457200"/>
+          </a:xfrm>
+          <a:prstGeom prst="rect">
+            <a:avLst/>
+          </a:prstGeom>
+          <a:noFill/>
+        </p:spPr>
+        <p:txBody>
+          <a:bodyPr wrap="square">
+            <a:spAutoFit/>
+          </a:bodyPr>
+          <a:lstStyle/>
+          <a:p>
+            <a:pPr algn="l"/>
+            <a:r>
+              <a:rPr sz="1300" b="1" i="0">
+                <a:solidFill>
+                  <a:srgbClr val="FFFFFF"/>
                 </a:solidFill>
                 <a:latin typeface="Arial"/>
               </a:rPr>
-              <a:t>3. Führung heißt: Bedingungen schaffen, nicht Lösungen liefern.</a:t>
-            </a:r>
-          </a:p>
-          <a:p>
-            <a:pPr>
-              <a:spcBef>
-                <a:spcPts val="400"/>
-              </a:spcBef>
-              <a:spcAft>
-                <a:spcPts val="200"/>
-              </a:spcAft>
-            </a:pPr>
-            <a:r>
-              <a:rPr sz="1200">
-                <a:solidFill>
-                  <a:srgbClr val="3D5466"/>
-                </a:solidFill>
-                <a:latin typeface="Arial"/>
-              </a:rPr>
-              <a:t>Wenn jemand aus meinem Team ein Problem bringt, ist meine erste Frage: „Was haben Sie schon überlegt?" – nicht: „Ich sehe das so."</a:t>
-            </a:r>
-          </a:p>
-          <a:p>
-            <a:pPr>
-              <a:spcBef>
-                <a:spcPts val="400"/>
-              </a:spcBef>
-              <a:spcAft>
-                <a:spcPts val="200"/>
-              </a:spcAft>
-            </a:pPr>
-            <a:r>
-              <a:rPr sz="1200">
-                <a:solidFill>
-                  <a:srgbClr val="3D5466"/>
-                </a:solidFill>
-                <a:latin typeface="Arial"/>
-              </a:rPr>
-              <a:t>4. Ehemalige Kollegen sind jetzt Mitarbeitende. Das ist kein Verrat – das ist Klarheit.</a:t>
-            </a:r>
-          </a:p>
-          <a:p>
-            <a:pPr>
-              <a:spcBef>
-                <a:spcPts val="400"/>
-              </a:spcBef>
-              <a:spcAft>
-                <a:spcPts val="200"/>
-              </a:spcAft>
-            </a:pPr>
-            <a:r>
-              <a:rPr sz="1200">
-                <a:solidFill>
-                  <a:srgbClr val="3D5466"/>
-                </a:solidFill>
-                <a:latin typeface="Arial"/>
-              </a:rPr>
-              <a:t>Die neue Rollenklarheit schützt beide Seiten. Ich kann und soll partnerschaftlich führen – aber die Verantwortung liegt jetzt bei mir.</a:t>
-            </a:r>
-          </a:p>
-          <a:p>
-            <a:pPr>
-              <a:spcBef>
-                <a:spcPts val="400"/>
-              </a:spcBef>
-              <a:spcAft>
-                <a:spcPts val="200"/>
-              </a:spcAft>
-            </a:pPr>
-            <a:r>
-              <a:rPr sz="1200">
-                <a:solidFill>
-                  <a:srgbClr val="3D5466"/>
-                </a:solidFill>
-                <a:latin typeface="Arial"/>
-              </a:rPr>
-              <a:t>5. Servant Leadership bedeutet: Wachstum als Führungsmaßstab.</a:t>
-            </a:r>
-          </a:p>
-          <a:p>
-            <a:pPr>
-              <a:spcBef>
-                <a:spcPts val="400"/>
-              </a:spcBef>
-              <a:spcAft>
-                <a:spcPts val="200"/>
-              </a:spcAft>
-            </a:pPr>
-            <a:r>
-              <a:rPr sz="1200">
-                <a:solidFill>
-                  <a:srgbClr val="3D5466"/>
-                </a:solidFill>
-                <a:latin typeface="Arial"/>
-              </a:rPr>
-              <a:t>Mein Maßstab ist nicht: Wie viel habe ich heute geleistet? Sondern: Was konnte mein Team heute mehr, als es gestern konnte?</a:t>
-            </a:r>
-          </a:p>
-        </p:txBody>
-      </p:sp>
-      <p:sp>
-        <p:nvSpPr>
-          <p:cNvPr id="9" name="Rectangle 8"/>
+              <a:t>→  Bearbeitung im Teilnehmer-Workbook (Arbeitsblatt mit Ausfüllfeldern)</a:t>
+            </a:r>
+          </a:p>
+        </p:txBody>
+      </p:sp>
+      <p:sp>
+        <p:nvSpPr>
+          <p:cNvPr id="11" name="Rectangle 10"/>
           <p:cNvSpPr/>
           <p:nvPr/>
         </p:nvSpPr>
@@ -9201,7 +9556,7 @@
       </p:sp>
       <p:sp>
         <p:nvSpPr>
-          <p:cNvPr id="10" name="TextBox 9"/>
+          <p:cNvPr id="12" name="TextBox 11"/>
           <p:cNvSpPr txBox="1"/>
           <p:nvPr/>
         </p:nvSpPr>

</xml_diff>

<commit_message>
TL-Piloten: kuratierte Decks + aktualisierte Trainerhandbuecher
- Praesentation TL00/02/04: kuratierte Decks (18/29/23 Folien) statt Bootstrap
- Trainerhandbuch TL00/TL02: neuer Reporting-Beobachtungsanker (Sec 6.3)

Co-Authored-By: Claude Opus 4.8 <noreply@anthropic.com>
</commit_message>
<xml_diff>
--- a/protected-downloads/praesentation/TL00.pptx
+++ b/protected-downloads/praesentation/TL00.pptx
@@ -17,6 +17,12 @@
     <p:sldId id="265" r:id="rId17"/>
     <p:sldId id="266" r:id="rId18"/>
     <p:sldId id="267" r:id="rId19"/>
+    <p:sldId id="268" r:id="rId20"/>
+    <p:sldId id="269" r:id="rId21"/>
+    <p:sldId id="270" r:id="rId22"/>
+    <p:sldId id="271" r:id="rId23"/>
+    <p:sldId id="272" r:id="rId24"/>
+    <p:sldId id="273" r:id="rId25"/>
   </p:sldIdLst>
   <p:sldSz cx="12188952" cy="6858000" type="screen4x3"/>
   <p:notesSz cx="6858000" cy="9144000"/>
@@ -538,6 +544,381 @@
 </p:notes>
 </file>
 
+<file path=ppt/notesSlides/notesSlide10.xml><?xml version="1.0" encoding="utf-8"?>
+<p:notes xmlns:a="http://schemas.openxmlformats.org/drawingml/2006/main" xmlns:p="http://schemas.openxmlformats.org/presentationml/2006/main" xmlns:r="http://schemas.openxmlformats.org/officeDocument/2006/relationships">
+  <p:cSld>
+    <p:spTree>
+      <p:nvGrpSpPr>
+        <p:cNvPr id="1" name=""/>
+        <p:cNvGrpSpPr/>
+        <p:nvPr/>
+      </p:nvGrpSpPr>
+      <p:grpSpPr>
+        <a:xfrm>
+          <a:off x="0" y="0"/>
+          <a:ext cx="0" cy="0"/>
+          <a:chOff x="0" y="0"/>
+          <a:chExt cx="0" cy="0"/>
+        </a:xfrm>
+      </p:grpSpPr>
+      <p:sp>
+        <p:nvSpPr>
+          <p:cNvPr id="2" name="Slide Image Placeholder 1"/>
+          <p:cNvSpPr>
+            <a:spLocks noGrp="1"/>
+          </p:cNvSpPr>
+          <p:nvPr>
+            <p:ph type="sldImg" idx="2"/>
+          </p:nvPr>
+        </p:nvSpPr>
+        <p:spPr/>
+      </p:sp>
+      <p:sp>
+        <p:nvSpPr>
+          <p:cNvPr id="3" name="Notes Placeholder 2"/>
+          <p:cNvSpPr>
+            <a:spLocks noGrp="1"/>
+          </p:cNvSpPr>
+          <p:nvPr>
+            <p:ph type="body" idx="3" sz="quarter"/>
+          </p:nvPr>
+        </p:nvSpPr>
+        <p:spPr/>
+        <p:txBody>
+          <a:bodyPr/>
+          <a:lstStyle/>
+          <a:p>
+            <a:r>
+              <a:t>Vor Beginn: Vertraulichkeit explizit zusichern – „Was hier geteilt wird, bleibt hier.“</a:t>
+            </a:r>
+          </a:p>
+          <a:p>
+            <a:r>
+              <a:t>Fallvorstellung-Runde: jeder 60 Sek., Trainer notiert Fälle am Flipchart ohne Kommentar. Dann gemeinsam abstimmen.</a:t>
+            </a:r>
+          </a:p>
+          <a:p>
+            <a:r>
+              <a:t>Notfallfall bereit: anonymisierte Abwandlung Situation D (Leistungsfeedback gemieden) – bei Peer-Statusangst sofort einsetzen, ohne Pause der Verlegenheit.</a:t>
+            </a:r>
+          </a:p>
+        </p:txBody>
+      </p:sp>
+      <p:sp>
+        <p:nvSpPr>
+          <p:cNvPr id="4" name="Slide Number Placeholder 3"/>
+          <p:cNvSpPr>
+            <a:spLocks noGrp="1"/>
+          </p:cNvSpPr>
+          <p:nvPr>
+            <p:ph type="sldNum" idx="5" sz="quarter"/>
+          </p:nvPr>
+        </p:nvSpPr>
+        <p:spPr/>
+      </p:sp>
+    </p:spTree>
+  </p:cSld>
+  <p:clrMapOvr>
+    <a:masterClrMapping/>
+  </p:clrMapOvr>
+</p:notes>
+</file>
+
+<file path=ppt/notesSlides/notesSlide11.xml><?xml version="1.0" encoding="utf-8"?>
+<p:notes xmlns:a="http://schemas.openxmlformats.org/drawingml/2006/main" xmlns:p="http://schemas.openxmlformats.org/presentationml/2006/main" xmlns:r="http://schemas.openxmlformats.org/officeDocument/2006/relationships">
+  <p:cSld>
+    <p:spTree>
+      <p:nvGrpSpPr>
+        <p:cNvPr id="1" name=""/>
+        <p:cNvGrpSpPr/>
+        <p:nvPr/>
+      </p:nvGrpSpPr>
+      <p:grpSpPr>
+        <a:xfrm>
+          <a:off x="0" y="0"/>
+          <a:ext cx="0" cy="0"/>
+          <a:chOff x="0" y="0"/>
+          <a:chExt cx="0" cy="0"/>
+        </a:xfrm>
+      </p:grpSpPr>
+      <p:sp>
+        <p:nvSpPr>
+          <p:cNvPr id="2" name="Slide Image Placeholder 1"/>
+          <p:cNvSpPr>
+            <a:spLocks noGrp="1"/>
+          </p:cNvSpPr>
+          <p:nvPr>
+            <p:ph type="sldImg" idx="2"/>
+          </p:nvPr>
+        </p:nvSpPr>
+        <p:spPr/>
+      </p:sp>
+      <p:sp>
+        <p:nvSpPr>
+          <p:cNvPr id="3" name="Notes Placeholder 2"/>
+          <p:cNvSpPr>
+            <a:spLocks noGrp="1"/>
+          </p:cNvSpPr>
+          <p:nvPr>
+            <p:ph type="body" idx="3" sz="quarter"/>
+          </p:nvPr>
+        </p:nvSpPr>
+        <p:spPr/>
+        <p:txBody>
+          <a:bodyPr/>
+          <a:lstStyle/>
+          <a:p>
+            <a:r>
+              <a:t>Schritt 5 ist nicht kürzbar. Schritt 6 (Transfer-Runde) kann bei Zeitdruck auf stille Einzelnotiz 30 Sek. komprimiert werden.</a:t>
+            </a:r>
+          </a:p>
+          <a:p>
+            <a:r>
+              <a:t>Häufigste Hürde in unerfahrenen Gruppen: in Schritt 2 kommen versteckte Ratschläge als Fragen verkleidet. Trainer bricht höflich ab: „Das klingt schon nach einer Empfehlung – die kommt in Schritt 4.“</a:t>
+            </a:r>
+          </a:p>
+        </p:txBody>
+      </p:sp>
+      <p:sp>
+        <p:nvSpPr>
+          <p:cNvPr id="4" name="Slide Number Placeholder 3"/>
+          <p:cNvSpPr>
+            <a:spLocks noGrp="1"/>
+          </p:cNvSpPr>
+          <p:nvPr>
+            <p:ph type="sldNum" idx="5" sz="quarter"/>
+          </p:nvPr>
+        </p:nvSpPr>
+        <p:spPr/>
+      </p:sp>
+    </p:spTree>
+  </p:cSld>
+  <p:clrMapOvr>
+    <a:masterClrMapping/>
+  </p:clrMapOvr>
+</p:notes>
+</file>
+
+<file path=ppt/notesSlides/notesSlide12.xml><?xml version="1.0" encoding="utf-8"?>
+<p:notes xmlns:a="http://schemas.openxmlformats.org/drawingml/2006/main" xmlns:p="http://schemas.openxmlformats.org/presentationml/2006/main" xmlns:r="http://schemas.openxmlformats.org/officeDocument/2006/relationships">
+  <p:cSld>
+    <p:spTree>
+      <p:nvGrpSpPr>
+        <p:cNvPr id="1" name=""/>
+        <p:cNvGrpSpPr/>
+        <p:nvPr/>
+      </p:nvGrpSpPr>
+      <p:grpSpPr>
+        <a:xfrm>
+          <a:off x="0" y="0"/>
+          <a:ext cx="0" cy="0"/>
+          <a:chOff x="0" y="0"/>
+          <a:chExt cx="0" cy="0"/>
+        </a:xfrm>
+      </p:grpSpPr>
+      <p:sp>
+        <p:nvSpPr>
+          <p:cNvPr id="2" name="Slide Image Placeholder 1"/>
+          <p:cNvSpPr>
+            <a:spLocks noGrp="1"/>
+          </p:cNvSpPr>
+          <p:nvPr>
+            <p:ph type="sldImg" idx="2"/>
+          </p:nvPr>
+        </p:nvSpPr>
+        <p:spPr/>
+      </p:sp>
+      <p:sp>
+        <p:nvSpPr>
+          <p:cNvPr id="3" name="Notes Placeholder 2"/>
+          <p:cNvSpPr>
+            <a:spLocks noGrp="1"/>
+          </p:cNvSpPr>
+          <p:nvPr>
+            <p:ph type="body" idx="3" sz="quarter"/>
+          </p:nvPr>
+        </p:nvSpPr>
+        <p:spPr/>
+        <p:txBody>
+          <a:bodyPr/>
+          <a:lstStyle/>
+          <a:p>
+            <a:r>
+              <a:t>AB-2 ist der „Ernstfall“ des Moduls. Stille hier ist produktiv – nicht unterbrechen.</a:t>
+            </a:r>
+          </a:p>
+          <a:p>
+            <a:r>
+              <a:t>Plenum-Echo freiwillig: 90 Sek. Feedback-Schema: „Was war stark?“ / „Was könnte schärfer sein?“ – nur zur Formulierung, nicht zum geplanten Gespräch selbst.</a:t>
+            </a:r>
+          </a:p>
+        </p:txBody>
+      </p:sp>
+      <p:sp>
+        <p:nvSpPr>
+          <p:cNvPr id="4" name="Slide Number Placeholder 3"/>
+          <p:cNvSpPr>
+            <a:spLocks noGrp="1"/>
+          </p:cNvSpPr>
+          <p:nvPr>
+            <p:ph type="sldNum" idx="5" sz="quarter"/>
+          </p:nvPr>
+        </p:nvSpPr>
+        <p:spPr/>
+      </p:sp>
+    </p:spTree>
+  </p:cSld>
+  <p:clrMapOvr>
+    <a:masterClrMapping/>
+  </p:clrMapOvr>
+</p:notes>
+</file>
+
+<file path=ppt/notesSlides/notesSlide13.xml><?xml version="1.0" encoding="utf-8"?>
+<p:notes xmlns:a="http://schemas.openxmlformats.org/drawingml/2006/main" xmlns:p="http://schemas.openxmlformats.org/presentationml/2006/main" xmlns:r="http://schemas.openxmlformats.org/officeDocument/2006/relationships">
+  <p:cSld>
+    <p:spTree>
+      <p:nvGrpSpPr>
+        <p:cNvPr id="1" name=""/>
+        <p:cNvGrpSpPr/>
+        <p:nvPr/>
+      </p:nvGrpSpPr>
+      <p:grpSpPr>
+        <a:xfrm>
+          <a:off x="0" y="0"/>
+          <a:ext cx="0" cy="0"/>
+          <a:chOff x="0" y="0"/>
+          <a:chExt cx="0" cy="0"/>
+        </a:xfrm>
+      </p:grpSpPr>
+      <p:sp>
+        <p:nvSpPr>
+          <p:cNvPr id="2" name="Slide Image Placeholder 1"/>
+          <p:cNvSpPr>
+            <a:spLocks noGrp="1"/>
+          </p:cNvSpPr>
+          <p:nvPr>
+            <p:ph type="sldImg" idx="2"/>
+          </p:nvPr>
+        </p:nvSpPr>
+        <p:spPr/>
+      </p:sp>
+      <p:sp>
+        <p:nvSpPr>
+          <p:cNvPr id="3" name="Notes Placeholder 2"/>
+          <p:cNvSpPr>
+            <a:spLocks noGrp="1"/>
+          </p:cNvSpPr>
+          <p:nvPr>
+            <p:ph type="body" idx="3" sz="quarter"/>
+          </p:nvPr>
+        </p:nvSpPr>
+        <p:spPr/>
+        <p:txBody>
+          <a:bodyPr/>
+          <a:lstStyle/>
+          <a:p>
+            <a:r>
+              <a:t>Vorbild Situation D Musterlösung: Einstiegssatz benennt den Sachverhalt direkt, ohne Umschweife. Häufigste Fehler: zu lang erklären; offen enden ohne Nächstes.</a:t>
+            </a:r>
+          </a:p>
+        </p:txBody>
+      </p:sp>
+      <p:sp>
+        <p:nvSpPr>
+          <p:cNvPr id="4" name="Slide Number Placeholder 3"/>
+          <p:cNvSpPr>
+            <a:spLocks noGrp="1"/>
+          </p:cNvSpPr>
+          <p:nvPr>
+            <p:ph type="sldNum" idx="5" sz="quarter"/>
+          </p:nvPr>
+        </p:nvSpPr>
+        <p:spPr/>
+      </p:sp>
+    </p:spTree>
+  </p:cSld>
+  <p:clrMapOvr>
+    <a:masterClrMapping/>
+  </p:clrMapOvr>
+</p:notes>
+</file>
+
+<file path=ppt/notesSlides/notesSlide14.xml><?xml version="1.0" encoding="utf-8"?>
+<p:notes xmlns:a="http://schemas.openxmlformats.org/drawingml/2006/main" xmlns:p="http://schemas.openxmlformats.org/presentationml/2006/main" xmlns:r="http://schemas.openxmlformats.org/officeDocument/2006/relationships">
+  <p:cSld>
+    <p:spTree>
+      <p:nvGrpSpPr>
+        <p:cNvPr id="1" name=""/>
+        <p:cNvGrpSpPr/>
+        <p:nvPr/>
+      </p:nvGrpSpPr>
+      <p:grpSpPr>
+        <a:xfrm>
+          <a:off x="0" y="0"/>
+          <a:ext cx="0" cy="0"/>
+          <a:chOff x="0" y="0"/>
+          <a:chExt cx="0" cy="0"/>
+        </a:xfrm>
+      </p:grpSpPr>
+      <p:sp>
+        <p:nvSpPr>
+          <p:cNvPr id="2" name="Slide Image Placeholder 1"/>
+          <p:cNvSpPr>
+            <a:spLocks noGrp="1"/>
+          </p:cNvSpPr>
+          <p:nvPr>
+            <p:ph type="sldImg" idx="2"/>
+          </p:nvPr>
+        </p:nvSpPr>
+        <p:spPr/>
+      </p:sp>
+      <p:sp>
+        <p:nvSpPr>
+          <p:cNvPr id="3" name="Notes Placeholder 2"/>
+          <p:cNvSpPr>
+            <a:spLocks noGrp="1"/>
+          </p:cNvSpPr>
+          <p:nvPr>
+            <p:ph type="body" idx="3" sz="quarter"/>
+          </p:nvPr>
+        </p:nvSpPr>
+        <p:spPr/>
+        <p:txBody>
+          <a:bodyPr/>
+          <a:lstStyle/>
+          <a:p>
+            <a:r>
+              <a:t>Transferaufgaben 1–3 aus Sec 5 kurz benennen. Checkliste mitgeben: „Legen Sie diese Karte in vier Wochen wieder vor sich – das ist Ihr eigener Maßstab.“</a:t>
+            </a:r>
+          </a:p>
+          <a:p>
+            <a:r>
+              <a:t>Wenn Bereichsleiter anwesend: Folgetermin für L3-Entwicklungsgespräch noch heute vereinbaren (4–12 Wochen, 30 Min.).</a:t>
+            </a:r>
+          </a:p>
+        </p:txBody>
+      </p:sp>
+      <p:sp>
+        <p:nvSpPr>
+          <p:cNvPr id="4" name="Slide Number Placeholder 3"/>
+          <p:cNvSpPr>
+            <a:spLocks noGrp="1"/>
+          </p:cNvSpPr>
+          <p:nvPr>
+            <p:ph type="sldNum" idx="5" sz="quarter"/>
+          </p:nvPr>
+        </p:nvSpPr>
+        <p:spPr/>
+      </p:sp>
+    </p:spTree>
+  </p:cSld>
+  <p:clrMapOvr>
+    <a:masterClrMapping/>
+  </p:clrMapOvr>
+</p:notes>
+</file>
+
 <file path=ppt/notesSlides/notesSlide2.xml><?xml version="1.0" encoding="utf-8"?>
 <p:notes xmlns:a="http://schemas.openxmlformats.org/drawingml/2006/main" xmlns:p="http://schemas.openxmlformats.org/presentationml/2006/main" xmlns:r="http://schemas.openxmlformats.org/officeDocument/2006/relationships">
   <p:cSld>
@@ -583,7 +964,7 @@
           <a:lstStyle/>
           <a:p>
             <a:r>
-              <a:t>Siehe Trainerhandbuch (Sektion 3) für Moderationshinweise, Timing und erwartete Teilnehmerreaktionen.</a:t>
+              <a:t>Einstieg-Frage (Plenum): „Wie lange sind Sie schon Teamleiter?“ – Bandbreite am Flipchart notieren. Danach: „Was hat sich in der ersten Woche anders angefühlt als erwartet?“ – Erst danach Folie zeigen.</a:t>
             </a:r>
           </a:p>
         </p:txBody>
@@ -653,7 +1034,12 @@
           <a:lstStyle/>
           <a:p>
             <a:r>
-              <a:t>Siehe Trainerhandbuch (Sektion 3) für Moderationshinweise, Timing und erwartete Teilnehmerreaktionen.</a:t>
+              <a:t>Kernbotschaft: Die Beförderung passiert dir. Der Rollenwechsel ist deine Aufgabe.</a:t>
+            </a:r>
+          </a:p>
+          <a:p>
+            <a:r>
+              <a:t>Hill (2003, Q-226): Längsschnittstudie 19 neue Führungskräfte – alle interpretierten die Aufgabe initial als Erweiterung des Fachexpertentums.</a:t>
             </a:r>
           </a:p>
         </p:txBody>
@@ -723,7 +1109,12 @@
           <a:lstStyle/>
           <a:p>
             <a:r>
-              <a:t>Siehe Trainerhandbuch (Sektion 3) für Moderationshinweise, Timing und erwartete Teilnehmerreaktionen.</a:t>
+              <a:t>Tabelle langsam durchgehen – nicht rasen. Nach jeder Zeile kurze Pause, Resonanz holen. Häufige Reaktion: Erleichterung. Normalisierungsfunktion nutzen.</a:t>
+            </a:r>
+          </a:p>
+          <a:p>
+            <a:r>
+              <a:t>Yukl (2002, Q-058): radikale Verschiebung des Selbstverständnisses.</a:t>
             </a:r>
           </a:p>
         </p:txBody>
@@ -793,37 +1184,12 @@
           <a:lstStyle/>
           <a:p>
             <a:r>
-              <a:t>Trainer-Hinweis: Musterlösung im Trainer-Abschnitt unten. Die Situationen decken alle vier Dimensionen des Rollenwechsels ab: Situation A (Erfolgslogik/Delegation), Situation B1+B2 (Identität/Rollenklarheit – emotionalster Block, nicht abwürgen, sondern moderieren; B2 unbedingt im Plenum besprechen, da sie den Moment der Teamakzeptanz zeigt), Situation C (Zeit/Führungsleistung benennen), Situation D (Leistungsverantwortung wahrnehmen – häufig der am stärksten gemiedene Moment des ersten Jahres; in der kollegialen Fallberatung besonders wertvoll).</a:t>
-            </a:r>
-          </a:p>
-          <a:p>
-            <a:r>
-              <a:t>AB-1 Musterlösung (Trainer-Version)</a:t>
-            </a:r>
-          </a:p>
-          <a:p>
-            <a:r>
-              <a:t>Situation A: Thomas delegiert das Gespräch vollständig an Marcus Bauer und begleitet es im ersten Schritt als stille Beobachtung (Beobachtungsbogen, 30 Minuten). Danach gibt er Marcus strukturiertes Feedback: Was war gut? Was würde er beim nächsten Mal anders machen? Thomas tritt damit als Coach auf, nicht als besserer Berater. Der Stammkunde ist ein idealer erster „Transferfall" – der Beziehungsaufbau zwischen Marcus und dem Kunden ist echte Führungsleistung.</a:t>
-            </a:r>
-          </a:p>
-          <a:p>
-            <a:r>
-              <a:t>Situation B1: Thomas klärt mit Marco in einem kurzen Einzelgespräch die neue Rollenerwartung: „Ich werde deine Kreditausarbeitungen nicht mehr inhaltlich kommentieren – das ist jetzt deine fachliche Verantwortung. Ich bin da, wenn du eine Meinung brauchst, aber ich fordere sie nicht ungefragt. Wenn ich Feedback gebe, dann zur Struktur und zum Vorgehen, nicht zur Lösung." Dieser Satz setzt eine klare Grenze ohne Hierarchisierung. Das Gespräch sollte explizit, ruhig und kurz sein.</a:t>
-            </a:r>
-          </a:p>
-          <a:p>
-            <a:r>
-              <a:t>Situation B2: Thomas reagiert im Teammeeting sofort – aber ohne Eskalation. Bewährte Formulierung: „Marco, danke für den Einwand – der verdient eine Antwort. Wir haben das frühere Verfahren bewusst überprüft, und ich habe mich aus folgenden Gründen für diesen neuen Standard entschieden: [kurze Begründung, 2 Sätze]. Wer konkrete Bedenken zur Umsetzung hat, nehme ich gern im Einzelgespräch entgegen." Drei Dinge passieren gleichzeitig: Thomas zeigt, dass er sachliche Einwände ernst nimmt, nennt seine Entscheidungsgrundlage, und verschiebt die Detaildiskussion aus dem Plenum ins Vieraugengespräch. Marco behält sein Gesicht – und das Team sieht, dass Thomas entscheidungsstark bleibt. Zentral: Dieser Moment erfordert kein späteres Strafgespräch mit Marco. Die richtige Reaktion im Meeting ist die Führungshandlung.</a:t>
-            </a:r>
-          </a:p>
-          <a:p>
-            <a:r>
-              <a:t>Trainer-Hinweis: Situation B2 ist der Moment, der über Akzeptanz oder Erosion der Teamleiter-Rolle entscheidet. Im Plenum gemeinsam Formulierungsalternativen sammeln: Was würde „zu weich" klingen? Was „zu hart"? Der Raum zwischen beidem ist die Führungskompetenz. Kein Rollenspiel – stattdessen: Teilnehmer schreiben ihren eigenen Einstiegssatz auf, ein Freiwilliger liest vor.</a:t>
-            </a:r>
-          </a:p>
-          <a:p>
-            <a:r>
-              <a:t>Situation C: Echte Führungsleistung in vier Monaten: Wie viele Ei</a:t>
+              <a:t>Anker: „Wo stehen Sie gerade in dieser Tabelle?“ – Einzelnen befragen, nicht Gesamtgruppe.</a:t>
+            </a:r>
+          </a:p>
+          <a:p>
+            <a:r>
+              <a:t>Wichtig: Ziel nicht Null Facharbeit – sondern bewusste, aktiv gewählte Verschiebung. Selbst 20→30 % Führungszeit ist echter Fortschritt.</a:t>
             </a:r>
           </a:p>
         </p:txBody>
@@ -893,7 +1259,7 @@
           <a:lstStyle/>
           <a:p>
             <a:r>
-              <a:t>Siehe Trainerhandbuch (Sektion 3) für Moderationshinweise, Timing und erwartete Teilnehmerreaktionen.</a:t>
+              <a:t>Klaren Auftrag geben, dann Stille zulassen. Teil 1–3 ca. 10 Min., Teil 4 ca. 5 Min. Paarphase nicht unterbrechen.</a:t>
             </a:r>
           </a:p>
         </p:txBody>
@@ -963,7 +1329,12 @@
           <a:lstStyle/>
           <a:p>
             <a:r>
-              <a:t>Siehe Trainerhandbuch (Sektion 3) für Moderationshinweise, Timing und erwartete Teilnehmerreaktionen.</a:t>
+              <a:t>Häufigste Falle: Facheingriff. Wichtig: nicht werten, normalisieren.</a:t>
+            </a:r>
+          </a:p>
+          <a:p>
+            <a:r>
+              <a:t>Plenumsrunde: nur 2–3 Freiwillige, kein Druck.</a:t>
             </a:r>
           </a:p>
         </p:txBody>
@@ -1033,7 +1404,77 @@
           <a:lstStyle/>
           <a:p>
             <a:r>
-              <a:t>Siehe Trainerhandbuch (Sektion 3) für Moderationshinweise, Timing und erwartete Teilnehmerreaktionen.</a:t>
+              <a:t>Dieser Block setzt die Haltungsklammer für den Gesamttag (Mezirow, 1991, Q-011). Am Abschluss (12:45 Uhr) nur Rückverweis auf Karte – kein neuer Theorie-Input.</a:t>
+            </a:r>
+          </a:p>
+        </p:txBody>
+      </p:sp>
+      <p:sp>
+        <p:nvSpPr>
+          <p:cNvPr id="4" name="Slide Number Placeholder 3"/>
+          <p:cNvSpPr>
+            <a:spLocks noGrp="1"/>
+          </p:cNvSpPr>
+          <p:nvPr>
+            <p:ph type="sldNum" idx="5" sz="quarter"/>
+          </p:nvPr>
+        </p:nvSpPr>
+        <p:spPr/>
+      </p:sp>
+    </p:spTree>
+  </p:cSld>
+  <p:clrMapOvr>
+    <a:masterClrMapping/>
+  </p:clrMapOvr>
+</p:notes>
+</file>
+
+<file path=ppt/notesSlides/notesSlide9.xml><?xml version="1.0" encoding="utf-8"?>
+<p:notes xmlns:a="http://schemas.openxmlformats.org/drawingml/2006/main" xmlns:p="http://schemas.openxmlformats.org/presentationml/2006/main" xmlns:r="http://schemas.openxmlformats.org/officeDocument/2006/relationships">
+  <p:cSld>
+    <p:spTree>
+      <p:nvGrpSpPr>
+        <p:cNvPr id="1" name=""/>
+        <p:cNvGrpSpPr/>
+        <p:nvPr/>
+      </p:nvGrpSpPr>
+      <p:grpSpPr>
+        <a:xfrm>
+          <a:off x="0" y="0"/>
+          <a:ext cx="0" cy="0"/>
+          <a:chOff x="0" y="0"/>
+          <a:chExt cx="0" cy="0"/>
+        </a:xfrm>
+      </p:grpSpPr>
+      <p:sp>
+        <p:nvSpPr>
+          <p:cNvPr id="2" name="Slide Image Placeholder 1"/>
+          <p:cNvSpPr>
+            <a:spLocks noGrp="1"/>
+          </p:cNvSpPr>
+          <p:nvPr>
+            <p:ph type="sldImg" idx="2"/>
+          </p:nvPr>
+        </p:nvSpPr>
+        <p:spPr/>
+      </p:sp>
+      <p:sp>
+        <p:nvSpPr>
+          <p:cNvPr id="3" name="Notes Placeholder 2"/>
+          <p:cNvSpPr>
+            <a:spLocks noGrp="1"/>
+          </p:cNvSpPr>
+          <p:nvPr>
+            <p:ph type="body" idx="3" sz="quarter"/>
+          </p:nvPr>
+        </p:nvSpPr>
+        <p:spPr/>
+        <p:txBody>
+          <a:bodyPr/>
+          <a:lstStyle/>
+          <a:p>
+            <a:r>
+              <a:t>Ausgangslage laut vorlesen – gemeinsame Szene schaffen. Situationen gezielt verteilen: B2 immer der erfahrensten Gruppe oder ans Plenum.</a:t>
             </a:r>
           </a:p>
         </p:txBody>
@@ -4629,7 +5070,7 @@
             <a:avLst/>
           </a:prstGeom>
           <a:solidFill>
-            <a:srgbClr val="EDEDF3"/>
+            <a:srgbClr val="1F2C56"/>
           </a:solidFill>
           <a:ln>
             <a:noFill/>
@@ -4659,57 +5100,14 @@
       </p:sp>
       <p:sp>
         <p:nvSpPr>
-          <p:cNvPr id="3" name="Rectangle 2"/>
-          <p:cNvSpPr/>
-          <p:nvPr/>
-        </p:nvSpPr>
-        <p:spPr>
-          <a:xfrm>
-            <a:off x="0" y="0"/>
-            <a:ext cx="12188952" cy="50292"/>
-          </a:xfrm>
-          <a:prstGeom prst="rect">
-            <a:avLst/>
-          </a:prstGeom>
-          <a:solidFill>
-            <a:srgbClr val="1F2C56"/>
-          </a:solidFill>
-          <a:ln>
-            <a:noFill/>
-          </a:ln>
-        </p:spPr>
-        <p:style>
-          <a:lnRef idx="1">
-            <a:schemeClr val="accent1"/>
-          </a:lnRef>
-          <a:fillRef idx="3">
-            <a:schemeClr val="accent1"/>
-          </a:fillRef>
-          <a:effectRef idx="2">
-            <a:schemeClr val="accent1"/>
-          </a:effectRef>
-          <a:fontRef idx="minor">
-            <a:schemeClr val="lt1"/>
-          </a:fontRef>
-        </p:style>
-        <p:txBody>
-          <a:bodyPr rtlCol="0" anchor="ctr"/>
-          <a:lstStyle/>
-          <a:p>
-            <a:pPr algn="ctr"/>
-          </a:p>
-        </p:txBody>
-      </p:sp>
-      <p:sp>
-        <p:nvSpPr>
-          <p:cNvPr id="4" name="TextBox 3"/>
+          <p:cNvPr id="3" name="TextBox 2"/>
           <p:cNvSpPr txBox="1"/>
           <p:nvPr/>
         </p:nvSpPr>
         <p:spPr>
           <a:xfrm>
-            <a:off x="685800" y="109728"/>
-            <a:ext cx="10817352" cy="228600"/>
+            <a:off x="685800" y="2377440"/>
+            <a:ext cx="10817352" cy="365760"/>
           </a:xfrm>
           <a:prstGeom prst="rect">
             <a:avLst/>
@@ -4724,70 +5122,27 @@
           <a:p>
             <a:pPr algn="l"/>
             <a:r>
-              <a:rPr sz="750">
-                <a:solidFill>
-                  <a:srgbClr val="78808C"/>
+              <a:rPr sz="1200">
+                <a:solidFill>
+                  <a:srgbClr val="D9C089"/>
                 </a:solidFill>
                 <a:latin typeface="Consolas"/>
               </a:rPr>
-              <a:t>TL00  ·  INHALT</a:t>
-            </a:r>
-          </a:p>
-        </p:txBody>
-      </p:sp>
-      <p:sp>
-        <p:nvSpPr>
-          <p:cNvPr id="5" name="Rectangle 4"/>
+              <a:t>EINZELARBEIT (20 MIN.) + PAARREFLEXION (8 MIN.)</a:t>
+            </a:r>
+          </a:p>
+        </p:txBody>
+      </p:sp>
+      <p:sp>
+        <p:nvSpPr>
+          <p:cNvPr id="4" name="Rectangle 3"/>
           <p:cNvSpPr/>
           <p:nvPr/>
         </p:nvSpPr>
         <p:spPr>
           <a:xfrm>
-            <a:off x="0" y="1234440"/>
-            <a:ext cx="12188952" cy="12700"/>
-          </a:xfrm>
-          <a:prstGeom prst="rect">
-            <a:avLst/>
-          </a:prstGeom>
-          <a:solidFill>
-            <a:srgbClr val="D8DFE4"/>
-          </a:solidFill>
-          <a:ln>
-            <a:noFill/>
-          </a:ln>
-        </p:spPr>
-        <p:style>
-          <a:lnRef idx="1">
-            <a:schemeClr val="accent1"/>
-          </a:lnRef>
-          <a:fillRef idx="3">
-            <a:schemeClr val="accent1"/>
-          </a:fillRef>
-          <a:effectRef idx="2">
-            <a:schemeClr val="accent1"/>
-          </a:effectRef>
-          <a:fontRef idx="minor">
-            <a:schemeClr val="lt1"/>
-          </a:fontRef>
-        </p:style>
-        <p:txBody>
-          <a:bodyPr rtlCol="0" anchor="ctr"/>
-          <a:lstStyle/>
-          <a:p>
-            <a:pPr algn="ctr"/>
-          </a:p>
-        </p:txBody>
-      </p:sp>
-      <p:sp>
-        <p:nvSpPr>
-          <p:cNvPr id="6" name="Rectangle 5"/>
-          <p:cNvSpPr/>
-          <p:nvPr/>
-        </p:nvSpPr>
-        <p:spPr>
-          <a:xfrm>
-            <a:off x="685800" y="502920"/>
-            <a:ext cx="36576" cy="658368"/>
+            <a:off x="685800" y="2788920"/>
+            <a:ext cx="548640" cy="38100"/>
           </a:xfrm>
           <a:prstGeom prst="rect">
             <a:avLst/>
@@ -4823,14 +5178,14 @@
       </p:sp>
       <p:sp>
         <p:nvSpPr>
-          <p:cNvPr id="7" name="TextBox 6"/>
+          <p:cNvPr id="5" name="TextBox 4"/>
           <p:cNvSpPr txBox="1"/>
           <p:nvPr/>
         </p:nvSpPr>
         <p:spPr>
           <a:xfrm>
-            <a:off x="813816" y="502920"/>
-            <a:ext cx="10634472" cy="685800"/>
+            <a:off x="685800" y="3017520"/>
+            <a:ext cx="10817352" cy="1463040"/>
           </a:xfrm>
           <a:prstGeom prst="rect">
             <a:avLst/>
@@ -4845,27 +5200,27 @@
           <a:p>
             <a:pPr algn="l"/>
             <a:r>
-              <a:rPr sz="2400" b="1" i="0">
-                <a:solidFill>
-                  <a:srgbClr val="1F2C56"/>
+              <a:rPr sz="4000" b="1" i="0">
+                <a:solidFill>
+                  <a:srgbClr val="FFFFFF"/>
                 </a:solidFill>
                 <a:latin typeface="Arial"/>
               </a:rPr>
-              <a:t>Merk- und Haltungskarte: Der Rollenwechsel in fünf Sätzen</a:t>
-            </a:r>
-          </a:p>
-        </p:txBody>
-      </p:sp>
-      <p:sp>
-        <p:nvSpPr>
-          <p:cNvPr id="8" name="TextBox 7"/>
+              <a:t>AB-1: Mein Rollenwechsel – Standortbestimmung</a:t>
+            </a:r>
+          </a:p>
+        </p:txBody>
+      </p:sp>
+      <p:sp>
+        <p:nvSpPr>
+          <p:cNvPr id="6" name="TextBox 5"/>
           <p:cNvSpPr txBox="1"/>
           <p:nvPr/>
         </p:nvSpPr>
         <p:spPr>
           <a:xfrm>
-            <a:off x="685800" y="1417320"/>
-            <a:ext cx="10817352" cy="4892040"/>
+            <a:off x="685800" y="4480560"/>
+            <a:ext cx="8653881" cy="1280160"/>
           </a:xfrm>
           <a:prstGeom prst="rect">
             <a:avLst/>
@@ -4878,269 +5233,29 @@
           </a:bodyPr>
           <a:lstStyle/>
           <a:p>
-            <a:pPr>
-              <a:spcBef>
-                <a:spcPts val="400"/>
-              </a:spcBef>
-              <a:spcAft>
-                <a:spcPts val="200"/>
-              </a:spcAft>
-            </a:pPr>
-            <a:r>
-              <a:rPr sz="1200">
-                <a:solidFill>
-                  <a:srgbClr val="3D5466"/>
+            <a:pPr algn="l"/>
+            <a:r>
+              <a:rPr sz="1600" b="0" i="0">
+                <a:solidFill>
+                  <a:srgbClr val="C8D2E6"/>
                 </a:solidFill>
                 <a:latin typeface="Arial"/>
               </a:rPr>
-              <a:t>Diese Karte fasst die fünf wichtigsten Haltungsanker des Rollenwechsels zusammen. Nehmen Sie sie mit – und legen Sie sie sich in zwei Wochen wieder vor.</a:t>
-            </a:r>
-          </a:p>
-          <a:p>
-            <a:pPr>
-              <a:spcBef>
-                <a:spcPts val="400"/>
-              </a:spcBef>
-              <a:spcAft>
-                <a:spcPts val="200"/>
-              </a:spcAft>
-            </a:pPr>
-            <a:r>
-              <a:rPr sz="1200">
-                <a:solidFill>
-                  <a:srgbClr val="3D5466"/>
-                </a:solidFill>
-                <a:latin typeface="Arial"/>
-              </a:rPr>
-              <a:t>1. Mein Erfolg findet jetzt im Team statt.</a:t>
-            </a:r>
-          </a:p>
-          <a:p>
-            <a:pPr>
-              <a:spcBef>
-                <a:spcPts val="400"/>
-              </a:spcBef>
-              <a:spcAft>
-                <a:spcPts val="200"/>
-              </a:spcAft>
-            </a:pPr>
-            <a:r>
-              <a:rPr sz="1200">
-                <a:solidFill>
-                  <a:srgbClr val="3D5466"/>
-                </a:solidFill>
-                <a:latin typeface="Arial"/>
-              </a:rPr>
-              <a:t>Was ich selbst erreiche, zählt. Was mein Team erreicht, zählt mehr. Beides addiert sich – aber nur das zweite skaliert.</a:t>
-            </a:r>
-          </a:p>
-          <a:p>
-            <a:pPr>
-              <a:spcBef>
-                <a:spcPts val="400"/>
-              </a:spcBef>
-              <a:spcAft>
-                <a:spcPts val="200"/>
-              </a:spcAft>
-            </a:pPr>
-            <a:r>
-              <a:rPr sz="1200">
-                <a:solidFill>
-                  <a:srgbClr val="3D5466"/>
-                </a:solidFill>
-                <a:latin typeface="Arial"/>
-              </a:rPr>
-              <a:t>2. Autorität entsteht durch Vertrauen, nicht durch Fachkompetenz.</a:t>
-            </a:r>
-          </a:p>
-          <a:p>
-            <a:pPr>
-              <a:spcBef>
-                <a:spcPts val="400"/>
-              </a:spcBef>
-              <a:spcAft>
-                <a:spcPts val="200"/>
-              </a:spcAft>
-            </a:pPr>
-            <a:r>
-              <a:rPr sz="1200">
-                <a:solidFill>
-                  <a:srgbClr val="3D5466"/>
-                </a:solidFill>
-                <a:latin typeface="Arial"/>
-              </a:rPr>
-              <a:t>Ich muss nicht mehr der Beste in jedem Kreditthema sein. Ich muss derjenige sein, dem das Team zutraut, es zu unterstützen, fair zu behandeln und zu vertreten.</a:t>
-            </a:r>
-          </a:p>
-          <a:p>
-            <a:pPr>
-              <a:spcBef>
-                <a:spcPts val="400"/>
-              </a:spcBef>
-              <a:spcAft>
-                <a:spcPts val="200"/>
-              </a:spcAft>
-            </a:pPr>
-            <a:r>
-              <a:rPr sz="1200">
-                <a:solidFill>
-                  <a:srgbClr val="3D5466"/>
-                </a:solidFill>
-                <a:latin typeface="Arial"/>
-              </a:rPr>
-              <a:t>3. Führung heißt: Bedingungen schaffen, nicht Lösungen liefern.</a:t>
-            </a:r>
-          </a:p>
-          <a:p>
-            <a:pPr>
-              <a:spcBef>
-                <a:spcPts val="400"/>
-              </a:spcBef>
-              <a:spcAft>
-                <a:spcPts val="200"/>
-              </a:spcAft>
-            </a:pPr>
-            <a:r>
-              <a:rPr sz="1200">
-                <a:solidFill>
-                  <a:srgbClr val="3D5466"/>
-                </a:solidFill>
-                <a:latin typeface="Arial"/>
-              </a:rPr>
-              <a:t>Wenn jemand aus meinem Team ein Problem bringt, ist meine erste Frage: „Was haben Sie schon überlegt?" – nicht: „Ich sehe das so."</a:t>
-            </a:r>
-          </a:p>
-          <a:p>
-            <a:pPr>
-              <a:spcBef>
-                <a:spcPts val="400"/>
-              </a:spcBef>
-              <a:spcAft>
-                <a:spcPts val="200"/>
-              </a:spcAft>
-            </a:pPr>
-            <a:r>
-              <a:rPr sz="1200">
-                <a:solidFill>
-                  <a:srgbClr val="3D5466"/>
-                </a:solidFill>
-                <a:latin typeface="Arial"/>
-              </a:rPr>
-              <a:t>4. Ehemalige Kollegen sind jetzt Mitarbeitende. Das ist kein Verrat – das ist Klarheit.</a:t>
-            </a:r>
-          </a:p>
-          <a:p>
-            <a:pPr>
-              <a:spcBef>
-                <a:spcPts val="400"/>
-              </a:spcBef>
-              <a:spcAft>
-                <a:spcPts val="200"/>
-              </a:spcAft>
-            </a:pPr>
-            <a:r>
-              <a:rPr sz="1200">
-                <a:solidFill>
-                  <a:srgbClr val="3D5466"/>
-                </a:solidFill>
-                <a:latin typeface="Arial"/>
-              </a:rPr>
-              <a:t>Die neue Rollenklarheit schützt beide Seiten. Ich kann und soll partnerschaftlich führen – aber die Verantwortung liegt jetzt bei mir.</a:t>
-            </a:r>
-          </a:p>
-          <a:p>
-            <a:pPr>
-              <a:spcBef>
-                <a:spcPts val="400"/>
-              </a:spcBef>
-              <a:spcAft>
-                <a:spcPts val="200"/>
-              </a:spcAft>
-            </a:pPr>
-            <a:r>
-              <a:rPr sz="1200">
-                <a:solidFill>
-                  <a:srgbClr val="3D5466"/>
-                </a:solidFill>
-                <a:latin typeface="Arial"/>
-              </a:rPr>
-              <a:t>5. Servant Leadership bedeutet: Wachstum als Führungsmaßstab.</a:t>
-            </a:r>
-          </a:p>
-          <a:p>
-            <a:pPr>
-              <a:spcBef>
-                <a:spcPts val="400"/>
-              </a:spcBef>
-              <a:spcAft>
-                <a:spcPts val="200"/>
-              </a:spcAft>
-            </a:pPr>
-            <a:r>
-              <a:rPr sz="1200">
-                <a:solidFill>
-                  <a:srgbClr val="3D5466"/>
-                </a:solidFill>
-                <a:latin typeface="Arial"/>
-              </a:rPr>
-              <a:t>Mein Maßstab ist nicht: Wie viel habe ich heute geleistet? Sondern: Was konnte mein Team heute mehr, als es gestern konnte?</a:t>
-            </a:r>
-          </a:p>
-        </p:txBody>
-      </p:sp>
-      <p:sp>
-        <p:nvSpPr>
-          <p:cNvPr id="9" name="Rectangle 8"/>
-          <p:cNvSpPr/>
-          <p:nvPr/>
-        </p:nvSpPr>
-        <p:spPr>
-          <a:xfrm>
-            <a:off x="0" y="6510528"/>
-            <a:ext cx="12188952" cy="347472"/>
-          </a:xfrm>
-          <a:prstGeom prst="rect">
-            <a:avLst/>
-          </a:prstGeom>
-          <a:solidFill>
-            <a:srgbClr val="0A1937"/>
-          </a:solidFill>
-          <a:ln>
-            <a:noFill/>
-          </a:ln>
-        </p:spPr>
-        <p:style>
-          <a:lnRef idx="1">
-            <a:schemeClr val="accent1"/>
-          </a:lnRef>
-          <a:fillRef idx="3">
-            <a:schemeClr val="accent1"/>
-          </a:fillRef>
-          <a:effectRef idx="2">
-            <a:schemeClr val="accent1"/>
-          </a:effectRef>
-          <a:fontRef idx="minor">
-            <a:schemeClr val="lt1"/>
-          </a:fontRef>
-        </p:style>
-        <p:txBody>
-          <a:bodyPr rtlCol="0" anchor="ctr"/>
-          <a:lstStyle/>
-          <a:p>
-            <a:pPr algn="ctr"/>
-          </a:p>
-        </p:txBody>
-      </p:sp>
-      <p:sp>
-        <p:nvSpPr>
-          <p:cNvPr id="10" name="TextBox 9"/>
+              <a:t>Eigenen Stand im Rollenwechsel klären – Stärken, Rollenfallen, erste Schritte</a:t>
+            </a:r>
+          </a:p>
+        </p:txBody>
+      </p:sp>
+      <p:sp>
+        <p:nvSpPr>
+          <p:cNvPr id="7" name="TextBox 6"/>
           <p:cNvSpPr txBox="1"/>
           <p:nvPr/>
         </p:nvSpPr>
         <p:spPr>
           <a:xfrm>
-            <a:off x="685800" y="6583680"/>
-            <a:ext cx="6490411" cy="256032"/>
+            <a:off x="685800" y="6355080"/>
+            <a:ext cx="10817352" cy="274320"/>
           </a:xfrm>
           <a:prstGeom prst="rect">
             <a:avLst/>
@@ -5157,7 +5272,7 @@
             <a:r>
               <a:rPr sz="700">
                 <a:solidFill>
-                  <a:srgbClr val="A0B4D2"/>
+                  <a:srgbClr val="8CA0C3"/>
                 </a:solidFill>
                 <a:latin typeface="Consolas"/>
               </a:rPr>
@@ -5300,7 +5415,7 @@
                 </a:solidFill>
                 <a:latin typeface="Consolas"/>
               </a:rPr>
-              <a:t>TL00  ·  INHALT</a:t>
+              <a:t>TL00  ·  ARBEITSBLATT</a:t>
             </a:r>
           </a:p>
         </p:txBody>
@@ -5421,7 +5536,7 @@
                 </a:solidFill>
                 <a:latin typeface="Arial"/>
               </a:rPr>
-              <a:t>Checkliste: Bin ich in der Führungsrolle angekommen?</a:t>
+              <a:t>Jede Stärke, die Sie zur Führungskraft machte, kann Sie dort bremsen</a:t>
             </a:r>
           </a:p>
         </p:txBody>
@@ -5434,8 +5549,8 @@
         </p:nvSpPr>
         <p:spPr>
           <a:xfrm>
-            <a:off x="685800" y="1417320"/>
-            <a:ext cx="10817352" cy="4892040"/>
+            <a:off x="685800" y="1554480"/>
+            <a:ext cx="10817352" cy="3840480"/>
           </a:xfrm>
           <a:prstGeom prst="rect">
             <a:avLst/>
@@ -5443,12 +5558,12 @@
           <a:noFill/>
         </p:spPr>
         <p:txBody>
-          <a:bodyPr wrap="square" anchor="ctr">
+          <a:bodyPr wrap="square">
             <a:spAutoFit/>
           </a:bodyPr>
           <a:lstStyle/>
           <a:p>
-            <a:pPr>
+            <a:pPr marL="190500" indent="-190500">
               <a:spcBef>
                 <a:spcPts val="400"/>
               </a:spcBef>
@@ -5457,13 +5572,51 @@
               </a:spcAft>
             </a:pPr>
             <a:r>
-              <a:rPr sz="1200">
+              <a:rPr sz="1400">
                 <a:solidFill>
                   <a:srgbClr val="3D5466"/>
                 </a:solidFill>
                 <a:latin typeface="Arial"/>
               </a:rPr>
-              <a:t>Beantworten Sie diese Fragen ehrlich – nach dem heutigen Workshop und erneut nach vier Wochen.</a:t>
+              <a:t>▸  AB-1 Teil 1: Drei Stärken als Berater benennen</a:t>
+            </a:r>
+          </a:p>
+          <a:p>
+            <a:pPr marL="190500" indent="-190500">
+              <a:spcBef>
+                <a:spcPts val="400"/>
+              </a:spcBef>
+              <a:spcAft>
+                <a:spcPts val="200"/>
+              </a:spcAft>
+            </a:pPr>
+            <a:r>
+              <a:rPr sz="1400">
+                <a:solidFill>
+                  <a:srgbClr val="3D5466"/>
+                </a:solidFill>
+                <a:latin typeface="Arial"/>
+              </a:rPr>
+              <a:t>▸  AB-1 Teil 4: Rollenfalle identifizieren – Facheingriff, Kollegenbehandlung oder Eigenoutput-Messung?</a:t>
+            </a:r>
+          </a:p>
+          <a:p>
+            <a:pPr marL="190500" indent="-190500">
+              <a:spcBef>
+                <a:spcPts val="400"/>
+              </a:spcBef>
+              <a:spcAft>
+                <a:spcPts val="200"/>
+              </a:spcAft>
+            </a:pPr>
+            <a:r>
+              <a:rPr sz="1400">
+                <a:solidFill>
+                  <a:srgbClr val="3D5466"/>
+                </a:solidFill>
+                <a:latin typeface="Arial"/>
+              </a:rPr>
+              <a:t>▸  Paarreflexion: „Welche Rollenfalle fühlt sich bei dir am naheliegendsten an?“</a:t>
             </a:r>
           </a:p>
         </p:txBody>
@@ -5471,6 +5624,84 @@
       <p:sp>
         <p:nvSpPr>
           <p:cNvPr id="9" name="Rectangle 8"/>
+          <p:cNvSpPr/>
+          <p:nvPr/>
+        </p:nvSpPr>
+        <p:spPr>
+          <a:xfrm>
+            <a:off x="685800" y="5486400"/>
+            <a:ext cx="10817352" cy="640080"/>
+          </a:xfrm>
+          <a:prstGeom prst="rect">
+            <a:avLst/>
+          </a:prstGeom>
+          <a:solidFill>
+            <a:srgbClr val="1F2C56"/>
+          </a:solidFill>
+          <a:ln>
+            <a:noFill/>
+          </a:ln>
+        </p:spPr>
+        <p:style>
+          <a:lnRef idx="1">
+            <a:schemeClr val="accent1"/>
+          </a:lnRef>
+          <a:fillRef idx="3">
+            <a:schemeClr val="accent1"/>
+          </a:fillRef>
+          <a:effectRef idx="2">
+            <a:schemeClr val="accent1"/>
+          </a:effectRef>
+          <a:fontRef idx="minor">
+            <a:schemeClr val="lt1"/>
+          </a:fontRef>
+        </p:style>
+        <p:txBody>
+          <a:bodyPr rtlCol="0" anchor="ctr"/>
+          <a:lstStyle/>
+          <a:p>
+            <a:pPr algn="ctr"/>
+          </a:p>
+        </p:txBody>
+      </p:sp>
+      <p:sp>
+        <p:nvSpPr>
+          <p:cNvPr id="10" name="TextBox 9"/>
+          <p:cNvSpPr txBox="1"/>
+          <p:nvPr/>
+        </p:nvSpPr>
+        <p:spPr>
+          <a:xfrm>
+            <a:off x="868680" y="5596128"/>
+            <a:ext cx="10451592" cy="457200"/>
+          </a:xfrm>
+          <a:prstGeom prst="rect">
+            <a:avLst/>
+          </a:prstGeom>
+          <a:noFill/>
+        </p:spPr>
+        <p:txBody>
+          <a:bodyPr wrap="square">
+            <a:spAutoFit/>
+          </a:bodyPr>
+          <a:lstStyle/>
+          <a:p>
+            <a:pPr algn="l"/>
+            <a:r>
+              <a:rPr sz="1300" b="1" i="0">
+                <a:solidFill>
+                  <a:srgbClr val="FFFFFF"/>
+                </a:solidFill>
+                <a:latin typeface="Arial"/>
+              </a:rPr>
+              <a:t>→  Bearbeitung im Teilnehmer-Workbook (Arbeitsblatt mit Ausfüllfeldern)</a:t>
+            </a:r>
+          </a:p>
+        </p:txBody>
+      </p:sp>
+      <p:sp>
+        <p:nvSpPr>
+          <p:cNvPr id="11" name="Rectangle 10"/>
           <p:cNvSpPr/>
           <p:nvPr/>
         </p:nvSpPr>
@@ -5513,7 +5744,7 @@
       </p:sp>
       <p:sp>
         <p:nvSpPr>
-          <p:cNvPr id="10" name="TextBox 9"/>
+          <p:cNvPr id="12" name="TextBox 11"/>
           <p:cNvSpPr txBox="1"/>
           <p:nvPr/>
         </p:nvSpPr>
@@ -5801,7 +6032,1562 @@
                 </a:solidFill>
                 <a:latin typeface="Arial"/>
               </a:rPr>
-              <a:t>Reflexionsfragen</a:t>
+              <a:t>Führen, um andere besser zu machen</a:t>
+            </a:r>
+          </a:p>
+        </p:txBody>
+      </p:sp>
+      <p:sp>
+        <p:nvSpPr>
+          <p:cNvPr id="8" name="Rectangle 7"/>
+          <p:cNvSpPr/>
+          <p:nvPr/>
+        </p:nvSpPr>
+        <p:spPr>
+          <a:xfrm>
+            <a:off x="0" y="6510528"/>
+            <a:ext cx="12188952" cy="347472"/>
+          </a:xfrm>
+          <a:prstGeom prst="rect">
+            <a:avLst/>
+          </a:prstGeom>
+          <a:solidFill>
+            <a:srgbClr val="0A1937"/>
+          </a:solidFill>
+          <a:ln>
+            <a:noFill/>
+          </a:ln>
+        </p:spPr>
+        <p:style>
+          <a:lnRef idx="1">
+            <a:schemeClr val="accent1"/>
+          </a:lnRef>
+          <a:fillRef idx="3">
+            <a:schemeClr val="accent1"/>
+          </a:fillRef>
+          <a:effectRef idx="2">
+            <a:schemeClr val="accent1"/>
+          </a:effectRef>
+          <a:fontRef idx="minor">
+            <a:schemeClr val="lt1"/>
+          </a:fontRef>
+        </p:style>
+        <p:txBody>
+          <a:bodyPr rtlCol="0" anchor="ctr"/>
+          <a:lstStyle/>
+          <a:p>
+            <a:pPr algn="ctr"/>
+          </a:p>
+        </p:txBody>
+      </p:sp>
+      <p:sp>
+        <p:nvSpPr>
+          <p:cNvPr id="9" name="TextBox 8"/>
+          <p:cNvSpPr txBox="1"/>
+          <p:nvPr/>
+        </p:nvSpPr>
+        <p:spPr>
+          <a:xfrm>
+            <a:off x="685800" y="6583680"/>
+            <a:ext cx="6490411" cy="256032"/>
+          </a:xfrm>
+          <a:prstGeom prst="rect">
+            <a:avLst/>
+          </a:prstGeom>
+          <a:noFill/>
+        </p:spPr>
+        <p:txBody>
+          <a:bodyPr wrap="none">
+            <a:spAutoFit/>
+          </a:bodyPr>
+          <a:lstStyle/>
+          <a:p>
+            <a:pPr algn="l"/>
+            <a:r>
+              <a:rPr sz="700">
+                <a:solidFill>
+                  <a:srgbClr val="A0B4D2"/>
+                </a:solidFill>
+                <a:latin typeface="Consolas"/>
+              </a:rPr>
+              <a:t>FKB Campus  ·  TL00</a:t>
+            </a:r>
+          </a:p>
+        </p:txBody>
+      </p:sp>
+    </p:spTree>
+  </p:cSld>
+  <p:clrMapOvr>
+    <a:masterClrMapping/>
+  </p:clrMapOvr>
+</p:sld>
+</file>
+
+<file path=ppt/slides/slide13.xml><?xml version="1.0" encoding="utf-8"?>
+<p:sld xmlns:a="http://schemas.openxmlformats.org/drawingml/2006/main" xmlns:p="http://schemas.openxmlformats.org/presentationml/2006/main" xmlns:r="http://schemas.openxmlformats.org/officeDocument/2006/relationships">
+  <p:cSld>
+    <p:spTree>
+      <p:nvGrpSpPr>
+        <p:cNvPr id="1" name=""/>
+        <p:cNvGrpSpPr/>
+        <p:nvPr/>
+      </p:nvGrpSpPr>
+      <p:grpSpPr/>
+      <p:sp>
+        <p:nvSpPr>
+          <p:cNvPr id="2" name="Rectangle 1"/>
+          <p:cNvSpPr/>
+          <p:nvPr/>
+        </p:nvSpPr>
+        <p:spPr>
+          <a:xfrm>
+            <a:off x="0" y="0"/>
+            <a:ext cx="12188952" cy="6858000"/>
+          </a:xfrm>
+          <a:prstGeom prst="rect">
+            <a:avLst/>
+          </a:prstGeom>
+          <a:solidFill>
+            <a:srgbClr val="1F2C56"/>
+          </a:solidFill>
+          <a:ln>
+            <a:noFill/>
+          </a:ln>
+        </p:spPr>
+        <p:style>
+          <a:lnRef idx="1">
+            <a:schemeClr val="accent1"/>
+          </a:lnRef>
+          <a:fillRef idx="3">
+            <a:schemeClr val="accent1"/>
+          </a:fillRef>
+          <a:effectRef idx="2">
+            <a:schemeClr val="accent1"/>
+          </a:effectRef>
+          <a:fontRef idx="minor">
+            <a:schemeClr val="lt1"/>
+          </a:fontRef>
+        </p:style>
+        <p:txBody>
+          <a:bodyPr rtlCol="0" anchor="ctr"/>
+          <a:lstStyle/>
+          <a:p>
+            <a:pPr algn="ctr"/>
+          </a:p>
+        </p:txBody>
+      </p:sp>
+      <p:sp>
+        <p:nvSpPr>
+          <p:cNvPr id="3" name="TextBox 2"/>
+          <p:cNvSpPr txBox="1"/>
+          <p:nvPr/>
+        </p:nvSpPr>
+        <p:spPr>
+          <a:xfrm>
+            <a:off x="685800" y="2377440"/>
+            <a:ext cx="10817352" cy="365760"/>
+          </a:xfrm>
+          <a:prstGeom prst="rect">
+            <a:avLst/>
+          </a:prstGeom>
+          <a:noFill/>
+        </p:spPr>
+        <p:txBody>
+          <a:bodyPr wrap="none">
+            <a:spAutoFit/>
+          </a:bodyPr>
+          <a:lstStyle/>
+          <a:p>
+            <a:pPr algn="l"/>
+            <a:r>
+              <a:rPr sz="1200">
+                <a:solidFill>
+                  <a:srgbClr val="D9C089"/>
+                </a:solidFill>
+                <a:latin typeface="Consolas"/>
+              </a:rPr>
+              <a:t>GRUPPENARBEIT (15 MIN.) + PLENUMSAUSWERTUNG (15 MIN.)</a:t>
+            </a:r>
+          </a:p>
+        </p:txBody>
+      </p:sp>
+      <p:sp>
+        <p:nvSpPr>
+          <p:cNvPr id="4" name="Rectangle 3"/>
+          <p:cNvSpPr/>
+          <p:nvPr/>
+        </p:nvSpPr>
+        <p:spPr>
+          <a:xfrm>
+            <a:off x="685800" y="2788920"/>
+            <a:ext cx="548640" cy="38100"/>
+          </a:xfrm>
+          <a:prstGeom prst="rect">
+            <a:avLst/>
+          </a:prstGeom>
+          <a:solidFill>
+            <a:srgbClr val="D9C089"/>
+          </a:solidFill>
+          <a:ln>
+            <a:noFill/>
+          </a:ln>
+        </p:spPr>
+        <p:style>
+          <a:lnRef idx="1">
+            <a:schemeClr val="accent1"/>
+          </a:lnRef>
+          <a:fillRef idx="3">
+            <a:schemeClr val="accent1"/>
+          </a:fillRef>
+          <a:effectRef idx="2">
+            <a:schemeClr val="accent1"/>
+          </a:effectRef>
+          <a:fontRef idx="minor">
+            <a:schemeClr val="lt1"/>
+          </a:fontRef>
+        </p:style>
+        <p:txBody>
+          <a:bodyPr rtlCol="0" anchor="ctr"/>
+          <a:lstStyle/>
+          <a:p>
+            <a:pPr algn="ctr"/>
+          </a:p>
+        </p:txBody>
+      </p:sp>
+      <p:sp>
+        <p:nvSpPr>
+          <p:cNvPr id="5" name="TextBox 4"/>
+          <p:cNvSpPr txBox="1"/>
+          <p:nvPr/>
+        </p:nvSpPr>
+        <p:spPr>
+          <a:xfrm>
+            <a:off x="685800" y="3017520"/>
+            <a:ext cx="10817352" cy="1463040"/>
+          </a:xfrm>
+          <a:prstGeom prst="rect">
+            <a:avLst/>
+          </a:prstGeom>
+          <a:noFill/>
+        </p:spPr>
+        <p:txBody>
+          <a:bodyPr wrap="square">
+            <a:spAutoFit/>
+          </a:bodyPr>
+          <a:lstStyle/>
+          <a:p>
+            <a:pPr algn="l"/>
+            <a:r>
+              <a:rPr sz="4000" b="1" i="0">
+                <a:solidFill>
+                  <a:srgbClr val="FFFFFF"/>
+                </a:solidFill>
+                <a:latin typeface="Arial"/>
+              </a:rPr>
+              <a:t>Praxisfall: Thomas K. – vier Monate als Teamleiter</a:t>
+            </a:r>
+          </a:p>
+        </p:txBody>
+      </p:sp>
+      <p:sp>
+        <p:nvSpPr>
+          <p:cNvPr id="6" name="TextBox 5"/>
+          <p:cNvSpPr txBox="1"/>
+          <p:nvPr/>
+        </p:nvSpPr>
+        <p:spPr>
+          <a:xfrm>
+            <a:off x="685800" y="4480560"/>
+            <a:ext cx="8653881" cy="1280160"/>
+          </a:xfrm>
+          <a:prstGeom prst="rect">
+            <a:avLst/>
+          </a:prstGeom>
+          <a:noFill/>
+        </p:spPr>
+        <p:txBody>
+          <a:bodyPr wrap="square">
+            <a:spAutoFit/>
+          </a:bodyPr>
+          <a:lstStyle/>
+          <a:p>
+            <a:pPr algn="l"/>
+            <a:r>
+              <a:rPr sz="1600" b="0" i="0">
+                <a:solidFill>
+                  <a:srgbClr val="C8D2E6"/>
+                </a:solidFill>
+                <a:latin typeface="Arial"/>
+              </a:rPr>
+              <a:t>Rollenfallen und Führungshandlungen an vier konkreten Situationen durchdenken</a:t>
+            </a:r>
+          </a:p>
+        </p:txBody>
+      </p:sp>
+      <p:sp>
+        <p:nvSpPr>
+          <p:cNvPr id="7" name="TextBox 6"/>
+          <p:cNvSpPr txBox="1"/>
+          <p:nvPr/>
+        </p:nvSpPr>
+        <p:spPr>
+          <a:xfrm>
+            <a:off x="685800" y="6355080"/>
+            <a:ext cx="10817352" cy="274320"/>
+          </a:xfrm>
+          <a:prstGeom prst="rect">
+            <a:avLst/>
+          </a:prstGeom>
+          <a:noFill/>
+        </p:spPr>
+        <p:txBody>
+          <a:bodyPr wrap="none">
+            <a:spAutoFit/>
+          </a:bodyPr>
+          <a:lstStyle/>
+          <a:p>
+            <a:pPr algn="l"/>
+            <a:r>
+              <a:rPr sz="700">
+                <a:solidFill>
+                  <a:srgbClr val="8CA0C3"/>
+                </a:solidFill>
+                <a:latin typeface="Consolas"/>
+              </a:rPr>
+              <a:t>FKB Campus  ·  TL00</a:t>
+            </a:r>
+          </a:p>
+        </p:txBody>
+      </p:sp>
+    </p:spTree>
+  </p:cSld>
+  <p:clrMapOvr>
+    <a:masterClrMapping/>
+  </p:clrMapOvr>
+</p:sld>
+</file>
+
+<file path=ppt/slides/slide14.xml><?xml version="1.0" encoding="utf-8"?>
+<p:sld xmlns:a="http://schemas.openxmlformats.org/drawingml/2006/main" xmlns:p="http://schemas.openxmlformats.org/presentationml/2006/main" xmlns:r="http://schemas.openxmlformats.org/officeDocument/2006/relationships">
+  <p:cSld>
+    <p:spTree>
+      <p:nvGrpSpPr>
+        <p:cNvPr id="1" name=""/>
+        <p:cNvGrpSpPr/>
+        <p:nvPr/>
+      </p:nvGrpSpPr>
+      <p:grpSpPr/>
+      <p:sp>
+        <p:nvSpPr>
+          <p:cNvPr id="2" name="Rectangle 1"/>
+          <p:cNvSpPr/>
+          <p:nvPr/>
+        </p:nvSpPr>
+        <p:spPr>
+          <a:xfrm>
+            <a:off x="0" y="0"/>
+            <a:ext cx="12188952" cy="6858000"/>
+          </a:xfrm>
+          <a:prstGeom prst="rect">
+            <a:avLst/>
+          </a:prstGeom>
+          <a:solidFill>
+            <a:srgbClr val="1F2C56"/>
+          </a:solidFill>
+          <a:ln>
+            <a:noFill/>
+          </a:ln>
+        </p:spPr>
+        <p:style>
+          <a:lnRef idx="1">
+            <a:schemeClr val="accent1"/>
+          </a:lnRef>
+          <a:fillRef idx="3">
+            <a:schemeClr val="accent1"/>
+          </a:fillRef>
+          <a:effectRef idx="2">
+            <a:schemeClr val="accent1"/>
+          </a:effectRef>
+          <a:fontRef idx="minor">
+            <a:schemeClr val="lt1"/>
+          </a:fontRef>
+        </p:style>
+        <p:txBody>
+          <a:bodyPr rtlCol="0" anchor="ctr"/>
+          <a:lstStyle/>
+          <a:p>
+            <a:pPr algn="ctr"/>
+          </a:p>
+        </p:txBody>
+      </p:sp>
+      <p:sp>
+        <p:nvSpPr>
+          <p:cNvPr id="3" name="TextBox 2"/>
+          <p:cNvSpPr txBox="1"/>
+          <p:nvPr/>
+        </p:nvSpPr>
+        <p:spPr>
+          <a:xfrm>
+            <a:off x="685800" y="2377440"/>
+            <a:ext cx="10817352" cy="365760"/>
+          </a:xfrm>
+          <a:prstGeom prst="rect">
+            <a:avLst/>
+          </a:prstGeom>
+          <a:noFill/>
+        </p:spPr>
+        <p:txBody>
+          <a:bodyPr wrap="none">
+            <a:spAutoFit/>
+          </a:bodyPr>
+          <a:lstStyle/>
+          <a:p>
+            <a:pPr algn="l"/>
+            <a:r>
+              <a:rPr sz="1200">
+                <a:solidFill>
+                  <a:srgbClr val="D9C089"/>
+                </a:solidFill>
+                <a:latin typeface="Consolas"/>
+              </a:rPr>
+              <a:t>KERNBLOCK 40 MIN. (FALLVORSTELLUNG-RUNDE 8–10 MIN. + VERTIEFUNGSFALL 30 MIN.)</a:t>
+            </a:r>
+          </a:p>
+        </p:txBody>
+      </p:sp>
+      <p:sp>
+        <p:nvSpPr>
+          <p:cNvPr id="4" name="Rectangle 3"/>
+          <p:cNvSpPr/>
+          <p:nvPr/>
+        </p:nvSpPr>
+        <p:spPr>
+          <a:xfrm>
+            <a:off x="685800" y="2788920"/>
+            <a:ext cx="548640" cy="38100"/>
+          </a:xfrm>
+          <a:prstGeom prst="rect">
+            <a:avLst/>
+          </a:prstGeom>
+          <a:solidFill>
+            <a:srgbClr val="D9C089"/>
+          </a:solidFill>
+          <a:ln>
+            <a:noFill/>
+          </a:ln>
+        </p:spPr>
+        <p:style>
+          <a:lnRef idx="1">
+            <a:schemeClr val="accent1"/>
+          </a:lnRef>
+          <a:fillRef idx="3">
+            <a:schemeClr val="accent1"/>
+          </a:fillRef>
+          <a:effectRef idx="2">
+            <a:schemeClr val="accent1"/>
+          </a:effectRef>
+          <a:fontRef idx="minor">
+            <a:schemeClr val="lt1"/>
+          </a:fontRef>
+        </p:style>
+        <p:txBody>
+          <a:bodyPr rtlCol="0" anchor="ctr"/>
+          <a:lstStyle/>
+          <a:p>
+            <a:pPr algn="ctr"/>
+          </a:p>
+        </p:txBody>
+      </p:sp>
+      <p:sp>
+        <p:nvSpPr>
+          <p:cNvPr id="5" name="TextBox 4"/>
+          <p:cNvSpPr txBox="1"/>
+          <p:nvPr/>
+        </p:nvSpPr>
+        <p:spPr>
+          <a:xfrm>
+            <a:off x="685800" y="3017520"/>
+            <a:ext cx="10817352" cy="1463040"/>
+          </a:xfrm>
+          <a:prstGeom prst="rect">
+            <a:avLst/>
+          </a:prstGeom>
+          <a:noFill/>
+        </p:spPr>
+        <p:txBody>
+          <a:bodyPr wrap="square">
+            <a:spAutoFit/>
+          </a:bodyPr>
+          <a:lstStyle/>
+          <a:p>
+            <a:pPr algn="l"/>
+            <a:r>
+              <a:rPr sz="4000" b="1" i="0">
+                <a:solidFill>
+                  <a:srgbClr val="FFFFFF"/>
+                </a:solidFill>
+                <a:latin typeface="Arial"/>
+              </a:rPr>
+              <a:t>Kollegiale Fallberatung</a:t>
+            </a:r>
+          </a:p>
+        </p:txBody>
+      </p:sp>
+      <p:sp>
+        <p:nvSpPr>
+          <p:cNvPr id="6" name="TextBox 5"/>
+          <p:cNvSpPr txBox="1"/>
+          <p:nvPr/>
+        </p:nvSpPr>
+        <p:spPr>
+          <a:xfrm>
+            <a:off x="685800" y="4480560"/>
+            <a:ext cx="8653881" cy="1280160"/>
+          </a:xfrm>
+          <a:prstGeom prst="rect">
+            <a:avLst/>
+          </a:prstGeom>
+          <a:noFill/>
+        </p:spPr>
+        <p:txBody>
+          <a:bodyPr wrap="square">
+            <a:spAutoFit/>
+          </a:bodyPr>
+          <a:lstStyle/>
+          <a:p>
+            <a:pPr algn="l"/>
+            <a:r>
+              <a:rPr sz="1600" b="0" i="0">
+                <a:solidFill>
+                  <a:srgbClr val="C8D2E6"/>
+                </a:solidFill>
+                <a:latin typeface="Arial"/>
+              </a:rPr>
+              <a:t>Einen realen Führungsfall aus der Gruppe nach dem Sechs-Schritte-Format bearbeiten</a:t>
+            </a:r>
+          </a:p>
+        </p:txBody>
+      </p:sp>
+      <p:sp>
+        <p:nvSpPr>
+          <p:cNvPr id="7" name="TextBox 6"/>
+          <p:cNvSpPr txBox="1"/>
+          <p:nvPr/>
+        </p:nvSpPr>
+        <p:spPr>
+          <a:xfrm>
+            <a:off x="685800" y="6355080"/>
+            <a:ext cx="10817352" cy="274320"/>
+          </a:xfrm>
+          <a:prstGeom prst="rect">
+            <a:avLst/>
+          </a:prstGeom>
+          <a:noFill/>
+        </p:spPr>
+        <p:txBody>
+          <a:bodyPr wrap="none">
+            <a:spAutoFit/>
+          </a:bodyPr>
+          <a:lstStyle/>
+          <a:p>
+            <a:pPr algn="l"/>
+            <a:r>
+              <a:rPr sz="700">
+                <a:solidFill>
+                  <a:srgbClr val="8CA0C3"/>
+                </a:solidFill>
+                <a:latin typeface="Consolas"/>
+              </a:rPr>
+              <a:t>FKB Campus  ·  TL00</a:t>
+            </a:r>
+          </a:p>
+        </p:txBody>
+      </p:sp>
+    </p:spTree>
+  </p:cSld>
+  <p:clrMapOvr>
+    <a:masterClrMapping/>
+  </p:clrMapOvr>
+</p:sld>
+</file>
+
+<file path=ppt/slides/slide15.xml><?xml version="1.0" encoding="utf-8"?>
+<p:sld xmlns:a="http://schemas.openxmlformats.org/drawingml/2006/main" xmlns:p="http://schemas.openxmlformats.org/presentationml/2006/main" xmlns:r="http://schemas.openxmlformats.org/officeDocument/2006/relationships">
+  <p:cSld>
+    <p:spTree>
+      <p:nvGrpSpPr>
+        <p:cNvPr id="1" name=""/>
+        <p:cNvGrpSpPr/>
+        <p:nvPr/>
+      </p:nvGrpSpPr>
+      <p:grpSpPr/>
+      <p:sp>
+        <p:nvSpPr>
+          <p:cNvPr id="2" name="Rectangle 1"/>
+          <p:cNvSpPr/>
+          <p:nvPr/>
+        </p:nvSpPr>
+        <p:spPr>
+          <a:xfrm>
+            <a:off x="0" y="0"/>
+            <a:ext cx="12188952" cy="6858000"/>
+          </a:xfrm>
+          <a:prstGeom prst="rect">
+            <a:avLst/>
+          </a:prstGeom>
+          <a:solidFill>
+            <a:srgbClr val="FFFFFF"/>
+          </a:solidFill>
+          <a:ln>
+            <a:noFill/>
+          </a:ln>
+        </p:spPr>
+        <p:style>
+          <a:lnRef idx="1">
+            <a:schemeClr val="accent1"/>
+          </a:lnRef>
+          <a:fillRef idx="3">
+            <a:schemeClr val="accent1"/>
+          </a:fillRef>
+          <a:effectRef idx="2">
+            <a:schemeClr val="accent1"/>
+          </a:effectRef>
+          <a:fontRef idx="minor">
+            <a:schemeClr val="lt1"/>
+          </a:fontRef>
+        </p:style>
+        <p:txBody>
+          <a:bodyPr rtlCol="0" anchor="ctr"/>
+          <a:lstStyle/>
+          <a:p>
+            <a:pPr algn="ctr"/>
+          </a:p>
+        </p:txBody>
+      </p:sp>
+      <p:sp>
+        <p:nvSpPr>
+          <p:cNvPr id="3" name="Rectangle 2"/>
+          <p:cNvSpPr/>
+          <p:nvPr/>
+        </p:nvSpPr>
+        <p:spPr>
+          <a:xfrm>
+            <a:off x="0" y="0"/>
+            <a:ext cx="12188952" cy="50292"/>
+          </a:xfrm>
+          <a:prstGeom prst="rect">
+            <a:avLst/>
+          </a:prstGeom>
+          <a:solidFill>
+            <a:srgbClr val="1F2C56"/>
+          </a:solidFill>
+          <a:ln>
+            <a:noFill/>
+          </a:ln>
+        </p:spPr>
+        <p:style>
+          <a:lnRef idx="1">
+            <a:schemeClr val="accent1"/>
+          </a:lnRef>
+          <a:fillRef idx="3">
+            <a:schemeClr val="accent1"/>
+          </a:fillRef>
+          <a:effectRef idx="2">
+            <a:schemeClr val="accent1"/>
+          </a:effectRef>
+          <a:fontRef idx="minor">
+            <a:schemeClr val="lt1"/>
+          </a:fontRef>
+        </p:style>
+        <p:txBody>
+          <a:bodyPr rtlCol="0" anchor="ctr"/>
+          <a:lstStyle/>
+          <a:p>
+            <a:pPr algn="ctr"/>
+          </a:p>
+        </p:txBody>
+      </p:sp>
+      <p:sp>
+        <p:nvSpPr>
+          <p:cNvPr id="4" name="TextBox 3"/>
+          <p:cNvSpPr txBox="1"/>
+          <p:nvPr/>
+        </p:nvSpPr>
+        <p:spPr>
+          <a:xfrm>
+            <a:off x="685800" y="109728"/>
+            <a:ext cx="10817352" cy="228600"/>
+          </a:xfrm>
+          <a:prstGeom prst="rect">
+            <a:avLst/>
+          </a:prstGeom>
+          <a:noFill/>
+        </p:spPr>
+        <p:txBody>
+          <a:bodyPr wrap="none">
+            <a:spAutoFit/>
+          </a:bodyPr>
+          <a:lstStyle/>
+          <a:p>
+            <a:pPr algn="l"/>
+            <a:r>
+              <a:rPr sz="750">
+                <a:solidFill>
+                  <a:srgbClr val="78808C"/>
+                </a:solidFill>
+                <a:latin typeface="Consolas"/>
+              </a:rPr>
+              <a:t>TL00  ·  ÜBERSICHT</a:t>
+            </a:r>
+          </a:p>
+        </p:txBody>
+      </p:sp>
+      <p:sp>
+        <p:nvSpPr>
+          <p:cNvPr id="5" name="TextBox 4"/>
+          <p:cNvSpPr txBox="1"/>
+          <p:nvPr/>
+        </p:nvSpPr>
+        <p:spPr>
+          <a:xfrm>
+            <a:off x="685800" y="502920"/>
+            <a:ext cx="10817352" cy="594360"/>
+          </a:xfrm>
+          <a:prstGeom prst="rect">
+            <a:avLst/>
+          </a:prstGeom>
+          <a:noFill/>
+        </p:spPr>
+        <p:txBody>
+          <a:bodyPr wrap="square">
+            <a:spAutoFit/>
+          </a:bodyPr>
+          <a:lstStyle/>
+          <a:p>
+            <a:pPr algn="l"/>
+            <a:r>
+              <a:rPr sz="2000" b="1" i="0">
+                <a:solidFill>
+                  <a:srgbClr val="1F2C56"/>
+                </a:solidFill>
+                <a:latin typeface="Arial"/>
+              </a:rPr>
+              <a:t>Sechs Schritte – Disziplin ist die Methode</a:t>
+            </a:r>
+          </a:p>
+        </p:txBody>
+      </p:sp>
+      <p:sp>
+        <p:nvSpPr>
+          <p:cNvPr id="6" name="Rectangle 5"/>
+          <p:cNvSpPr/>
+          <p:nvPr/>
+        </p:nvSpPr>
+        <p:spPr>
+          <a:xfrm>
+            <a:off x="685800" y="1143000"/>
+            <a:ext cx="10817352" cy="25400"/>
+          </a:xfrm>
+          <a:prstGeom prst="rect">
+            <a:avLst/>
+          </a:prstGeom>
+          <a:solidFill>
+            <a:srgbClr val="D9C089"/>
+          </a:solidFill>
+          <a:ln>
+            <a:noFill/>
+          </a:ln>
+        </p:spPr>
+        <p:style>
+          <a:lnRef idx="1">
+            <a:schemeClr val="accent1"/>
+          </a:lnRef>
+          <a:fillRef idx="3">
+            <a:schemeClr val="accent1"/>
+          </a:fillRef>
+          <a:effectRef idx="2">
+            <a:schemeClr val="accent1"/>
+          </a:effectRef>
+          <a:fontRef idx="minor">
+            <a:schemeClr val="lt1"/>
+          </a:fontRef>
+        </p:style>
+        <p:txBody>
+          <a:bodyPr rtlCol="0" anchor="ctr"/>
+          <a:lstStyle/>
+          <a:p>
+            <a:pPr algn="ctr"/>
+          </a:p>
+        </p:txBody>
+      </p:sp>
+      <p:graphicFrame>
+        <p:nvGraphicFramePr>
+          <p:cNvPr id="7" name="Table 6"/>
+          <p:cNvGraphicFramePr>
+            <a:graphicFrameLocks noGrp="1"/>
+          </p:cNvGraphicFramePr>
+          <p:nvPr/>
+        </p:nvGraphicFramePr>
+        <p:xfrm>
+          <a:off x="685800" y="1417320"/>
+          <a:ext cx="10817352" cy="2688336"/>
+        </p:xfrm>
+        <a:graphic>
+          <a:graphicData uri="http://schemas.openxmlformats.org/drawingml/2006/table">
+            <a:tbl>
+              <a:tblPr firstRow="1" bandRow="1">
+                <a:tableStyleId>{5C22544A-7EE6-4342-B048-85BDC9FD1C3A}</a:tableStyleId>
+              </a:tblPr>
+              <a:tblGrid>
+                <a:gridCol w="10817352"/>
+              </a:tblGrid>
+              <a:tr h="384048">
+                <a:tc>
+                  <a:txBody>
+                    <a:bodyPr/>
+                    <a:lstStyle/>
+                    <a:p/>
+                  </a:txBody>
+                  <a:tcPr/>
+                </a:tc>
+              </a:tr>
+              <a:tr h="384048">
+                <a:tc>
+                  <a:txBody>
+                    <a:bodyPr/>
+                    <a:lstStyle/>
+                    <a:p>
+                      <a:r>
+                        <a:rPr sz="1050">
+                          <a:solidFill>
+                            <a:srgbClr val="3D5466"/>
+                          </a:solidFill>
+                          <a:latin typeface="Arial"/>
+                        </a:rPr>
+                        <a:t>Schritt</a:t>
+                      </a:r>
+                    </a:p>
+                  </a:txBody>
+                  <a:tcPr/>
+                </a:tc>
+              </a:tr>
+              <a:tr h="384048">
+                <a:tc>
+                  <a:txBody>
+                    <a:bodyPr/>
+                    <a:lstStyle/>
+                    <a:p>
+                      <a:r>
+                        <a:rPr sz="1050">
+                          <a:solidFill>
+                            <a:srgbClr val="3D5466"/>
+                          </a:solidFill>
+                          <a:latin typeface="Arial"/>
+                        </a:rPr>
+                        <a:t>1 Fallschilderung</a:t>
+                      </a:r>
+                    </a:p>
+                  </a:txBody>
+                  <a:tcPr/>
+                </a:tc>
+              </a:tr>
+              <a:tr h="384048">
+                <a:tc>
+                  <a:txBody>
+                    <a:bodyPr/>
+                    <a:lstStyle/>
+                    <a:p>
+                      <a:r>
+                        <a:rPr sz="1050">
+                          <a:solidFill>
+                            <a:srgbClr val="3D5466"/>
+                          </a:solidFill>
+                          <a:latin typeface="Arial"/>
+                        </a:rPr>
+                        <a:t>2 Klärungsfragen</a:t>
+                      </a:r>
+                    </a:p>
+                  </a:txBody>
+                  <a:tcPr/>
+                </a:tc>
+              </a:tr>
+              <a:tr h="384048">
+                <a:tc>
+                  <a:txBody>
+                    <a:bodyPr/>
+                    <a:lstStyle/>
+                    <a:p>
+                      <a:r>
+                        <a:rPr sz="1050">
+                          <a:solidFill>
+                            <a:srgbClr val="3D5466"/>
+                          </a:solidFill>
+                          <a:latin typeface="Arial"/>
+                        </a:rPr>
+                        <a:t>3 Hypothesen</a:t>
+                      </a:r>
+                    </a:p>
+                  </a:txBody>
+                  <a:tcPr/>
+                </a:tc>
+              </a:tr>
+              <a:tr h="384048">
+                <a:tc>
+                  <a:txBody>
+                    <a:bodyPr/>
+                    <a:lstStyle/>
+                    <a:p>
+                      <a:r>
+                        <a:rPr sz="1050">
+                          <a:solidFill>
+                            <a:srgbClr val="3D5466"/>
+                          </a:solidFill>
+                          <a:latin typeface="Arial"/>
+                        </a:rPr>
+                        <a:t>4 Ideen</a:t>
+                      </a:r>
+                    </a:p>
+                  </a:txBody>
+                  <a:tcPr/>
+                </a:tc>
+              </a:tr>
+              <a:tr h="384048">
+                <a:tc>
+                  <a:txBody>
+                    <a:bodyPr/>
+                    <a:lstStyle/>
+                    <a:p>
+                      <a:r>
+                        <a:rPr sz="1050">
+                          <a:solidFill>
+                            <a:srgbClr val="3D5466"/>
+                          </a:solidFill>
+                          <a:latin typeface="Arial"/>
+                        </a:rPr>
+                        <a:t>5 Fallgeber wählt</a:t>
+                      </a:r>
+                    </a:p>
+                  </a:txBody>
+                  <a:tcPr/>
+                </a:tc>
+              </a:tr>
+            </a:tbl>
+          </a:graphicData>
+        </a:graphic>
+      </p:graphicFrame>
+      <p:sp>
+        <p:nvSpPr>
+          <p:cNvPr id="8" name="Rectangle 7"/>
+          <p:cNvSpPr/>
+          <p:nvPr/>
+        </p:nvSpPr>
+        <p:spPr>
+          <a:xfrm>
+            <a:off x="0" y="6510528"/>
+            <a:ext cx="12188952" cy="347472"/>
+          </a:xfrm>
+          <a:prstGeom prst="rect">
+            <a:avLst/>
+          </a:prstGeom>
+          <a:solidFill>
+            <a:srgbClr val="0A1937"/>
+          </a:solidFill>
+          <a:ln>
+            <a:noFill/>
+          </a:ln>
+        </p:spPr>
+        <p:style>
+          <a:lnRef idx="1">
+            <a:schemeClr val="accent1"/>
+          </a:lnRef>
+          <a:fillRef idx="3">
+            <a:schemeClr val="accent1"/>
+          </a:fillRef>
+          <a:effectRef idx="2">
+            <a:schemeClr val="accent1"/>
+          </a:effectRef>
+          <a:fontRef idx="minor">
+            <a:schemeClr val="lt1"/>
+          </a:fontRef>
+        </p:style>
+        <p:txBody>
+          <a:bodyPr rtlCol="0" anchor="ctr"/>
+          <a:lstStyle/>
+          <a:p>
+            <a:pPr algn="ctr"/>
+          </a:p>
+        </p:txBody>
+      </p:sp>
+      <p:sp>
+        <p:nvSpPr>
+          <p:cNvPr id="9" name="TextBox 8"/>
+          <p:cNvSpPr txBox="1"/>
+          <p:nvPr/>
+        </p:nvSpPr>
+        <p:spPr>
+          <a:xfrm>
+            <a:off x="685800" y="6583680"/>
+            <a:ext cx="6490411" cy="256032"/>
+          </a:xfrm>
+          <a:prstGeom prst="rect">
+            <a:avLst/>
+          </a:prstGeom>
+          <a:noFill/>
+        </p:spPr>
+        <p:txBody>
+          <a:bodyPr wrap="none">
+            <a:spAutoFit/>
+          </a:bodyPr>
+          <a:lstStyle/>
+          <a:p>
+            <a:pPr algn="l"/>
+            <a:r>
+              <a:rPr sz="700">
+                <a:solidFill>
+                  <a:srgbClr val="A0B4D2"/>
+                </a:solidFill>
+                <a:latin typeface="Consolas"/>
+              </a:rPr>
+              <a:t>FKB Campus  ·  TL00</a:t>
+            </a:r>
+          </a:p>
+        </p:txBody>
+      </p:sp>
+      <p:sp>
+        <p:nvSpPr>
+          <p:cNvPr id="10" name="TextBox 9"/>
+          <p:cNvSpPr txBox="1"/>
+          <p:nvPr/>
+        </p:nvSpPr>
+        <p:spPr>
+          <a:xfrm>
+            <a:off x="7176211" y="6583680"/>
+            <a:ext cx="4326940" cy="256032"/>
+          </a:xfrm>
+          <a:prstGeom prst="rect">
+            <a:avLst/>
+          </a:prstGeom>
+          <a:noFill/>
+        </p:spPr>
+        <p:txBody>
+          <a:bodyPr wrap="none">
+            <a:spAutoFit/>
+          </a:bodyPr>
+          <a:lstStyle/>
+          <a:p>
+            <a:pPr algn="r"/>
+            <a:r>
+              <a:rPr sz="700">
+                <a:solidFill>
+                  <a:srgbClr val="A0B4D2"/>
+                </a:solidFill>
+                <a:latin typeface="Consolas"/>
+              </a:rPr>
+              <a:t>Übersicht</a:t>
+            </a:r>
+          </a:p>
+        </p:txBody>
+      </p:sp>
+    </p:spTree>
+  </p:cSld>
+  <p:clrMapOvr>
+    <a:masterClrMapping/>
+  </p:clrMapOvr>
+</p:sld>
+</file>
+
+<file path=ppt/slides/slide16.xml><?xml version="1.0" encoding="utf-8"?>
+<p:sld xmlns:a="http://schemas.openxmlformats.org/drawingml/2006/main" xmlns:p="http://schemas.openxmlformats.org/presentationml/2006/main" xmlns:r="http://schemas.openxmlformats.org/officeDocument/2006/relationships">
+  <p:cSld>
+    <p:spTree>
+      <p:nvGrpSpPr>
+        <p:cNvPr id="1" name=""/>
+        <p:cNvGrpSpPr/>
+        <p:nvPr/>
+      </p:nvGrpSpPr>
+      <p:grpSpPr/>
+      <p:sp>
+        <p:nvSpPr>
+          <p:cNvPr id="2" name="Rectangle 1"/>
+          <p:cNvSpPr/>
+          <p:nvPr/>
+        </p:nvSpPr>
+        <p:spPr>
+          <a:xfrm>
+            <a:off x="0" y="0"/>
+            <a:ext cx="12188952" cy="6858000"/>
+          </a:xfrm>
+          <a:prstGeom prst="rect">
+            <a:avLst/>
+          </a:prstGeom>
+          <a:solidFill>
+            <a:srgbClr val="1F2C56"/>
+          </a:solidFill>
+          <a:ln>
+            <a:noFill/>
+          </a:ln>
+        </p:spPr>
+        <p:style>
+          <a:lnRef idx="1">
+            <a:schemeClr val="accent1"/>
+          </a:lnRef>
+          <a:fillRef idx="3">
+            <a:schemeClr val="accent1"/>
+          </a:fillRef>
+          <a:effectRef idx="2">
+            <a:schemeClr val="accent1"/>
+          </a:effectRef>
+          <a:fontRef idx="minor">
+            <a:schemeClr val="lt1"/>
+          </a:fontRef>
+        </p:style>
+        <p:txBody>
+          <a:bodyPr rtlCol="0" anchor="ctr"/>
+          <a:lstStyle/>
+          <a:p>
+            <a:pPr algn="ctr"/>
+          </a:p>
+        </p:txBody>
+      </p:sp>
+      <p:sp>
+        <p:nvSpPr>
+          <p:cNvPr id="3" name="TextBox 2"/>
+          <p:cNvSpPr txBox="1"/>
+          <p:nvPr/>
+        </p:nvSpPr>
+        <p:spPr>
+          <a:xfrm>
+            <a:off x="685800" y="2377440"/>
+            <a:ext cx="10817352" cy="365760"/>
+          </a:xfrm>
+          <a:prstGeom prst="rect">
+            <a:avLst/>
+          </a:prstGeom>
+          <a:noFill/>
+        </p:spPr>
+        <p:txBody>
+          <a:bodyPr wrap="none">
+            <a:spAutoFit/>
+          </a:bodyPr>
+          <a:lstStyle/>
+          <a:p>
+            <a:pPr algn="l"/>
+            <a:r>
+              <a:rPr sz="1200">
+                <a:solidFill>
+                  <a:srgbClr val="D9C089"/>
+                </a:solidFill>
+                <a:latin typeface="Consolas"/>
+              </a:rPr>
+              <a:t>EINZELARBEIT 20 MIN. + OPTIONALES PLENUM-ECHO 10 MIN.</a:t>
+            </a:r>
+          </a:p>
+        </p:txBody>
+      </p:sp>
+      <p:sp>
+        <p:nvSpPr>
+          <p:cNvPr id="4" name="Rectangle 3"/>
+          <p:cNvSpPr/>
+          <p:nvPr/>
+        </p:nvSpPr>
+        <p:spPr>
+          <a:xfrm>
+            <a:off x="685800" y="2788920"/>
+            <a:ext cx="548640" cy="38100"/>
+          </a:xfrm>
+          <a:prstGeom prst="rect">
+            <a:avLst/>
+          </a:prstGeom>
+          <a:solidFill>
+            <a:srgbClr val="D9C089"/>
+          </a:solidFill>
+          <a:ln>
+            <a:noFill/>
+          </a:ln>
+        </p:spPr>
+        <p:style>
+          <a:lnRef idx="1">
+            <a:schemeClr val="accent1"/>
+          </a:lnRef>
+          <a:fillRef idx="3">
+            <a:schemeClr val="accent1"/>
+          </a:fillRef>
+          <a:effectRef idx="2">
+            <a:schemeClr val="accent1"/>
+          </a:effectRef>
+          <a:fontRef idx="minor">
+            <a:schemeClr val="lt1"/>
+          </a:fontRef>
+        </p:style>
+        <p:txBody>
+          <a:bodyPr rtlCol="0" anchor="ctr"/>
+          <a:lstStyle/>
+          <a:p>
+            <a:pPr algn="ctr"/>
+          </a:p>
+        </p:txBody>
+      </p:sp>
+      <p:sp>
+        <p:nvSpPr>
+          <p:cNvPr id="5" name="TextBox 4"/>
+          <p:cNvSpPr txBox="1"/>
+          <p:nvPr/>
+        </p:nvSpPr>
+        <p:spPr>
+          <a:xfrm>
+            <a:off x="685800" y="3017520"/>
+            <a:ext cx="10817352" cy="1463040"/>
+          </a:xfrm>
+          <a:prstGeom prst="rect">
+            <a:avLst/>
+          </a:prstGeom>
+          <a:noFill/>
+        </p:spPr>
+        <p:txBody>
+          <a:bodyPr wrap="square">
+            <a:spAutoFit/>
+          </a:bodyPr>
+          <a:lstStyle/>
+          <a:p>
+            <a:pPr algn="l"/>
+            <a:r>
+              <a:rPr sz="4000" b="1" i="0">
+                <a:solidFill>
+                  <a:srgbClr val="FFFFFF"/>
+                </a:solidFill>
+                <a:latin typeface="Arial"/>
+              </a:rPr>
+              <a:t>AB-2: Mein nächster Führungsmoment</a:t>
+            </a:r>
+          </a:p>
+        </p:txBody>
+      </p:sp>
+      <p:sp>
+        <p:nvSpPr>
+          <p:cNvPr id="6" name="TextBox 5"/>
+          <p:cNvSpPr txBox="1"/>
+          <p:nvPr/>
+        </p:nvSpPr>
+        <p:spPr>
+          <a:xfrm>
+            <a:off x="685800" y="4480560"/>
+            <a:ext cx="8653881" cy="1280160"/>
+          </a:xfrm>
+          <a:prstGeom prst="rect">
+            <a:avLst/>
+          </a:prstGeom>
+          <a:noFill/>
+        </p:spPr>
+        <p:txBody>
+          <a:bodyPr wrap="square">
+            <a:spAutoFit/>
+          </a:bodyPr>
+          <a:lstStyle/>
+          <a:p>
+            <a:pPr algn="l"/>
+            <a:r>
+              <a:rPr sz="1600" b="0" i="0">
+                <a:solidFill>
+                  <a:srgbClr val="C8D2E6"/>
+                </a:solidFill>
+                <a:latin typeface="Arial"/>
+              </a:rPr>
+              <a:t>Ein konkretes reales Führungsgespräch vorbereiten – Einstiegssatz, Leitfragen, Abschluss</a:t>
+            </a:r>
+          </a:p>
+        </p:txBody>
+      </p:sp>
+      <p:sp>
+        <p:nvSpPr>
+          <p:cNvPr id="7" name="TextBox 6"/>
+          <p:cNvSpPr txBox="1"/>
+          <p:nvPr/>
+        </p:nvSpPr>
+        <p:spPr>
+          <a:xfrm>
+            <a:off x="685800" y="6355080"/>
+            <a:ext cx="10817352" cy="274320"/>
+          </a:xfrm>
+          <a:prstGeom prst="rect">
+            <a:avLst/>
+          </a:prstGeom>
+          <a:noFill/>
+        </p:spPr>
+        <p:txBody>
+          <a:bodyPr wrap="none">
+            <a:spAutoFit/>
+          </a:bodyPr>
+          <a:lstStyle/>
+          <a:p>
+            <a:pPr algn="l"/>
+            <a:r>
+              <a:rPr sz="700">
+                <a:solidFill>
+                  <a:srgbClr val="8CA0C3"/>
+                </a:solidFill>
+                <a:latin typeface="Consolas"/>
+              </a:rPr>
+              <a:t>FKB Campus  ·  TL00</a:t>
+            </a:r>
+          </a:p>
+        </p:txBody>
+      </p:sp>
+    </p:spTree>
+  </p:cSld>
+  <p:clrMapOvr>
+    <a:masterClrMapping/>
+  </p:clrMapOvr>
+</p:sld>
+</file>
+
+<file path=ppt/slides/slide17.xml><?xml version="1.0" encoding="utf-8"?>
+<p:sld xmlns:a="http://schemas.openxmlformats.org/drawingml/2006/main" xmlns:p="http://schemas.openxmlformats.org/presentationml/2006/main" xmlns:r="http://schemas.openxmlformats.org/officeDocument/2006/relationships">
+  <p:cSld>
+    <p:spTree>
+      <p:nvGrpSpPr>
+        <p:cNvPr id="1" name=""/>
+        <p:cNvGrpSpPr/>
+        <p:nvPr/>
+      </p:nvGrpSpPr>
+      <p:grpSpPr/>
+      <p:sp>
+        <p:nvSpPr>
+          <p:cNvPr id="2" name="Rectangle 1"/>
+          <p:cNvSpPr/>
+          <p:nvPr/>
+        </p:nvSpPr>
+        <p:spPr>
+          <a:xfrm>
+            <a:off x="0" y="0"/>
+            <a:ext cx="12188952" cy="6858000"/>
+          </a:xfrm>
+          <a:prstGeom prst="rect">
+            <a:avLst/>
+          </a:prstGeom>
+          <a:solidFill>
+            <a:srgbClr val="EDEDF3"/>
+          </a:solidFill>
+          <a:ln>
+            <a:noFill/>
+          </a:ln>
+        </p:spPr>
+        <p:style>
+          <a:lnRef idx="1">
+            <a:schemeClr val="accent1"/>
+          </a:lnRef>
+          <a:fillRef idx="3">
+            <a:schemeClr val="accent1"/>
+          </a:fillRef>
+          <a:effectRef idx="2">
+            <a:schemeClr val="accent1"/>
+          </a:effectRef>
+          <a:fontRef idx="minor">
+            <a:schemeClr val="lt1"/>
+          </a:fontRef>
+        </p:style>
+        <p:txBody>
+          <a:bodyPr rtlCol="0" anchor="ctr"/>
+          <a:lstStyle/>
+          <a:p>
+            <a:pPr algn="ctr"/>
+          </a:p>
+        </p:txBody>
+      </p:sp>
+      <p:sp>
+        <p:nvSpPr>
+          <p:cNvPr id="3" name="Rectangle 2"/>
+          <p:cNvSpPr/>
+          <p:nvPr/>
+        </p:nvSpPr>
+        <p:spPr>
+          <a:xfrm>
+            <a:off x="0" y="0"/>
+            <a:ext cx="12188952" cy="50292"/>
+          </a:xfrm>
+          <a:prstGeom prst="rect">
+            <a:avLst/>
+          </a:prstGeom>
+          <a:solidFill>
+            <a:srgbClr val="1F2C56"/>
+          </a:solidFill>
+          <a:ln>
+            <a:noFill/>
+          </a:ln>
+        </p:spPr>
+        <p:style>
+          <a:lnRef idx="1">
+            <a:schemeClr val="accent1"/>
+          </a:lnRef>
+          <a:fillRef idx="3">
+            <a:schemeClr val="accent1"/>
+          </a:fillRef>
+          <a:effectRef idx="2">
+            <a:schemeClr val="accent1"/>
+          </a:effectRef>
+          <a:fontRef idx="minor">
+            <a:schemeClr val="lt1"/>
+          </a:fontRef>
+        </p:style>
+        <p:txBody>
+          <a:bodyPr rtlCol="0" anchor="ctr"/>
+          <a:lstStyle/>
+          <a:p>
+            <a:pPr algn="ctr"/>
+          </a:p>
+        </p:txBody>
+      </p:sp>
+      <p:sp>
+        <p:nvSpPr>
+          <p:cNvPr id="4" name="TextBox 3"/>
+          <p:cNvSpPr txBox="1"/>
+          <p:nvPr/>
+        </p:nvSpPr>
+        <p:spPr>
+          <a:xfrm>
+            <a:off x="685800" y="109728"/>
+            <a:ext cx="10817352" cy="228600"/>
+          </a:xfrm>
+          <a:prstGeom prst="rect">
+            <a:avLst/>
+          </a:prstGeom>
+          <a:noFill/>
+        </p:spPr>
+        <p:txBody>
+          <a:bodyPr wrap="none">
+            <a:spAutoFit/>
+          </a:bodyPr>
+          <a:lstStyle/>
+          <a:p>
+            <a:pPr algn="l"/>
+            <a:r>
+              <a:rPr sz="750">
+                <a:solidFill>
+                  <a:srgbClr val="78808C"/>
+                </a:solidFill>
+                <a:latin typeface="Consolas"/>
+              </a:rPr>
+              <a:t>TL00  ·  ARBEITSBLATT</a:t>
+            </a:r>
+          </a:p>
+        </p:txBody>
+      </p:sp>
+      <p:sp>
+        <p:nvSpPr>
+          <p:cNvPr id="5" name="Rectangle 4"/>
+          <p:cNvSpPr/>
+          <p:nvPr/>
+        </p:nvSpPr>
+        <p:spPr>
+          <a:xfrm>
+            <a:off x="0" y="1234440"/>
+            <a:ext cx="12188952" cy="12700"/>
+          </a:xfrm>
+          <a:prstGeom prst="rect">
+            <a:avLst/>
+          </a:prstGeom>
+          <a:solidFill>
+            <a:srgbClr val="D8DFE4"/>
+          </a:solidFill>
+          <a:ln>
+            <a:noFill/>
+          </a:ln>
+        </p:spPr>
+        <p:style>
+          <a:lnRef idx="1">
+            <a:schemeClr val="accent1"/>
+          </a:lnRef>
+          <a:fillRef idx="3">
+            <a:schemeClr val="accent1"/>
+          </a:fillRef>
+          <a:effectRef idx="2">
+            <a:schemeClr val="accent1"/>
+          </a:effectRef>
+          <a:fontRef idx="minor">
+            <a:schemeClr val="lt1"/>
+          </a:fontRef>
+        </p:style>
+        <p:txBody>
+          <a:bodyPr rtlCol="0" anchor="ctr"/>
+          <a:lstStyle/>
+          <a:p>
+            <a:pPr algn="ctr"/>
+          </a:p>
+        </p:txBody>
+      </p:sp>
+      <p:sp>
+        <p:nvSpPr>
+          <p:cNvPr id="6" name="Rectangle 5"/>
+          <p:cNvSpPr/>
+          <p:nvPr/>
+        </p:nvSpPr>
+        <p:spPr>
+          <a:xfrm>
+            <a:off x="685800" y="502920"/>
+            <a:ext cx="36576" cy="658368"/>
+          </a:xfrm>
+          <a:prstGeom prst="rect">
+            <a:avLst/>
+          </a:prstGeom>
+          <a:solidFill>
+            <a:srgbClr val="D9C089"/>
+          </a:solidFill>
+          <a:ln>
+            <a:noFill/>
+          </a:ln>
+        </p:spPr>
+        <p:style>
+          <a:lnRef idx="1">
+            <a:schemeClr val="accent1"/>
+          </a:lnRef>
+          <a:fillRef idx="3">
+            <a:schemeClr val="accent1"/>
+          </a:fillRef>
+          <a:effectRef idx="2">
+            <a:schemeClr val="accent1"/>
+          </a:effectRef>
+          <a:fontRef idx="minor">
+            <a:schemeClr val="lt1"/>
+          </a:fontRef>
+        </p:style>
+        <p:txBody>
+          <a:bodyPr rtlCol="0" anchor="ctr"/>
+          <a:lstStyle/>
+          <a:p>
+            <a:pPr algn="ctr"/>
+          </a:p>
+        </p:txBody>
+      </p:sp>
+      <p:sp>
+        <p:nvSpPr>
+          <p:cNvPr id="7" name="TextBox 6"/>
+          <p:cNvSpPr txBox="1"/>
+          <p:nvPr/>
+        </p:nvSpPr>
+        <p:spPr>
+          <a:xfrm>
+            <a:off x="813816" y="502920"/>
+            <a:ext cx="10634472" cy="685800"/>
+          </a:xfrm>
+          <a:prstGeom prst="rect">
+            <a:avLst/>
+          </a:prstGeom>
+          <a:noFill/>
+        </p:spPr>
+        <p:txBody>
+          <a:bodyPr wrap="square">
+            <a:spAutoFit/>
+          </a:bodyPr>
+          <a:lstStyle/>
+          <a:p>
+            <a:pPr algn="l"/>
+            <a:r>
+              <a:rPr sz="2400" b="1" i="0">
+                <a:solidFill>
+                  <a:srgbClr val="1F2C56"/>
+                </a:solidFill>
+                <a:latin typeface="Arial"/>
+              </a:rPr>
+              <a:t>AB-2 bearbeiten – Ihr nächstes echtes Gespräch</a:t>
             </a:r>
           </a:p>
         </p:txBody>
@@ -5814,8 +7600,8 @@
         </p:nvSpPr>
         <p:spPr>
           <a:xfrm>
-            <a:off x="685800" y="1417320"/>
-            <a:ext cx="10817352" cy="4892040"/>
+            <a:off x="685800" y="1554480"/>
+            <a:ext cx="10817352" cy="3840480"/>
           </a:xfrm>
           <a:prstGeom prst="rect">
             <a:avLst/>
@@ -5823,29 +7609,10 @@
           <a:noFill/>
         </p:spPr>
         <p:txBody>
-          <a:bodyPr wrap="square" anchor="ctr">
+          <a:bodyPr wrap="square">
             <a:spAutoFit/>
           </a:bodyPr>
           <a:lstStyle/>
-          <a:p>
-            <a:pPr>
-              <a:spcBef>
-                <a:spcPts val="400"/>
-              </a:spcBef>
-              <a:spcAft>
-                <a:spcPts val="200"/>
-              </a:spcAft>
-            </a:pPr>
-            <a:r>
-              <a:rPr sz="1200">
-                <a:solidFill>
-                  <a:srgbClr val="3D5466"/>
-                </a:solidFill>
-                <a:latin typeface="Arial"/>
-              </a:rPr>
-              <a:t>Nehmen Sie sich vor dem Ende des Workshops fünf Minuten Zeit für diese Fragen. Sie sind für Sie – nicht zum Vorlesen.</a:t>
-            </a:r>
-          </a:p>
           <a:p>
             <a:pPr marL="190500" indent="-190500">
               <a:spcBef>
@@ -5856,13 +7623,13 @@
               </a:spcAft>
             </a:pPr>
             <a:r>
-              <a:rPr sz="1300">
+              <a:rPr sz="1400">
                 <a:solidFill>
                   <a:srgbClr val="3D5466"/>
                 </a:solidFill>
                 <a:latin typeface="Arial"/>
               </a:rPr>
-              <a:t>▸  Was war Ihr größter Erfolg als Berater, der Ihnen gleichzeitig in der Führungsrolle am wenigsten hilft?</a:t>
+              <a:t>▸  AB-2: Mit wem führe ich dieses Gespräch – und was ist mein Ziel?</a:t>
             </a:r>
           </a:p>
           <a:p>
@@ -5875,13 +7642,13 @@
               </a:spcAft>
             </a:pPr>
             <a:r>
-              <a:rPr sz="1300">
+              <a:rPr sz="1400">
                 <a:solidFill>
                   <a:srgbClr val="3D5466"/>
                 </a:solidFill>
                 <a:latin typeface="Arial"/>
               </a:rPr>
-              <a:t>▸  Was wünschen Sie sich von Ihren Mitarbeitenden in einem Jahr über Sie als Führungskraft zu sagen – welchen Satz?</a:t>
+              <a:t>▸  AB-2: Mein Einstiegssatz (direkt, ohne Umschweife)</a:t>
             </a:r>
           </a:p>
           <a:p>
@@ -5894,13 +7661,13 @@
               </a:spcAft>
             </a:pPr>
             <a:r>
-              <a:rPr sz="1300">
+              <a:rPr sz="1400">
                 <a:solidFill>
                   <a:srgbClr val="3D5466"/>
                 </a:solidFill>
                 <a:latin typeface="Arial"/>
               </a:rPr>
-              <a:t>▸  Welche Führungssituation aus den ersten Wochen hat Sie am meisten überrascht oder verunsichert? Was verrät das über Ihre Erwartung an die Rolle?</a:t>
+              <a:t>▸  AB-2: Drei Leitfragen – was frage ich, nicht was erkläre ich</a:t>
             </a:r>
           </a:p>
           <a:p>
@@ -5913,13 +7680,547 @@
               </a:spcAft>
             </a:pPr>
             <a:r>
-              <a:rPr sz="1300">
+              <a:rPr sz="1400">
                 <a:solidFill>
                   <a:srgbClr val="3D5466"/>
                 </a:solidFill>
                 <a:latin typeface="Arial"/>
               </a:rPr>
-              <a:t>▸  Wie möchten Sie führen – und wer aus Ihrem eigenen Umfeld (frühere Führungskraft, Mentor) hat Ihnen das vorgelebt?</a:t>
+              <a:t>▸  AB-2: Erwartete Reaktion + Formulierungsbaustein dafür</a:t>
+            </a:r>
+          </a:p>
+          <a:p>
+            <a:pPr marL="190500" indent="-190500">
+              <a:spcBef>
+                <a:spcPts val="400"/>
+              </a:spcBef>
+              <a:spcAft>
+                <a:spcPts val="200"/>
+              </a:spcAft>
+            </a:pPr>
+            <a:r>
+              <a:rPr sz="1400">
+                <a:solidFill>
+                  <a:srgbClr val="3D5466"/>
+                </a:solidFill>
+                <a:latin typeface="Arial"/>
+              </a:rPr>
+              <a:t>▸  AB-2: Mein Abschluss – klares Ergebnis oder klares Nächstes</a:t>
+            </a:r>
+          </a:p>
+        </p:txBody>
+      </p:sp>
+      <p:sp>
+        <p:nvSpPr>
+          <p:cNvPr id="9" name="Rectangle 8"/>
+          <p:cNvSpPr/>
+          <p:nvPr/>
+        </p:nvSpPr>
+        <p:spPr>
+          <a:xfrm>
+            <a:off x="685800" y="5486400"/>
+            <a:ext cx="10817352" cy="640080"/>
+          </a:xfrm>
+          <a:prstGeom prst="rect">
+            <a:avLst/>
+          </a:prstGeom>
+          <a:solidFill>
+            <a:srgbClr val="1F2C56"/>
+          </a:solidFill>
+          <a:ln>
+            <a:noFill/>
+          </a:ln>
+        </p:spPr>
+        <p:style>
+          <a:lnRef idx="1">
+            <a:schemeClr val="accent1"/>
+          </a:lnRef>
+          <a:fillRef idx="3">
+            <a:schemeClr val="accent1"/>
+          </a:fillRef>
+          <a:effectRef idx="2">
+            <a:schemeClr val="accent1"/>
+          </a:effectRef>
+          <a:fontRef idx="minor">
+            <a:schemeClr val="lt1"/>
+          </a:fontRef>
+        </p:style>
+        <p:txBody>
+          <a:bodyPr rtlCol="0" anchor="ctr"/>
+          <a:lstStyle/>
+          <a:p>
+            <a:pPr algn="ctr"/>
+          </a:p>
+        </p:txBody>
+      </p:sp>
+      <p:sp>
+        <p:nvSpPr>
+          <p:cNvPr id="10" name="TextBox 9"/>
+          <p:cNvSpPr txBox="1"/>
+          <p:nvPr/>
+        </p:nvSpPr>
+        <p:spPr>
+          <a:xfrm>
+            <a:off x="868680" y="5596128"/>
+            <a:ext cx="10451592" cy="457200"/>
+          </a:xfrm>
+          <a:prstGeom prst="rect">
+            <a:avLst/>
+          </a:prstGeom>
+          <a:noFill/>
+        </p:spPr>
+        <p:txBody>
+          <a:bodyPr wrap="square">
+            <a:spAutoFit/>
+          </a:bodyPr>
+          <a:lstStyle/>
+          <a:p>
+            <a:pPr algn="l"/>
+            <a:r>
+              <a:rPr sz="1300" b="1" i="0">
+                <a:solidFill>
+                  <a:srgbClr val="FFFFFF"/>
+                </a:solidFill>
+                <a:latin typeface="Arial"/>
+              </a:rPr>
+              <a:t>→  Bearbeitung im Teilnehmer-Workbook (Arbeitsblatt mit Ausfüllfeldern)</a:t>
+            </a:r>
+          </a:p>
+        </p:txBody>
+      </p:sp>
+      <p:sp>
+        <p:nvSpPr>
+          <p:cNvPr id="11" name="Rectangle 10"/>
+          <p:cNvSpPr/>
+          <p:nvPr/>
+        </p:nvSpPr>
+        <p:spPr>
+          <a:xfrm>
+            <a:off x="0" y="6510528"/>
+            <a:ext cx="12188952" cy="347472"/>
+          </a:xfrm>
+          <a:prstGeom prst="rect">
+            <a:avLst/>
+          </a:prstGeom>
+          <a:solidFill>
+            <a:srgbClr val="0A1937"/>
+          </a:solidFill>
+          <a:ln>
+            <a:noFill/>
+          </a:ln>
+        </p:spPr>
+        <p:style>
+          <a:lnRef idx="1">
+            <a:schemeClr val="accent1"/>
+          </a:lnRef>
+          <a:fillRef idx="3">
+            <a:schemeClr val="accent1"/>
+          </a:fillRef>
+          <a:effectRef idx="2">
+            <a:schemeClr val="accent1"/>
+          </a:effectRef>
+          <a:fontRef idx="minor">
+            <a:schemeClr val="lt1"/>
+          </a:fontRef>
+        </p:style>
+        <p:txBody>
+          <a:bodyPr rtlCol="0" anchor="ctr"/>
+          <a:lstStyle/>
+          <a:p>
+            <a:pPr algn="ctr"/>
+          </a:p>
+        </p:txBody>
+      </p:sp>
+      <p:sp>
+        <p:nvSpPr>
+          <p:cNvPr id="12" name="TextBox 11"/>
+          <p:cNvSpPr txBox="1"/>
+          <p:nvPr/>
+        </p:nvSpPr>
+        <p:spPr>
+          <a:xfrm>
+            <a:off x="685800" y="6583680"/>
+            <a:ext cx="6490411" cy="256032"/>
+          </a:xfrm>
+          <a:prstGeom prst="rect">
+            <a:avLst/>
+          </a:prstGeom>
+          <a:noFill/>
+        </p:spPr>
+        <p:txBody>
+          <a:bodyPr wrap="none">
+            <a:spAutoFit/>
+          </a:bodyPr>
+          <a:lstStyle/>
+          <a:p>
+            <a:pPr algn="l"/>
+            <a:r>
+              <a:rPr sz="700">
+                <a:solidFill>
+                  <a:srgbClr val="A0B4D2"/>
+                </a:solidFill>
+                <a:latin typeface="Consolas"/>
+              </a:rPr>
+              <a:t>FKB Campus  ·  TL00</a:t>
+            </a:r>
+          </a:p>
+        </p:txBody>
+      </p:sp>
+    </p:spTree>
+  </p:cSld>
+  <p:clrMapOvr>
+    <a:masterClrMapping/>
+  </p:clrMapOvr>
+</p:sld>
+</file>
+
+<file path=ppt/slides/slide18.xml><?xml version="1.0" encoding="utf-8"?>
+<p:sld xmlns:a="http://schemas.openxmlformats.org/drawingml/2006/main" xmlns:p="http://schemas.openxmlformats.org/presentationml/2006/main" xmlns:r="http://schemas.openxmlformats.org/officeDocument/2006/relationships">
+  <p:cSld>
+    <p:spTree>
+      <p:nvGrpSpPr>
+        <p:cNvPr id="1" name=""/>
+        <p:cNvGrpSpPr/>
+        <p:nvPr/>
+      </p:nvGrpSpPr>
+      <p:grpSpPr/>
+      <p:sp>
+        <p:nvSpPr>
+          <p:cNvPr id="2" name="Rectangle 1"/>
+          <p:cNvSpPr/>
+          <p:nvPr/>
+        </p:nvSpPr>
+        <p:spPr>
+          <a:xfrm>
+            <a:off x="0" y="0"/>
+            <a:ext cx="12188952" cy="6858000"/>
+          </a:xfrm>
+          <a:prstGeom prst="rect">
+            <a:avLst/>
+          </a:prstGeom>
+          <a:solidFill>
+            <a:srgbClr val="EDEDF3"/>
+          </a:solidFill>
+          <a:ln>
+            <a:noFill/>
+          </a:ln>
+        </p:spPr>
+        <p:style>
+          <a:lnRef idx="1">
+            <a:schemeClr val="accent1"/>
+          </a:lnRef>
+          <a:fillRef idx="3">
+            <a:schemeClr val="accent1"/>
+          </a:fillRef>
+          <a:effectRef idx="2">
+            <a:schemeClr val="accent1"/>
+          </a:effectRef>
+          <a:fontRef idx="minor">
+            <a:schemeClr val="lt1"/>
+          </a:fontRef>
+        </p:style>
+        <p:txBody>
+          <a:bodyPr rtlCol="0" anchor="ctr"/>
+          <a:lstStyle/>
+          <a:p>
+            <a:pPr algn="ctr"/>
+          </a:p>
+        </p:txBody>
+      </p:sp>
+      <p:sp>
+        <p:nvSpPr>
+          <p:cNvPr id="3" name="Rectangle 2"/>
+          <p:cNvSpPr/>
+          <p:nvPr/>
+        </p:nvSpPr>
+        <p:spPr>
+          <a:xfrm>
+            <a:off x="0" y="0"/>
+            <a:ext cx="12188952" cy="50292"/>
+          </a:xfrm>
+          <a:prstGeom prst="rect">
+            <a:avLst/>
+          </a:prstGeom>
+          <a:solidFill>
+            <a:srgbClr val="1F2C56"/>
+          </a:solidFill>
+          <a:ln>
+            <a:noFill/>
+          </a:ln>
+        </p:spPr>
+        <p:style>
+          <a:lnRef idx="1">
+            <a:schemeClr val="accent1"/>
+          </a:lnRef>
+          <a:fillRef idx="3">
+            <a:schemeClr val="accent1"/>
+          </a:fillRef>
+          <a:effectRef idx="2">
+            <a:schemeClr val="accent1"/>
+          </a:effectRef>
+          <a:fontRef idx="minor">
+            <a:schemeClr val="lt1"/>
+          </a:fontRef>
+        </p:style>
+        <p:txBody>
+          <a:bodyPr rtlCol="0" anchor="ctr"/>
+          <a:lstStyle/>
+          <a:p>
+            <a:pPr algn="ctr"/>
+          </a:p>
+        </p:txBody>
+      </p:sp>
+      <p:sp>
+        <p:nvSpPr>
+          <p:cNvPr id="4" name="TextBox 3"/>
+          <p:cNvSpPr txBox="1"/>
+          <p:nvPr/>
+        </p:nvSpPr>
+        <p:spPr>
+          <a:xfrm>
+            <a:off x="685800" y="109728"/>
+            <a:ext cx="10817352" cy="228600"/>
+          </a:xfrm>
+          <a:prstGeom prst="rect">
+            <a:avLst/>
+          </a:prstGeom>
+          <a:noFill/>
+        </p:spPr>
+        <p:txBody>
+          <a:bodyPr wrap="none">
+            <a:spAutoFit/>
+          </a:bodyPr>
+          <a:lstStyle/>
+          <a:p>
+            <a:pPr algn="l"/>
+            <a:r>
+              <a:rPr sz="750">
+                <a:solidFill>
+                  <a:srgbClr val="78808C"/>
+                </a:solidFill>
+                <a:latin typeface="Consolas"/>
+              </a:rPr>
+              <a:t>TL00  ·  INHALT</a:t>
+            </a:r>
+          </a:p>
+        </p:txBody>
+      </p:sp>
+      <p:sp>
+        <p:nvSpPr>
+          <p:cNvPr id="5" name="Rectangle 4"/>
+          <p:cNvSpPr/>
+          <p:nvPr/>
+        </p:nvSpPr>
+        <p:spPr>
+          <a:xfrm>
+            <a:off x="0" y="1234440"/>
+            <a:ext cx="12188952" cy="12700"/>
+          </a:xfrm>
+          <a:prstGeom prst="rect">
+            <a:avLst/>
+          </a:prstGeom>
+          <a:solidFill>
+            <a:srgbClr val="D8DFE4"/>
+          </a:solidFill>
+          <a:ln>
+            <a:noFill/>
+          </a:ln>
+        </p:spPr>
+        <p:style>
+          <a:lnRef idx="1">
+            <a:schemeClr val="accent1"/>
+          </a:lnRef>
+          <a:fillRef idx="3">
+            <a:schemeClr val="accent1"/>
+          </a:fillRef>
+          <a:effectRef idx="2">
+            <a:schemeClr val="accent1"/>
+          </a:effectRef>
+          <a:fontRef idx="minor">
+            <a:schemeClr val="lt1"/>
+          </a:fontRef>
+        </p:style>
+        <p:txBody>
+          <a:bodyPr rtlCol="0" anchor="ctr"/>
+          <a:lstStyle/>
+          <a:p>
+            <a:pPr algn="ctr"/>
+          </a:p>
+        </p:txBody>
+      </p:sp>
+      <p:sp>
+        <p:nvSpPr>
+          <p:cNvPr id="6" name="Rectangle 5"/>
+          <p:cNvSpPr/>
+          <p:nvPr/>
+        </p:nvSpPr>
+        <p:spPr>
+          <a:xfrm>
+            <a:off x="685800" y="502920"/>
+            <a:ext cx="36576" cy="658368"/>
+          </a:xfrm>
+          <a:prstGeom prst="rect">
+            <a:avLst/>
+          </a:prstGeom>
+          <a:solidFill>
+            <a:srgbClr val="D9C089"/>
+          </a:solidFill>
+          <a:ln>
+            <a:noFill/>
+          </a:ln>
+        </p:spPr>
+        <p:style>
+          <a:lnRef idx="1">
+            <a:schemeClr val="accent1"/>
+          </a:lnRef>
+          <a:fillRef idx="3">
+            <a:schemeClr val="accent1"/>
+          </a:fillRef>
+          <a:effectRef idx="2">
+            <a:schemeClr val="accent1"/>
+          </a:effectRef>
+          <a:fontRef idx="minor">
+            <a:schemeClr val="lt1"/>
+          </a:fontRef>
+        </p:style>
+        <p:txBody>
+          <a:bodyPr rtlCol="0" anchor="ctr"/>
+          <a:lstStyle/>
+          <a:p>
+            <a:pPr algn="ctr"/>
+          </a:p>
+        </p:txBody>
+      </p:sp>
+      <p:sp>
+        <p:nvSpPr>
+          <p:cNvPr id="7" name="TextBox 6"/>
+          <p:cNvSpPr txBox="1"/>
+          <p:nvPr/>
+        </p:nvSpPr>
+        <p:spPr>
+          <a:xfrm>
+            <a:off x="813816" y="502920"/>
+            <a:ext cx="10634472" cy="685800"/>
+          </a:xfrm>
+          <a:prstGeom prst="rect">
+            <a:avLst/>
+          </a:prstGeom>
+          <a:noFill/>
+        </p:spPr>
+        <p:txBody>
+          <a:bodyPr wrap="square">
+            <a:spAutoFit/>
+          </a:bodyPr>
+          <a:lstStyle/>
+          <a:p>
+            <a:pPr algn="l"/>
+            <a:r>
+              <a:rPr sz="2400" b="1" i="0">
+                <a:solidFill>
+                  <a:srgbClr val="1F2C56"/>
+                </a:solidFill>
+                <a:latin typeface="Arial"/>
+              </a:rPr>
+              <a:t>Ihr Maßstab für die nächsten vier Wochen</a:t>
+            </a:r>
+          </a:p>
+        </p:txBody>
+      </p:sp>
+      <p:sp>
+        <p:nvSpPr>
+          <p:cNvPr id="8" name="TextBox 7"/>
+          <p:cNvSpPr txBox="1"/>
+          <p:nvPr/>
+        </p:nvSpPr>
+        <p:spPr>
+          <a:xfrm>
+            <a:off x="685800" y="1417320"/>
+            <a:ext cx="10817352" cy="4892040"/>
+          </a:xfrm>
+          <a:prstGeom prst="rect">
+            <a:avLst/>
+          </a:prstGeom>
+          <a:noFill/>
+        </p:spPr>
+        <p:txBody>
+          <a:bodyPr wrap="square" anchor="ctr">
+            <a:spAutoFit/>
+          </a:bodyPr>
+          <a:lstStyle/>
+          <a:p>
+            <a:pPr marL="190500" indent="-190500">
+              <a:spcBef>
+                <a:spcPts val="400"/>
+              </a:spcBef>
+              <a:spcAft>
+                <a:spcPts val="200"/>
+              </a:spcAft>
+            </a:pPr>
+            <a:r>
+              <a:rPr sz="1300">
+                <a:solidFill>
+                  <a:srgbClr val="3D5466"/>
+                </a:solidFill>
+                <a:latin typeface="Arial"/>
+              </a:rPr>
+              <a:t>▸  Vorbereitetes Gespräch führen (AB-2)</a:t>
+            </a:r>
+          </a:p>
+          <a:p>
+            <a:pPr marL="190500" indent="-190500">
+              <a:spcBef>
+                <a:spcPts val="400"/>
+              </a:spcBef>
+              <a:spcAft>
+                <a:spcPts val="200"/>
+              </a:spcAft>
+            </a:pPr>
+            <a:r>
+              <a:rPr sz="1300">
+                <a:solidFill>
+                  <a:srgbClr val="3D5466"/>
+                </a:solidFill>
+                <a:latin typeface="Arial"/>
+              </a:rPr>
+              <a:t>▸  Führungszeit-Anteil messen und erhöhen</a:t>
+            </a:r>
+          </a:p>
+          <a:p>
+            <a:pPr marL="190500" indent="-190500">
+              <a:spcBef>
+                <a:spcPts val="400"/>
+              </a:spcBef>
+              <a:spcAft>
+                <a:spcPts val="200"/>
+              </a:spcAft>
+            </a:pPr>
+            <a:r>
+              <a:rPr sz="1300">
+                <a:solidFill>
+                  <a:srgbClr val="3D5466"/>
+                </a:solidFill>
+                <a:latin typeface="Arial"/>
+              </a:rPr>
+              <a:t>▸  Klärungsgespräch mit ehemaligem Kollegen</a:t>
+            </a:r>
+          </a:p>
+          <a:p>
+            <a:pPr marL="190500" indent="-190500">
+              <a:spcBef>
+                <a:spcPts val="400"/>
+              </a:spcBef>
+              <a:spcAft>
+                <a:spcPts val="200"/>
+              </a:spcAft>
+            </a:pPr>
+            <a:r>
+              <a:rPr sz="1300">
+                <a:solidFill>
+                  <a:srgbClr val="3D5466"/>
+                </a:solidFill>
+                <a:latin typeface="Arial"/>
+              </a:rPr>
+              <a:t>▸  Checkliste: in vier Wochen wieder vorlegen</a:t>
             </a:r>
           </a:p>
         </p:txBody>
@@ -7687,7 +9988,7 @@
                 </a:solidFill>
                 <a:latin typeface="Arial"/>
               </a:rPr>
-              <a:t>Theorie-Input: Warum der Rollenwechsel oft unterschätzt wird</a:t>
+              <a:t>Der Wechsel, den niemand ankündigt</a:t>
             </a:r>
           </a:p>
         </p:txBody>
@@ -8025,7 +10326,7 @@
                 </a:solidFill>
                 <a:latin typeface="Arial"/>
               </a:rPr>
-              <a:t>Theorie-Input: Drei Dimensionen des Rollenwechsels</a:t>
+              <a:t>Beförderung ist kein Rollenwechsel – er ist eine Entscheidung</a:t>
             </a:r>
           </a:p>
         </p:txBody>
@@ -8047,12 +10348,12 @@
           <a:noFill/>
         </p:spPr>
         <p:txBody>
-          <a:bodyPr wrap="square">
+          <a:bodyPr wrap="square" anchor="ctr">
             <a:spAutoFit/>
           </a:bodyPr>
           <a:lstStyle/>
           <a:p>
-            <a:pPr>
+            <a:pPr marL="190500" indent="-190500">
               <a:spcBef>
                 <a:spcPts val="400"/>
               </a:spcBef>
@@ -8061,93 +10362,17 @@
               </a:spcAft>
             </a:pPr>
             <a:r>
-              <a:rPr sz="1200">
+              <a:rPr sz="1300">
                 <a:solidFill>
                   <a:srgbClr val="3D5466"/>
                 </a:solidFill>
                 <a:latin typeface="Arial"/>
               </a:rPr>
-              <a:t>Der Übergang von der Beratungs- zur Führungsrolle verändert drei Dimensionen gleichzeitig. Wer nur eine davon reflektiert, bleibt halb fertig.</a:t>
-            </a:r>
-          </a:p>
-          <a:p>
-            <a:pPr>
-              <a:spcBef>
-                <a:spcPts val="1000"/>
-              </a:spcBef>
-              <a:spcAft>
-                <a:spcPts val="200"/>
-              </a:spcAft>
-            </a:pPr>
-            <a:r>
-              <a:rPr sz="800" b="1">
-                <a:solidFill>
-                  <a:srgbClr val="78808C"/>
-                </a:solidFill>
-                <a:latin typeface="Consolas"/>
-              </a:rPr>
-              <a:t>DIMENSION 2: DIE IDENTITÄT</a:t>
-            </a:r>
-          </a:p>
-          <a:p>
-            <a:pPr marL="177800" indent="-177800">
-              <a:spcBef>
-                <a:spcPts val="600"/>
-              </a:spcBef>
-              <a:spcAft>
-                <a:spcPts val="200"/>
-              </a:spcAft>
-            </a:pPr>
-            <a:r>
-              <a:rPr sz="1200" i="1">
-                <a:solidFill>
-                  <a:srgbClr val="3D5466"/>
-                </a:solidFill>
-                <a:latin typeface="Arial"/>
-              </a:rPr>
-              <a:t>→  Handlungsempfehlung</a:t>
-            </a:r>
-          </a:p>
-          <a:p>
-            <a:pPr marL="177800" indent="-177800">
-              <a:spcBef>
-                <a:spcPts val="600"/>
-              </a:spcBef>
-              <a:spcAft>
-                <a:spcPts val="200"/>
-              </a:spcAft>
-            </a:pPr>
-            <a:r>
-              <a:rPr sz="1200" i="1">
-                <a:solidFill>
-                  <a:srgbClr val="3D5466"/>
-                </a:solidFill>
-                <a:latin typeface="Arial"/>
-              </a:rPr>
-              <a:t>→  Wenn Sie merken, dass Sie bei einem Kundenproblem im Team wieder selbst zur Lösung greifen, weil Sie die Antwort kennen</a:t>
-            </a:r>
-          </a:p>
-          <a:p>
-            <a:pPr>
-              <a:spcBef>
-                <a:spcPts val="1000"/>
-              </a:spcBef>
-              <a:spcAft>
-                <a:spcPts val="200"/>
-              </a:spcAft>
-            </a:pPr>
-            <a:r>
-              <a:rPr sz="800" b="1">
-                <a:solidFill>
-                  <a:srgbClr val="78808C"/>
-                </a:solidFill>
-                <a:latin typeface="Consolas"/>
-              </a:rPr>
-              <a:t>DIMENSION 3: DIE ZEIT</a:t>
-            </a:r>
-          </a:p>
-          <a:p>
-            <a:pPr>
+              <a:t>▸  Beförderung = Auslöser, nicht Ergebnis</a:t>
+            </a:r>
+          </a:p>
+          <a:p>
+            <a:pPr marL="190500" indent="-190500">
               <a:spcBef>
                 <a:spcPts val="400"/>
               </a:spcBef>
@@ -8156,51 +10381,51 @@
               </a:spcAft>
             </a:pPr>
             <a:r>
-              <a:rPr sz="1200">
+              <a:rPr sz="1300">
                 <a:solidFill>
                   <a:srgbClr val="3D5466"/>
                 </a:solidFill>
                 <a:latin typeface="Arial"/>
               </a:rPr>
-              <a:t>Als Berater gehört die Zeit Ihnen und Ihren Kunden. Als Teamleiter gehört Ihre Zeit Ihrem Team. Diese Umverteilung ist keine Metapher – sie ist messbar. Typische Zeitverschiebung im ersten Jahr:</a:t>
-            </a:r>
-          </a:p>
-          <a:p>
-            <a:pPr marL="177800" indent="-177800">
+              <a:t>▸  Rollenwechsel muss aktiv vollzogen werden</a:t>
+            </a:r>
+          </a:p>
+          <a:p>
+            <a:pPr marL="190500" indent="-190500">
               <a:spcBef>
-                <a:spcPts val="600"/>
+                <a:spcPts val="400"/>
               </a:spcBef>
               <a:spcAft>
                 <a:spcPts val="200"/>
               </a:spcAft>
             </a:pPr>
             <a:r>
-              <a:rPr sz="1200" i="1">
+              <a:rPr sz="1300">
                 <a:solidFill>
                   <a:srgbClr val="3D5466"/>
                 </a:solidFill>
                 <a:latin typeface="Arial"/>
               </a:rPr>
-              <a:t>→  Handlungsempfehlung</a:t>
-            </a:r>
-          </a:p>
-          <a:p>
-            <a:pPr marL="177800" indent="-177800">
+              <a:t>▸  Ohne Entscheidung: erweiterter Fachexperte</a:t>
+            </a:r>
+          </a:p>
+          <a:p>
+            <a:pPr marL="190500" indent="-190500">
               <a:spcBef>
-                <a:spcPts val="600"/>
+                <a:spcPts val="400"/>
               </a:spcBef>
               <a:spcAft>
                 <a:spcPts val="200"/>
               </a:spcAft>
             </a:pPr>
             <a:r>
-              <a:rPr sz="1200" i="1">
+              <a:rPr sz="1300">
                 <a:solidFill>
                   <a:srgbClr val="3D5466"/>
                 </a:solidFill>
                 <a:latin typeface="Arial"/>
               </a:rPr>
-              <a:t>→  Wenn die Geschäftsleitung Erwartungen an Sie als Teamleiter stellt, die Sie für Ihr Team als unrealistisch oder unfair einschätzen</a:t>
+              <a:t>▸  Hill (2003): nahezu universeller Anfangsfehler</a:t>
             </a:r>
           </a:p>
         </p:txBody>
@@ -8452,7 +10677,7 @@
                 </a:solidFill>
                 <a:latin typeface="Arial"/>
               </a:rPr>
-              <a:t>Drei Dimensionen des Rollenwechsels: Für die Dimensionen Erfolgslogik, Identität und Zeit zeigt die Grafik jeweils die Verschiebung von der Beratungsrolle zur Führungsrolle</a:t>
+              <a:t>Drei Dimensionen</a:t>
             </a:r>
           </a:p>
         </p:txBody>
@@ -8670,7 +10895,7 @@
             <a:avLst/>
           </a:prstGeom>
           <a:solidFill>
-            <a:srgbClr val="EDEDF3"/>
+            <a:srgbClr val="FFFFFF"/>
           </a:solidFill>
           <a:ln>
             <a:noFill/>
@@ -8771,51 +10996,43 @@
                 </a:solidFill>
                 <a:latin typeface="Consolas"/>
               </a:rPr>
-              <a:t>TL00  ·  INHALT</a:t>
-            </a:r>
-          </a:p>
-        </p:txBody>
-      </p:sp>
-      <p:sp>
-        <p:nvSpPr>
-          <p:cNvPr id="5" name="Rectangle 4"/>
-          <p:cNvSpPr/>
-          <p:nvPr/>
-        </p:nvSpPr>
-        <p:spPr>
-          <a:xfrm>
-            <a:off x="0" y="1234440"/>
-            <a:ext cx="12188952" cy="12700"/>
-          </a:xfrm>
-          <a:prstGeom prst="rect">
-            <a:avLst/>
-          </a:prstGeom>
-          <a:solidFill>
-            <a:srgbClr val="D8DFE4"/>
-          </a:solidFill>
-          <a:ln>
-            <a:noFill/>
-          </a:ln>
-        </p:spPr>
-        <p:style>
-          <a:lnRef idx="1">
-            <a:schemeClr val="accent1"/>
-          </a:lnRef>
-          <a:fillRef idx="3">
-            <a:schemeClr val="accent1"/>
-          </a:fillRef>
-          <a:effectRef idx="2">
-            <a:schemeClr val="accent1"/>
-          </a:effectRef>
-          <a:fontRef idx="minor">
-            <a:schemeClr val="lt1"/>
-          </a:fontRef>
-        </p:style>
-        <p:txBody>
-          <a:bodyPr rtlCol="0" anchor="ctr"/>
-          <a:lstStyle/>
-          <a:p>
-            <a:pPr algn="ctr"/>
+              <a:t>TL00  ·  ÜBERSICHT</a:t>
+            </a:r>
+          </a:p>
+        </p:txBody>
+      </p:sp>
+      <p:sp>
+        <p:nvSpPr>
+          <p:cNvPr id="5" name="TextBox 4"/>
+          <p:cNvSpPr txBox="1"/>
+          <p:nvPr/>
+        </p:nvSpPr>
+        <p:spPr>
+          <a:xfrm>
+            <a:off x="685800" y="502920"/>
+            <a:ext cx="10817352" cy="594360"/>
+          </a:xfrm>
+          <a:prstGeom prst="rect">
+            <a:avLst/>
+          </a:prstGeom>
+          <a:noFill/>
+        </p:spPr>
+        <p:txBody>
+          <a:bodyPr wrap="square">
+            <a:spAutoFit/>
+          </a:bodyPr>
+          <a:lstStyle/>
+          <a:p>
+            <a:pPr algn="l"/>
+            <a:r>
+              <a:rPr sz="2000" b="1" i="0">
+                <a:solidFill>
+                  <a:srgbClr val="1F2C56"/>
+                </a:solidFill>
+                <a:latin typeface="Arial"/>
+              </a:rPr>
+              <a:t>Führungserfolg entsteht anders – radikal anders</a:t>
+            </a:r>
           </a:p>
         </p:txBody>
       </p:sp>
@@ -8827,8 +11044,8 @@
         </p:nvSpPr>
         <p:spPr>
           <a:xfrm>
-            <a:off x="685800" y="502920"/>
-            <a:ext cx="36576" cy="658368"/>
+            <a:off x="685800" y="1143000"/>
+            <a:ext cx="10817352" cy="25400"/>
           </a:xfrm>
           <a:prstGeom prst="rect">
             <a:avLst/>
@@ -8862,124 +11079,144 @@
           </a:p>
         </p:txBody>
       </p:sp>
-      <p:sp>
-        <p:nvSpPr>
-          <p:cNvPr id="7" name="TextBox 6"/>
-          <p:cNvSpPr txBox="1"/>
-          <p:nvPr/>
-        </p:nvSpPr>
-        <p:spPr>
-          <a:xfrm>
-            <a:off x="813816" y="502920"/>
-            <a:ext cx="10634472" cy="685800"/>
-          </a:xfrm>
-          <a:prstGeom prst="rect">
-            <a:avLst/>
-          </a:prstGeom>
-          <a:noFill/>
-        </p:spPr>
-        <p:txBody>
-          <a:bodyPr wrap="square">
-            <a:spAutoFit/>
-          </a:bodyPr>
-          <a:lstStyle/>
-          <a:p>
-            <a:pPr algn="l"/>
-            <a:r>
-              <a:rPr sz="2400" b="1" i="0">
-                <a:solidFill>
-                  <a:srgbClr val="1F2C56"/>
-                </a:solidFill>
-                <a:latin typeface="Arial"/>
-              </a:rPr>
-              <a:t>Theorie-Input: Servant Leadership als Haltungsgrundlage</a:t>
-            </a:r>
-          </a:p>
-        </p:txBody>
-      </p:sp>
-      <p:sp>
-        <p:nvSpPr>
-          <p:cNvPr id="8" name="TextBox 7"/>
-          <p:cNvSpPr txBox="1"/>
-          <p:nvPr/>
-        </p:nvSpPr>
-        <p:spPr>
-          <a:xfrm>
-            <a:off x="685800" y="1417320"/>
-            <a:ext cx="10817352" cy="4892040"/>
-          </a:xfrm>
-          <a:prstGeom prst="rect">
-            <a:avLst/>
-          </a:prstGeom>
-          <a:noFill/>
-        </p:spPr>
-        <p:txBody>
-          <a:bodyPr wrap="square" anchor="ctr">
-            <a:spAutoFit/>
-          </a:bodyPr>
-          <a:lstStyle/>
-          <a:p>
-            <a:pPr marL="177800" indent="-177800">
-              <a:spcBef>
-                <a:spcPts val="600"/>
-              </a:spcBef>
-              <a:spcAft>
-                <a:spcPts val="200"/>
-              </a:spcAft>
-            </a:pPr>
-            <a:r>
-              <a:rPr sz="1200" i="1">
-                <a:solidFill>
-                  <a:srgbClr val="3D5466"/>
-                </a:solidFill>
-                <a:latin typeface="Arial"/>
-              </a:rPr>
-              <a:t>→  Handlungsempfehlung</a:t>
-            </a:r>
-          </a:p>
-          <a:p>
-            <a:pPr marL="177800" indent="-177800">
-              <a:spcBef>
-                <a:spcPts val="600"/>
-              </a:spcBef>
-              <a:spcAft>
-                <a:spcPts val="200"/>
-              </a:spcAft>
-            </a:pPr>
-            <a:r>
-              <a:rPr sz="1200" i="1">
-                <a:solidFill>
-                  <a:srgbClr val="3D5466"/>
-                </a:solidFill>
-                <a:latin typeface="Arial"/>
-              </a:rPr>
-              <a:t>→  Wenn ein Berater eine Teamentscheidung nicht akzeptiert und darauf besteht, seinen abweichenden Weg zu gehen</a:t>
-            </a:r>
-          </a:p>
-          <a:p>
-            <a:pPr>
-              <a:spcBef>
-                <a:spcPts val="400"/>
-              </a:spcBef>
-              <a:spcAft>
-                <a:spcPts val="200"/>
-              </a:spcAft>
-            </a:pPr>
-            <a:r>
-              <a:rPr sz="1200">
-                <a:solidFill>
-                  <a:srgbClr val="3D5466"/>
-                </a:solidFill>
-                <a:latin typeface="Arial"/>
-              </a:rPr>
-              <a:t>Merksatz: Führung ist nicht das, was ich tue. Führung ist, was in meinem Team möglich wird – und was ich klar verantworte.</a:t>
-            </a:r>
-          </a:p>
-        </p:txBody>
-      </p:sp>
-      <p:sp>
-        <p:nvSpPr>
-          <p:cNvPr id="9" name="Rectangle 8"/>
+      <p:graphicFrame>
+        <p:nvGraphicFramePr>
+          <p:cNvPr id="7" name="Table 6"/>
+          <p:cNvGraphicFramePr>
+            <a:graphicFrameLocks noGrp="1"/>
+          </p:cNvGraphicFramePr>
+          <p:nvPr/>
+        </p:nvGraphicFramePr>
+        <p:xfrm>
+          <a:off x="685800" y="1417320"/>
+          <a:ext cx="10817352" cy="2304288"/>
+        </p:xfrm>
+        <a:graphic>
+          <a:graphicData uri="http://schemas.openxmlformats.org/drawingml/2006/table">
+            <a:tbl>
+              <a:tblPr firstRow="1" bandRow="1">
+                <a:tableStyleId>{5C22544A-7EE6-4342-B048-85BDC9FD1C3A}</a:tableStyleId>
+              </a:tblPr>
+              <a:tblGrid>
+                <a:gridCol w="10817352"/>
+              </a:tblGrid>
+              <a:tr h="384048">
+                <a:tc>
+                  <a:txBody>
+                    <a:bodyPr/>
+                    <a:lstStyle/>
+                    <a:p/>
+                  </a:txBody>
+                  <a:tcPr/>
+                </a:tc>
+              </a:tr>
+              <a:tr h="384048">
+                <a:tc>
+                  <a:txBody>
+                    <a:bodyPr/>
+                    <a:lstStyle/>
+                    <a:p>
+                      <a:r>
+                        <a:rPr sz="1050">
+                          <a:solidFill>
+                            <a:srgbClr val="3D5466"/>
+                          </a:solidFill>
+                          <a:latin typeface="Arial"/>
+                        </a:rPr>
+                        <a:t>Dimension</a:t>
+                      </a:r>
+                    </a:p>
+                  </a:txBody>
+                  <a:tcPr/>
+                </a:tc>
+              </a:tr>
+              <a:tr h="384048">
+                <a:tc>
+                  <a:txBody>
+                    <a:bodyPr/>
+                    <a:lstStyle/>
+                    <a:p>
+                      <a:r>
+                        <a:rPr sz="1050">
+                          <a:solidFill>
+                            <a:srgbClr val="3D5466"/>
+                          </a:solidFill>
+                          <a:latin typeface="Arial"/>
+                        </a:rPr>
+                        <a:t>Wirkung</a:t>
+                      </a:r>
+                    </a:p>
+                  </a:txBody>
+                  <a:tcPr/>
+                </a:tc>
+              </a:tr>
+              <a:tr h="384048">
+                <a:tc>
+                  <a:txBody>
+                    <a:bodyPr/>
+                    <a:lstStyle/>
+                    <a:p>
+                      <a:r>
+                        <a:rPr sz="1050">
+                          <a:solidFill>
+                            <a:srgbClr val="3D5466"/>
+                          </a:solidFill>
+                          <a:latin typeface="Arial"/>
+                        </a:rPr>
+                        <a:t>Autorität</a:t>
+                      </a:r>
+                    </a:p>
+                  </a:txBody>
+                  <a:tcPr/>
+                </a:tc>
+              </a:tr>
+              <a:tr h="384048">
+                <a:tc>
+                  <a:txBody>
+                    <a:bodyPr/>
+                    <a:lstStyle/>
+                    <a:p>
+                      <a:r>
+                        <a:rPr sz="1050">
+                          <a:solidFill>
+                            <a:srgbClr val="3D5466"/>
+                          </a:solidFill>
+                          <a:latin typeface="Arial"/>
+                        </a:rPr>
+                        <a:t>Aufgabe</a:t>
+                      </a:r>
+                    </a:p>
+                  </a:txBody>
+                  <a:tcPr/>
+                </a:tc>
+              </a:tr>
+              <a:tr h="384048">
+                <a:tc>
+                  <a:txBody>
+                    <a:bodyPr/>
+                    <a:lstStyle/>
+                    <a:p>
+                      <a:r>
+                        <a:rPr sz="1050">
+                          <a:solidFill>
+                            <a:srgbClr val="3D5466"/>
+                          </a:solidFill>
+                          <a:latin typeface="Arial"/>
+                        </a:rPr>
+                        <a:t>Zeit</a:t>
+                      </a:r>
+                    </a:p>
+                  </a:txBody>
+                  <a:tcPr/>
+                </a:tc>
+              </a:tr>
+            </a:tbl>
+          </a:graphicData>
+        </a:graphic>
+      </p:graphicFrame>
+      <p:sp>
+        <p:nvSpPr>
+          <p:cNvPr id="8" name="Rectangle 7"/>
           <p:cNvSpPr/>
           <p:nvPr/>
         </p:nvSpPr>
@@ -9022,7 +11259,7 @@
       </p:sp>
       <p:sp>
         <p:nvSpPr>
-          <p:cNvPr id="10" name="TextBox 9"/>
+          <p:cNvPr id="9" name="TextBox 8"/>
           <p:cNvSpPr txBox="1"/>
           <p:nvPr/>
         </p:nvSpPr>
@@ -9051,6 +11288,41 @@
                 <a:latin typeface="Consolas"/>
               </a:rPr>
               <a:t>FKB Campus  ·  TL00</a:t>
+            </a:r>
+          </a:p>
+        </p:txBody>
+      </p:sp>
+      <p:sp>
+        <p:nvSpPr>
+          <p:cNvPr id="10" name="TextBox 9"/>
+          <p:cNvSpPr txBox="1"/>
+          <p:nvPr/>
+        </p:nvSpPr>
+        <p:spPr>
+          <a:xfrm>
+            <a:off x="7176211" y="6583680"/>
+            <a:ext cx="4326940" cy="256032"/>
+          </a:xfrm>
+          <a:prstGeom prst="rect">
+            <a:avLst/>
+          </a:prstGeom>
+          <a:noFill/>
+        </p:spPr>
+        <p:txBody>
+          <a:bodyPr wrap="none">
+            <a:spAutoFit/>
+          </a:bodyPr>
+          <a:lstStyle/>
+          <a:p>
+            <a:pPr algn="r"/>
+            <a:r>
+              <a:rPr sz="700">
+                <a:solidFill>
+                  <a:srgbClr val="A0B4D2"/>
+                </a:solidFill>
+                <a:latin typeface="Consolas"/>
+              </a:rPr>
+              <a:t>Übersicht</a:t>
             </a:r>
           </a:p>
         </p:txBody>
@@ -9088,7 +11360,7 @@
             <a:avLst/>
           </a:prstGeom>
           <a:solidFill>
-            <a:srgbClr val="EDEDF3"/>
+            <a:srgbClr val="FFFFFF"/>
           </a:solidFill>
           <a:ln>
             <a:noFill/>
@@ -9189,51 +11461,43 @@
                 </a:solidFill>
                 <a:latin typeface="Consolas"/>
               </a:rPr>
-              <a:t>TL00  ·  ARBEITSBLATT</a:t>
-            </a:r>
-          </a:p>
-        </p:txBody>
-      </p:sp>
-      <p:sp>
-        <p:nvSpPr>
-          <p:cNvPr id="5" name="Rectangle 4"/>
-          <p:cNvSpPr/>
-          <p:nvPr/>
-        </p:nvSpPr>
-        <p:spPr>
-          <a:xfrm>
-            <a:off x="0" y="1234440"/>
-            <a:ext cx="12188952" cy="12700"/>
-          </a:xfrm>
-          <a:prstGeom prst="rect">
-            <a:avLst/>
-          </a:prstGeom>
-          <a:solidFill>
-            <a:srgbClr val="D8DFE4"/>
-          </a:solidFill>
-          <a:ln>
-            <a:noFill/>
-          </a:ln>
-        </p:spPr>
-        <p:style>
-          <a:lnRef idx="1">
-            <a:schemeClr val="accent1"/>
-          </a:lnRef>
-          <a:fillRef idx="3">
-            <a:schemeClr val="accent1"/>
-          </a:fillRef>
-          <a:effectRef idx="2">
-            <a:schemeClr val="accent1"/>
-          </a:effectRef>
-          <a:fontRef idx="minor">
-            <a:schemeClr val="lt1"/>
-          </a:fontRef>
-        </p:style>
-        <p:txBody>
-          <a:bodyPr rtlCol="0" anchor="ctr"/>
-          <a:lstStyle/>
-          <a:p>
-            <a:pPr algn="ctr"/>
+              <a:t>TL00  ·  ÜBERSICHT</a:t>
+            </a:r>
+          </a:p>
+        </p:txBody>
+      </p:sp>
+      <p:sp>
+        <p:nvSpPr>
+          <p:cNvPr id="5" name="TextBox 4"/>
+          <p:cNvSpPr txBox="1"/>
+          <p:nvPr/>
+        </p:nvSpPr>
+        <p:spPr>
+          <a:xfrm>
+            <a:off x="685800" y="502920"/>
+            <a:ext cx="10817352" cy="594360"/>
+          </a:xfrm>
+          <a:prstGeom prst="rect">
+            <a:avLst/>
+          </a:prstGeom>
+          <a:noFill/>
+        </p:spPr>
+        <p:txBody>
+          <a:bodyPr wrap="square">
+            <a:spAutoFit/>
+          </a:bodyPr>
+          <a:lstStyle/>
+          <a:p>
+            <a:pPr algn="l"/>
+            <a:r>
+              <a:rPr sz="2000" b="1" i="0">
+                <a:solidFill>
+                  <a:srgbClr val="1F2C56"/>
+                </a:solidFill>
+                <a:latin typeface="Arial"/>
+              </a:rPr>
+              <a:t>Ihre Zeit gehört jetzt Ihrem Team – das ist messbar</a:t>
+            </a:r>
           </a:p>
         </p:txBody>
       </p:sp>
@@ -9245,8 +11509,8 @@
         </p:nvSpPr>
         <p:spPr>
           <a:xfrm>
-            <a:off x="685800" y="502920"/>
-            <a:ext cx="36576" cy="658368"/>
+            <a:off x="685800" y="1143000"/>
+            <a:ext cx="10817352" cy="25400"/>
           </a:xfrm>
           <a:prstGeom prst="rect">
             <a:avLst/>
@@ -9280,240 +11544,144 @@
           </a:p>
         </p:txBody>
       </p:sp>
-      <p:sp>
-        <p:nvSpPr>
-          <p:cNvPr id="7" name="TextBox 6"/>
-          <p:cNvSpPr txBox="1"/>
-          <p:nvPr/>
-        </p:nvSpPr>
-        <p:spPr>
-          <a:xfrm>
-            <a:off x="813816" y="502920"/>
-            <a:ext cx="10634472" cy="685800"/>
-          </a:xfrm>
-          <a:prstGeom prst="rect">
-            <a:avLst/>
-          </a:prstGeom>
-          <a:noFill/>
-        </p:spPr>
-        <p:txBody>
-          <a:bodyPr wrap="square">
-            <a:spAutoFit/>
-          </a:bodyPr>
-          <a:lstStyle/>
-          <a:p>
-            <a:pPr algn="l"/>
-            <a:r>
-              <a:rPr sz="2400" b="1" i="0">
-                <a:solidFill>
-                  <a:srgbClr val="1F2C56"/>
-                </a:solidFill>
-                <a:latin typeface="Arial"/>
-              </a:rPr>
-              <a:t>Praxisfall: Thomas K. – vier Monate als Teamleiter</a:t>
-            </a:r>
-          </a:p>
-        </p:txBody>
-      </p:sp>
-      <p:sp>
-        <p:nvSpPr>
-          <p:cNvPr id="8" name="TextBox 7"/>
-          <p:cNvSpPr txBox="1"/>
-          <p:nvPr/>
-        </p:nvSpPr>
-        <p:spPr>
-          <a:xfrm>
-            <a:off x="685800" y="1554480"/>
-            <a:ext cx="10817352" cy="3840480"/>
-          </a:xfrm>
-          <a:prstGeom prst="rect">
-            <a:avLst/>
-          </a:prstGeom>
-          <a:noFill/>
-        </p:spPr>
-        <p:txBody>
-          <a:bodyPr wrap="square">
-            <a:spAutoFit/>
-          </a:bodyPr>
-          <a:lstStyle/>
-          <a:p>
-            <a:pPr marL="190500" indent="-190500">
-              <a:spcBef>
-                <a:spcPts val="400"/>
-              </a:spcBef>
-              <a:spcAft>
-                <a:spcPts val="200"/>
-              </a:spcAft>
-            </a:pPr>
-            <a:r>
-              <a:rPr sz="1400">
-                <a:solidFill>
-                  <a:srgbClr val="3D5466"/>
-                </a:solidFill>
-                <a:latin typeface="Arial"/>
-              </a:rPr>
-              <a:t>▸  Ausgangslage (anonymisiert, branchentypisch)</a:t>
-            </a:r>
-          </a:p>
-          <a:p>
-            <a:pPr marL="190500" indent="-190500">
-              <a:spcBef>
-                <a:spcPts val="400"/>
-              </a:spcBef>
-              <a:spcAft>
-                <a:spcPts val="200"/>
-              </a:spcAft>
-            </a:pPr>
-            <a:r>
-              <a:rPr sz="1400">
-                <a:solidFill>
-                  <a:srgbClr val="3D5466"/>
-                </a:solidFill>
-                <a:latin typeface="Arial"/>
-              </a:rPr>
-              <a:t>▸  Vier Entscheidungssituationen</a:t>
-            </a:r>
-          </a:p>
-          <a:p>
-            <a:pPr marL="190500" indent="-190500">
-              <a:spcBef>
-                <a:spcPts val="400"/>
-              </a:spcBef>
-              <a:spcAft>
-                <a:spcPts val="200"/>
-              </a:spcAft>
-            </a:pPr>
-            <a:r>
-              <a:rPr sz="1400">
-                <a:solidFill>
-                  <a:srgbClr val="3D5466"/>
-                </a:solidFill>
-                <a:latin typeface="Arial"/>
-              </a:rPr>
-              <a:t>▸  Situation A – Das eigene Kreditengagement:</a:t>
-            </a:r>
-          </a:p>
-          <a:p>
-            <a:pPr marL="190500" indent="-190500">
-              <a:spcBef>
-                <a:spcPts val="400"/>
-              </a:spcBef>
-              <a:spcAft>
-                <a:spcPts val="200"/>
-              </a:spcAft>
-            </a:pPr>
-            <a:r>
-              <a:rPr sz="1400">
-                <a:solidFill>
-                  <a:srgbClr val="3D5466"/>
-                </a:solidFill>
-                <a:latin typeface="Arial"/>
-              </a:rPr>
-              <a:t>▸  Welche Entscheidung trifft Thomas – und mit welcher Begründung?</a:t>
-            </a:r>
-          </a:p>
-          <a:p>
-            <a:pPr marL="190500" indent="-190500">
-              <a:spcBef>
-                <a:spcPts val="400"/>
-              </a:spcBef>
-              <a:spcAft>
-                <a:spcPts val="200"/>
-              </a:spcAft>
-            </a:pPr>
-            <a:r>
-              <a:rPr sz="1400">
-                <a:solidFill>
-                  <a:srgbClr val="3D5466"/>
-                </a:solidFill>
-                <a:latin typeface="Arial"/>
-              </a:rPr>
-              <a:t>▸  Situation B1 – Der Kollege als Mitarbeiter (Rückzugs-Variante):</a:t>
-            </a:r>
-          </a:p>
-        </p:txBody>
-      </p:sp>
-      <p:sp>
-        <p:nvSpPr>
-          <p:cNvPr id="9" name="Rectangle 8"/>
-          <p:cNvSpPr/>
-          <p:nvPr/>
-        </p:nvSpPr>
-        <p:spPr>
-          <a:xfrm>
-            <a:off x="685800" y="5486400"/>
-            <a:ext cx="10817352" cy="640080"/>
-          </a:xfrm>
-          <a:prstGeom prst="rect">
-            <a:avLst/>
-          </a:prstGeom>
-          <a:solidFill>
-            <a:srgbClr val="1F2C56"/>
-          </a:solidFill>
-          <a:ln>
-            <a:noFill/>
-          </a:ln>
-        </p:spPr>
-        <p:style>
-          <a:lnRef idx="1">
-            <a:schemeClr val="accent1"/>
-          </a:lnRef>
-          <a:fillRef idx="3">
-            <a:schemeClr val="accent1"/>
-          </a:fillRef>
-          <a:effectRef idx="2">
-            <a:schemeClr val="accent1"/>
-          </a:effectRef>
-          <a:fontRef idx="minor">
-            <a:schemeClr val="lt1"/>
-          </a:fontRef>
-        </p:style>
-        <p:txBody>
-          <a:bodyPr rtlCol="0" anchor="ctr"/>
-          <a:lstStyle/>
-          <a:p>
-            <a:pPr algn="ctr"/>
-          </a:p>
-        </p:txBody>
-      </p:sp>
-      <p:sp>
-        <p:nvSpPr>
-          <p:cNvPr id="10" name="TextBox 9"/>
-          <p:cNvSpPr txBox="1"/>
-          <p:nvPr/>
-        </p:nvSpPr>
-        <p:spPr>
-          <a:xfrm>
-            <a:off x="868680" y="5596128"/>
-            <a:ext cx="10451592" cy="457200"/>
-          </a:xfrm>
-          <a:prstGeom prst="rect">
-            <a:avLst/>
-          </a:prstGeom>
-          <a:noFill/>
-        </p:spPr>
-        <p:txBody>
-          <a:bodyPr wrap="square">
-            <a:spAutoFit/>
-          </a:bodyPr>
-          <a:lstStyle/>
-          <a:p>
-            <a:pPr algn="l"/>
-            <a:r>
-              <a:rPr sz="1300" b="1" i="0">
-                <a:solidFill>
-                  <a:srgbClr val="FFFFFF"/>
-                </a:solidFill>
-                <a:latin typeface="Arial"/>
-              </a:rPr>
-              <a:t>→  Bearbeitung im Teilnehmer-Workbook (Arbeitsblatt mit Ausfüllfeldern)</a:t>
-            </a:r>
-          </a:p>
-        </p:txBody>
-      </p:sp>
-      <p:sp>
-        <p:nvSpPr>
-          <p:cNvPr id="11" name="Rectangle 10"/>
+      <p:graphicFrame>
+        <p:nvGraphicFramePr>
+          <p:cNvPr id="7" name="Table 6"/>
+          <p:cNvGraphicFramePr>
+            <a:graphicFrameLocks noGrp="1"/>
+          </p:cNvGraphicFramePr>
+          <p:nvPr/>
+        </p:nvGraphicFramePr>
+        <p:xfrm>
+          <a:off x="685800" y="1417320"/>
+          <a:ext cx="10817352" cy="2304288"/>
+        </p:xfrm>
+        <a:graphic>
+          <a:graphicData uri="http://schemas.openxmlformats.org/drawingml/2006/table">
+            <a:tbl>
+              <a:tblPr firstRow="1" bandRow="1">
+                <a:tableStyleId>{5C22544A-7EE6-4342-B048-85BDC9FD1C3A}</a:tableStyleId>
+              </a:tblPr>
+              <a:tblGrid>
+                <a:gridCol w="10817352"/>
+              </a:tblGrid>
+              <a:tr h="384048">
+                <a:tc>
+                  <a:txBody>
+                    <a:bodyPr/>
+                    <a:lstStyle/>
+                    <a:p/>
+                  </a:txBody>
+                  <a:tcPr/>
+                </a:tc>
+              </a:tr>
+              <a:tr h="384048">
+                <a:tc>
+                  <a:txBody>
+                    <a:bodyPr/>
+                    <a:lstStyle/>
+                    <a:p>
+                      <a:r>
+                        <a:rPr sz="1050">
+                          <a:solidFill>
+                            <a:srgbClr val="3D5466"/>
+                          </a:solidFill>
+                          <a:latin typeface="Arial"/>
+                        </a:rPr>
+                        <a:t>Tätigkeit</a:t>
+                      </a:r>
+                    </a:p>
+                  </a:txBody>
+                  <a:tcPr/>
+                </a:tc>
+              </a:tr>
+              <a:tr h="384048">
+                <a:tc>
+                  <a:txBody>
+                    <a:bodyPr/>
+                    <a:lstStyle/>
+                    <a:p>
+                      <a:r>
+                        <a:rPr sz="1050">
+                          <a:solidFill>
+                            <a:srgbClr val="3D5466"/>
+                          </a:solidFill>
+                          <a:latin typeface="Arial"/>
+                        </a:rPr>
+                        <a:t>Kundengespräche</a:t>
+                      </a:r>
+                    </a:p>
+                  </a:txBody>
+                  <a:tcPr/>
+                </a:tc>
+              </a:tr>
+              <a:tr h="384048">
+                <a:tc>
+                  <a:txBody>
+                    <a:bodyPr/>
+                    <a:lstStyle/>
+                    <a:p>
+                      <a:r>
+                        <a:rPr sz="1050">
+                          <a:solidFill>
+                            <a:srgbClr val="3D5466"/>
+                          </a:solidFill>
+                          <a:latin typeface="Arial"/>
+                        </a:rPr>
+                        <a:t>Facharbeit / Kredit</a:t>
+                      </a:r>
+                    </a:p>
+                  </a:txBody>
+                  <a:tcPr/>
+                </a:tc>
+              </a:tr>
+              <a:tr h="384048">
+                <a:tc>
+                  <a:txBody>
+                    <a:bodyPr/>
+                    <a:lstStyle/>
+                    <a:p>
+                      <a:r>
+                        <a:rPr sz="1050">
+                          <a:solidFill>
+                            <a:srgbClr val="3D5466"/>
+                          </a:solidFill>
+                          <a:latin typeface="Arial"/>
+                        </a:rPr>
+                        <a:t>Führungsgespräche / Steuerung</a:t>
+                      </a:r>
+                    </a:p>
+                  </a:txBody>
+                  <a:tcPr/>
+                </a:tc>
+              </a:tr>
+              <a:tr h="384048">
+                <a:tc>
+                  <a:txBody>
+                    <a:bodyPr/>
+                    <a:lstStyle/>
+                    <a:p>
+                      <a:r>
+                        <a:rPr sz="1050">
+                          <a:solidFill>
+                            <a:srgbClr val="3D5466"/>
+                          </a:solidFill>
+                          <a:latin typeface="Arial"/>
+                        </a:rPr>
+                        <a:t>Abstimmung nach oben</a:t>
+                      </a:r>
+                    </a:p>
+                  </a:txBody>
+                  <a:tcPr/>
+                </a:tc>
+              </a:tr>
+            </a:tbl>
+          </a:graphicData>
+        </a:graphic>
+      </p:graphicFrame>
+      <p:sp>
+        <p:nvSpPr>
+          <p:cNvPr id="8" name="Rectangle 7"/>
           <p:cNvSpPr/>
           <p:nvPr/>
         </p:nvSpPr>
@@ -9556,7 +11724,7 @@
       </p:sp>
       <p:sp>
         <p:nvSpPr>
-          <p:cNvPr id="12" name="TextBox 11"/>
+          <p:cNvPr id="9" name="TextBox 8"/>
           <p:cNvSpPr txBox="1"/>
           <p:nvPr/>
         </p:nvSpPr>
@@ -9585,6 +11753,41 @@
                 <a:latin typeface="Consolas"/>
               </a:rPr>
               <a:t>FKB Campus  ·  TL00</a:t>
+            </a:r>
+          </a:p>
+        </p:txBody>
+      </p:sp>
+      <p:sp>
+        <p:nvSpPr>
+          <p:cNvPr id="10" name="TextBox 9"/>
+          <p:cNvSpPr txBox="1"/>
+          <p:nvPr/>
+        </p:nvSpPr>
+        <p:spPr>
+          <a:xfrm>
+            <a:off x="7176211" y="6583680"/>
+            <a:ext cx="4326940" cy="256032"/>
+          </a:xfrm>
+          <a:prstGeom prst="rect">
+            <a:avLst/>
+          </a:prstGeom>
+          <a:noFill/>
+        </p:spPr>
+        <p:txBody>
+          <a:bodyPr wrap="none">
+            <a:spAutoFit/>
+          </a:bodyPr>
+          <a:lstStyle/>
+          <a:p>
+            <a:pPr algn="r"/>
+            <a:r>
+              <a:rPr sz="700">
+                <a:solidFill>
+                  <a:srgbClr val="A0B4D2"/>
+                </a:solidFill>
+                <a:latin typeface="Consolas"/>
+              </a:rPr>
+              <a:t>Übersicht</a:t>
             </a:r>
           </a:p>
         </p:txBody>

</xml_diff>

<commit_message>
TL-Decks neu generiert: Blocktrenner-Fix + TL03 Martell-Werkzeuge
</commit_message>
<xml_diff>
--- a/protected-downloads/praesentation/TL00.pptx
+++ b/protected-downloads/praesentation/TL00.pptx
@@ -5810,7 +5810,7 @@
             <a:avLst/>
           </a:prstGeom>
           <a:solidFill>
-            <a:srgbClr val="EDEDF3"/>
+            <a:srgbClr val="1F2C56"/>
           </a:solidFill>
           <a:ln>
             <a:noFill/>
@@ -5846,129 +5846,8 @@
         </p:nvSpPr>
         <p:spPr>
           <a:xfrm>
-            <a:off x="0" y="0"/>
-            <a:ext cx="12188952" cy="50292"/>
-          </a:xfrm>
-          <a:prstGeom prst="rect">
-            <a:avLst/>
-          </a:prstGeom>
-          <a:solidFill>
-            <a:srgbClr val="1F2C56"/>
-          </a:solidFill>
-          <a:ln>
-            <a:noFill/>
-          </a:ln>
-        </p:spPr>
-        <p:style>
-          <a:lnRef idx="1">
-            <a:schemeClr val="accent1"/>
-          </a:lnRef>
-          <a:fillRef idx="3">
-            <a:schemeClr val="accent1"/>
-          </a:fillRef>
-          <a:effectRef idx="2">
-            <a:schemeClr val="accent1"/>
-          </a:effectRef>
-          <a:fontRef idx="minor">
-            <a:schemeClr val="lt1"/>
-          </a:fontRef>
-        </p:style>
-        <p:txBody>
-          <a:bodyPr rtlCol="0" anchor="ctr"/>
-          <a:lstStyle/>
-          <a:p>
-            <a:pPr algn="ctr"/>
-          </a:p>
-        </p:txBody>
-      </p:sp>
-      <p:sp>
-        <p:nvSpPr>
-          <p:cNvPr id="4" name="TextBox 3"/>
-          <p:cNvSpPr txBox="1"/>
-          <p:nvPr/>
-        </p:nvSpPr>
-        <p:spPr>
-          <a:xfrm>
-            <a:off x="685800" y="109728"/>
-            <a:ext cx="10817352" cy="228600"/>
-          </a:xfrm>
-          <a:prstGeom prst="rect">
-            <a:avLst/>
-          </a:prstGeom>
-          <a:noFill/>
-        </p:spPr>
-        <p:txBody>
-          <a:bodyPr wrap="none">
-            <a:spAutoFit/>
-          </a:bodyPr>
-          <a:lstStyle/>
-          <a:p>
-            <a:pPr algn="l"/>
-            <a:r>
-              <a:rPr sz="750">
-                <a:solidFill>
-                  <a:srgbClr val="78808C"/>
-                </a:solidFill>
-                <a:latin typeface="Consolas"/>
-              </a:rPr>
-              <a:t>TL00  ·  INHALT</a:t>
-            </a:r>
-          </a:p>
-        </p:txBody>
-      </p:sp>
-      <p:sp>
-        <p:nvSpPr>
-          <p:cNvPr id="5" name="Rectangle 4"/>
-          <p:cNvSpPr/>
-          <p:nvPr/>
-        </p:nvSpPr>
-        <p:spPr>
-          <a:xfrm>
-            <a:off x="0" y="1234440"/>
-            <a:ext cx="12188952" cy="12700"/>
-          </a:xfrm>
-          <a:prstGeom prst="rect">
-            <a:avLst/>
-          </a:prstGeom>
-          <a:solidFill>
-            <a:srgbClr val="D8DFE4"/>
-          </a:solidFill>
-          <a:ln>
-            <a:noFill/>
-          </a:ln>
-        </p:spPr>
-        <p:style>
-          <a:lnRef idx="1">
-            <a:schemeClr val="accent1"/>
-          </a:lnRef>
-          <a:fillRef idx="3">
-            <a:schemeClr val="accent1"/>
-          </a:fillRef>
-          <a:effectRef idx="2">
-            <a:schemeClr val="accent1"/>
-          </a:effectRef>
-          <a:fontRef idx="minor">
-            <a:schemeClr val="lt1"/>
-          </a:fontRef>
-        </p:style>
-        <p:txBody>
-          <a:bodyPr rtlCol="0" anchor="ctr"/>
-          <a:lstStyle/>
-          <a:p>
-            <a:pPr algn="ctr"/>
-          </a:p>
-        </p:txBody>
-      </p:sp>
-      <p:sp>
-        <p:nvSpPr>
-          <p:cNvPr id="6" name="Rectangle 5"/>
-          <p:cNvSpPr/>
-          <p:nvPr/>
-        </p:nvSpPr>
-        <p:spPr>
-          <a:xfrm>
-            <a:off x="685800" y="502920"/>
-            <a:ext cx="36576" cy="658368"/>
+            <a:off x="685800" y="2788920"/>
+            <a:ext cx="548640" cy="38100"/>
           </a:xfrm>
           <a:prstGeom prst="rect">
             <a:avLst/>
@@ -6004,14 +5883,14 @@
       </p:sp>
       <p:sp>
         <p:nvSpPr>
-          <p:cNvPr id="7" name="TextBox 6"/>
+          <p:cNvPr id="4" name="TextBox 3"/>
           <p:cNvSpPr txBox="1"/>
           <p:nvPr/>
         </p:nvSpPr>
         <p:spPr>
           <a:xfrm>
-            <a:off x="813816" y="502920"/>
-            <a:ext cx="10634472" cy="685800"/>
+            <a:off x="685800" y="3017520"/>
+            <a:ext cx="10817352" cy="1463040"/>
           </a:xfrm>
           <a:prstGeom prst="rect">
             <a:avLst/>
@@ -6026,9 +5905,9 @@
           <a:p>
             <a:pPr algn="l"/>
             <a:r>
-              <a:rPr sz="2400" b="1" i="0">
-                <a:solidFill>
-                  <a:srgbClr val="1F2C56"/>
+              <a:rPr sz="4000" b="1" i="0">
+                <a:solidFill>
+                  <a:srgbClr val="FFFFFF"/>
                 </a:solidFill>
                 <a:latin typeface="Arial"/>
               </a:rPr>
@@ -6039,57 +5918,49 @@
       </p:sp>
       <p:sp>
         <p:nvSpPr>
-          <p:cNvPr id="8" name="Rectangle 7"/>
-          <p:cNvSpPr/>
-          <p:nvPr/>
-        </p:nvSpPr>
-        <p:spPr>
-          <a:xfrm>
-            <a:off x="0" y="6510528"/>
-            <a:ext cx="12188952" cy="347472"/>
-          </a:xfrm>
-          <a:prstGeom prst="rect">
-            <a:avLst/>
-          </a:prstGeom>
-          <a:solidFill>
-            <a:srgbClr val="0A1937"/>
-          </a:solidFill>
-          <a:ln>
-            <a:noFill/>
-          </a:ln>
-        </p:spPr>
-        <p:style>
-          <a:lnRef idx="1">
-            <a:schemeClr val="accent1"/>
-          </a:lnRef>
-          <a:fillRef idx="3">
-            <a:schemeClr val="accent1"/>
-          </a:fillRef>
-          <a:effectRef idx="2">
-            <a:schemeClr val="accent1"/>
-          </a:effectRef>
-          <a:fontRef idx="minor">
-            <a:schemeClr val="lt1"/>
-          </a:fontRef>
-        </p:style>
-        <p:txBody>
-          <a:bodyPr rtlCol="0" anchor="ctr"/>
-          <a:lstStyle/>
-          <a:p>
-            <a:pPr algn="ctr"/>
-          </a:p>
-        </p:txBody>
-      </p:sp>
-      <p:sp>
-        <p:nvSpPr>
-          <p:cNvPr id="9" name="TextBox 8"/>
+          <p:cNvPr id="5" name="TextBox 4"/>
           <p:cNvSpPr txBox="1"/>
           <p:nvPr/>
         </p:nvSpPr>
         <p:spPr>
           <a:xfrm>
-            <a:off x="685800" y="6583680"/>
-            <a:ext cx="6490411" cy="256032"/>
+            <a:off x="685800" y="4480560"/>
+            <a:ext cx="8653881" cy="1280160"/>
+          </a:xfrm>
+          <a:prstGeom prst="rect">
+            <a:avLst/>
+          </a:prstGeom>
+          <a:noFill/>
+        </p:spPr>
+        <p:txBody>
+          <a:bodyPr wrap="square">
+            <a:spAutoFit/>
+          </a:bodyPr>
+          <a:lstStyle/>
+          <a:p>
+            <a:pPr algn="l"/>
+            <a:r>
+              <a:rPr sz="1600" b="0" i="0">
+                <a:solidFill>
+                  <a:srgbClr val="C8D2E6"/>
+                </a:solidFill>
+                <a:latin typeface="Arial"/>
+              </a:rPr>
+              <a:t>Servant Leadership als Haltungsgrundlage des FKB-Campus-Führungstracks</a:t>
+            </a:r>
+          </a:p>
+        </p:txBody>
+      </p:sp>
+      <p:sp>
+        <p:nvSpPr>
+          <p:cNvPr id="6" name="TextBox 5"/>
+          <p:cNvSpPr txBox="1"/>
+          <p:nvPr/>
+        </p:nvSpPr>
+        <p:spPr>
+          <a:xfrm>
+            <a:off x="685800" y="6355080"/>
+            <a:ext cx="10817352" cy="274320"/>
           </a:xfrm>
           <a:prstGeom prst="rect">
             <a:avLst/>
@@ -6106,7 +5977,7 @@
             <a:r>
               <a:rPr sz="700">
                 <a:solidFill>
-                  <a:srgbClr val="A0B4D2"/>
+                  <a:srgbClr val="8CA0C3"/>
                 </a:solidFill>
                 <a:latin typeface="Consolas"/>
               </a:rPr>
@@ -9766,7 +9637,7 @@
             <a:avLst/>
           </a:prstGeom>
           <a:solidFill>
-            <a:srgbClr val="EDEDF3"/>
+            <a:srgbClr val="1F2C56"/>
           </a:solidFill>
           <a:ln>
             <a:noFill/>
@@ -9802,129 +9673,8 @@
         </p:nvSpPr>
         <p:spPr>
           <a:xfrm>
-            <a:off x="0" y="0"/>
-            <a:ext cx="12188952" cy="50292"/>
-          </a:xfrm>
-          <a:prstGeom prst="rect">
-            <a:avLst/>
-          </a:prstGeom>
-          <a:solidFill>
-            <a:srgbClr val="1F2C56"/>
-          </a:solidFill>
-          <a:ln>
-            <a:noFill/>
-          </a:ln>
-        </p:spPr>
-        <p:style>
-          <a:lnRef idx="1">
-            <a:schemeClr val="accent1"/>
-          </a:lnRef>
-          <a:fillRef idx="3">
-            <a:schemeClr val="accent1"/>
-          </a:fillRef>
-          <a:effectRef idx="2">
-            <a:schemeClr val="accent1"/>
-          </a:effectRef>
-          <a:fontRef idx="minor">
-            <a:schemeClr val="lt1"/>
-          </a:fontRef>
-        </p:style>
-        <p:txBody>
-          <a:bodyPr rtlCol="0" anchor="ctr"/>
-          <a:lstStyle/>
-          <a:p>
-            <a:pPr algn="ctr"/>
-          </a:p>
-        </p:txBody>
-      </p:sp>
-      <p:sp>
-        <p:nvSpPr>
-          <p:cNvPr id="4" name="TextBox 3"/>
-          <p:cNvSpPr txBox="1"/>
-          <p:nvPr/>
-        </p:nvSpPr>
-        <p:spPr>
-          <a:xfrm>
-            <a:off x="685800" y="109728"/>
-            <a:ext cx="10817352" cy="228600"/>
-          </a:xfrm>
-          <a:prstGeom prst="rect">
-            <a:avLst/>
-          </a:prstGeom>
-          <a:noFill/>
-        </p:spPr>
-        <p:txBody>
-          <a:bodyPr wrap="none">
-            <a:spAutoFit/>
-          </a:bodyPr>
-          <a:lstStyle/>
-          <a:p>
-            <a:pPr algn="l"/>
-            <a:r>
-              <a:rPr sz="750">
-                <a:solidFill>
-                  <a:srgbClr val="78808C"/>
-                </a:solidFill>
-                <a:latin typeface="Consolas"/>
-              </a:rPr>
-              <a:t>TL00  ·  INHALT</a:t>
-            </a:r>
-          </a:p>
-        </p:txBody>
-      </p:sp>
-      <p:sp>
-        <p:nvSpPr>
-          <p:cNvPr id="5" name="Rectangle 4"/>
-          <p:cNvSpPr/>
-          <p:nvPr/>
-        </p:nvSpPr>
-        <p:spPr>
-          <a:xfrm>
-            <a:off x="0" y="1234440"/>
-            <a:ext cx="12188952" cy="12700"/>
-          </a:xfrm>
-          <a:prstGeom prst="rect">
-            <a:avLst/>
-          </a:prstGeom>
-          <a:solidFill>
-            <a:srgbClr val="D8DFE4"/>
-          </a:solidFill>
-          <a:ln>
-            <a:noFill/>
-          </a:ln>
-        </p:spPr>
-        <p:style>
-          <a:lnRef idx="1">
-            <a:schemeClr val="accent1"/>
-          </a:lnRef>
-          <a:fillRef idx="3">
-            <a:schemeClr val="accent1"/>
-          </a:fillRef>
-          <a:effectRef idx="2">
-            <a:schemeClr val="accent1"/>
-          </a:effectRef>
-          <a:fontRef idx="minor">
-            <a:schemeClr val="lt1"/>
-          </a:fontRef>
-        </p:style>
-        <p:txBody>
-          <a:bodyPr rtlCol="0" anchor="ctr"/>
-          <a:lstStyle/>
-          <a:p>
-            <a:pPr algn="ctr"/>
-          </a:p>
-        </p:txBody>
-      </p:sp>
-      <p:sp>
-        <p:nvSpPr>
-          <p:cNvPr id="6" name="Rectangle 5"/>
-          <p:cNvSpPr/>
-          <p:nvPr/>
-        </p:nvSpPr>
-        <p:spPr>
-          <a:xfrm>
-            <a:off x="685800" y="502920"/>
-            <a:ext cx="36576" cy="658368"/>
+            <a:off x="685800" y="2788920"/>
+            <a:ext cx="548640" cy="38100"/>
           </a:xfrm>
           <a:prstGeom prst="rect">
             <a:avLst/>
@@ -9960,14 +9710,14 @@
       </p:sp>
       <p:sp>
         <p:nvSpPr>
-          <p:cNvPr id="7" name="TextBox 6"/>
+          <p:cNvPr id="4" name="TextBox 3"/>
           <p:cNvSpPr txBox="1"/>
           <p:nvPr/>
         </p:nvSpPr>
         <p:spPr>
           <a:xfrm>
-            <a:off x="813816" y="502920"/>
-            <a:ext cx="10634472" cy="685800"/>
+            <a:off x="685800" y="3017520"/>
+            <a:ext cx="10817352" cy="1463040"/>
           </a:xfrm>
           <a:prstGeom prst="rect">
             <a:avLst/>
@@ -9982,9 +9732,9 @@
           <a:p>
             <a:pPr algn="l"/>
             <a:r>
-              <a:rPr sz="2400" b="1" i="0">
-                <a:solidFill>
-                  <a:srgbClr val="1F2C56"/>
+              <a:rPr sz="4000" b="1" i="0">
+                <a:solidFill>
+                  <a:srgbClr val="FFFFFF"/>
                 </a:solidFill>
                 <a:latin typeface="Arial"/>
               </a:rPr>
@@ -9995,57 +9745,49 @@
       </p:sp>
       <p:sp>
         <p:nvSpPr>
-          <p:cNvPr id="8" name="Rectangle 7"/>
-          <p:cNvSpPr/>
-          <p:nvPr/>
-        </p:nvSpPr>
-        <p:spPr>
-          <a:xfrm>
-            <a:off x="0" y="6510528"/>
-            <a:ext cx="12188952" cy="347472"/>
-          </a:xfrm>
-          <a:prstGeom prst="rect">
-            <a:avLst/>
-          </a:prstGeom>
-          <a:solidFill>
-            <a:srgbClr val="0A1937"/>
-          </a:solidFill>
-          <a:ln>
-            <a:noFill/>
-          </a:ln>
-        </p:spPr>
-        <p:style>
-          <a:lnRef idx="1">
-            <a:schemeClr val="accent1"/>
-          </a:lnRef>
-          <a:fillRef idx="3">
-            <a:schemeClr val="accent1"/>
-          </a:fillRef>
-          <a:effectRef idx="2">
-            <a:schemeClr val="accent1"/>
-          </a:effectRef>
-          <a:fontRef idx="minor">
-            <a:schemeClr val="lt1"/>
-          </a:fontRef>
-        </p:style>
-        <p:txBody>
-          <a:bodyPr rtlCol="0" anchor="ctr"/>
-          <a:lstStyle/>
-          <a:p>
-            <a:pPr algn="ctr"/>
-          </a:p>
-        </p:txBody>
-      </p:sp>
-      <p:sp>
-        <p:nvSpPr>
-          <p:cNvPr id="9" name="TextBox 8"/>
+          <p:cNvPr id="5" name="TextBox 4"/>
           <p:cNvSpPr txBox="1"/>
           <p:nvPr/>
         </p:nvSpPr>
         <p:spPr>
           <a:xfrm>
-            <a:off x="685800" y="6583680"/>
-            <a:ext cx="6490411" cy="256032"/>
+            <a:off x="685800" y="4480560"/>
+            <a:ext cx="8653881" cy="1280160"/>
+          </a:xfrm>
+          <a:prstGeom prst="rect">
+            <a:avLst/>
+          </a:prstGeom>
+          <a:noFill/>
+        </p:spPr>
+        <p:txBody>
+          <a:bodyPr wrap="square">
+            <a:spAutoFit/>
+          </a:bodyPr>
+          <a:lstStyle/>
+          <a:p>
+            <a:pPr algn="l"/>
+            <a:r>
+              <a:rPr sz="1600" b="0" i="0">
+                <a:solidFill>
+                  <a:srgbClr val="C8D2E6"/>
+                </a:solidFill>
+                <a:latin typeface="Arial"/>
+              </a:rPr>
+              <a:t>Was sich wirklich verändert, wenn aus dem besten Berater der Teamleiter wird</a:t>
+            </a:r>
+          </a:p>
+        </p:txBody>
+      </p:sp>
+      <p:sp>
+        <p:nvSpPr>
+          <p:cNvPr id="6" name="TextBox 5"/>
+          <p:cNvSpPr txBox="1"/>
+          <p:nvPr/>
+        </p:nvSpPr>
+        <p:spPr>
+          <a:xfrm>
+            <a:off x="685800" y="6355080"/>
+            <a:ext cx="10817352" cy="274320"/>
           </a:xfrm>
           <a:prstGeom prst="rect">
             <a:avLst/>
@@ -10062,7 +9804,7 @@
             <a:r>
               <a:rPr sz="700">
                 <a:solidFill>
-                  <a:srgbClr val="A0B4D2"/>
+                  <a:srgbClr val="8CA0C3"/>
                 </a:solidFill>
                 <a:latin typeface="Consolas"/>
               </a:rPr>

</xml_diff>

<commit_message>
TL-Decks: 10 bisher fehlende Folien (praxisfall/headline/pullquote)
</commit_message>
<xml_diff>
--- a/protected-downloads/praesentation/TL00.pptx
+++ b/protected-downloads/praesentation/TL00.pptx
@@ -23,6 +23,9 @@
     <p:sldId id="271" r:id="rId23"/>
     <p:sldId id="272" r:id="rId24"/>
     <p:sldId id="273" r:id="rId25"/>
+    <p:sldId id="274" r:id="rId26"/>
+    <p:sldId id="275" r:id="rId27"/>
+    <p:sldId id="276" r:id="rId28"/>
   </p:sldIdLst>
   <p:sldSz cx="12188952" cy="6858000" type="screen4x3"/>
   <p:notesSz cx="6858000" cy="9144000"/>
@@ -589,17 +592,7 @@
           <a:lstStyle/>
           <a:p>
             <a:r>
-              <a:t>Vor Beginn: Vertraulichkeit explizit zusichern – „Was hier geteilt wird, bleibt hier.“</a:t>
-            </a:r>
-          </a:p>
-          <a:p>
-            <a:r>
-              <a:t>Fallvorstellung-Runde: jeder 60 Sek., Trainer notiert Fälle am Flipchart ohne Kommentar. Dann gemeinsam abstimmen.</a:t>
-            </a:r>
-          </a:p>
-          <a:p>
-            <a:r>
-              <a:t>Notfallfall bereit: anonymisierte Abwandlung Situation D (Leistungsfeedback gemieden) – bei Peer-Statusangst sofort einsetzen, ohne Pause der Verlegenheit.</a:t>
+              <a:t>Ausgangslage laut vorlesen – gemeinsame Szene schaffen. Situationen gezielt verteilen: B2 immer der erfahrensten Gruppe oder ans Plenum.</a:t>
             </a:r>
           </a:p>
         </p:txBody>
@@ -669,12 +662,17 @@
           <a:lstStyle/>
           <a:p>
             <a:r>
-              <a:t>Schritt 5 ist nicht kürzbar. Schritt 6 (Transfer-Runde) kann bei Zeitdruck auf stille Einzelnotiz 30 Sek. komprimiert werden.</a:t>
-            </a:r>
-          </a:p>
-          <a:p>
-            <a:r>
-              <a:t>Häufigste Hürde in unerfahrenen Gruppen: in Schritt 2 kommen versteckte Ratschläge als Fragen verkleidet. Trainer bricht höflich ab: „Das klingt schon nach einer Empfehlung – die kommt in Schritt 4.“</a:t>
+              <a:t>Vier Situationen: A (Delegation Stammkunde), B1 (Kollege/Rückzug), B2 (Kollege/ Koalition – emotionalster Moment, im Plenum), C (GL-Entwicklungsgespräch), D (erstes kritisches Leistungsfeedback – häufigste Vermeidung).</a:t>
+            </a:r>
+          </a:p>
+          <a:p>
+            <a:r>
+              <a:t>Musterlösung erst NACH Gruppenarbeit zeigen. Teilnehmerlösungen zuerst am Flipchart sammeln.</a:t>
+            </a:r>
+          </a:p>
+          <a:p>
+            <a:r>
+              <a:t>Bei Situation D: „Wer kennt ein ähnliches Gespräch, das zu lange aufgeschoben wurde?“ – Fast alle kennen es. Direkte Brücke zu AB-2.</a:t>
             </a:r>
           </a:p>
         </p:txBody>
@@ -744,12 +742,17 @@
           <a:lstStyle/>
           <a:p>
             <a:r>
-              <a:t>AB-2 ist der „Ernstfall“ des Moduls. Stille hier ist produktiv – nicht unterbrechen.</a:t>
-            </a:r>
-          </a:p>
-          <a:p>
-            <a:r>
-              <a:t>Plenum-Echo freiwillig: 90 Sek. Feedback-Schema: „Was war stark?“ / „Was könnte schärfer sein?“ – nur zur Formulierung, nicht zum geplanten Gespräch selbst.</a:t>
+              <a:t>Vor Beginn: Vertraulichkeit explizit zusichern – „Was hier geteilt wird, bleibt hier.“</a:t>
+            </a:r>
+          </a:p>
+          <a:p>
+            <a:r>
+              <a:t>Fallvorstellung-Runde: jeder 60 Sek., Trainer notiert Fälle am Flipchart ohne Kommentar. Dann gemeinsam abstimmen.</a:t>
+            </a:r>
+          </a:p>
+          <a:p>
+            <a:r>
+              <a:t>Notfallfall bereit: anonymisierte Abwandlung Situation D (Leistungsfeedback gemieden) – bei Peer-Statusangst sofort einsetzen, ohne Pause der Verlegenheit.</a:t>
             </a:r>
           </a:p>
         </p:txBody>
@@ -819,7 +822,12 @@
           <a:lstStyle/>
           <a:p>
             <a:r>
-              <a:t>Vorbild Situation D Musterlösung: Einstiegssatz benennt den Sachverhalt direkt, ohne Umschweife. Häufigste Fehler: zu lang erklären; offen enden ohne Nächstes.</a:t>
+              <a:t>Schritt 5 ist nicht kürzbar. Schritt 6 (Transfer-Runde) kann bei Zeitdruck auf stille Einzelnotiz 30 Sek. komprimiert werden.</a:t>
+            </a:r>
+          </a:p>
+          <a:p>
+            <a:r>
+              <a:t>Häufigste Hürde in unerfahrenen Gruppen: in Schritt 2 kommen versteckte Ratschläge als Fragen verkleidet. Trainer bricht höflich ab: „Das klingt schon nach einer Empfehlung – die kommt in Schritt 4.“</a:t>
             </a:r>
           </a:p>
         </p:txBody>
@@ -889,6 +897,231 @@
           <a:lstStyle/>
           <a:p>
             <a:r>
+              <a:t>AB-2 ist der „Ernstfall“ des Moduls. Stille hier ist produktiv – nicht unterbrechen.</a:t>
+            </a:r>
+          </a:p>
+          <a:p>
+            <a:r>
+              <a:t>Plenum-Echo freiwillig: 90 Sek. Feedback-Schema: „Was war stark?“ / „Was könnte schärfer sein?“ – nur zur Formulierung, nicht zum geplanten Gespräch selbst.</a:t>
+            </a:r>
+          </a:p>
+        </p:txBody>
+      </p:sp>
+      <p:sp>
+        <p:nvSpPr>
+          <p:cNvPr id="4" name="Slide Number Placeholder 3"/>
+          <p:cNvSpPr>
+            <a:spLocks noGrp="1"/>
+          </p:cNvSpPr>
+          <p:nvPr>
+            <p:ph type="sldNum" idx="5" sz="quarter"/>
+          </p:nvPr>
+        </p:nvSpPr>
+        <p:spPr/>
+      </p:sp>
+    </p:spTree>
+  </p:cSld>
+  <p:clrMapOvr>
+    <a:masterClrMapping/>
+  </p:clrMapOvr>
+</p:notes>
+</file>
+
+<file path=ppt/notesSlides/notesSlide15.xml><?xml version="1.0" encoding="utf-8"?>
+<p:notes xmlns:a="http://schemas.openxmlformats.org/drawingml/2006/main" xmlns:p="http://schemas.openxmlformats.org/presentationml/2006/main" xmlns:r="http://schemas.openxmlformats.org/officeDocument/2006/relationships">
+  <p:cSld>
+    <p:spTree>
+      <p:nvGrpSpPr>
+        <p:cNvPr id="1" name=""/>
+        <p:cNvGrpSpPr/>
+        <p:nvPr/>
+      </p:nvGrpSpPr>
+      <p:grpSpPr>
+        <a:xfrm>
+          <a:off x="0" y="0"/>
+          <a:ext cx="0" cy="0"/>
+          <a:chOff x="0" y="0"/>
+          <a:chExt cx="0" cy="0"/>
+        </a:xfrm>
+      </p:grpSpPr>
+      <p:sp>
+        <p:nvSpPr>
+          <p:cNvPr id="2" name="Slide Image Placeholder 1"/>
+          <p:cNvSpPr>
+            <a:spLocks noGrp="1"/>
+          </p:cNvSpPr>
+          <p:nvPr>
+            <p:ph type="sldImg" idx="2"/>
+          </p:nvPr>
+        </p:nvSpPr>
+        <p:spPr/>
+      </p:sp>
+      <p:sp>
+        <p:nvSpPr>
+          <p:cNvPr id="3" name="Notes Placeholder 2"/>
+          <p:cNvSpPr>
+            <a:spLocks noGrp="1"/>
+          </p:cNvSpPr>
+          <p:nvPr>
+            <p:ph type="body" idx="3" sz="quarter"/>
+          </p:nvPr>
+        </p:nvSpPr>
+        <p:spPr/>
+        <p:txBody>
+          <a:bodyPr/>
+          <a:lstStyle/>
+          <a:p>
+            <a:r>
+              <a:t>Vorbild Situation D Musterlösung: Einstiegssatz benennt den Sachverhalt direkt, ohne Umschweife. Häufigste Fehler: zu lang erklären; offen enden ohne Nächstes.</a:t>
+            </a:r>
+          </a:p>
+        </p:txBody>
+      </p:sp>
+      <p:sp>
+        <p:nvSpPr>
+          <p:cNvPr id="4" name="Slide Number Placeholder 3"/>
+          <p:cNvSpPr>
+            <a:spLocks noGrp="1"/>
+          </p:cNvSpPr>
+          <p:nvPr>
+            <p:ph type="sldNum" idx="5" sz="quarter"/>
+          </p:nvPr>
+        </p:nvSpPr>
+        <p:spPr/>
+      </p:sp>
+    </p:spTree>
+  </p:cSld>
+  <p:clrMapOvr>
+    <a:masterClrMapping/>
+  </p:clrMapOvr>
+</p:notes>
+</file>
+
+<file path=ppt/notesSlides/notesSlide16.xml><?xml version="1.0" encoding="utf-8"?>
+<p:notes xmlns:a="http://schemas.openxmlformats.org/drawingml/2006/main" xmlns:p="http://schemas.openxmlformats.org/presentationml/2006/main" xmlns:r="http://schemas.openxmlformats.org/officeDocument/2006/relationships">
+  <p:cSld>
+    <p:spTree>
+      <p:nvGrpSpPr>
+        <p:cNvPr id="1" name=""/>
+        <p:cNvGrpSpPr/>
+        <p:nvPr/>
+      </p:nvGrpSpPr>
+      <p:grpSpPr>
+        <a:xfrm>
+          <a:off x="0" y="0"/>
+          <a:ext cx="0" cy="0"/>
+          <a:chOff x="0" y="0"/>
+          <a:chExt cx="0" cy="0"/>
+        </a:xfrm>
+      </p:grpSpPr>
+      <p:sp>
+        <p:nvSpPr>
+          <p:cNvPr id="2" name="Slide Image Placeholder 1"/>
+          <p:cNvSpPr>
+            <a:spLocks noGrp="1"/>
+          </p:cNvSpPr>
+          <p:nvPr>
+            <p:ph type="sldImg" idx="2"/>
+          </p:nvPr>
+        </p:nvSpPr>
+        <p:spPr/>
+      </p:sp>
+      <p:sp>
+        <p:nvSpPr>
+          <p:cNvPr id="3" name="Notes Placeholder 2"/>
+          <p:cNvSpPr>
+            <a:spLocks noGrp="1"/>
+          </p:cNvSpPr>
+          <p:nvPr>
+            <p:ph type="body" idx="3" sz="quarter"/>
+          </p:nvPr>
+        </p:nvSpPr>
+        <p:spPr/>
+        <p:txBody>
+          <a:bodyPr/>
+          <a:lstStyle/>
+          <a:p>
+            <a:r>
+              <a:t>Merk-/Haltungskarte gemeinsam laut vorlesen (ca. 2 Min.) – Rückverweis auf Rollenwechsel-Impuls vom Morgen. Stille Reflexion 3 Min.</a:t>
+            </a:r>
+          </a:p>
+          <a:p>
+            <a:r>
+              <a:t>Abschlussrunde: jeder spricht einen Satz – „Mein konkreter nächster Schritt in der Führungsrolle ist …“. Öffentliches Commitment (soziale Selbstverpflichtung).</a:t>
+            </a:r>
+          </a:p>
+          <a:p>
+            <a:r>
+              <a:t>Transferaufgaben und Checkliste austeilen – nicht diskutieren, nur klar kommunizieren.</a:t>
+            </a:r>
+          </a:p>
+        </p:txBody>
+      </p:sp>
+      <p:sp>
+        <p:nvSpPr>
+          <p:cNvPr id="4" name="Slide Number Placeholder 3"/>
+          <p:cNvSpPr>
+            <a:spLocks noGrp="1"/>
+          </p:cNvSpPr>
+          <p:nvPr>
+            <p:ph type="sldNum" idx="5" sz="quarter"/>
+          </p:nvPr>
+        </p:nvSpPr>
+        <p:spPr/>
+      </p:sp>
+    </p:spTree>
+  </p:cSld>
+  <p:clrMapOvr>
+    <a:masterClrMapping/>
+  </p:clrMapOvr>
+</p:notes>
+</file>
+
+<file path=ppt/notesSlides/notesSlide17.xml><?xml version="1.0" encoding="utf-8"?>
+<p:notes xmlns:a="http://schemas.openxmlformats.org/drawingml/2006/main" xmlns:p="http://schemas.openxmlformats.org/presentationml/2006/main" xmlns:r="http://schemas.openxmlformats.org/officeDocument/2006/relationships">
+  <p:cSld>
+    <p:spTree>
+      <p:nvGrpSpPr>
+        <p:cNvPr id="1" name=""/>
+        <p:cNvGrpSpPr/>
+        <p:nvPr/>
+      </p:nvGrpSpPr>
+      <p:grpSpPr>
+        <a:xfrm>
+          <a:off x="0" y="0"/>
+          <a:ext cx="0" cy="0"/>
+          <a:chOff x="0" y="0"/>
+          <a:chExt cx="0" cy="0"/>
+        </a:xfrm>
+      </p:grpSpPr>
+      <p:sp>
+        <p:nvSpPr>
+          <p:cNvPr id="2" name="Slide Image Placeholder 1"/>
+          <p:cNvSpPr>
+            <a:spLocks noGrp="1"/>
+          </p:cNvSpPr>
+          <p:nvPr>
+            <p:ph type="sldImg" idx="2"/>
+          </p:nvPr>
+        </p:nvSpPr>
+        <p:spPr/>
+      </p:sp>
+      <p:sp>
+        <p:nvSpPr>
+          <p:cNvPr id="3" name="Notes Placeholder 2"/>
+          <p:cNvSpPr>
+            <a:spLocks noGrp="1"/>
+          </p:cNvSpPr>
+          <p:nvPr>
+            <p:ph type="body" idx="3" sz="quarter"/>
+          </p:nvPr>
+        </p:nvSpPr>
+        <p:spPr/>
+        <p:txBody>
+          <a:bodyPr/>
+          <a:lstStyle/>
+          <a:p>
+            <a:r>
               <a:t>Transferaufgaben 1–3 aus Sec 5 kurz benennen. Checkliste mitgeben: „Legen Sie diese Karte in vier Wochen wieder vor sich – das ist Ihr eigener Maßstab.“</a:t>
             </a:r>
           </a:p>
@@ -1474,7 +1707,12 @@
           <a:lstStyle/>
           <a:p>
             <a:r>
-              <a:t>Ausgangslage laut vorlesen – gemeinsame Szene schaffen. Situationen gezielt verteilen: B2 immer der erfahrensten Gruppe oder ans Plenum.</a:t>
+              <a:t>Skepsis-Reaktion abfangen: „Servant Leadership ist kein Konflikt-Vermeidungs-Modell.“ van Dierendonck (2011, Q-219): klare Orientierung und konsequente Steuerung sind ausdrücklich Kernbestandteile – nicht Durchgreifen schließt es aus, sondern Hierarchie als Selbstzweck.</a:t>
+            </a:r>
+          </a:p>
+          <a:p>
+            <a:r>
+              <a:t>Passung zum Genossenschaftskontext: Förderauftrag § 1 GenG, Subsidiaritätsprinzip.</a:t>
             </a:r>
           </a:p>
         </p:txBody>
@@ -6049,49 +6287,14 @@
       </p:sp>
       <p:sp>
         <p:nvSpPr>
-          <p:cNvPr id="3" name="TextBox 2"/>
-          <p:cNvSpPr txBox="1"/>
-          <p:nvPr/>
-        </p:nvSpPr>
-        <p:spPr>
-          <a:xfrm>
-            <a:off x="685800" y="2377440"/>
-            <a:ext cx="10817352" cy="365760"/>
-          </a:xfrm>
-          <a:prstGeom prst="rect">
-            <a:avLst/>
-          </a:prstGeom>
-          <a:noFill/>
-        </p:spPr>
-        <p:txBody>
-          <a:bodyPr wrap="none">
-            <a:spAutoFit/>
-          </a:bodyPr>
-          <a:lstStyle/>
-          <a:p>
-            <a:pPr algn="l"/>
-            <a:r>
-              <a:rPr sz="1200">
-                <a:solidFill>
-                  <a:srgbClr val="D9C089"/>
-                </a:solidFill>
-                <a:latin typeface="Consolas"/>
-              </a:rPr>
-              <a:t>GRUPPENARBEIT (15 MIN.) + PLENUMSAUSWERTUNG (15 MIN.)</a:t>
-            </a:r>
-          </a:p>
-        </p:txBody>
-      </p:sp>
-      <p:sp>
-        <p:nvSpPr>
-          <p:cNvPr id="4" name="Rectangle 3"/>
+          <p:cNvPr id="3" name="Rectangle 2"/>
           <p:cNvSpPr/>
           <p:nvPr/>
         </p:nvSpPr>
         <p:spPr>
           <a:xfrm>
-            <a:off x="685800" y="2788920"/>
-            <a:ext cx="548640" cy="38100"/>
+            <a:off x="0" y="0"/>
+            <a:ext cx="12188952" cy="54864"/>
           </a:xfrm>
           <a:prstGeom prst="rect">
             <a:avLst/>
@@ -6127,13 +6330,48 @@
       </p:sp>
       <p:sp>
         <p:nvSpPr>
+          <p:cNvPr id="4" name="TextBox 3"/>
+          <p:cNvSpPr txBox="1"/>
+          <p:nvPr/>
+        </p:nvSpPr>
+        <p:spPr>
+          <a:xfrm>
+            <a:off x="685800" y="201168"/>
+            <a:ext cx="10817352" cy="256032"/>
+          </a:xfrm>
+          <a:prstGeom prst="rect">
+            <a:avLst/>
+          </a:prstGeom>
+          <a:noFill/>
+        </p:spPr>
+        <p:txBody>
+          <a:bodyPr wrap="none">
+            <a:spAutoFit/>
+          </a:bodyPr>
+          <a:lstStyle/>
+          <a:p>
+            <a:pPr algn="l"/>
+            <a:r>
+              <a:rPr sz="750">
+                <a:solidFill>
+                  <a:srgbClr val="C8D2E6"/>
+                </a:solidFill>
+                <a:latin typeface="Consolas"/>
+              </a:rPr>
+              <a:t>FKB CAMPUS  ·  TL00</a:t>
+            </a:r>
+          </a:p>
+        </p:txBody>
+      </p:sp>
+      <p:sp>
+        <p:nvSpPr>
           <p:cNvPr id="5" name="TextBox 4"/>
           <p:cNvSpPr txBox="1"/>
           <p:nvPr/>
         </p:nvSpPr>
         <p:spPr>
           <a:xfrm>
-            <a:off x="685800" y="3017520"/>
+            <a:off x="685800" y="1051560"/>
             <a:ext cx="10817352" cy="1463040"/>
           </a:xfrm>
           <a:prstGeom prst="rect">
@@ -6149,27 +6387,70 @@
           <a:p>
             <a:pPr algn="l"/>
             <a:r>
-              <a:rPr sz="4000" b="1" i="0">
+              <a:rPr sz="3200" b="1" i="0">
                 <a:solidFill>
                   <a:srgbClr val="FFFFFF"/>
                 </a:solidFill>
                 <a:latin typeface="Arial"/>
               </a:rPr>
-              <a:t>Praxisfall: Thomas K. – vier Monate als Teamleiter</a:t>
-            </a:r>
-          </a:p>
-        </p:txBody>
-      </p:sp>
-      <p:sp>
-        <p:nvSpPr>
-          <p:cNvPr id="6" name="TextBox 5"/>
+              <a:t>Servant Leadership bedeutet: Ich bin gut darin, andere besser zu machen.</a:t>
+            </a:r>
+          </a:p>
+        </p:txBody>
+      </p:sp>
+      <p:sp>
+        <p:nvSpPr>
+          <p:cNvPr id="6" name="Rectangle 5"/>
+          <p:cNvSpPr/>
+          <p:nvPr/>
+        </p:nvSpPr>
+        <p:spPr>
+          <a:xfrm>
+            <a:off x="685800" y="2788920"/>
+            <a:ext cx="548640" cy="38100"/>
+          </a:xfrm>
+          <a:prstGeom prst="rect">
+            <a:avLst/>
+          </a:prstGeom>
+          <a:solidFill>
+            <a:srgbClr val="D9C089"/>
+          </a:solidFill>
+          <a:ln>
+            <a:noFill/>
+          </a:ln>
+        </p:spPr>
+        <p:style>
+          <a:lnRef idx="1">
+            <a:schemeClr val="accent1"/>
+          </a:lnRef>
+          <a:fillRef idx="3">
+            <a:schemeClr val="accent1"/>
+          </a:fillRef>
+          <a:effectRef idx="2">
+            <a:schemeClr val="accent1"/>
+          </a:effectRef>
+          <a:fontRef idx="minor">
+            <a:schemeClr val="lt1"/>
+          </a:fontRef>
+        </p:style>
+        <p:txBody>
+          <a:bodyPr rtlCol="0" anchor="ctr"/>
+          <a:lstStyle/>
+          <a:p>
+            <a:pPr algn="ctr"/>
+          </a:p>
+        </p:txBody>
+      </p:sp>
+      <p:sp>
+        <p:nvSpPr>
+          <p:cNvPr id="7" name="TextBox 6"/>
           <p:cNvSpPr txBox="1"/>
           <p:nvPr/>
         </p:nvSpPr>
         <p:spPr>
           <a:xfrm>
-            <a:off x="685800" y="4480560"/>
-            <a:ext cx="8653881" cy="1280160"/>
+            <a:off x="685800" y="3200400"/>
+            <a:ext cx="5134356" cy="2377440"/>
           </a:xfrm>
           <a:prstGeom prst="rect">
             <a:avLst/>
@@ -6182,22 +6463,55 @@
           </a:bodyPr>
           <a:lstStyle/>
           <a:p>
-            <a:pPr algn="l"/>
-            <a:r>
-              <a:rPr sz="1600" b="0" i="0">
+            <a:r>
+              <a:rPr sz="1400">
                 <a:solidFill>
                   <a:srgbClr val="C8D2E6"/>
                 </a:solidFill>
                 <a:latin typeface="Arial"/>
               </a:rPr>
-              <a:t>Rollenfallen und Führungshandlungen an vier konkreten Situationen durchdenken</a:t>
-            </a:r>
-          </a:p>
-        </p:txBody>
-      </p:sp>
-      <p:sp>
-        <p:nvSpPr>
-          <p:cNvPr id="7" name="TextBox 6"/>
+              <a:t>Greenleafs leitende Frage: Wachsen die Menschen, denen ich führe, als Persönlichkeiten? Werden sie handlungsfähiger, kompetenter, autonomer? Diese Frage ersetzt die Frage nach der eigenen Leistung.</a:t>
+            </a:r>
+          </a:p>
+        </p:txBody>
+      </p:sp>
+      <p:sp>
+        <p:nvSpPr>
+          <p:cNvPr id="8" name="TextBox 7"/>
+          <p:cNvSpPr txBox="1"/>
+          <p:nvPr/>
+        </p:nvSpPr>
+        <p:spPr>
+          <a:xfrm>
+            <a:off x="6368796" y="3200400"/>
+            <a:ext cx="5134356" cy="2377440"/>
+          </a:xfrm>
+          <a:prstGeom prst="rect">
+            <a:avLst/>
+          </a:prstGeom>
+          <a:noFill/>
+        </p:spPr>
+        <p:txBody>
+          <a:bodyPr wrap="square">
+            <a:spAutoFit/>
+          </a:bodyPr>
+          <a:lstStyle/>
+          <a:p>
+            <a:r>
+              <a:rPr sz="1400">
+                <a:solidFill>
+                  <a:srgbClr val="C8D2E6"/>
+                </a:solidFill>
+                <a:latin typeface="Arial"/>
+              </a:rPr>
+              <a:t>Merksatz für die Führungsrolle: Führung ist nicht das, was ich tue. Führung ist, was in meinem Team möglich wird – und was ich klar verantworte.</a:t>
+            </a:r>
+          </a:p>
+        </p:txBody>
+      </p:sp>
+      <p:sp>
+        <p:nvSpPr>
+          <p:cNvPr id="9" name="TextBox 8"/>
           <p:cNvSpPr txBox="1"/>
           <p:nvPr/>
         </p:nvSpPr>
@@ -6321,7 +6635,7 @@
                 </a:solidFill>
                 <a:latin typeface="Consolas"/>
               </a:rPr>
-              <a:t>KERNBLOCK 40 MIN. (FALLVORSTELLUNG-RUNDE 8–10 MIN. + VERTIEFUNGSFALL 30 MIN.)</a:t>
+              <a:t>GRUPPENARBEIT (15 MIN.) + PLENUMSAUSWERTUNG (15 MIN.)</a:t>
             </a:r>
           </a:p>
         </p:txBody>
@@ -6399,7 +6713,7 @@
                 </a:solidFill>
                 <a:latin typeface="Arial"/>
               </a:rPr>
-              <a:t>Kollegiale Fallberatung</a:t>
+              <a:t>Praxisfall: Thomas K. – vier Monate als Teamleiter</a:t>
             </a:r>
           </a:p>
         </p:txBody>
@@ -6434,7 +6748,7 @@
                 </a:solidFill>
                 <a:latin typeface="Arial"/>
               </a:rPr>
-              <a:t>Einen realen Führungsfall aus der Gruppe nach dem Sechs-Schritte-Format bearbeiten</a:t>
+              <a:t>Rollenfallen und Führungshandlungen an vier konkreten Situationen durchdenken</a:t>
             </a:r>
           </a:p>
         </p:txBody>
@@ -6483,6 +6797,785 @@
 </file>
 
 <file path=ppt/slides/slide15.xml><?xml version="1.0" encoding="utf-8"?>
+<p:sld xmlns:a="http://schemas.openxmlformats.org/drawingml/2006/main" xmlns:p="http://schemas.openxmlformats.org/presentationml/2006/main" xmlns:r="http://schemas.openxmlformats.org/officeDocument/2006/relationships">
+  <p:cSld>
+    <p:spTree>
+      <p:nvGrpSpPr>
+        <p:cNvPr id="1" name=""/>
+        <p:cNvGrpSpPr/>
+        <p:nvPr/>
+      </p:nvGrpSpPr>
+      <p:grpSpPr/>
+      <p:sp>
+        <p:nvSpPr>
+          <p:cNvPr id="2" name="Rectangle 1"/>
+          <p:cNvSpPr/>
+          <p:nvPr/>
+        </p:nvSpPr>
+        <p:spPr>
+          <a:xfrm>
+            <a:off x="0" y="0"/>
+            <a:ext cx="12188952" cy="6858000"/>
+          </a:xfrm>
+          <a:prstGeom prst="rect">
+            <a:avLst/>
+          </a:prstGeom>
+          <a:solidFill>
+            <a:srgbClr val="EDEDF3"/>
+          </a:solidFill>
+          <a:ln>
+            <a:noFill/>
+          </a:ln>
+        </p:spPr>
+        <p:style>
+          <a:lnRef idx="1">
+            <a:schemeClr val="accent1"/>
+          </a:lnRef>
+          <a:fillRef idx="3">
+            <a:schemeClr val="accent1"/>
+          </a:fillRef>
+          <a:effectRef idx="2">
+            <a:schemeClr val="accent1"/>
+          </a:effectRef>
+          <a:fontRef idx="minor">
+            <a:schemeClr val="lt1"/>
+          </a:fontRef>
+        </p:style>
+        <p:txBody>
+          <a:bodyPr rtlCol="0" anchor="ctr"/>
+          <a:lstStyle/>
+          <a:p>
+            <a:pPr algn="ctr"/>
+          </a:p>
+        </p:txBody>
+      </p:sp>
+      <p:sp>
+        <p:nvSpPr>
+          <p:cNvPr id="3" name="Rectangle 2"/>
+          <p:cNvSpPr/>
+          <p:nvPr/>
+        </p:nvSpPr>
+        <p:spPr>
+          <a:xfrm>
+            <a:off x="0" y="0"/>
+            <a:ext cx="12188952" cy="50292"/>
+          </a:xfrm>
+          <a:prstGeom prst="rect">
+            <a:avLst/>
+          </a:prstGeom>
+          <a:solidFill>
+            <a:srgbClr val="1F2C56"/>
+          </a:solidFill>
+          <a:ln>
+            <a:noFill/>
+          </a:ln>
+        </p:spPr>
+        <p:style>
+          <a:lnRef idx="1">
+            <a:schemeClr val="accent1"/>
+          </a:lnRef>
+          <a:fillRef idx="3">
+            <a:schemeClr val="accent1"/>
+          </a:fillRef>
+          <a:effectRef idx="2">
+            <a:schemeClr val="accent1"/>
+          </a:effectRef>
+          <a:fontRef idx="minor">
+            <a:schemeClr val="lt1"/>
+          </a:fontRef>
+        </p:style>
+        <p:txBody>
+          <a:bodyPr rtlCol="0" anchor="ctr"/>
+          <a:lstStyle/>
+          <a:p>
+            <a:pPr algn="ctr"/>
+          </a:p>
+        </p:txBody>
+      </p:sp>
+      <p:sp>
+        <p:nvSpPr>
+          <p:cNvPr id="4" name="TextBox 3"/>
+          <p:cNvSpPr txBox="1"/>
+          <p:nvPr/>
+        </p:nvSpPr>
+        <p:spPr>
+          <a:xfrm>
+            <a:off x="685800" y="109728"/>
+            <a:ext cx="10817352" cy="228600"/>
+          </a:xfrm>
+          <a:prstGeom prst="rect">
+            <a:avLst/>
+          </a:prstGeom>
+          <a:noFill/>
+        </p:spPr>
+        <p:txBody>
+          <a:bodyPr wrap="none">
+            <a:spAutoFit/>
+          </a:bodyPr>
+          <a:lstStyle/>
+          <a:p>
+            <a:pPr algn="l"/>
+            <a:r>
+              <a:rPr sz="750">
+                <a:solidFill>
+                  <a:srgbClr val="78808C"/>
+                </a:solidFill>
+                <a:latin typeface="Consolas"/>
+              </a:rPr>
+              <a:t>TL00  ·  PRAXISFALL</a:t>
+            </a:r>
+          </a:p>
+        </p:txBody>
+      </p:sp>
+      <p:sp>
+        <p:nvSpPr>
+          <p:cNvPr id="5" name="Rectangle 4"/>
+          <p:cNvSpPr/>
+          <p:nvPr/>
+        </p:nvSpPr>
+        <p:spPr>
+          <a:xfrm>
+            <a:off x="0" y="1234440"/>
+            <a:ext cx="12188952" cy="12700"/>
+          </a:xfrm>
+          <a:prstGeom prst="rect">
+            <a:avLst/>
+          </a:prstGeom>
+          <a:solidFill>
+            <a:srgbClr val="D8DFE4"/>
+          </a:solidFill>
+          <a:ln>
+            <a:noFill/>
+          </a:ln>
+        </p:spPr>
+        <p:style>
+          <a:lnRef idx="1">
+            <a:schemeClr val="accent1"/>
+          </a:lnRef>
+          <a:fillRef idx="3">
+            <a:schemeClr val="accent1"/>
+          </a:fillRef>
+          <a:effectRef idx="2">
+            <a:schemeClr val="accent1"/>
+          </a:effectRef>
+          <a:fontRef idx="minor">
+            <a:schemeClr val="lt1"/>
+          </a:fontRef>
+        </p:style>
+        <p:txBody>
+          <a:bodyPr rtlCol="0" anchor="ctr"/>
+          <a:lstStyle/>
+          <a:p>
+            <a:pPr algn="ctr"/>
+          </a:p>
+        </p:txBody>
+      </p:sp>
+      <p:sp>
+        <p:nvSpPr>
+          <p:cNvPr id="6" name="Rectangle 5"/>
+          <p:cNvSpPr/>
+          <p:nvPr/>
+        </p:nvSpPr>
+        <p:spPr>
+          <a:xfrm>
+            <a:off x="685800" y="502920"/>
+            <a:ext cx="36576" cy="658368"/>
+          </a:xfrm>
+          <a:prstGeom prst="rect">
+            <a:avLst/>
+          </a:prstGeom>
+          <a:solidFill>
+            <a:srgbClr val="D9C089"/>
+          </a:solidFill>
+          <a:ln>
+            <a:noFill/>
+          </a:ln>
+        </p:spPr>
+        <p:style>
+          <a:lnRef idx="1">
+            <a:schemeClr val="accent1"/>
+          </a:lnRef>
+          <a:fillRef idx="3">
+            <a:schemeClr val="accent1"/>
+          </a:fillRef>
+          <a:effectRef idx="2">
+            <a:schemeClr val="accent1"/>
+          </a:effectRef>
+          <a:fontRef idx="minor">
+            <a:schemeClr val="lt1"/>
+          </a:fontRef>
+        </p:style>
+        <p:txBody>
+          <a:bodyPr rtlCol="0" anchor="ctr"/>
+          <a:lstStyle/>
+          <a:p>
+            <a:pPr algn="ctr"/>
+          </a:p>
+        </p:txBody>
+      </p:sp>
+      <p:sp>
+        <p:nvSpPr>
+          <p:cNvPr id="7" name="TextBox 6"/>
+          <p:cNvSpPr txBox="1"/>
+          <p:nvPr/>
+        </p:nvSpPr>
+        <p:spPr>
+          <a:xfrm>
+            <a:off x="813816" y="502920"/>
+            <a:ext cx="10634472" cy="685800"/>
+          </a:xfrm>
+          <a:prstGeom prst="rect">
+            <a:avLst/>
+          </a:prstGeom>
+          <a:noFill/>
+        </p:spPr>
+        <p:txBody>
+          <a:bodyPr wrap="square">
+            <a:spAutoFit/>
+          </a:bodyPr>
+          <a:lstStyle/>
+          <a:p>
+            <a:pPr algn="l"/>
+            <a:r>
+              <a:rPr sz="2400" b="1" i="0">
+                <a:solidFill>
+                  <a:srgbClr val="1F2C56"/>
+                </a:solidFill>
+                <a:latin typeface="Arial"/>
+              </a:rPr>
+              <a:t>Thomas K., VR-Bank Musterregion eG</a:t>
+            </a:r>
+          </a:p>
+        </p:txBody>
+      </p:sp>
+      <p:sp>
+        <p:nvSpPr>
+          <p:cNvPr id="8" name="Rectangle 7"/>
+          <p:cNvSpPr/>
+          <p:nvPr/>
+        </p:nvSpPr>
+        <p:spPr>
+          <a:xfrm>
+            <a:off x="685800" y="1600200"/>
+            <a:ext cx="10817352" cy="1828800"/>
+          </a:xfrm>
+          <a:prstGeom prst="rect">
+            <a:avLst/>
+          </a:prstGeom>
+          <a:solidFill>
+            <a:srgbClr val="FFFFFF"/>
+          </a:solidFill>
+          <a:ln w="9525">
+            <a:solidFill>
+              <a:srgbClr val="D8DFE4"/>
+            </a:solidFill>
+          </a:ln>
+        </p:spPr>
+        <p:style>
+          <a:lnRef idx="1">
+            <a:schemeClr val="accent1"/>
+          </a:lnRef>
+          <a:fillRef idx="3">
+            <a:schemeClr val="accent1"/>
+          </a:fillRef>
+          <a:effectRef idx="2">
+            <a:schemeClr val="accent1"/>
+          </a:effectRef>
+          <a:fontRef idx="minor">
+            <a:schemeClr val="lt1"/>
+          </a:fontRef>
+        </p:style>
+        <p:txBody>
+          <a:bodyPr rtlCol="0" anchor="ctr"/>
+          <a:lstStyle/>
+          <a:p>
+            <a:pPr algn="ctr"/>
+          </a:p>
+        </p:txBody>
+      </p:sp>
+      <p:sp>
+        <p:nvSpPr>
+          <p:cNvPr id="9" name="Rectangle 8"/>
+          <p:cNvSpPr/>
+          <p:nvPr/>
+        </p:nvSpPr>
+        <p:spPr>
+          <a:xfrm>
+            <a:off x="685800" y="1600200"/>
+            <a:ext cx="36576" cy="1828800"/>
+          </a:xfrm>
+          <a:prstGeom prst="rect">
+            <a:avLst/>
+          </a:prstGeom>
+          <a:solidFill>
+            <a:srgbClr val="1F2C56"/>
+          </a:solidFill>
+          <a:ln>
+            <a:noFill/>
+          </a:ln>
+        </p:spPr>
+        <p:style>
+          <a:lnRef idx="1">
+            <a:schemeClr val="accent1"/>
+          </a:lnRef>
+          <a:fillRef idx="3">
+            <a:schemeClr val="accent1"/>
+          </a:fillRef>
+          <a:effectRef idx="2">
+            <a:schemeClr val="accent1"/>
+          </a:effectRef>
+          <a:fontRef idx="minor">
+            <a:schemeClr val="lt1"/>
+          </a:fontRef>
+        </p:style>
+        <p:txBody>
+          <a:bodyPr rtlCol="0" anchor="ctr"/>
+          <a:lstStyle/>
+          <a:p>
+            <a:pPr algn="ctr"/>
+          </a:p>
+        </p:txBody>
+      </p:sp>
+      <p:sp>
+        <p:nvSpPr>
+          <p:cNvPr id="10" name="TextBox 9"/>
+          <p:cNvSpPr txBox="1"/>
+          <p:nvPr/>
+        </p:nvSpPr>
+        <p:spPr>
+          <a:xfrm>
+            <a:off x="941832" y="1783080"/>
+            <a:ext cx="10268712" cy="228600"/>
+          </a:xfrm>
+          <a:prstGeom prst="rect">
+            <a:avLst/>
+          </a:prstGeom>
+          <a:noFill/>
+        </p:spPr>
+        <p:txBody>
+          <a:bodyPr wrap="none">
+            <a:spAutoFit/>
+          </a:bodyPr>
+          <a:lstStyle/>
+          <a:p>
+            <a:pPr algn="l"/>
+            <a:r>
+              <a:rPr sz="750">
+                <a:solidFill>
+                  <a:srgbClr val="78808C"/>
+                </a:solidFill>
+                <a:latin typeface="Consolas"/>
+              </a:rPr>
+              <a:t>AUSGANGSSITUATION</a:t>
+            </a:r>
+          </a:p>
+        </p:txBody>
+      </p:sp>
+      <p:sp>
+        <p:nvSpPr>
+          <p:cNvPr id="11" name="TextBox 10"/>
+          <p:cNvSpPr txBox="1"/>
+          <p:nvPr/>
+        </p:nvSpPr>
+        <p:spPr>
+          <a:xfrm>
+            <a:off x="941832" y="2084831"/>
+            <a:ext cx="7680960" cy="1188720"/>
+          </a:xfrm>
+          <a:prstGeom prst="rect">
+            <a:avLst/>
+          </a:prstGeom>
+          <a:noFill/>
+        </p:spPr>
+        <p:txBody>
+          <a:bodyPr wrap="square">
+            <a:spAutoFit/>
+          </a:bodyPr>
+          <a:lstStyle/>
+          <a:p>
+            <a:pPr>
+              <a:spcAft>
+                <a:spcPts val="600"/>
+              </a:spcAft>
+            </a:pPr>
+            <a:r>
+              <a:rPr sz="1500">
+                <a:solidFill>
+                  <a:srgbClr val="3D5466"/>
+                </a:solidFill>
+                <a:latin typeface="Arial"/>
+              </a:rPr>
+              <a:t>Thomas K. (38) ist seit vier Monaten Teamleiter Firmenkunden. Vorher neun Jahre lang der umsatzstärkste Berater. Er greift in Kreditausarbeitungen ein, hält zwei Stammkunden selbst – und sein früherer Bürokollege Marco sagt: „Ich dachte, du lässt mich das jetzt machen.“</a:t>
+            </a:r>
+          </a:p>
+        </p:txBody>
+      </p:sp>
+      <p:sp>
+        <p:nvSpPr>
+          <p:cNvPr id="12" name="Rectangle 11"/>
+          <p:cNvSpPr/>
+          <p:nvPr/>
+        </p:nvSpPr>
+        <p:spPr>
+          <a:xfrm>
+            <a:off x="0" y="6510528"/>
+            <a:ext cx="12188952" cy="347472"/>
+          </a:xfrm>
+          <a:prstGeom prst="rect">
+            <a:avLst/>
+          </a:prstGeom>
+          <a:solidFill>
+            <a:srgbClr val="0A1937"/>
+          </a:solidFill>
+          <a:ln>
+            <a:noFill/>
+          </a:ln>
+        </p:spPr>
+        <p:style>
+          <a:lnRef idx="1">
+            <a:schemeClr val="accent1"/>
+          </a:lnRef>
+          <a:fillRef idx="3">
+            <a:schemeClr val="accent1"/>
+          </a:fillRef>
+          <a:effectRef idx="2">
+            <a:schemeClr val="accent1"/>
+          </a:effectRef>
+          <a:fontRef idx="minor">
+            <a:schemeClr val="lt1"/>
+          </a:fontRef>
+        </p:style>
+        <p:txBody>
+          <a:bodyPr rtlCol="0" anchor="ctr"/>
+          <a:lstStyle/>
+          <a:p>
+            <a:pPr algn="ctr"/>
+          </a:p>
+        </p:txBody>
+      </p:sp>
+      <p:sp>
+        <p:nvSpPr>
+          <p:cNvPr id="13" name="TextBox 12"/>
+          <p:cNvSpPr txBox="1"/>
+          <p:nvPr/>
+        </p:nvSpPr>
+        <p:spPr>
+          <a:xfrm>
+            <a:off x="685800" y="6583680"/>
+            <a:ext cx="6490411" cy="256032"/>
+          </a:xfrm>
+          <a:prstGeom prst="rect">
+            <a:avLst/>
+          </a:prstGeom>
+          <a:noFill/>
+        </p:spPr>
+        <p:txBody>
+          <a:bodyPr wrap="none">
+            <a:spAutoFit/>
+          </a:bodyPr>
+          <a:lstStyle/>
+          <a:p>
+            <a:pPr algn="l"/>
+            <a:r>
+              <a:rPr sz="700">
+                <a:solidFill>
+                  <a:srgbClr val="A0B4D2"/>
+                </a:solidFill>
+                <a:latin typeface="Consolas"/>
+              </a:rPr>
+              <a:t>FKB Campus  ·  TL00</a:t>
+            </a:r>
+          </a:p>
+        </p:txBody>
+      </p:sp>
+      <p:sp>
+        <p:nvSpPr>
+          <p:cNvPr id="14" name="TextBox 13"/>
+          <p:cNvSpPr txBox="1"/>
+          <p:nvPr/>
+        </p:nvSpPr>
+        <p:spPr>
+          <a:xfrm>
+            <a:off x="7176211" y="6583680"/>
+            <a:ext cx="4326940" cy="256032"/>
+          </a:xfrm>
+          <a:prstGeom prst="rect">
+            <a:avLst/>
+          </a:prstGeom>
+          <a:noFill/>
+        </p:spPr>
+        <p:txBody>
+          <a:bodyPr wrap="none">
+            <a:spAutoFit/>
+          </a:bodyPr>
+          <a:lstStyle/>
+          <a:p>
+            <a:pPr algn="r"/>
+            <a:r>
+              <a:rPr sz="700">
+                <a:solidFill>
+                  <a:srgbClr val="A0B4D2"/>
+                </a:solidFill>
+                <a:latin typeface="Consolas"/>
+              </a:rPr>
+              <a:t>Fall zuerst lesen</a:t>
+            </a:r>
+          </a:p>
+        </p:txBody>
+      </p:sp>
+    </p:spTree>
+  </p:cSld>
+  <p:clrMapOvr>
+    <a:masterClrMapping/>
+  </p:clrMapOvr>
+</p:sld>
+</file>
+
+<file path=ppt/slides/slide16.xml><?xml version="1.0" encoding="utf-8"?>
+<p:sld xmlns:a="http://schemas.openxmlformats.org/drawingml/2006/main" xmlns:p="http://schemas.openxmlformats.org/presentationml/2006/main" xmlns:r="http://schemas.openxmlformats.org/officeDocument/2006/relationships">
+  <p:cSld>
+    <p:spTree>
+      <p:nvGrpSpPr>
+        <p:cNvPr id="1" name=""/>
+        <p:cNvGrpSpPr/>
+        <p:nvPr/>
+      </p:nvGrpSpPr>
+      <p:grpSpPr/>
+      <p:sp>
+        <p:nvSpPr>
+          <p:cNvPr id="2" name="Rectangle 1"/>
+          <p:cNvSpPr/>
+          <p:nvPr/>
+        </p:nvSpPr>
+        <p:spPr>
+          <a:xfrm>
+            <a:off x="0" y="0"/>
+            <a:ext cx="12188952" cy="6858000"/>
+          </a:xfrm>
+          <a:prstGeom prst="rect">
+            <a:avLst/>
+          </a:prstGeom>
+          <a:solidFill>
+            <a:srgbClr val="1F2C56"/>
+          </a:solidFill>
+          <a:ln>
+            <a:noFill/>
+          </a:ln>
+        </p:spPr>
+        <p:style>
+          <a:lnRef idx="1">
+            <a:schemeClr val="accent1"/>
+          </a:lnRef>
+          <a:fillRef idx="3">
+            <a:schemeClr val="accent1"/>
+          </a:fillRef>
+          <a:effectRef idx="2">
+            <a:schemeClr val="accent1"/>
+          </a:effectRef>
+          <a:fontRef idx="minor">
+            <a:schemeClr val="lt1"/>
+          </a:fontRef>
+        </p:style>
+        <p:txBody>
+          <a:bodyPr rtlCol="0" anchor="ctr"/>
+          <a:lstStyle/>
+          <a:p>
+            <a:pPr algn="ctr"/>
+          </a:p>
+        </p:txBody>
+      </p:sp>
+      <p:sp>
+        <p:nvSpPr>
+          <p:cNvPr id="3" name="TextBox 2"/>
+          <p:cNvSpPr txBox="1"/>
+          <p:nvPr/>
+        </p:nvSpPr>
+        <p:spPr>
+          <a:xfrm>
+            <a:off x="685800" y="2377440"/>
+            <a:ext cx="10817352" cy="365760"/>
+          </a:xfrm>
+          <a:prstGeom prst="rect">
+            <a:avLst/>
+          </a:prstGeom>
+          <a:noFill/>
+        </p:spPr>
+        <p:txBody>
+          <a:bodyPr wrap="none">
+            <a:spAutoFit/>
+          </a:bodyPr>
+          <a:lstStyle/>
+          <a:p>
+            <a:pPr algn="l"/>
+            <a:r>
+              <a:rPr sz="1200">
+                <a:solidFill>
+                  <a:srgbClr val="D9C089"/>
+                </a:solidFill>
+                <a:latin typeface="Consolas"/>
+              </a:rPr>
+              <a:t>KERNBLOCK 40 MIN. (FALLVORSTELLUNG-RUNDE 8–10 MIN. + VERTIEFUNGSFALL 30 MIN.)</a:t>
+            </a:r>
+          </a:p>
+        </p:txBody>
+      </p:sp>
+      <p:sp>
+        <p:nvSpPr>
+          <p:cNvPr id="4" name="Rectangle 3"/>
+          <p:cNvSpPr/>
+          <p:nvPr/>
+        </p:nvSpPr>
+        <p:spPr>
+          <a:xfrm>
+            <a:off x="685800" y="2788920"/>
+            <a:ext cx="548640" cy="38100"/>
+          </a:xfrm>
+          <a:prstGeom prst="rect">
+            <a:avLst/>
+          </a:prstGeom>
+          <a:solidFill>
+            <a:srgbClr val="D9C089"/>
+          </a:solidFill>
+          <a:ln>
+            <a:noFill/>
+          </a:ln>
+        </p:spPr>
+        <p:style>
+          <a:lnRef idx="1">
+            <a:schemeClr val="accent1"/>
+          </a:lnRef>
+          <a:fillRef idx="3">
+            <a:schemeClr val="accent1"/>
+          </a:fillRef>
+          <a:effectRef idx="2">
+            <a:schemeClr val="accent1"/>
+          </a:effectRef>
+          <a:fontRef idx="minor">
+            <a:schemeClr val="lt1"/>
+          </a:fontRef>
+        </p:style>
+        <p:txBody>
+          <a:bodyPr rtlCol="0" anchor="ctr"/>
+          <a:lstStyle/>
+          <a:p>
+            <a:pPr algn="ctr"/>
+          </a:p>
+        </p:txBody>
+      </p:sp>
+      <p:sp>
+        <p:nvSpPr>
+          <p:cNvPr id="5" name="TextBox 4"/>
+          <p:cNvSpPr txBox="1"/>
+          <p:nvPr/>
+        </p:nvSpPr>
+        <p:spPr>
+          <a:xfrm>
+            <a:off x="685800" y="3017520"/>
+            <a:ext cx="10817352" cy="1463040"/>
+          </a:xfrm>
+          <a:prstGeom prst="rect">
+            <a:avLst/>
+          </a:prstGeom>
+          <a:noFill/>
+        </p:spPr>
+        <p:txBody>
+          <a:bodyPr wrap="square">
+            <a:spAutoFit/>
+          </a:bodyPr>
+          <a:lstStyle/>
+          <a:p>
+            <a:pPr algn="l"/>
+            <a:r>
+              <a:rPr sz="4000" b="1" i="0">
+                <a:solidFill>
+                  <a:srgbClr val="FFFFFF"/>
+                </a:solidFill>
+                <a:latin typeface="Arial"/>
+              </a:rPr>
+              <a:t>Kollegiale Fallberatung</a:t>
+            </a:r>
+          </a:p>
+        </p:txBody>
+      </p:sp>
+      <p:sp>
+        <p:nvSpPr>
+          <p:cNvPr id="6" name="TextBox 5"/>
+          <p:cNvSpPr txBox="1"/>
+          <p:nvPr/>
+        </p:nvSpPr>
+        <p:spPr>
+          <a:xfrm>
+            <a:off x="685800" y="4480560"/>
+            <a:ext cx="8653881" cy="1280160"/>
+          </a:xfrm>
+          <a:prstGeom prst="rect">
+            <a:avLst/>
+          </a:prstGeom>
+          <a:noFill/>
+        </p:spPr>
+        <p:txBody>
+          <a:bodyPr wrap="square">
+            <a:spAutoFit/>
+          </a:bodyPr>
+          <a:lstStyle/>
+          <a:p>
+            <a:pPr algn="l"/>
+            <a:r>
+              <a:rPr sz="1600" b="0" i="0">
+                <a:solidFill>
+                  <a:srgbClr val="C8D2E6"/>
+                </a:solidFill>
+                <a:latin typeface="Arial"/>
+              </a:rPr>
+              <a:t>Einen realen Führungsfall aus der Gruppe nach dem Sechs-Schritte-Format bearbeiten</a:t>
+            </a:r>
+          </a:p>
+        </p:txBody>
+      </p:sp>
+      <p:sp>
+        <p:nvSpPr>
+          <p:cNvPr id="7" name="TextBox 6"/>
+          <p:cNvSpPr txBox="1"/>
+          <p:nvPr/>
+        </p:nvSpPr>
+        <p:spPr>
+          <a:xfrm>
+            <a:off x="685800" y="6355080"/>
+            <a:ext cx="10817352" cy="274320"/>
+          </a:xfrm>
+          <a:prstGeom prst="rect">
+            <a:avLst/>
+          </a:prstGeom>
+          <a:noFill/>
+        </p:spPr>
+        <p:txBody>
+          <a:bodyPr wrap="none">
+            <a:spAutoFit/>
+          </a:bodyPr>
+          <a:lstStyle/>
+          <a:p>
+            <a:pPr algn="l"/>
+            <a:r>
+              <a:rPr sz="700">
+                <a:solidFill>
+                  <a:srgbClr val="8CA0C3"/>
+                </a:solidFill>
+                <a:latin typeface="Consolas"/>
+              </a:rPr>
+              <a:t>FKB Campus  ·  TL00</a:t>
+            </a:r>
+          </a:p>
+        </p:txBody>
+      </p:sp>
+    </p:spTree>
+  </p:cSld>
+  <p:clrMapOvr>
+    <a:masterClrMapping/>
+  </p:clrMapOvr>
+</p:sld>
+</file>
+
+<file path=ppt/slides/slide17.xml><?xml version="1.0" encoding="utf-8"?>
 <p:sld xmlns:a="http://schemas.openxmlformats.org/drawingml/2006/main" xmlns:p="http://schemas.openxmlformats.org/presentationml/2006/main" xmlns:r="http://schemas.openxmlformats.org/officeDocument/2006/relationships">
   <p:cSld>
     <p:spTree>
@@ -6967,784 +8060,6 @@
 </p:sld>
 </file>
 
-<file path=ppt/slides/slide16.xml><?xml version="1.0" encoding="utf-8"?>
-<p:sld xmlns:a="http://schemas.openxmlformats.org/drawingml/2006/main" xmlns:p="http://schemas.openxmlformats.org/presentationml/2006/main" xmlns:r="http://schemas.openxmlformats.org/officeDocument/2006/relationships">
-  <p:cSld>
-    <p:spTree>
-      <p:nvGrpSpPr>
-        <p:cNvPr id="1" name=""/>
-        <p:cNvGrpSpPr/>
-        <p:nvPr/>
-      </p:nvGrpSpPr>
-      <p:grpSpPr/>
-      <p:sp>
-        <p:nvSpPr>
-          <p:cNvPr id="2" name="Rectangle 1"/>
-          <p:cNvSpPr/>
-          <p:nvPr/>
-        </p:nvSpPr>
-        <p:spPr>
-          <a:xfrm>
-            <a:off x="0" y="0"/>
-            <a:ext cx="12188952" cy="6858000"/>
-          </a:xfrm>
-          <a:prstGeom prst="rect">
-            <a:avLst/>
-          </a:prstGeom>
-          <a:solidFill>
-            <a:srgbClr val="1F2C56"/>
-          </a:solidFill>
-          <a:ln>
-            <a:noFill/>
-          </a:ln>
-        </p:spPr>
-        <p:style>
-          <a:lnRef idx="1">
-            <a:schemeClr val="accent1"/>
-          </a:lnRef>
-          <a:fillRef idx="3">
-            <a:schemeClr val="accent1"/>
-          </a:fillRef>
-          <a:effectRef idx="2">
-            <a:schemeClr val="accent1"/>
-          </a:effectRef>
-          <a:fontRef idx="minor">
-            <a:schemeClr val="lt1"/>
-          </a:fontRef>
-        </p:style>
-        <p:txBody>
-          <a:bodyPr rtlCol="0" anchor="ctr"/>
-          <a:lstStyle/>
-          <a:p>
-            <a:pPr algn="ctr"/>
-          </a:p>
-        </p:txBody>
-      </p:sp>
-      <p:sp>
-        <p:nvSpPr>
-          <p:cNvPr id="3" name="TextBox 2"/>
-          <p:cNvSpPr txBox="1"/>
-          <p:nvPr/>
-        </p:nvSpPr>
-        <p:spPr>
-          <a:xfrm>
-            <a:off x="685800" y="2377440"/>
-            <a:ext cx="10817352" cy="365760"/>
-          </a:xfrm>
-          <a:prstGeom prst="rect">
-            <a:avLst/>
-          </a:prstGeom>
-          <a:noFill/>
-        </p:spPr>
-        <p:txBody>
-          <a:bodyPr wrap="none">
-            <a:spAutoFit/>
-          </a:bodyPr>
-          <a:lstStyle/>
-          <a:p>
-            <a:pPr algn="l"/>
-            <a:r>
-              <a:rPr sz="1200">
-                <a:solidFill>
-                  <a:srgbClr val="D9C089"/>
-                </a:solidFill>
-                <a:latin typeface="Consolas"/>
-              </a:rPr>
-              <a:t>EINZELARBEIT 20 MIN. + OPTIONALES PLENUM-ECHO 10 MIN.</a:t>
-            </a:r>
-          </a:p>
-        </p:txBody>
-      </p:sp>
-      <p:sp>
-        <p:nvSpPr>
-          <p:cNvPr id="4" name="Rectangle 3"/>
-          <p:cNvSpPr/>
-          <p:nvPr/>
-        </p:nvSpPr>
-        <p:spPr>
-          <a:xfrm>
-            <a:off x="685800" y="2788920"/>
-            <a:ext cx="548640" cy="38100"/>
-          </a:xfrm>
-          <a:prstGeom prst="rect">
-            <a:avLst/>
-          </a:prstGeom>
-          <a:solidFill>
-            <a:srgbClr val="D9C089"/>
-          </a:solidFill>
-          <a:ln>
-            <a:noFill/>
-          </a:ln>
-        </p:spPr>
-        <p:style>
-          <a:lnRef idx="1">
-            <a:schemeClr val="accent1"/>
-          </a:lnRef>
-          <a:fillRef idx="3">
-            <a:schemeClr val="accent1"/>
-          </a:fillRef>
-          <a:effectRef idx="2">
-            <a:schemeClr val="accent1"/>
-          </a:effectRef>
-          <a:fontRef idx="minor">
-            <a:schemeClr val="lt1"/>
-          </a:fontRef>
-        </p:style>
-        <p:txBody>
-          <a:bodyPr rtlCol="0" anchor="ctr"/>
-          <a:lstStyle/>
-          <a:p>
-            <a:pPr algn="ctr"/>
-          </a:p>
-        </p:txBody>
-      </p:sp>
-      <p:sp>
-        <p:nvSpPr>
-          <p:cNvPr id="5" name="TextBox 4"/>
-          <p:cNvSpPr txBox="1"/>
-          <p:nvPr/>
-        </p:nvSpPr>
-        <p:spPr>
-          <a:xfrm>
-            <a:off x="685800" y="3017520"/>
-            <a:ext cx="10817352" cy="1463040"/>
-          </a:xfrm>
-          <a:prstGeom prst="rect">
-            <a:avLst/>
-          </a:prstGeom>
-          <a:noFill/>
-        </p:spPr>
-        <p:txBody>
-          <a:bodyPr wrap="square">
-            <a:spAutoFit/>
-          </a:bodyPr>
-          <a:lstStyle/>
-          <a:p>
-            <a:pPr algn="l"/>
-            <a:r>
-              <a:rPr sz="4000" b="1" i="0">
-                <a:solidFill>
-                  <a:srgbClr val="FFFFFF"/>
-                </a:solidFill>
-                <a:latin typeface="Arial"/>
-              </a:rPr>
-              <a:t>AB-2: Mein nächster Führungsmoment</a:t>
-            </a:r>
-          </a:p>
-        </p:txBody>
-      </p:sp>
-      <p:sp>
-        <p:nvSpPr>
-          <p:cNvPr id="6" name="TextBox 5"/>
-          <p:cNvSpPr txBox="1"/>
-          <p:nvPr/>
-        </p:nvSpPr>
-        <p:spPr>
-          <a:xfrm>
-            <a:off x="685800" y="4480560"/>
-            <a:ext cx="8653881" cy="1280160"/>
-          </a:xfrm>
-          <a:prstGeom prst="rect">
-            <a:avLst/>
-          </a:prstGeom>
-          <a:noFill/>
-        </p:spPr>
-        <p:txBody>
-          <a:bodyPr wrap="square">
-            <a:spAutoFit/>
-          </a:bodyPr>
-          <a:lstStyle/>
-          <a:p>
-            <a:pPr algn="l"/>
-            <a:r>
-              <a:rPr sz="1600" b="0" i="0">
-                <a:solidFill>
-                  <a:srgbClr val="C8D2E6"/>
-                </a:solidFill>
-                <a:latin typeface="Arial"/>
-              </a:rPr>
-              <a:t>Ein konkretes reales Führungsgespräch vorbereiten – Einstiegssatz, Leitfragen, Abschluss</a:t>
-            </a:r>
-          </a:p>
-        </p:txBody>
-      </p:sp>
-      <p:sp>
-        <p:nvSpPr>
-          <p:cNvPr id="7" name="TextBox 6"/>
-          <p:cNvSpPr txBox="1"/>
-          <p:nvPr/>
-        </p:nvSpPr>
-        <p:spPr>
-          <a:xfrm>
-            <a:off x="685800" y="6355080"/>
-            <a:ext cx="10817352" cy="274320"/>
-          </a:xfrm>
-          <a:prstGeom prst="rect">
-            <a:avLst/>
-          </a:prstGeom>
-          <a:noFill/>
-        </p:spPr>
-        <p:txBody>
-          <a:bodyPr wrap="none">
-            <a:spAutoFit/>
-          </a:bodyPr>
-          <a:lstStyle/>
-          <a:p>
-            <a:pPr algn="l"/>
-            <a:r>
-              <a:rPr sz="700">
-                <a:solidFill>
-                  <a:srgbClr val="8CA0C3"/>
-                </a:solidFill>
-                <a:latin typeface="Consolas"/>
-              </a:rPr>
-              <a:t>FKB Campus  ·  TL00</a:t>
-            </a:r>
-          </a:p>
-        </p:txBody>
-      </p:sp>
-    </p:spTree>
-  </p:cSld>
-  <p:clrMapOvr>
-    <a:masterClrMapping/>
-  </p:clrMapOvr>
-</p:sld>
-</file>
-
-<file path=ppt/slides/slide17.xml><?xml version="1.0" encoding="utf-8"?>
-<p:sld xmlns:a="http://schemas.openxmlformats.org/drawingml/2006/main" xmlns:p="http://schemas.openxmlformats.org/presentationml/2006/main" xmlns:r="http://schemas.openxmlformats.org/officeDocument/2006/relationships">
-  <p:cSld>
-    <p:spTree>
-      <p:nvGrpSpPr>
-        <p:cNvPr id="1" name=""/>
-        <p:cNvGrpSpPr/>
-        <p:nvPr/>
-      </p:nvGrpSpPr>
-      <p:grpSpPr/>
-      <p:sp>
-        <p:nvSpPr>
-          <p:cNvPr id="2" name="Rectangle 1"/>
-          <p:cNvSpPr/>
-          <p:nvPr/>
-        </p:nvSpPr>
-        <p:spPr>
-          <a:xfrm>
-            <a:off x="0" y="0"/>
-            <a:ext cx="12188952" cy="6858000"/>
-          </a:xfrm>
-          <a:prstGeom prst="rect">
-            <a:avLst/>
-          </a:prstGeom>
-          <a:solidFill>
-            <a:srgbClr val="EDEDF3"/>
-          </a:solidFill>
-          <a:ln>
-            <a:noFill/>
-          </a:ln>
-        </p:spPr>
-        <p:style>
-          <a:lnRef idx="1">
-            <a:schemeClr val="accent1"/>
-          </a:lnRef>
-          <a:fillRef idx="3">
-            <a:schemeClr val="accent1"/>
-          </a:fillRef>
-          <a:effectRef idx="2">
-            <a:schemeClr val="accent1"/>
-          </a:effectRef>
-          <a:fontRef idx="minor">
-            <a:schemeClr val="lt1"/>
-          </a:fontRef>
-        </p:style>
-        <p:txBody>
-          <a:bodyPr rtlCol="0" anchor="ctr"/>
-          <a:lstStyle/>
-          <a:p>
-            <a:pPr algn="ctr"/>
-          </a:p>
-        </p:txBody>
-      </p:sp>
-      <p:sp>
-        <p:nvSpPr>
-          <p:cNvPr id="3" name="Rectangle 2"/>
-          <p:cNvSpPr/>
-          <p:nvPr/>
-        </p:nvSpPr>
-        <p:spPr>
-          <a:xfrm>
-            <a:off x="0" y="0"/>
-            <a:ext cx="12188952" cy="50292"/>
-          </a:xfrm>
-          <a:prstGeom prst="rect">
-            <a:avLst/>
-          </a:prstGeom>
-          <a:solidFill>
-            <a:srgbClr val="1F2C56"/>
-          </a:solidFill>
-          <a:ln>
-            <a:noFill/>
-          </a:ln>
-        </p:spPr>
-        <p:style>
-          <a:lnRef idx="1">
-            <a:schemeClr val="accent1"/>
-          </a:lnRef>
-          <a:fillRef idx="3">
-            <a:schemeClr val="accent1"/>
-          </a:fillRef>
-          <a:effectRef idx="2">
-            <a:schemeClr val="accent1"/>
-          </a:effectRef>
-          <a:fontRef idx="minor">
-            <a:schemeClr val="lt1"/>
-          </a:fontRef>
-        </p:style>
-        <p:txBody>
-          <a:bodyPr rtlCol="0" anchor="ctr"/>
-          <a:lstStyle/>
-          <a:p>
-            <a:pPr algn="ctr"/>
-          </a:p>
-        </p:txBody>
-      </p:sp>
-      <p:sp>
-        <p:nvSpPr>
-          <p:cNvPr id="4" name="TextBox 3"/>
-          <p:cNvSpPr txBox="1"/>
-          <p:nvPr/>
-        </p:nvSpPr>
-        <p:spPr>
-          <a:xfrm>
-            <a:off x="685800" y="109728"/>
-            <a:ext cx="10817352" cy="228600"/>
-          </a:xfrm>
-          <a:prstGeom prst="rect">
-            <a:avLst/>
-          </a:prstGeom>
-          <a:noFill/>
-        </p:spPr>
-        <p:txBody>
-          <a:bodyPr wrap="none">
-            <a:spAutoFit/>
-          </a:bodyPr>
-          <a:lstStyle/>
-          <a:p>
-            <a:pPr algn="l"/>
-            <a:r>
-              <a:rPr sz="750">
-                <a:solidFill>
-                  <a:srgbClr val="78808C"/>
-                </a:solidFill>
-                <a:latin typeface="Consolas"/>
-              </a:rPr>
-              <a:t>TL00  ·  ARBEITSBLATT</a:t>
-            </a:r>
-          </a:p>
-        </p:txBody>
-      </p:sp>
-      <p:sp>
-        <p:nvSpPr>
-          <p:cNvPr id="5" name="Rectangle 4"/>
-          <p:cNvSpPr/>
-          <p:nvPr/>
-        </p:nvSpPr>
-        <p:spPr>
-          <a:xfrm>
-            <a:off x="0" y="1234440"/>
-            <a:ext cx="12188952" cy="12700"/>
-          </a:xfrm>
-          <a:prstGeom prst="rect">
-            <a:avLst/>
-          </a:prstGeom>
-          <a:solidFill>
-            <a:srgbClr val="D8DFE4"/>
-          </a:solidFill>
-          <a:ln>
-            <a:noFill/>
-          </a:ln>
-        </p:spPr>
-        <p:style>
-          <a:lnRef idx="1">
-            <a:schemeClr val="accent1"/>
-          </a:lnRef>
-          <a:fillRef idx="3">
-            <a:schemeClr val="accent1"/>
-          </a:fillRef>
-          <a:effectRef idx="2">
-            <a:schemeClr val="accent1"/>
-          </a:effectRef>
-          <a:fontRef idx="minor">
-            <a:schemeClr val="lt1"/>
-          </a:fontRef>
-        </p:style>
-        <p:txBody>
-          <a:bodyPr rtlCol="0" anchor="ctr"/>
-          <a:lstStyle/>
-          <a:p>
-            <a:pPr algn="ctr"/>
-          </a:p>
-        </p:txBody>
-      </p:sp>
-      <p:sp>
-        <p:nvSpPr>
-          <p:cNvPr id="6" name="Rectangle 5"/>
-          <p:cNvSpPr/>
-          <p:nvPr/>
-        </p:nvSpPr>
-        <p:spPr>
-          <a:xfrm>
-            <a:off x="685800" y="502920"/>
-            <a:ext cx="36576" cy="658368"/>
-          </a:xfrm>
-          <a:prstGeom prst="rect">
-            <a:avLst/>
-          </a:prstGeom>
-          <a:solidFill>
-            <a:srgbClr val="D9C089"/>
-          </a:solidFill>
-          <a:ln>
-            <a:noFill/>
-          </a:ln>
-        </p:spPr>
-        <p:style>
-          <a:lnRef idx="1">
-            <a:schemeClr val="accent1"/>
-          </a:lnRef>
-          <a:fillRef idx="3">
-            <a:schemeClr val="accent1"/>
-          </a:fillRef>
-          <a:effectRef idx="2">
-            <a:schemeClr val="accent1"/>
-          </a:effectRef>
-          <a:fontRef idx="minor">
-            <a:schemeClr val="lt1"/>
-          </a:fontRef>
-        </p:style>
-        <p:txBody>
-          <a:bodyPr rtlCol="0" anchor="ctr"/>
-          <a:lstStyle/>
-          <a:p>
-            <a:pPr algn="ctr"/>
-          </a:p>
-        </p:txBody>
-      </p:sp>
-      <p:sp>
-        <p:nvSpPr>
-          <p:cNvPr id="7" name="TextBox 6"/>
-          <p:cNvSpPr txBox="1"/>
-          <p:nvPr/>
-        </p:nvSpPr>
-        <p:spPr>
-          <a:xfrm>
-            <a:off x="813816" y="502920"/>
-            <a:ext cx="10634472" cy="685800"/>
-          </a:xfrm>
-          <a:prstGeom prst="rect">
-            <a:avLst/>
-          </a:prstGeom>
-          <a:noFill/>
-        </p:spPr>
-        <p:txBody>
-          <a:bodyPr wrap="square">
-            <a:spAutoFit/>
-          </a:bodyPr>
-          <a:lstStyle/>
-          <a:p>
-            <a:pPr algn="l"/>
-            <a:r>
-              <a:rPr sz="2400" b="1" i="0">
-                <a:solidFill>
-                  <a:srgbClr val="1F2C56"/>
-                </a:solidFill>
-                <a:latin typeface="Arial"/>
-              </a:rPr>
-              <a:t>AB-2 bearbeiten – Ihr nächstes echtes Gespräch</a:t>
-            </a:r>
-          </a:p>
-        </p:txBody>
-      </p:sp>
-      <p:sp>
-        <p:nvSpPr>
-          <p:cNvPr id="8" name="TextBox 7"/>
-          <p:cNvSpPr txBox="1"/>
-          <p:nvPr/>
-        </p:nvSpPr>
-        <p:spPr>
-          <a:xfrm>
-            <a:off x="685800" y="1554480"/>
-            <a:ext cx="10817352" cy="3840480"/>
-          </a:xfrm>
-          <a:prstGeom prst="rect">
-            <a:avLst/>
-          </a:prstGeom>
-          <a:noFill/>
-        </p:spPr>
-        <p:txBody>
-          <a:bodyPr wrap="square">
-            <a:spAutoFit/>
-          </a:bodyPr>
-          <a:lstStyle/>
-          <a:p>
-            <a:pPr marL="190500" indent="-190500">
-              <a:spcBef>
-                <a:spcPts val="400"/>
-              </a:spcBef>
-              <a:spcAft>
-                <a:spcPts val="200"/>
-              </a:spcAft>
-            </a:pPr>
-            <a:r>
-              <a:rPr sz="1400">
-                <a:solidFill>
-                  <a:srgbClr val="3D5466"/>
-                </a:solidFill>
-                <a:latin typeface="Arial"/>
-              </a:rPr>
-              <a:t>▸  AB-2: Mit wem führe ich dieses Gespräch – und was ist mein Ziel?</a:t>
-            </a:r>
-          </a:p>
-          <a:p>
-            <a:pPr marL="190500" indent="-190500">
-              <a:spcBef>
-                <a:spcPts val="400"/>
-              </a:spcBef>
-              <a:spcAft>
-                <a:spcPts val="200"/>
-              </a:spcAft>
-            </a:pPr>
-            <a:r>
-              <a:rPr sz="1400">
-                <a:solidFill>
-                  <a:srgbClr val="3D5466"/>
-                </a:solidFill>
-                <a:latin typeface="Arial"/>
-              </a:rPr>
-              <a:t>▸  AB-2: Mein Einstiegssatz (direkt, ohne Umschweife)</a:t>
-            </a:r>
-          </a:p>
-          <a:p>
-            <a:pPr marL="190500" indent="-190500">
-              <a:spcBef>
-                <a:spcPts val="400"/>
-              </a:spcBef>
-              <a:spcAft>
-                <a:spcPts val="200"/>
-              </a:spcAft>
-            </a:pPr>
-            <a:r>
-              <a:rPr sz="1400">
-                <a:solidFill>
-                  <a:srgbClr val="3D5466"/>
-                </a:solidFill>
-                <a:latin typeface="Arial"/>
-              </a:rPr>
-              <a:t>▸  AB-2: Drei Leitfragen – was frage ich, nicht was erkläre ich</a:t>
-            </a:r>
-          </a:p>
-          <a:p>
-            <a:pPr marL="190500" indent="-190500">
-              <a:spcBef>
-                <a:spcPts val="400"/>
-              </a:spcBef>
-              <a:spcAft>
-                <a:spcPts val="200"/>
-              </a:spcAft>
-            </a:pPr>
-            <a:r>
-              <a:rPr sz="1400">
-                <a:solidFill>
-                  <a:srgbClr val="3D5466"/>
-                </a:solidFill>
-                <a:latin typeface="Arial"/>
-              </a:rPr>
-              <a:t>▸  AB-2: Erwartete Reaktion + Formulierungsbaustein dafür</a:t>
-            </a:r>
-          </a:p>
-          <a:p>
-            <a:pPr marL="190500" indent="-190500">
-              <a:spcBef>
-                <a:spcPts val="400"/>
-              </a:spcBef>
-              <a:spcAft>
-                <a:spcPts val="200"/>
-              </a:spcAft>
-            </a:pPr>
-            <a:r>
-              <a:rPr sz="1400">
-                <a:solidFill>
-                  <a:srgbClr val="3D5466"/>
-                </a:solidFill>
-                <a:latin typeface="Arial"/>
-              </a:rPr>
-              <a:t>▸  AB-2: Mein Abschluss – klares Ergebnis oder klares Nächstes</a:t>
-            </a:r>
-          </a:p>
-        </p:txBody>
-      </p:sp>
-      <p:sp>
-        <p:nvSpPr>
-          <p:cNvPr id="9" name="Rectangle 8"/>
-          <p:cNvSpPr/>
-          <p:nvPr/>
-        </p:nvSpPr>
-        <p:spPr>
-          <a:xfrm>
-            <a:off x="685800" y="5486400"/>
-            <a:ext cx="10817352" cy="640080"/>
-          </a:xfrm>
-          <a:prstGeom prst="rect">
-            <a:avLst/>
-          </a:prstGeom>
-          <a:solidFill>
-            <a:srgbClr val="1F2C56"/>
-          </a:solidFill>
-          <a:ln>
-            <a:noFill/>
-          </a:ln>
-        </p:spPr>
-        <p:style>
-          <a:lnRef idx="1">
-            <a:schemeClr val="accent1"/>
-          </a:lnRef>
-          <a:fillRef idx="3">
-            <a:schemeClr val="accent1"/>
-          </a:fillRef>
-          <a:effectRef idx="2">
-            <a:schemeClr val="accent1"/>
-          </a:effectRef>
-          <a:fontRef idx="minor">
-            <a:schemeClr val="lt1"/>
-          </a:fontRef>
-        </p:style>
-        <p:txBody>
-          <a:bodyPr rtlCol="0" anchor="ctr"/>
-          <a:lstStyle/>
-          <a:p>
-            <a:pPr algn="ctr"/>
-          </a:p>
-        </p:txBody>
-      </p:sp>
-      <p:sp>
-        <p:nvSpPr>
-          <p:cNvPr id="10" name="TextBox 9"/>
-          <p:cNvSpPr txBox="1"/>
-          <p:nvPr/>
-        </p:nvSpPr>
-        <p:spPr>
-          <a:xfrm>
-            <a:off x="868680" y="5596128"/>
-            <a:ext cx="10451592" cy="457200"/>
-          </a:xfrm>
-          <a:prstGeom prst="rect">
-            <a:avLst/>
-          </a:prstGeom>
-          <a:noFill/>
-        </p:spPr>
-        <p:txBody>
-          <a:bodyPr wrap="square">
-            <a:spAutoFit/>
-          </a:bodyPr>
-          <a:lstStyle/>
-          <a:p>
-            <a:pPr algn="l"/>
-            <a:r>
-              <a:rPr sz="1300" b="1" i="0">
-                <a:solidFill>
-                  <a:srgbClr val="FFFFFF"/>
-                </a:solidFill>
-                <a:latin typeface="Arial"/>
-              </a:rPr>
-              <a:t>→  Bearbeitung im Teilnehmer-Workbook (Arbeitsblatt mit Ausfüllfeldern)</a:t>
-            </a:r>
-          </a:p>
-        </p:txBody>
-      </p:sp>
-      <p:sp>
-        <p:nvSpPr>
-          <p:cNvPr id="11" name="Rectangle 10"/>
-          <p:cNvSpPr/>
-          <p:nvPr/>
-        </p:nvSpPr>
-        <p:spPr>
-          <a:xfrm>
-            <a:off x="0" y="6510528"/>
-            <a:ext cx="12188952" cy="347472"/>
-          </a:xfrm>
-          <a:prstGeom prst="rect">
-            <a:avLst/>
-          </a:prstGeom>
-          <a:solidFill>
-            <a:srgbClr val="0A1937"/>
-          </a:solidFill>
-          <a:ln>
-            <a:noFill/>
-          </a:ln>
-        </p:spPr>
-        <p:style>
-          <a:lnRef idx="1">
-            <a:schemeClr val="accent1"/>
-          </a:lnRef>
-          <a:fillRef idx="3">
-            <a:schemeClr val="accent1"/>
-          </a:fillRef>
-          <a:effectRef idx="2">
-            <a:schemeClr val="accent1"/>
-          </a:effectRef>
-          <a:fontRef idx="minor">
-            <a:schemeClr val="lt1"/>
-          </a:fontRef>
-        </p:style>
-        <p:txBody>
-          <a:bodyPr rtlCol="0" anchor="ctr"/>
-          <a:lstStyle/>
-          <a:p>
-            <a:pPr algn="ctr"/>
-          </a:p>
-        </p:txBody>
-      </p:sp>
-      <p:sp>
-        <p:nvSpPr>
-          <p:cNvPr id="12" name="TextBox 11"/>
-          <p:cNvSpPr txBox="1"/>
-          <p:nvPr/>
-        </p:nvSpPr>
-        <p:spPr>
-          <a:xfrm>
-            <a:off x="685800" y="6583680"/>
-            <a:ext cx="6490411" cy="256032"/>
-          </a:xfrm>
-          <a:prstGeom prst="rect">
-            <a:avLst/>
-          </a:prstGeom>
-          <a:noFill/>
-        </p:spPr>
-        <p:txBody>
-          <a:bodyPr wrap="none">
-            <a:spAutoFit/>
-          </a:bodyPr>
-          <a:lstStyle/>
-          <a:p>
-            <a:pPr algn="l"/>
-            <a:r>
-              <a:rPr sz="700">
-                <a:solidFill>
-                  <a:srgbClr val="A0B4D2"/>
-                </a:solidFill>
-                <a:latin typeface="Consolas"/>
-              </a:rPr>
-              <a:t>FKB Campus  ·  TL00</a:t>
-            </a:r>
-          </a:p>
-        </p:txBody>
-      </p:sp>
-    </p:spTree>
-  </p:cSld>
-  <p:clrMapOvr>
-    <a:masterClrMapping/>
-  </p:clrMapOvr>
-</p:sld>
-</file>
-
 <file path=ppt/slides/slide18.xml><?xml version="1.0" encoding="utf-8"?>
 <p:sld xmlns:a="http://schemas.openxmlformats.org/drawingml/2006/main" xmlns:p="http://schemas.openxmlformats.org/presentationml/2006/main" xmlns:r="http://schemas.openxmlformats.org/officeDocument/2006/relationships">
   <p:cSld>
@@ -7770,6 +8085,250 @@
             <a:avLst/>
           </a:prstGeom>
           <a:solidFill>
+            <a:srgbClr val="1F2C56"/>
+          </a:solidFill>
+          <a:ln>
+            <a:noFill/>
+          </a:ln>
+        </p:spPr>
+        <p:style>
+          <a:lnRef idx="1">
+            <a:schemeClr val="accent1"/>
+          </a:lnRef>
+          <a:fillRef idx="3">
+            <a:schemeClr val="accent1"/>
+          </a:fillRef>
+          <a:effectRef idx="2">
+            <a:schemeClr val="accent1"/>
+          </a:effectRef>
+          <a:fontRef idx="minor">
+            <a:schemeClr val="lt1"/>
+          </a:fontRef>
+        </p:style>
+        <p:txBody>
+          <a:bodyPr rtlCol="0" anchor="ctr"/>
+          <a:lstStyle/>
+          <a:p>
+            <a:pPr algn="ctr"/>
+          </a:p>
+        </p:txBody>
+      </p:sp>
+      <p:sp>
+        <p:nvSpPr>
+          <p:cNvPr id="3" name="TextBox 2"/>
+          <p:cNvSpPr txBox="1"/>
+          <p:nvPr/>
+        </p:nvSpPr>
+        <p:spPr>
+          <a:xfrm>
+            <a:off x="685800" y="2377440"/>
+            <a:ext cx="10817352" cy="365760"/>
+          </a:xfrm>
+          <a:prstGeom prst="rect">
+            <a:avLst/>
+          </a:prstGeom>
+          <a:noFill/>
+        </p:spPr>
+        <p:txBody>
+          <a:bodyPr wrap="none">
+            <a:spAutoFit/>
+          </a:bodyPr>
+          <a:lstStyle/>
+          <a:p>
+            <a:pPr algn="l"/>
+            <a:r>
+              <a:rPr sz="1200">
+                <a:solidFill>
+                  <a:srgbClr val="D9C089"/>
+                </a:solidFill>
+                <a:latin typeface="Consolas"/>
+              </a:rPr>
+              <a:t>EINZELARBEIT 20 MIN. + OPTIONALES PLENUM-ECHO 10 MIN.</a:t>
+            </a:r>
+          </a:p>
+        </p:txBody>
+      </p:sp>
+      <p:sp>
+        <p:nvSpPr>
+          <p:cNvPr id="4" name="Rectangle 3"/>
+          <p:cNvSpPr/>
+          <p:nvPr/>
+        </p:nvSpPr>
+        <p:spPr>
+          <a:xfrm>
+            <a:off x="685800" y="2788920"/>
+            <a:ext cx="548640" cy="38100"/>
+          </a:xfrm>
+          <a:prstGeom prst="rect">
+            <a:avLst/>
+          </a:prstGeom>
+          <a:solidFill>
+            <a:srgbClr val="D9C089"/>
+          </a:solidFill>
+          <a:ln>
+            <a:noFill/>
+          </a:ln>
+        </p:spPr>
+        <p:style>
+          <a:lnRef idx="1">
+            <a:schemeClr val="accent1"/>
+          </a:lnRef>
+          <a:fillRef idx="3">
+            <a:schemeClr val="accent1"/>
+          </a:fillRef>
+          <a:effectRef idx="2">
+            <a:schemeClr val="accent1"/>
+          </a:effectRef>
+          <a:fontRef idx="minor">
+            <a:schemeClr val="lt1"/>
+          </a:fontRef>
+        </p:style>
+        <p:txBody>
+          <a:bodyPr rtlCol="0" anchor="ctr"/>
+          <a:lstStyle/>
+          <a:p>
+            <a:pPr algn="ctr"/>
+          </a:p>
+        </p:txBody>
+      </p:sp>
+      <p:sp>
+        <p:nvSpPr>
+          <p:cNvPr id="5" name="TextBox 4"/>
+          <p:cNvSpPr txBox="1"/>
+          <p:nvPr/>
+        </p:nvSpPr>
+        <p:spPr>
+          <a:xfrm>
+            <a:off x="685800" y="3017520"/>
+            <a:ext cx="10817352" cy="1463040"/>
+          </a:xfrm>
+          <a:prstGeom prst="rect">
+            <a:avLst/>
+          </a:prstGeom>
+          <a:noFill/>
+        </p:spPr>
+        <p:txBody>
+          <a:bodyPr wrap="square">
+            <a:spAutoFit/>
+          </a:bodyPr>
+          <a:lstStyle/>
+          <a:p>
+            <a:pPr algn="l"/>
+            <a:r>
+              <a:rPr sz="4000" b="1" i="0">
+                <a:solidFill>
+                  <a:srgbClr val="FFFFFF"/>
+                </a:solidFill>
+                <a:latin typeface="Arial"/>
+              </a:rPr>
+              <a:t>AB-2: Mein nächster Führungsmoment</a:t>
+            </a:r>
+          </a:p>
+        </p:txBody>
+      </p:sp>
+      <p:sp>
+        <p:nvSpPr>
+          <p:cNvPr id="6" name="TextBox 5"/>
+          <p:cNvSpPr txBox="1"/>
+          <p:nvPr/>
+        </p:nvSpPr>
+        <p:spPr>
+          <a:xfrm>
+            <a:off x="685800" y="4480560"/>
+            <a:ext cx="8653881" cy="1280160"/>
+          </a:xfrm>
+          <a:prstGeom prst="rect">
+            <a:avLst/>
+          </a:prstGeom>
+          <a:noFill/>
+        </p:spPr>
+        <p:txBody>
+          <a:bodyPr wrap="square">
+            <a:spAutoFit/>
+          </a:bodyPr>
+          <a:lstStyle/>
+          <a:p>
+            <a:pPr algn="l"/>
+            <a:r>
+              <a:rPr sz="1600" b="0" i="0">
+                <a:solidFill>
+                  <a:srgbClr val="C8D2E6"/>
+                </a:solidFill>
+                <a:latin typeface="Arial"/>
+              </a:rPr>
+              <a:t>Ein konkretes reales Führungsgespräch vorbereiten – Einstiegssatz, Leitfragen, Abschluss</a:t>
+            </a:r>
+          </a:p>
+        </p:txBody>
+      </p:sp>
+      <p:sp>
+        <p:nvSpPr>
+          <p:cNvPr id="7" name="TextBox 6"/>
+          <p:cNvSpPr txBox="1"/>
+          <p:nvPr/>
+        </p:nvSpPr>
+        <p:spPr>
+          <a:xfrm>
+            <a:off x="685800" y="6355080"/>
+            <a:ext cx="10817352" cy="274320"/>
+          </a:xfrm>
+          <a:prstGeom prst="rect">
+            <a:avLst/>
+          </a:prstGeom>
+          <a:noFill/>
+        </p:spPr>
+        <p:txBody>
+          <a:bodyPr wrap="none">
+            <a:spAutoFit/>
+          </a:bodyPr>
+          <a:lstStyle/>
+          <a:p>
+            <a:pPr algn="l"/>
+            <a:r>
+              <a:rPr sz="700">
+                <a:solidFill>
+                  <a:srgbClr val="8CA0C3"/>
+                </a:solidFill>
+                <a:latin typeface="Consolas"/>
+              </a:rPr>
+              <a:t>FKB Campus  ·  TL00</a:t>
+            </a:r>
+          </a:p>
+        </p:txBody>
+      </p:sp>
+    </p:spTree>
+  </p:cSld>
+  <p:clrMapOvr>
+    <a:masterClrMapping/>
+  </p:clrMapOvr>
+</p:sld>
+</file>
+
+<file path=ppt/slides/slide19.xml><?xml version="1.0" encoding="utf-8"?>
+<p:sld xmlns:a="http://schemas.openxmlformats.org/drawingml/2006/main" xmlns:p="http://schemas.openxmlformats.org/presentationml/2006/main" xmlns:r="http://schemas.openxmlformats.org/officeDocument/2006/relationships">
+  <p:cSld>
+    <p:spTree>
+      <p:nvGrpSpPr>
+        <p:cNvPr id="1" name=""/>
+        <p:cNvGrpSpPr/>
+        <p:nvPr/>
+      </p:nvGrpSpPr>
+      <p:grpSpPr/>
+      <p:sp>
+        <p:nvSpPr>
+          <p:cNvPr id="2" name="Rectangle 1"/>
+          <p:cNvSpPr/>
+          <p:nvPr/>
+        </p:nvSpPr>
+        <p:spPr>
+          <a:xfrm>
+            <a:off x="0" y="0"/>
+            <a:ext cx="12188952" cy="6858000"/>
+          </a:xfrm>
+          <a:prstGeom prst="rect">
+            <a:avLst/>
+          </a:prstGeom>
+          <a:solidFill>
             <a:srgbClr val="EDEDF3"/>
           </a:solidFill>
           <a:ln>
@@ -7871,7 +8430,7 @@
                 </a:solidFill>
                 <a:latin typeface="Consolas"/>
               </a:rPr>
-              <a:t>TL00  ·  INHALT</a:t>
+              <a:t>TL00  ·  ARBEITSBLATT</a:t>
             </a:r>
           </a:p>
         </p:txBody>
@@ -7992,7 +8551,7 @@
                 </a:solidFill>
                 <a:latin typeface="Arial"/>
               </a:rPr>
-              <a:t>Ihr Maßstab für die nächsten vier Wochen</a:t>
+              <a:t>AB-2 bearbeiten – Ihr nächstes echtes Gespräch</a:t>
             </a:r>
           </a:p>
         </p:txBody>
@@ -8005,8 +8564,8 @@
         </p:nvSpPr>
         <p:spPr>
           <a:xfrm>
-            <a:off x="685800" y="1417320"/>
-            <a:ext cx="10817352" cy="4892040"/>
+            <a:off x="685800" y="1554480"/>
+            <a:ext cx="10817352" cy="3840480"/>
           </a:xfrm>
           <a:prstGeom prst="rect">
             <a:avLst/>
@@ -8014,7 +8573,7 @@
           <a:noFill/>
         </p:spPr>
         <p:txBody>
-          <a:bodyPr wrap="square" anchor="ctr">
+          <a:bodyPr wrap="square">
             <a:spAutoFit/>
           </a:bodyPr>
           <a:lstStyle/>
@@ -8028,13 +8587,13 @@
               </a:spcAft>
             </a:pPr>
             <a:r>
-              <a:rPr sz="1300">
+              <a:rPr sz="1400">
                 <a:solidFill>
                   <a:srgbClr val="3D5466"/>
                 </a:solidFill>
                 <a:latin typeface="Arial"/>
               </a:rPr>
-              <a:t>▸  Vorbereitetes Gespräch führen (AB-2)</a:t>
+              <a:t>▸  AB-2: Mit wem führe ich dieses Gespräch – und was ist mein Ziel?</a:t>
             </a:r>
           </a:p>
           <a:p>
@@ -8047,13 +8606,13 @@
               </a:spcAft>
             </a:pPr>
             <a:r>
-              <a:rPr sz="1300">
+              <a:rPr sz="1400">
                 <a:solidFill>
                   <a:srgbClr val="3D5466"/>
                 </a:solidFill>
                 <a:latin typeface="Arial"/>
               </a:rPr>
-              <a:t>▸  Führungszeit-Anteil messen und erhöhen</a:t>
+              <a:t>▸  AB-2: Mein Einstiegssatz (direkt, ohne Umschweife)</a:t>
             </a:r>
           </a:p>
           <a:p>
@@ -8066,13 +8625,13 @@
               </a:spcAft>
             </a:pPr>
             <a:r>
-              <a:rPr sz="1300">
+              <a:rPr sz="1400">
                 <a:solidFill>
                   <a:srgbClr val="3D5466"/>
                 </a:solidFill>
                 <a:latin typeface="Arial"/>
               </a:rPr>
-              <a:t>▸  Klärungsgespräch mit ehemaligem Kollegen</a:t>
+              <a:t>▸  AB-2: Drei Leitfragen – was frage ich, nicht was erkläre ich</a:t>
             </a:r>
           </a:p>
           <a:p>
@@ -8085,13 +8644,32 @@
               </a:spcAft>
             </a:pPr>
             <a:r>
-              <a:rPr sz="1300">
+              <a:rPr sz="1400">
                 <a:solidFill>
                   <a:srgbClr val="3D5466"/>
                 </a:solidFill>
                 <a:latin typeface="Arial"/>
               </a:rPr>
-              <a:t>▸  Checkliste: in vier Wochen wieder vorlegen</a:t>
+              <a:t>▸  AB-2: Erwartete Reaktion + Formulierungsbaustein dafür</a:t>
+            </a:r>
+          </a:p>
+          <a:p>
+            <a:pPr marL="190500" indent="-190500">
+              <a:spcBef>
+                <a:spcPts val="400"/>
+              </a:spcBef>
+              <a:spcAft>
+                <a:spcPts val="200"/>
+              </a:spcAft>
+            </a:pPr>
+            <a:r>
+              <a:rPr sz="1400">
+                <a:solidFill>
+                  <a:srgbClr val="3D5466"/>
+                </a:solidFill>
+                <a:latin typeface="Arial"/>
+              </a:rPr>
+              <a:t>▸  AB-2: Mein Abschluss – klares Ergebnis oder klares Nächstes</a:t>
             </a:r>
           </a:p>
         </p:txBody>
@@ -8099,6 +8677,84 @@
       <p:sp>
         <p:nvSpPr>
           <p:cNvPr id="9" name="Rectangle 8"/>
+          <p:cNvSpPr/>
+          <p:nvPr/>
+        </p:nvSpPr>
+        <p:spPr>
+          <a:xfrm>
+            <a:off x="685800" y="5486400"/>
+            <a:ext cx="10817352" cy="640080"/>
+          </a:xfrm>
+          <a:prstGeom prst="rect">
+            <a:avLst/>
+          </a:prstGeom>
+          <a:solidFill>
+            <a:srgbClr val="1F2C56"/>
+          </a:solidFill>
+          <a:ln>
+            <a:noFill/>
+          </a:ln>
+        </p:spPr>
+        <p:style>
+          <a:lnRef idx="1">
+            <a:schemeClr val="accent1"/>
+          </a:lnRef>
+          <a:fillRef idx="3">
+            <a:schemeClr val="accent1"/>
+          </a:fillRef>
+          <a:effectRef idx="2">
+            <a:schemeClr val="accent1"/>
+          </a:effectRef>
+          <a:fontRef idx="minor">
+            <a:schemeClr val="lt1"/>
+          </a:fontRef>
+        </p:style>
+        <p:txBody>
+          <a:bodyPr rtlCol="0" anchor="ctr"/>
+          <a:lstStyle/>
+          <a:p>
+            <a:pPr algn="ctr"/>
+          </a:p>
+        </p:txBody>
+      </p:sp>
+      <p:sp>
+        <p:nvSpPr>
+          <p:cNvPr id="10" name="TextBox 9"/>
+          <p:cNvSpPr txBox="1"/>
+          <p:nvPr/>
+        </p:nvSpPr>
+        <p:spPr>
+          <a:xfrm>
+            <a:off x="868680" y="5596128"/>
+            <a:ext cx="10451592" cy="457200"/>
+          </a:xfrm>
+          <a:prstGeom prst="rect">
+            <a:avLst/>
+          </a:prstGeom>
+          <a:noFill/>
+        </p:spPr>
+        <p:txBody>
+          <a:bodyPr wrap="square">
+            <a:spAutoFit/>
+          </a:bodyPr>
+          <a:lstStyle/>
+          <a:p>
+            <a:pPr algn="l"/>
+            <a:r>
+              <a:rPr sz="1300" b="1" i="0">
+                <a:solidFill>
+                  <a:srgbClr val="FFFFFF"/>
+                </a:solidFill>
+                <a:latin typeface="Arial"/>
+              </a:rPr>
+              <a:t>→  Bearbeitung im Teilnehmer-Workbook (Arbeitsblatt mit Ausfüllfeldern)</a:t>
+            </a:r>
+          </a:p>
+        </p:txBody>
+      </p:sp>
+      <p:sp>
+        <p:nvSpPr>
+          <p:cNvPr id="11" name="Rectangle 10"/>
           <p:cNvSpPr/>
           <p:nvPr/>
         </p:nvSpPr>
@@ -8141,7 +8797,7 @@
       </p:sp>
       <p:sp>
         <p:nvSpPr>
-          <p:cNvPr id="10" name="TextBox 9"/>
+          <p:cNvPr id="12" name="TextBox 11"/>
           <p:cNvSpPr txBox="1"/>
           <p:nvPr/>
         </p:nvSpPr>
@@ -8508,6 +9164,765 @@
       <p:sp>
         <p:nvSpPr>
           <p:cNvPr id="9" name="TextBox 8"/>
+          <p:cNvSpPr txBox="1"/>
+          <p:nvPr/>
+        </p:nvSpPr>
+        <p:spPr>
+          <a:xfrm>
+            <a:off x="685800" y="6583680"/>
+            <a:ext cx="6490411" cy="256032"/>
+          </a:xfrm>
+          <a:prstGeom prst="rect">
+            <a:avLst/>
+          </a:prstGeom>
+          <a:noFill/>
+        </p:spPr>
+        <p:txBody>
+          <a:bodyPr wrap="none">
+            <a:spAutoFit/>
+          </a:bodyPr>
+          <a:lstStyle/>
+          <a:p>
+            <a:pPr algn="l"/>
+            <a:r>
+              <a:rPr sz="700">
+                <a:solidFill>
+                  <a:srgbClr val="A0B4D2"/>
+                </a:solidFill>
+                <a:latin typeface="Consolas"/>
+              </a:rPr>
+              <a:t>FKB Campus  ·  TL00</a:t>
+            </a:r>
+          </a:p>
+        </p:txBody>
+      </p:sp>
+    </p:spTree>
+  </p:cSld>
+  <p:clrMapOvr>
+    <a:masterClrMapping/>
+  </p:clrMapOvr>
+</p:sld>
+</file>
+
+<file path=ppt/slides/slide20.xml><?xml version="1.0" encoding="utf-8"?>
+<p:sld xmlns:a="http://schemas.openxmlformats.org/drawingml/2006/main" xmlns:p="http://schemas.openxmlformats.org/presentationml/2006/main" xmlns:r="http://schemas.openxmlformats.org/officeDocument/2006/relationships">
+  <p:cSld>
+    <p:spTree>
+      <p:nvGrpSpPr>
+        <p:cNvPr id="1" name=""/>
+        <p:cNvGrpSpPr/>
+        <p:nvPr/>
+      </p:nvGrpSpPr>
+      <p:grpSpPr/>
+      <p:sp>
+        <p:nvSpPr>
+          <p:cNvPr id="2" name="Rectangle 1"/>
+          <p:cNvSpPr/>
+          <p:nvPr/>
+        </p:nvSpPr>
+        <p:spPr>
+          <a:xfrm>
+            <a:off x="0" y="0"/>
+            <a:ext cx="12188952" cy="6858000"/>
+          </a:xfrm>
+          <a:prstGeom prst="rect">
+            <a:avLst/>
+          </a:prstGeom>
+          <a:solidFill>
+            <a:srgbClr val="0A1937"/>
+          </a:solidFill>
+          <a:ln>
+            <a:noFill/>
+          </a:ln>
+        </p:spPr>
+        <p:style>
+          <a:lnRef idx="1">
+            <a:schemeClr val="accent1"/>
+          </a:lnRef>
+          <a:fillRef idx="3">
+            <a:schemeClr val="accent1"/>
+          </a:fillRef>
+          <a:effectRef idx="2">
+            <a:schemeClr val="accent1"/>
+          </a:effectRef>
+          <a:fontRef idx="minor">
+            <a:schemeClr val="lt1"/>
+          </a:fontRef>
+        </p:style>
+        <p:txBody>
+          <a:bodyPr rtlCol="0" anchor="ctr"/>
+          <a:lstStyle/>
+          <a:p>
+            <a:pPr algn="ctr"/>
+          </a:p>
+        </p:txBody>
+      </p:sp>
+      <p:sp>
+        <p:nvSpPr>
+          <p:cNvPr id="3" name="Rectangle 2"/>
+          <p:cNvSpPr/>
+          <p:nvPr/>
+        </p:nvSpPr>
+        <p:spPr>
+          <a:xfrm>
+            <a:off x="0" y="0"/>
+            <a:ext cx="12188952" cy="54864"/>
+          </a:xfrm>
+          <a:prstGeom prst="rect">
+            <a:avLst/>
+          </a:prstGeom>
+          <a:solidFill>
+            <a:srgbClr val="D9C089"/>
+          </a:solidFill>
+          <a:ln>
+            <a:noFill/>
+          </a:ln>
+        </p:spPr>
+        <p:style>
+          <a:lnRef idx="1">
+            <a:schemeClr val="accent1"/>
+          </a:lnRef>
+          <a:fillRef idx="3">
+            <a:schemeClr val="accent1"/>
+          </a:fillRef>
+          <a:effectRef idx="2">
+            <a:schemeClr val="accent1"/>
+          </a:effectRef>
+          <a:fontRef idx="minor">
+            <a:schemeClr val="lt1"/>
+          </a:fontRef>
+        </p:style>
+        <p:txBody>
+          <a:bodyPr rtlCol="0" anchor="ctr"/>
+          <a:lstStyle/>
+          <a:p>
+            <a:pPr algn="ctr"/>
+          </a:p>
+        </p:txBody>
+      </p:sp>
+      <p:sp>
+        <p:nvSpPr>
+          <p:cNvPr id="4" name="TextBox 3"/>
+          <p:cNvSpPr txBox="1"/>
+          <p:nvPr/>
+        </p:nvSpPr>
+        <p:spPr>
+          <a:xfrm>
+            <a:off x="685800" y="1005840"/>
+            <a:ext cx="1371600" cy="1097280"/>
+          </a:xfrm>
+          <a:prstGeom prst="rect">
+            <a:avLst/>
+          </a:prstGeom>
+          <a:noFill/>
+        </p:spPr>
+        <p:txBody>
+          <a:bodyPr wrap="square">
+            <a:spAutoFit/>
+          </a:bodyPr>
+          <a:lstStyle/>
+          <a:p>
+            <a:pPr algn="l"/>
+            <a:r>
+              <a:rPr sz="7200" b="1" i="0">
+                <a:solidFill>
+                  <a:srgbClr val="D9C089"/>
+                </a:solidFill>
+                <a:latin typeface="Arial"/>
+              </a:rPr>
+              <a:t>„</a:t>
+            </a:r>
+          </a:p>
+        </p:txBody>
+      </p:sp>
+      <p:sp>
+        <p:nvSpPr>
+          <p:cNvPr id="5" name="TextBox 4"/>
+          <p:cNvSpPr txBox="1"/>
+          <p:nvPr/>
+        </p:nvSpPr>
+        <p:spPr>
+          <a:xfrm>
+            <a:off x="685800" y="2148840"/>
+            <a:ext cx="9302922" cy="2377440"/>
+          </a:xfrm>
+          <a:prstGeom prst="rect">
+            <a:avLst/>
+          </a:prstGeom>
+          <a:noFill/>
+        </p:spPr>
+        <p:txBody>
+          <a:bodyPr wrap="square">
+            <a:spAutoFit/>
+          </a:bodyPr>
+          <a:lstStyle/>
+          <a:p>
+            <a:pPr algn="l"/>
+            <a:r>
+              <a:rPr sz="2600" b="0" i="1">
+                <a:solidFill>
+                  <a:srgbClr val="FFFFFF"/>
+                </a:solidFill>
+                <a:latin typeface="Arial"/>
+              </a:rPr>
+              <a:t>Mein Maßstab ist nicht: Wie viel habe ich heute geleistet? Sondern: Was konnte mein Team heute mehr, als es gestern konnte?</a:t>
+            </a:r>
+          </a:p>
+        </p:txBody>
+      </p:sp>
+      <p:sp>
+        <p:nvSpPr>
+          <p:cNvPr id="6" name="Rectangle 5"/>
+          <p:cNvSpPr/>
+          <p:nvPr/>
+        </p:nvSpPr>
+        <p:spPr>
+          <a:xfrm>
+            <a:off x="685800" y="4800600"/>
+            <a:ext cx="548640" cy="38100"/>
+          </a:xfrm>
+          <a:prstGeom prst="rect">
+            <a:avLst/>
+          </a:prstGeom>
+          <a:solidFill>
+            <a:srgbClr val="D9C089"/>
+          </a:solidFill>
+          <a:ln>
+            <a:noFill/>
+          </a:ln>
+        </p:spPr>
+        <p:style>
+          <a:lnRef idx="1">
+            <a:schemeClr val="accent1"/>
+          </a:lnRef>
+          <a:fillRef idx="3">
+            <a:schemeClr val="accent1"/>
+          </a:fillRef>
+          <a:effectRef idx="2">
+            <a:schemeClr val="accent1"/>
+          </a:effectRef>
+          <a:fontRef idx="minor">
+            <a:schemeClr val="lt1"/>
+          </a:fontRef>
+        </p:style>
+        <p:txBody>
+          <a:bodyPr rtlCol="0" anchor="ctr"/>
+          <a:lstStyle/>
+          <a:p>
+            <a:pPr algn="ctr"/>
+          </a:p>
+        </p:txBody>
+      </p:sp>
+      <p:sp>
+        <p:nvSpPr>
+          <p:cNvPr id="7" name="TextBox 6"/>
+          <p:cNvSpPr txBox="1"/>
+          <p:nvPr/>
+        </p:nvSpPr>
+        <p:spPr>
+          <a:xfrm>
+            <a:off x="685800" y="5029200"/>
+            <a:ext cx="10817352" cy="365760"/>
+          </a:xfrm>
+          <a:prstGeom prst="rect">
+            <a:avLst/>
+          </a:prstGeom>
+          <a:noFill/>
+        </p:spPr>
+        <p:txBody>
+          <a:bodyPr wrap="square">
+            <a:spAutoFit/>
+          </a:bodyPr>
+          <a:lstStyle/>
+          <a:p>
+            <a:pPr algn="l"/>
+            <a:r>
+              <a:rPr sz="1500" b="1" i="0">
+                <a:solidFill>
+                  <a:srgbClr val="D9C089"/>
+                </a:solidFill>
+                <a:latin typeface="Arial"/>
+              </a:rPr>
+              <a:t>Servant Leadership</a:t>
+            </a:r>
+          </a:p>
+        </p:txBody>
+      </p:sp>
+      <p:sp>
+        <p:nvSpPr>
+          <p:cNvPr id="8" name="TextBox 7"/>
+          <p:cNvSpPr txBox="1"/>
+          <p:nvPr/>
+        </p:nvSpPr>
+        <p:spPr>
+          <a:xfrm>
+            <a:off x="685800" y="5440680"/>
+            <a:ext cx="10817352" cy="274320"/>
+          </a:xfrm>
+          <a:prstGeom prst="rect">
+            <a:avLst/>
+          </a:prstGeom>
+          <a:noFill/>
+        </p:spPr>
+        <p:txBody>
+          <a:bodyPr wrap="none">
+            <a:spAutoFit/>
+          </a:bodyPr>
+          <a:lstStyle/>
+          <a:p>
+            <a:pPr algn="l"/>
+            <a:r>
+              <a:rPr sz="900">
+                <a:solidFill>
+                  <a:srgbClr val="A0B4D2"/>
+                </a:solidFill>
+                <a:latin typeface="Consolas"/>
+              </a:rPr>
+              <a:t>Greenleaf (1977) / van Dierendonck (2011)</a:t>
+            </a:r>
+          </a:p>
+        </p:txBody>
+      </p:sp>
+      <p:sp>
+        <p:nvSpPr>
+          <p:cNvPr id="9" name="TextBox 8"/>
+          <p:cNvSpPr txBox="1"/>
+          <p:nvPr/>
+        </p:nvSpPr>
+        <p:spPr>
+          <a:xfrm>
+            <a:off x="685800" y="6355080"/>
+            <a:ext cx="10817352" cy="274320"/>
+          </a:xfrm>
+          <a:prstGeom prst="rect">
+            <a:avLst/>
+          </a:prstGeom>
+          <a:noFill/>
+        </p:spPr>
+        <p:txBody>
+          <a:bodyPr wrap="none">
+            <a:spAutoFit/>
+          </a:bodyPr>
+          <a:lstStyle/>
+          <a:p>
+            <a:pPr algn="l"/>
+            <a:r>
+              <a:rPr sz="700">
+                <a:solidFill>
+                  <a:srgbClr val="8CA0C3"/>
+                </a:solidFill>
+                <a:latin typeface="Consolas"/>
+              </a:rPr>
+              <a:t>FKB Campus  ·  TL00</a:t>
+            </a:r>
+          </a:p>
+        </p:txBody>
+      </p:sp>
+    </p:spTree>
+  </p:cSld>
+  <p:clrMapOvr>
+    <a:masterClrMapping/>
+  </p:clrMapOvr>
+</p:sld>
+</file>
+
+<file path=ppt/slides/slide21.xml><?xml version="1.0" encoding="utf-8"?>
+<p:sld xmlns:a="http://schemas.openxmlformats.org/drawingml/2006/main" xmlns:p="http://schemas.openxmlformats.org/presentationml/2006/main" xmlns:r="http://schemas.openxmlformats.org/officeDocument/2006/relationships">
+  <p:cSld>
+    <p:spTree>
+      <p:nvGrpSpPr>
+        <p:cNvPr id="1" name=""/>
+        <p:cNvGrpSpPr/>
+        <p:nvPr/>
+      </p:nvGrpSpPr>
+      <p:grpSpPr/>
+      <p:sp>
+        <p:nvSpPr>
+          <p:cNvPr id="2" name="Rectangle 1"/>
+          <p:cNvSpPr/>
+          <p:nvPr/>
+        </p:nvSpPr>
+        <p:spPr>
+          <a:xfrm>
+            <a:off x="0" y="0"/>
+            <a:ext cx="12188952" cy="6858000"/>
+          </a:xfrm>
+          <a:prstGeom prst="rect">
+            <a:avLst/>
+          </a:prstGeom>
+          <a:solidFill>
+            <a:srgbClr val="EDEDF3"/>
+          </a:solidFill>
+          <a:ln>
+            <a:noFill/>
+          </a:ln>
+        </p:spPr>
+        <p:style>
+          <a:lnRef idx="1">
+            <a:schemeClr val="accent1"/>
+          </a:lnRef>
+          <a:fillRef idx="3">
+            <a:schemeClr val="accent1"/>
+          </a:fillRef>
+          <a:effectRef idx="2">
+            <a:schemeClr val="accent1"/>
+          </a:effectRef>
+          <a:fontRef idx="minor">
+            <a:schemeClr val="lt1"/>
+          </a:fontRef>
+        </p:style>
+        <p:txBody>
+          <a:bodyPr rtlCol="0" anchor="ctr"/>
+          <a:lstStyle/>
+          <a:p>
+            <a:pPr algn="ctr"/>
+          </a:p>
+        </p:txBody>
+      </p:sp>
+      <p:sp>
+        <p:nvSpPr>
+          <p:cNvPr id="3" name="Rectangle 2"/>
+          <p:cNvSpPr/>
+          <p:nvPr/>
+        </p:nvSpPr>
+        <p:spPr>
+          <a:xfrm>
+            <a:off x="0" y="0"/>
+            <a:ext cx="12188952" cy="50292"/>
+          </a:xfrm>
+          <a:prstGeom prst="rect">
+            <a:avLst/>
+          </a:prstGeom>
+          <a:solidFill>
+            <a:srgbClr val="1F2C56"/>
+          </a:solidFill>
+          <a:ln>
+            <a:noFill/>
+          </a:ln>
+        </p:spPr>
+        <p:style>
+          <a:lnRef idx="1">
+            <a:schemeClr val="accent1"/>
+          </a:lnRef>
+          <a:fillRef idx="3">
+            <a:schemeClr val="accent1"/>
+          </a:fillRef>
+          <a:effectRef idx="2">
+            <a:schemeClr val="accent1"/>
+          </a:effectRef>
+          <a:fontRef idx="minor">
+            <a:schemeClr val="lt1"/>
+          </a:fontRef>
+        </p:style>
+        <p:txBody>
+          <a:bodyPr rtlCol="0" anchor="ctr"/>
+          <a:lstStyle/>
+          <a:p>
+            <a:pPr algn="ctr"/>
+          </a:p>
+        </p:txBody>
+      </p:sp>
+      <p:sp>
+        <p:nvSpPr>
+          <p:cNvPr id="4" name="TextBox 3"/>
+          <p:cNvSpPr txBox="1"/>
+          <p:nvPr/>
+        </p:nvSpPr>
+        <p:spPr>
+          <a:xfrm>
+            <a:off x="685800" y="109728"/>
+            <a:ext cx="10817352" cy="228600"/>
+          </a:xfrm>
+          <a:prstGeom prst="rect">
+            <a:avLst/>
+          </a:prstGeom>
+          <a:noFill/>
+        </p:spPr>
+        <p:txBody>
+          <a:bodyPr wrap="none">
+            <a:spAutoFit/>
+          </a:bodyPr>
+          <a:lstStyle/>
+          <a:p>
+            <a:pPr algn="l"/>
+            <a:r>
+              <a:rPr sz="750">
+                <a:solidFill>
+                  <a:srgbClr val="78808C"/>
+                </a:solidFill>
+                <a:latin typeface="Consolas"/>
+              </a:rPr>
+              <a:t>TL00  ·  INHALT</a:t>
+            </a:r>
+          </a:p>
+        </p:txBody>
+      </p:sp>
+      <p:sp>
+        <p:nvSpPr>
+          <p:cNvPr id="5" name="Rectangle 4"/>
+          <p:cNvSpPr/>
+          <p:nvPr/>
+        </p:nvSpPr>
+        <p:spPr>
+          <a:xfrm>
+            <a:off x="0" y="1234440"/>
+            <a:ext cx="12188952" cy="12700"/>
+          </a:xfrm>
+          <a:prstGeom prst="rect">
+            <a:avLst/>
+          </a:prstGeom>
+          <a:solidFill>
+            <a:srgbClr val="D8DFE4"/>
+          </a:solidFill>
+          <a:ln>
+            <a:noFill/>
+          </a:ln>
+        </p:spPr>
+        <p:style>
+          <a:lnRef idx="1">
+            <a:schemeClr val="accent1"/>
+          </a:lnRef>
+          <a:fillRef idx="3">
+            <a:schemeClr val="accent1"/>
+          </a:fillRef>
+          <a:effectRef idx="2">
+            <a:schemeClr val="accent1"/>
+          </a:effectRef>
+          <a:fontRef idx="minor">
+            <a:schemeClr val="lt1"/>
+          </a:fontRef>
+        </p:style>
+        <p:txBody>
+          <a:bodyPr rtlCol="0" anchor="ctr"/>
+          <a:lstStyle/>
+          <a:p>
+            <a:pPr algn="ctr"/>
+          </a:p>
+        </p:txBody>
+      </p:sp>
+      <p:sp>
+        <p:nvSpPr>
+          <p:cNvPr id="6" name="Rectangle 5"/>
+          <p:cNvSpPr/>
+          <p:nvPr/>
+        </p:nvSpPr>
+        <p:spPr>
+          <a:xfrm>
+            <a:off x="685800" y="502920"/>
+            <a:ext cx="36576" cy="658368"/>
+          </a:xfrm>
+          <a:prstGeom prst="rect">
+            <a:avLst/>
+          </a:prstGeom>
+          <a:solidFill>
+            <a:srgbClr val="D9C089"/>
+          </a:solidFill>
+          <a:ln>
+            <a:noFill/>
+          </a:ln>
+        </p:spPr>
+        <p:style>
+          <a:lnRef idx="1">
+            <a:schemeClr val="accent1"/>
+          </a:lnRef>
+          <a:fillRef idx="3">
+            <a:schemeClr val="accent1"/>
+          </a:fillRef>
+          <a:effectRef idx="2">
+            <a:schemeClr val="accent1"/>
+          </a:effectRef>
+          <a:fontRef idx="minor">
+            <a:schemeClr val="lt1"/>
+          </a:fontRef>
+        </p:style>
+        <p:txBody>
+          <a:bodyPr rtlCol="0" anchor="ctr"/>
+          <a:lstStyle/>
+          <a:p>
+            <a:pPr algn="ctr"/>
+          </a:p>
+        </p:txBody>
+      </p:sp>
+      <p:sp>
+        <p:nvSpPr>
+          <p:cNvPr id="7" name="TextBox 6"/>
+          <p:cNvSpPr txBox="1"/>
+          <p:nvPr/>
+        </p:nvSpPr>
+        <p:spPr>
+          <a:xfrm>
+            <a:off x="813816" y="502920"/>
+            <a:ext cx="10634472" cy="685800"/>
+          </a:xfrm>
+          <a:prstGeom prst="rect">
+            <a:avLst/>
+          </a:prstGeom>
+          <a:noFill/>
+        </p:spPr>
+        <p:txBody>
+          <a:bodyPr wrap="square">
+            <a:spAutoFit/>
+          </a:bodyPr>
+          <a:lstStyle/>
+          <a:p>
+            <a:pPr algn="l"/>
+            <a:r>
+              <a:rPr sz="2400" b="1" i="0">
+                <a:solidFill>
+                  <a:srgbClr val="1F2C56"/>
+                </a:solidFill>
+                <a:latin typeface="Arial"/>
+              </a:rPr>
+              <a:t>Ihr Maßstab für die nächsten vier Wochen</a:t>
+            </a:r>
+          </a:p>
+        </p:txBody>
+      </p:sp>
+      <p:sp>
+        <p:nvSpPr>
+          <p:cNvPr id="8" name="TextBox 7"/>
+          <p:cNvSpPr txBox="1"/>
+          <p:nvPr/>
+        </p:nvSpPr>
+        <p:spPr>
+          <a:xfrm>
+            <a:off x="685800" y="1417320"/>
+            <a:ext cx="10817352" cy="4892040"/>
+          </a:xfrm>
+          <a:prstGeom prst="rect">
+            <a:avLst/>
+          </a:prstGeom>
+          <a:noFill/>
+        </p:spPr>
+        <p:txBody>
+          <a:bodyPr wrap="square" anchor="ctr">
+            <a:spAutoFit/>
+          </a:bodyPr>
+          <a:lstStyle/>
+          <a:p>
+            <a:pPr marL="190500" indent="-190500">
+              <a:spcBef>
+                <a:spcPts val="400"/>
+              </a:spcBef>
+              <a:spcAft>
+                <a:spcPts val="200"/>
+              </a:spcAft>
+            </a:pPr>
+            <a:r>
+              <a:rPr sz="1300">
+                <a:solidFill>
+                  <a:srgbClr val="3D5466"/>
+                </a:solidFill>
+                <a:latin typeface="Arial"/>
+              </a:rPr>
+              <a:t>▸  Vorbereitetes Gespräch führen (AB-2)</a:t>
+            </a:r>
+          </a:p>
+          <a:p>
+            <a:pPr marL="190500" indent="-190500">
+              <a:spcBef>
+                <a:spcPts val="400"/>
+              </a:spcBef>
+              <a:spcAft>
+                <a:spcPts val="200"/>
+              </a:spcAft>
+            </a:pPr>
+            <a:r>
+              <a:rPr sz="1300">
+                <a:solidFill>
+                  <a:srgbClr val="3D5466"/>
+                </a:solidFill>
+                <a:latin typeface="Arial"/>
+              </a:rPr>
+              <a:t>▸  Führungszeit-Anteil messen und erhöhen</a:t>
+            </a:r>
+          </a:p>
+          <a:p>
+            <a:pPr marL="190500" indent="-190500">
+              <a:spcBef>
+                <a:spcPts val="400"/>
+              </a:spcBef>
+              <a:spcAft>
+                <a:spcPts val="200"/>
+              </a:spcAft>
+            </a:pPr>
+            <a:r>
+              <a:rPr sz="1300">
+                <a:solidFill>
+                  <a:srgbClr val="3D5466"/>
+                </a:solidFill>
+                <a:latin typeface="Arial"/>
+              </a:rPr>
+              <a:t>▸  Klärungsgespräch mit ehemaligem Kollegen</a:t>
+            </a:r>
+          </a:p>
+          <a:p>
+            <a:pPr marL="190500" indent="-190500">
+              <a:spcBef>
+                <a:spcPts val="400"/>
+              </a:spcBef>
+              <a:spcAft>
+                <a:spcPts val="200"/>
+              </a:spcAft>
+            </a:pPr>
+            <a:r>
+              <a:rPr sz="1300">
+                <a:solidFill>
+                  <a:srgbClr val="3D5466"/>
+                </a:solidFill>
+                <a:latin typeface="Arial"/>
+              </a:rPr>
+              <a:t>▸  Checkliste: in vier Wochen wieder vorlegen</a:t>
+            </a:r>
+          </a:p>
+        </p:txBody>
+      </p:sp>
+      <p:sp>
+        <p:nvSpPr>
+          <p:cNvPr id="9" name="Rectangle 8"/>
+          <p:cNvSpPr/>
+          <p:nvPr/>
+        </p:nvSpPr>
+        <p:spPr>
+          <a:xfrm>
+            <a:off x="0" y="6510528"/>
+            <a:ext cx="12188952" cy="347472"/>
+          </a:xfrm>
+          <a:prstGeom prst="rect">
+            <a:avLst/>
+          </a:prstGeom>
+          <a:solidFill>
+            <a:srgbClr val="0A1937"/>
+          </a:solidFill>
+          <a:ln>
+            <a:noFill/>
+          </a:ln>
+        </p:spPr>
+        <p:style>
+          <a:lnRef idx="1">
+            <a:schemeClr val="accent1"/>
+          </a:lnRef>
+          <a:fillRef idx="3">
+            <a:schemeClr val="accent1"/>
+          </a:fillRef>
+          <a:effectRef idx="2">
+            <a:schemeClr val="accent1"/>
+          </a:effectRef>
+          <a:fontRef idx="minor">
+            <a:schemeClr val="lt1"/>
+          </a:fontRef>
+        </p:style>
+        <p:txBody>
+          <a:bodyPr rtlCol="0" anchor="ctr"/>
+          <a:lstStyle/>
+          <a:p>
+            <a:pPr algn="ctr"/>
+          </a:p>
+        </p:txBody>
+      </p:sp>
+      <p:sp>
+        <p:nvSpPr>
+          <p:cNvPr id="10" name="TextBox 9"/>
           <p:cNvSpPr txBox="1"/>
           <p:nvPr/>
         </p:nvSpPr>

</xml_diff>